<commit_message>
feat(mlops): complete operational monitoring lifecycle
</commit_message>
<xml_diff>
--- a/reports/SUPPORT_SOUTENANCE.pptx
+++ b/reports/SUPPORT_SOUTENANCE.pptx
@@ -2,35 +2,35 @@
 <file path=ppt/presentation.xml><?xml version="1.0" encoding="utf-8"?>
 <p:presentation xmlns:p="http://schemas.openxmlformats.org/presentationml/2006/main">
   <p:sldMasterIdLst>
-    <p:sldMasterId xmlns:r="http://schemas.openxmlformats.org/officeDocument/2006/relationships" id="2147483648" r:id="R7427e275cc544f67"/>
+    <p:sldMasterId xmlns:r="http://schemas.openxmlformats.org/officeDocument/2006/relationships" id="2147483648" r:id="Rdd59805a9aa9457b"/>
   </p:sldMasterIdLst>
   <p:notesMasterIdLst>
-    <p:notesMasterId xmlns:r="http://schemas.openxmlformats.org/officeDocument/2006/relationships" r:id="R693cea19274f4eee"/>
+    <p:notesMasterId xmlns:r="http://schemas.openxmlformats.org/officeDocument/2006/relationships" r:id="R3ffa92acb5a744e4"/>
   </p:notesMasterIdLst>
   <p:sldIdLst>
-    <p:sldId xmlns:r="http://schemas.openxmlformats.org/officeDocument/2006/relationships" id="256" r:id="Ra4eef13843ea45e2"/>
-    <p:sldId xmlns:r="http://schemas.openxmlformats.org/officeDocument/2006/relationships" id="257" r:id="R4c3befd1fad3475f"/>
-    <p:sldId xmlns:r="http://schemas.openxmlformats.org/officeDocument/2006/relationships" id="258" r:id="R559cb6f6fac74d15"/>
-    <p:sldId xmlns:r="http://schemas.openxmlformats.org/officeDocument/2006/relationships" id="259" r:id="Rb06e931248624b0a"/>
-    <p:sldId xmlns:r="http://schemas.openxmlformats.org/officeDocument/2006/relationships" id="260" r:id="R9df14b1db4d84234"/>
-    <p:sldId xmlns:r="http://schemas.openxmlformats.org/officeDocument/2006/relationships" id="261" r:id="Ra31df3ca4ebf43b3"/>
-    <p:sldId xmlns:r="http://schemas.openxmlformats.org/officeDocument/2006/relationships" id="262" r:id="R0114fa2682dc4e33"/>
-    <p:sldId xmlns:r="http://schemas.openxmlformats.org/officeDocument/2006/relationships" id="263" r:id="R8324460fe26340de"/>
-    <p:sldId xmlns:r="http://schemas.openxmlformats.org/officeDocument/2006/relationships" id="264" r:id="R30246d9906c744ba"/>
-    <p:sldId xmlns:r="http://schemas.openxmlformats.org/officeDocument/2006/relationships" id="265" r:id="R6235c11125054960"/>
-    <p:sldId xmlns:r="http://schemas.openxmlformats.org/officeDocument/2006/relationships" id="266" r:id="R419351c8aee44be8"/>
-    <p:sldId xmlns:r="http://schemas.openxmlformats.org/officeDocument/2006/relationships" id="267" r:id="Rc8edb552991c4c57"/>
-    <p:sldId xmlns:r="http://schemas.openxmlformats.org/officeDocument/2006/relationships" id="268" r:id="R4c27897ee8524827"/>
-    <p:sldId xmlns:r="http://schemas.openxmlformats.org/officeDocument/2006/relationships" id="269" r:id="R9143632312fc43e7"/>
-    <p:sldId xmlns:r="http://schemas.openxmlformats.org/officeDocument/2006/relationships" id="270" r:id="Re1597d5641864577"/>
-    <p:sldId xmlns:r="http://schemas.openxmlformats.org/officeDocument/2006/relationships" id="271" r:id="R2951f5a74d0f482d"/>
-    <p:sldId xmlns:r="http://schemas.openxmlformats.org/officeDocument/2006/relationships" id="272" r:id="R5924319528ca4996"/>
-    <p:sldId xmlns:r="http://schemas.openxmlformats.org/officeDocument/2006/relationships" id="273" r:id="Re584cec2546c443c"/>
-    <p:sldId xmlns:r="http://schemas.openxmlformats.org/officeDocument/2006/relationships" id="274" r:id="Rd9ab94358e624aad"/>
-    <p:sldId xmlns:r="http://schemas.openxmlformats.org/officeDocument/2006/relationships" id="275" r:id="Ra843bfc54c534b7f"/>
-    <p:sldId xmlns:r="http://schemas.openxmlformats.org/officeDocument/2006/relationships" id="276" r:id="R75f338d3d49d42f6"/>
-    <p:sldId xmlns:r="http://schemas.openxmlformats.org/officeDocument/2006/relationships" id="277" r:id="Rd27bb2a748014ce6"/>
-    <p:sldId xmlns:r="http://schemas.openxmlformats.org/officeDocument/2006/relationships" id="278" r:id="Rc06456fe03d34f27"/>
+    <p:sldId xmlns:r="http://schemas.openxmlformats.org/officeDocument/2006/relationships" id="256" r:id="R69f8e32e8bbc4237"/>
+    <p:sldId xmlns:r="http://schemas.openxmlformats.org/officeDocument/2006/relationships" id="257" r:id="R59e0b009420a4cfa"/>
+    <p:sldId xmlns:r="http://schemas.openxmlformats.org/officeDocument/2006/relationships" id="258" r:id="Rc62e8974654b44d0"/>
+    <p:sldId xmlns:r="http://schemas.openxmlformats.org/officeDocument/2006/relationships" id="259" r:id="Rec25ff73d7de4dd4"/>
+    <p:sldId xmlns:r="http://schemas.openxmlformats.org/officeDocument/2006/relationships" id="260" r:id="R396284be50e9430a"/>
+    <p:sldId xmlns:r="http://schemas.openxmlformats.org/officeDocument/2006/relationships" id="261" r:id="R8baf8c3f1d594a5d"/>
+    <p:sldId xmlns:r="http://schemas.openxmlformats.org/officeDocument/2006/relationships" id="262" r:id="Rc7207b6857ec454c"/>
+    <p:sldId xmlns:r="http://schemas.openxmlformats.org/officeDocument/2006/relationships" id="263" r:id="R47c81d080baf4cab"/>
+    <p:sldId xmlns:r="http://schemas.openxmlformats.org/officeDocument/2006/relationships" id="264" r:id="R3a523b68bbe7485f"/>
+    <p:sldId xmlns:r="http://schemas.openxmlformats.org/officeDocument/2006/relationships" id="265" r:id="R7dc060ea6f664bb4"/>
+    <p:sldId xmlns:r="http://schemas.openxmlformats.org/officeDocument/2006/relationships" id="266" r:id="R8895282395764129"/>
+    <p:sldId xmlns:r="http://schemas.openxmlformats.org/officeDocument/2006/relationships" id="267" r:id="R40f649687e194452"/>
+    <p:sldId xmlns:r="http://schemas.openxmlformats.org/officeDocument/2006/relationships" id="268" r:id="R7d4714b553464e10"/>
+    <p:sldId xmlns:r="http://schemas.openxmlformats.org/officeDocument/2006/relationships" id="269" r:id="Rd45ac69715c244e0"/>
+    <p:sldId xmlns:r="http://schemas.openxmlformats.org/officeDocument/2006/relationships" id="270" r:id="Rb8c1282fcd1443ea"/>
+    <p:sldId xmlns:r="http://schemas.openxmlformats.org/officeDocument/2006/relationships" id="271" r:id="Rac93d79357434ba6"/>
+    <p:sldId xmlns:r="http://schemas.openxmlformats.org/officeDocument/2006/relationships" id="272" r:id="Rb421fc63bb6f4ed7"/>
+    <p:sldId xmlns:r="http://schemas.openxmlformats.org/officeDocument/2006/relationships" id="273" r:id="R6384e1b1532849db"/>
+    <p:sldId xmlns:r="http://schemas.openxmlformats.org/officeDocument/2006/relationships" id="274" r:id="R60c136e8d4ae4080"/>
+    <p:sldId xmlns:r="http://schemas.openxmlformats.org/officeDocument/2006/relationships" id="275" r:id="Rb2e5f95925e449a3"/>
+    <p:sldId xmlns:r="http://schemas.openxmlformats.org/officeDocument/2006/relationships" id="276" r:id="R92aec4f7e92944cf"/>
+    <p:sldId xmlns:r="http://schemas.openxmlformats.org/officeDocument/2006/relationships" id="277" r:id="R03e1a8b2dec44a08"/>
+    <p:sldId xmlns:r="http://schemas.openxmlformats.org/officeDocument/2006/relationships" id="278" r:id="R97033922fb6e4f32"/>
   </p:sldIdLst>
   <p:sldSz cx="12192000" cy="6858000"/>
   <p:notesSz cx="6858000" cy="9144000"/>
@@ -2517,7 +2517,7 @@
   </p:cSld>
   <p:clrMap bg1="lt1" tx1="dk1" bg2="lt2" tx2="dk2" accent1="accent1" accent2="accent2" accent3="accent3" accent4="accent4" accent5="accent5" accent6="accent6" hlink="hlink" folHlink="folHlink"/>
   <p:sldLayoutIdLst>
-    <p:sldLayoutId xmlns:r="http://schemas.openxmlformats.org/officeDocument/2006/relationships" id="2147483649" r:id="R052d15bf5f1b49d5"/>
+    <p:sldLayoutId xmlns:r="http://schemas.openxmlformats.org/officeDocument/2006/relationships" id="2147483649" r:id="R1264ab96f56449b7"/>
   </p:sldLayoutIdLst>
   <p:txStyles>
     <p:titleStyle>
@@ -3127,6 +3127,7 @@
           <a:lstStyle xmlns:a="http://schemas.openxmlformats.org/drawingml/2006/main"/>
           <a:p xmlns:a="http://schemas.openxmlformats.org/drawingml/2006/main">
             <a:pPr>
+              <a:buNone/>
               <a:defRPr sz="3900" b="1">
                 <a:solidFill>
                   <a:srgbClr val="173B57"/>
@@ -3144,6 +3145,7 @@
           </a:p>
           <a:p xmlns:a="http://schemas.openxmlformats.org/drawingml/2006/main">
             <a:pPr>
+              <a:buNone/>
               <a:defRPr sz="3900" b="1">
                 <a:solidFill>
                   <a:srgbClr val="173B57"/>
@@ -3194,6 +3196,7 @@
           <a:lstStyle xmlns:a="http://schemas.openxmlformats.org/drawingml/2006/main"/>
           <a:p xmlns:a="http://schemas.openxmlformats.org/drawingml/2006/main">
             <a:pPr>
+              <a:buNone/>
               <a:defRPr sz="1875" b="1">
                 <a:solidFill>
                   <a:srgbClr val="1B252C"/>
@@ -3244,6 +3247,7 @@
           <a:lstStyle xmlns:a="http://schemas.openxmlformats.org/drawingml/2006/main"/>
           <a:p xmlns:a="http://schemas.openxmlformats.org/drawingml/2006/main">
             <a:pPr>
+              <a:buNone/>
               <a:defRPr sz="1425">
                 <a:solidFill>
                   <a:srgbClr val="5D6B76"/>
@@ -3294,6 +3298,7 @@
           <a:lstStyle xmlns:a="http://schemas.openxmlformats.org/drawingml/2006/main"/>
           <a:p xmlns:a="http://schemas.openxmlformats.org/drawingml/2006/main">
             <a:pPr>
+              <a:buNone/>
               <a:defRPr sz="1350">
                 <a:solidFill>
                   <a:srgbClr val="2E6F9E"/>
@@ -3344,6 +3349,7 @@
           <a:lstStyle xmlns:a="http://schemas.openxmlformats.org/drawingml/2006/main"/>
           <a:p xmlns:a="http://schemas.openxmlformats.org/drawingml/2006/main">
             <a:pPr algn="r">
+              <a:buNone/>
               <a:defRPr sz="900">
                 <a:solidFill>
                   <a:srgbClr val="85929B"/>
@@ -3423,6 +3429,7 @@
           <a:lstStyle xmlns:a="http://schemas.openxmlformats.org/drawingml/2006/main"/>
           <a:p xmlns:a="http://schemas.openxmlformats.org/drawingml/2006/main">
             <a:pPr>
+              <a:buNone/>
               <a:defRPr sz="2700" b="1">
                 <a:solidFill>
                   <a:srgbClr val="173B57"/>
@@ -3504,6 +3511,7 @@
           <a:lstStyle xmlns:a="http://schemas.openxmlformats.org/drawingml/2006/main"/>
           <a:p xmlns:a="http://schemas.openxmlformats.org/drawingml/2006/main">
             <a:pPr algn="r">
+              <a:buNone/>
               <a:defRPr sz="900">
                 <a:solidFill>
                   <a:srgbClr val="85929B"/>
@@ -3725,6 +3733,7 @@
           <a:lstStyle xmlns:a="http://schemas.openxmlformats.org/drawingml/2006/main"/>
           <a:p xmlns:a="http://schemas.openxmlformats.org/drawingml/2006/main">
             <a:pPr>
+              <a:buNone/>
               <a:defRPr sz="1500" b="1">
                 <a:solidFill>
                   <a:srgbClr val="173B57"/>
@@ -3804,6 +3813,7 @@
           <a:lstStyle xmlns:a="http://schemas.openxmlformats.org/drawingml/2006/main"/>
           <a:p xmlns:a="http://schemas.openxmlformats.org/drawingml/2006/main">
             <a:pPr>
+              <a:buNone/>
               <a:defRPr sz="2700" b="1">
                 <a:solidFill>
                   <a:srgbClr val="173B57"/>
@@ -3885,6 +3895,7 @@
           <a:lstStyle xmlns:a="http://schemas.openxmlformats.org/drawingml/2006/main"/>
           <a:p xmlns:a="http://schemas.openxmlformats.org/drawingml/2006/main">
             <a:pPr algn="r">
+              <a:buNone/>
               <a:defRPr sz="900">
                 <a:solidFill>
                   <a:srgbClr val="85929B"/>
@@ -3904,14 +3915,14 @@
       </p:sp>
       <p:pic>
         <p:nvPicPr>
-          <p:cNvPr id="10" name=""/>
+          <p:cNvPr id="12" name=""/>
           <p:cNvPicPr>
             <a:picLocks xmlns:a="http://schemas.openxmlformats.org/drawingml/2006/main" noChangeAspect="1"/>
           </p:cNvPicPr>
           <p:nvPr/>
         </p:nvPicPr>
         <p:blipFill>
-          <a:blip xmlns:r="http://schemas.openxmlformats.org/officeDocument/2006/relationships" xmlns:a="http://schemas.openxmlformats.org/drawingml/2006/main" r:embed="Rdd7fd86d9d69469e"/>
+          <a:blip xmlns:r="http://schemas.openxmlformats.org/officeDocument/2006/relationships" xmlns:a="http://schemas.openxmlformats.org/drawingml/2006/main" r:embed="Rdc9129b817c3465d"/>
           <a:stretch xmlns:a="http://schemas.openxmlformats.org/drawingml/2006/main"/>
         </p:blipFill>
         <p:spPr>
@@ -3957,6 +3968,7 @@
           <a:lstStyle xmlns:a="http://schemas.openxmlformats.org/drawingml/2006/main"/>
           <a:p xmlns:a="http://schemas.openxmlformats.org/drawingml/2006/main">
             <a:pPr>
+              <a:buNone/>
               <a:defRPr sz="2250" b="1">
                 <a:solidFill>
                   <a:srgbClr val="B95D48"/>
@@ -4132,6 +4144,7 @@
           <a:lstStyle xmlns:a="http://schemas.openxmlformats.org/drawingml/2006/main"/>
           <a:p xmlns:a="http://schemas.openxmlformats.org/drawingml/2006/main">
             <a:pPr>
+              <a:buNone/>
               <a:defRPr sz="2700" b="1">
                 <a:solidFill>
                   <a:srgbClr val="173B57"/>
@@ -4213,6 +4226,7 @@
           <a:lstStyle xmlns:a="http://schemas.openxmlformats.org/drawingml/2006/main"/>
           <a:p xmlns:a="http://schemas.openxmlformats.org/drawingml/2006/main">
             <a:pPr algn="r">
+              <a:buNone/>
               <a:defRPr sz="900">
                 <a:solidFill>
                   <a:srgbClr val="85929B"/>
@@ -4232,14 +4246,14 @@
       </p:sp>
       <p:pic>
         <p:nvPicPr>
-          <p:cNvPr id="11" name=""/>
+          <p:cNvPr id="14" name=""/>
           <p:cNvPicPr>
             <a:picLocks xmlns:a="http://schemas.openxmlformats.org/drawingml/2006/main" noChangeAspect="1"/>
           </p:cNvPicPr>
           <p:nvPr/>
         </p:nvPicPr>
         <p:blipFill>
-          <a:blip xmlns:r="http://schemas.openxmlformats.org/officeDocument/2006/relationships" xmlns:a="http://schemas.openxmlformats.org/drawingml/2006/main" r:embed="Rb08c795354a74656"/>
+          <a:blip xmlns:r="http://schemas.openxmlformats.org/officeDocument/2006/relationships" xmlns:a="http://schemas.openxmlformats.org/drawingml/2006/main" r:embed="R9a5a9464c3344f03"/>
           <a:stretch xmlns:a="http://schemas.openxmlformats.org/drawingml/2006/main"/>
         </p:blipFill>
         <p:spPr>
@@ -4254,7 +4268,7 @@
       </p:pic>
       <p:graphicFrame>
         <p:nvGraphicFramePr>
-          <p:cNvPr id="12" name=""/>
+          <p:cNvPr id="15" name=""/>
           <p:cNvGraphicFramePr/>
           <p:nvPr/>
         </p:nvGraphicFramePr>
@@ -4492,6 +4506,7 @@
           <a:lstStyle xmlns:a="http://schemas.openxmlformats.org/drawingml/2006/main"/>
           <a:p xmlns:a="http://schemas.openxmlformats.org/drawingml/2006/main">
             <a:pPr>
+              <a:buNone/>
               <a:defRPr sz="1500" b="1">
                 <a:solidFill>
                   <a:srgbClr val="B95D48"/>
@@ -4571,6 +4586,7 @@
           <a:lstStyle xmlns:a="http://schemas.openxmlformats.org/drawingml/2006/main"/>
           <a:p xmlns:a="http://schemas.openxmlformats.org/drawingml/2006/main">
             <a:pPr>
+              <a:buNone/>
               <a:defRPr sz="2700" b="1">
                 <a:solidFill>
                   <a:srgbClr val="173B57"/>
@@ -4652,6 +4668,7 @@
           <a:lstStyle xmlns:a="http://schemas.openxmlformats.org/drawingml/2006/main"/>
           <a:p xmlns:a="http://schemas.openxmlformats.org/drawingml/2006/main">
             <a:pPr algn="r">
+              <a:buNone/>
               <a:defRPr sz="900">
                 <a:solidFill>
                   <a:srgbClr val="85929B"/>
@@ -4671,14 +4688,14 @@
       </p:sp>
       <p:pic>
         <p:nvPicPr>
-          <p:cNvPr id="9" name=""/>
+          <p:cNvPr id="11" name=""/>
           <p:cNvPicPr>
             <a:picLocks xmlns:a="http://schemas.openxmlformats.org/drawingml/2006/main" noChangeAspect="1"/>
           </p:cNvPicPr>
           <p:nvPr/>
         </p:nvPicPr>
         <p:blipFill>
-          <a:blip xmlns:r="http://schemas.openxmlformats.org/officeDocument/2006/relationships" xmlns:a="http://schemas.openxmlformats.org/drawingml/2006/main" r:embed="Rc282e5dca6cf4bf5"/>
+          <a:blip xmlns:r="http://schemas.openxmlformats.org/officeDocument/2006/relationships" xmlns:a="http://schemas.openxmlformats.org/drawingml/2006/main" r:embed="R6b208a89258e4b9f"/>
           <a:stretch xmlns:a="http://schemas.openxmlformats.org/drawingml/2006/main"/>
         </p:blipFill>
         <p:spPr>
@@ -4870,6 +4887,7 @@
           <a:lstStyle xmlns:a="http://schemas.openxmlformats.org/drawingml/2006/main"/>
           <a:p xmlns:a="http://schemas.openxmlformats.org/drawingml/2006/main">
             <a:pPr>
+              <a:buNone/>
               <a:defRPr sz="2700" b="1">
                 <a:solidFill>
                   <a:srgbClr val="173B57"/>
@@ -4951,6 +4969,7 @@
           <a:lstStyle xmlns:a="http://schemas.openxmlformats.org/drawingml/2006/main"/>
           <a:p xmlns:a="http://schemas.openxmlformats.org/drawingml/2006/main">
             <a:pPr algn="r">
+              <a:buNone/>
               <a:defRPr sz="900">
                 <a:solidFill>
                   <a:srgbClr val="85929B"/>
@@ -4970,14 +4989,14 @@
       </p:sp>
       <p:pic>
         <p:nvPicPr>
-          <p:cNvPr id="10" name=""/>
+          <p:cNvPr id="12" name=""/>
           <p:cNvPicPr>
             <a:picLocks xmlns:a="http://schemas.openxmlformats.org/drawingml/2006/main" noChangeAspect="1"/>
           </p:cNvPicPr>
           <p:nvPr/>
         </p:nvPicPr>
         <p:blipFill>
-          <a:blip xmlns:r="http://schemas.openxmlformats.org/officeDocument/2006/relationships" xmlns:a="http://schemas.openxmlformats.org/drawingml/2006/main" r:embed="R66ffe47d28154cdd"/>
+          <a:blip xmlns:r="http://schemas.openxmlformats.org/officeDocument/2006/relationships" xmlns:a="http://schemas.openxmlformats.org/drawingml/2006/main" r:embed="R71dac04ae46441e0"/>
           <a:stretch xmlns:a="http://schemas.openxmlformats.org/drawingml/2006/main"/>
         </p:blipFill>
         <p:spPr>
@@ -5023,6 +5042,7 @@
           <a:lstStyle xmlns:a="http://schemas.openxmlformats.org/drawingml/2006/main"/>
           <a:p xmlns:a="http://schemas.openxmlformats.org/drawingml/2006/main">
             <a:pPr>
+              <a:buNone/>
               <a:defRPr sz="2550" b="1">
                 <a:solidFill>
                   <a:srgbClr val="2F7D67"/>
@@ -5198,6 +5218,7 @@
           <a:lstStyle xmlns:a="http://schemas.openxmlformats.org/drawingml/2006/main"/>
           <a:p xmlns:a="http://schemas.openxmlformats.org/drawingml/2006/main">
             <a:pPr>
+              <a:buNone/>
               <a:defRPr sz="2700" b="1">
                 <a:solidFill>
                   <a:srgbClr val="173B57"/>
@@ -5279,6 +5300,7 @@
           <a:lstStyle xmlns:a="http://schemas.openxmlformats.org/drawingml/2006/main"/>
           <a:p xmlns:a="http://schemas.openxmlformats.org/drawingml/2006/main">
             <a:pPr algn="r">
+              <a:buNone/>
               <a:defRPr sz="900">
                 <a:solidFill>
                   <a:srgbClr val="85929B"/>
@@ -5329,6 +5351,7 @@
           <a:lstStyle xmlns:a="http://schemas.openxmlformats.org/drawingml/2006/main"/>
           <a:p xmlns:a="http://schemas.openxmlformats.org/drawingml/2006/main">
             <a:pPr>
+              <a:buNone/>
               <a:defRPr sz="1875" b="1">
                 <a:solidFill>
                   <a:srgbClr val="2E6F9E"/>
@@ -5416,7 +5439,15 @@
                   <a:srgbClr val="1B252C"/>
                 </a:solidFill>
               </a:rPr>
-              <a:t>• CLI batch et API /predict</a:t>
+              <a:t>• </a:t>
+            </a:r>
+            <a:r>
+              <a:rPr sz="1575">
+                <a:solidFill>
+                  <a:srgbClr val="1B252C"/>
+                </a:solidFill>
+              </a:rPr>
+              <a:t>CLI / API + limite de débit</a:t>
             </a:r>
           </a:p>
           <a:p xmlns:a="http://schemas.openxmlformats.org/drawingml/2006/main">
@@ -5527,6 +5558,7 @@
           <a:lstStyle xmlns:a="http://schemas.openxmlformats.org/drawingml/2006/main"/>
           <a:p xmlns:a="http://schemas.openxmlformats.org/drawingml/2006/main">
             <a:pPr>
+              <a:buNone/>
               <a:defRPr sz="1875" b="1">
                 <a:solidFill>
                   <a:srgbClr val="2F7D67"/>
@@ -5593,7 +5625,15 @@
                   <a:srgbClr val="1B252C"/>
                 </a:solidFill>
               </a:rPr>
-              <a:t>• MLflow candidate / production / archived</a:t>
+              <a:t>• </a:t>
+            </a:r>
+            <a:r>
+              <a:rPr sz="1575">
+                <a:solidFill>
+                  <a:srgbClr val="1B252C"/>
+                </a:solidFill>
+              </a:rPr>
+              <a:t>MLflow runs + registre / rollback</a:t>
             </a:r>
           </a:p>
           <a:p xmlns:a="http://schemas.openxmlformats.org/drawingml/2006/main">
@@ -5614,7 +5654,15 @@
                   <a:srgbClr val="1B252C"/>
                 </a:solidFill>
               </a:rPr>
-              <a:t>• Prometheus / Grafana et /metrics</a:t>
+              <a:t>• </a:t>
+            </a:r>
+            <a:r>
+              <a:rPr sz="1575">
+                <a:solidFill>
+                  <a:srgbClr val="1B252C"/>
+                </a:solidFill>
+              </a:rPr>
+              <a:t>Dashboard Grafana + /metrics</a:t>
             </a:r>
           </a:p>
           <a:p xmlns:a="http://schemas.openxmlformats.org/drawingml/2006/main">
@@ -5635,7 +5683,15 @@
                   <a:srgbClr val="1B252C"/>
                 </a:solidFill>
               </a:rPr>
-              <a:t>• Alerting + heartbeat</a:t>
+              <a:t>• </a:t>
+            </a:r>
+            <a:r>
+              <a:rPr sz="1575">
+                <a:solidFill>
+                  <a:srgbClr val="1B252C"/>
+                </a:solidFill>
+              </a:rPr>
+              <a:t>APScheduler + heartbeat</a:t>
             </a:r>
           </a:p>
           <a:p xmlns:a="http://schemas.openxmlformats.org/drawingml/2006/main">
@@ -5727,6 +5783,7 @@
           <a:lstStyle xmlns:a="http://schemas.openxmlformats.org/drawingml/2006/main"/>
           <a:p xmlns:a="http://schemas.openxmlformats.org/drawingml/2006/main">
             <a:pPr>
+              <a:buNone/>
               <a:defRPr sz="1500" b="1">
                 <a:solidFill>
                   <a:srgbClr val="2F7D67"/>
@@ -5739,7 +5796,7 @@
                   <a:srgbClr val="2F7D67"/>
                 </a:solidFill>
               </a:rPr>
-              <a:t>36 tests automatisés : le cycle de vie est démontrable hors notebook.</a:t>
+              <a:t>48 tests automatisés : le cycle de vie est démontrable hors notebook.</a:t>
             </a:r>
           </a:p>
         </p:txBody>
@@ -5806,6 +5863,7 @@
           <a:lstStyle xmlns:a="http://schemas.openxmlformats.org/drawingml/2006/main"/>
           <a:p xmlns:a="http://schemas.openxmlformats.org/drawingml/2006/main">
             <a:pPr>
+              <a:buNone/>
               <a:defRPr sz="2700" b="1">
                 <a:solidFill>
                   <a:srgbClr val="173B57"/>
@@ -5887,6 +5945,7 @@
           <a:lstStyle xmlns:a="http://schemas.openxmlformats.org/drawingml/2006/main"/>
           <a:p xmlns:a="http://schemas.openxmlformats.org/drawingml/2006/main">
             <a:pPr algn="r">
+              <a:buNone/>
               <a:defRPr sz="900">
                 <a:solidFill>
                   <a:srgbClr val="85929B"/>
@@ -5937,6 +5996,7 @@
           <a:lstStyle xmlns:a="http://schemas.openxmlformats.org/drawingml/2006/main"/>
           <a:p xmlns:a="http://schemas.openxmlformats.org/drawingml/2006/main">
             <a:pPr algn="ctr">
+              <a:buNone/>
               <a:defRPr sz="1500" b="1">
                 <a:solidFill>
                   <a:srgbClr val="173B57"/>
@@ -5956,7 +6016,7 @@
       </p:sp>
       <p:graphicFrame>
         <p:nvGraphicFramePr>
-          <p:cNvPr id="11" name=""/>
+          <p:cNvPr id="13" name=""/>
           <p:cNvGraphicFramePr/>
           <p:nvPr/>
         </p:nvGraphicFramePr>
@@ -6234,6 +6294,7 @@
           <a:lstStyle xmlns:a="http://schemas.openxmlformats.org/drawingml/2006/main"/>
           <a:p xmlns:a="http://schemas.openxmlformats.org/drawingml/2006/main">
             <a:pPr algn="ctr">
+              <a:buNone/>
               <a:defRPr sz="1425">
                 <a:solidFill>
                   <a:srgbClr val="5D6B76"/>
@@ -6313,6 +6374,7 @@
           <a:lstStyle xmlns:a="http://schemas.openxmlformats.org/drawingml/2006/main"/>
           <a:p xmlns:a="http://schemas.openxmlformats.org/drawingml/2006/main">
             <a:pPr>
+              <a:buNone/>
               <a:defRPr sz="975" b="1">
                 <a:solidFill>
                   <a:srgbClr val="2E6F9E"/>
@@ -6363,6 +6425,7 @@
           <a:lstStyle xmlns:a="http://schemas.openxmlformats.org/drawingml/2006/main"/>
           <a:p xmlns:a="http://schemas.openxmlformats.org/drawingml/2006/main">
             <a:pPr>
+              <a:buNone/>
               <a:defRPr sz="2700" b="1">
                 <a:solidFill>
                   <a:srgbClr val="173B57"/>
@@ -6444,6 +6507,7 @@
           <a:lstStyle xmlns:a="http://schemas.openxmlformats.org/drawingml/2006/main"/>
           <a:p xmlns:a="http://schemas.openxmlformats.org/drawingml/2006/main">
             <a:pPr algn="r">
+              <a:buNone/>
               <a:defRPr sz="900">
                 <a:solidFill>
                   <a:srgbClr val="85929B"/>
@@ -6494,6 +6558,7 @@
           <a:lstStyle xmlns:a="http://schemas.openxmlformats.org/drawingml/2006/main"/>
           <a:p xmlns:a="http://schemas.openxmlformats.org/drawingml/2006/main">
             <a:pPr>
+              <a:buNone/>
               <a:defRPr sz="1575" b="1">
                 <a:solidFill>
                   <a:srgbClr val="B95D48"/>
@@ -6513,7 +6578,7 @@
       </p:sp>
       <p:graphicFrame>
         <p:nvGraphicFramePr>
-          <p:cNvPr id="14" name=""/>
+          <p:cNvPr id="16" name=""/>
           <p:cNvGraphicFramePr/>
           <p:nvPr/>
         </p:nvGraphicFramePr>
@@ -6823,6 +6888,7 @@
           <a:lstStyle xmlns:a="http://schemas.openxmlformats.org/drawingml/2006/main"/>
           <a:p xmlns:a="http://schemas.openxmlformats.org/drawingml/2006/main">
             <a:pPr>
+              <a:buNone/>
               <a:defRPr sz="1500" b="1">
                 <a:solidFill>
                   <a:srgbClr val="173B57"/>
@@ -6902,6 +6968,7 @@
           <a:lstStyle xmlns:a="http://schemas.openxmlformats.org/drawingml/2006/main"/>
           <a:p xmlns:a="http://schemas.openxmlformats.org/drawingml/2006/main">
             <a:pPr>
+              <a:buNone/>
               <a:defRPr sz="975" b="1">
                 <a:solidFill>
                   <a:srgbClr val="2E6F9E"/>
@@ -6952,6 +7019,7 @@
           <a:lstStyle xmlns:a="http://schemas.openxmlformats.org/drawingml/2006/main"/>
           <a:p xmlns:a="http://schemas.openxmlformats.org/drawingml/2006/main">
             <a:pPr>
+              <a:buNone/>
               <a:defRPr sz="2700" b="1">
                 <a:solidFill>
                   <a:srgbClr val="173B57"/>
@@ -7033,6 +7101,7 @@
           <a:lstStyle xmlns:a="http://schemas.openxmlformats.org/drawingml/2006/main"/>
           <a:p xmlns:a="http://schemas.openxmlformats.org/drawingml/2006/main">
             <a:pPr algn="r">
+              <a:buNone/>
               <a:defRPr sz="900">
                 <a:solidFill>
                   <a:srgbClr val="85929B"/>
@@ -7083,6 +7152,7 @@
           <a:lstStyle xmlns:a="http://schemas.openxmlformats.org/drawingml/2006/main"/>
           <a:p xmlns:a="http://schemas.openxmlformats.org/drawingml/2006/main">
             <a:pPr algn="ctr">
+              <a:buNone/>
               <a:defRPr sz="2100" b="1">
                 <a:solidFill>
                   <a:srgbClr val="2E6F9E"/>
@@ -7133,6 +7203,7 @@
           <a:lstStyle xmlns:a="http://schemas.openxmlformats.org/drawingml/2006/main"/>
           <a:p xmlns:a="http://schemas.openxmlformats.org/drawingml/2006/main">
             <a:pPr>
+              <a:buNone/>
               <a:defRPr sz="1725" b="1">
                 <a:solidFill>
                   <a:srgbClr val="173B57"/>
@@ -7183,6 +7254,7 @@
           <a:lstStyle xmlns:a="http://schemas.openxmlformats.org/drawingml/2006/main"/>
           <a:p xmlns:a="http://schemas.openxmlformats.org/drawingml/2006/main">
             <a:pPr>
+              <a:buNone/>
               <a:defRPr sz="1575">
                 <a:solidFill>
                   <a:srgbClr val="1B252C"/>
@@ -7195,7 +7267,7 @@
                   <a:srgbClr val="1B252C"/>
                 </a:solidFill>
               </a:rPr>
-              <a:t>Qualité + PSI à chaque batch</a:t>
+              <a:t>PSI hebdomadaire + chaque batch</a:t>
             </a:r>
           </a:p>
         </p:txBody>
@@ -7264,6 +7336,7 @@
           <a:lstStyle xmlns:a="http://schemas.openxmlformats.org/drawingml/2006/main"/>
           <a:p xmlns:a="http://schemas.openxmlformats.org/drawingml/2006/main">
             <a:pPr algn="ctr">
+              <a:buNone/>
               <a:defRPr sz="2100" b="1">
                 <a:solidFill>
                   <a:srgbClr val="2E6F9E"/>
@@ -7314,6 +7387,7 @@
           <a:lstStyle xmlns:a="http://schemas.openxmlformats.org/drawingml/2006/main"/>
           <a:p xmlns:a="http://schemas.openxmlformats.org/drawingml/2006/main">
             <a:pPr>
+              <a:buNone/>
               <a:defRPr sz="1725" b="1">
                 <a:solidFill>
                   <a:srgbClr val="173B57"/>
@@ -7364,6 +7438,7 @@
           <a:lstStyle xmlns:a="http://schemas.openxmlformats.org/drawingml/2006/main"/>
           <a:p xmlns:a="http://schemas.openxmlformats.org/drawingml/2006/main">
             <a:pPr>
+              <a:buNone/>
               <a:defRPr sz="1575">
                 <a:solidFill>
                   <a:srgbClr val="1B252C"/>
@@ -7376,7 +7451,7 @@
                   <a:srgbClr val="1B252C"/>
                 </a:solidFill>
               </a:rPr>
-              <a:t>Dérive sans labels = investigation</a:t>
+              <a:t>Dérive / performance / revue annuelle</a:t>
             </a:r>
           </a:p>
         </p:txBody>
@@ -7445,6 +7520,7 @@
           <a:lstStyle xmlns:a="http://schemas.openxmlformats.org/drawingml/2006/main"/>
           <a:p xmlns:a="http://schemas.openxmlformats.org/drawingml/2006/main">
             <a:pPr algn="ctr">
+              <a:buNone/>
               <a:defRPr sz="2100" b="1">
                 <a:solidFill>
                   <a:srgbClr val="2E6F9E"/>
@@ -7495,6 +7571,7 @@
           <a:lstStyle xmlns:a="http://schemas.openxmlformats.org/drawingml/2006/main"/>
           <a:p xmlns:a="http://schemas.openxmlformats.org/drawingml/2006/main">
             <a:pPr>
+              <a:buNone/>
               <a:defRPr sz="1725" b="1">
                 <a:solidFill>
                   <a:srgbClr val="173B57"/>
@@ -7545,6 +7622,7 @@
           <a:lstStyle xmlns:a="http://schemas.openxmlformats.org/drawingml/2006/main"/>
           <a:p xmlns:a="http://schemas.openxmlformats.org/drawingml/2006/main">
             <a:pPr>
+              <a:buNone/>
               <a:defRPr sz="1575">
                 <a:solidFill>
                   <a:srgbClr val="1B252C"/>
@@ -7557,7 +7635,7 @@
                   <a:srgbClr val="1B252C"/>
                 </a:solidFill>
               </a:rPr>
-              <a:t>Candidat annuel avec labels frais</a:t>
+              <a:t>Candidat tracé dans MLflow</a:t>
             </a:r>
           </a:p>
         </p:txBody>
@@ -7626,6 +7704,7 @@
           <a:lstStyle xmlns:a="http://schemas.openxmlformats.org/drawingml/2006/main"/>
           <a:p xmlns:a="http://schemas.openxmlformats.org/drawingml/2006/main">
             <a:pPr algn="ctr">
+              <a:buNone/>
               <a:defRPr sz="2100" b="1">
                 <a:solidFill>
                   <a:srgbClr val="2E6F9E"/>
@@ -7676,6 +7755,7 @@
           <a:lstStyle xmlns:a="http://schemas.openxmlformats.org/drawingml/2006/main"/>
           <a:p xmlns:a="http://schemas.openxmlformats.org/drawingml/2006/main">
             <a:pPr>
+              <a:buNone/>
               <a:defRPr sz="1725" b="1">
                 <a:solidFill>
                   <a:srgbClr val="173B57"/>
@@ -7726,6 +7806,7 @@
           <a:lstStyle xmlns:a="http://schemas.openxmlformats.org/drawingml/2006/main"/>
           <a:p xmlns:a="http://schemas.openxmlformats.org/drawingml/2006/main">
             <a:pPr>
+              <a:buNone/>
               <a:defRPr sz="1575">
                 <a:solidFill>
                   <a:srgbClr val="1B252C"/>
@@ -7738,7 +7819,7 @@
                   <a:srgbClr val="1B252C"/>
                 </a:solidFill>
               </a:rPr>
-              <a:t>AUC · rappel · équité + humain</a:t>
+              <a:t>Gate technique + approbation humaine</a:t>
             </a:r>
           </a:p>
         </p:txBody>
@@ -7807,6 +7888,7 @@
           <a:lstStyle xmlns:a="http://schemas.openxmlformats.org/drawingml/2006/main"/>
           <a:p xmlns:a="http://schemas.openxmlformats.org/drawingml/2006/main">
             <a:pPr algn="ctr">
+              <a:buNone/>
               <a:defRPr sz="2100" b="1">
                 <a:solidFill>
                   <a:srgbClr val="2E6F9E"/>
@@ -7857,6 +7939,7 @@
           <a:lstStyle xmlns:a="http://schemas.openxmlformats.org/drawingml/2006/main"/>
           <a:p xmlns:a="http://schemas.openxmlformats.org/drawingml/2006/main">
             <a:pPr>
+              <a:buNone/>
               <a:defRPr sz="1725" b="1">
                 <a:solidFill>
                   <a:srgbClr val="173B57"/>
@@ -7907,6 +7990,7 @@
           <a:lstStyle xmlns:a="http://schemas.openxmlformats.org/drawingml/2006/main"/>
           <a:p xmlns:a="http://schemas.openxmlformats.org/drawingml/2006/main">
             <a:pPr>
+              <a:buNone/>
               <a:defRPr sz="1575">
                 <a:solidFill>
                   <a:srgbClr val="1B252C"/>
@@ -7919,7 +8003,7 @@
                   <a:srgbClr val="1B252C"/>
                 </a:solidFill>
               </a:rPr>
-              <a:t>Alias production ou rollback</a:t>
+              <a:t>Promotion ou rollback</a:t>
             </a:r>
           </a:p>
         </p:txBody>
@@ -7990,6 +8074,7 @@
           <a:lstStyle xmlns:a="http://schemas.openxmlformats.org/drawingml/2006/main"/>
           <a:p xmlns:a="http://schemas.openxmlformats.org/drawingml/2006/main">
             <a:pPr>
+              <a:buNone/>
               <a:defRPr sz="1500" b="1">
                 <a:solidFill>
                   <a:srgbClr val="2F7D67"/>
@@ -8069,6 +8154,7 @@
           <a:lstStyle xmlns:a="http://schemas.openxmlformats.org/drawingml/2006/main"/>
           <a:p xmlns:a="http://schemas.openxmlformats.org/drawingml/2006/main">
             <a:pPr>
+              <a:buNone/>
               <a:defRPr sz="975" b="1">
                 <a:solidFill>
                   <a:srgbClr val="2E6F9E"/>
@@ -8119,6 +8205,7 @@
           <a:lstStyle xmlns:a="http://schemas.openxmlformats.org/drawingml/2006/main"/>
           <a:p xmlns:a="http://schemas.openxmlformats.org/drawingml/2006/main">
             <a:pPr>
+              <a:buNone/>
               <a:defRPr sz="2700" b="1">
                 <a:solidFill>
                   <a:srgbClr val="173B57"/>
@@ -8200,6 +8287,7 @@
           <a:lstStyle xmlns:a="http://schemas.openxmlformats.org/drawingml/2006/main"/>
           <a:p xmlns:a="http://schemas.openxmlformats.org/drawingml/2006/main">
             <a:pPr algn="r">
+              <a:buNone/>
               <a:defRPr sz="900">
                 <a:solidFill>
                   <a:srgbClr val="85929B"/>
@@ -8219,7 +8307,7 @@
       </p:sp>
       <p:graphicFrame>
         <p:nvGraphicFramePr>
-          <p:cNvPr id="12" name=""/>
+          <p:cNvPr id="14" name=""/>
           <p:cNvGraphicFramePr/>
           <p:nvPr/>
         </p:nvGraphicFramePr>
@@ -8291,7 +8379,7 @@
                             <a:srgbClr val="1B252C"/>
                           </a:solidFill>
                         </a:rPr>
-                        <a:t>Quotidien</a:t>
+                        <a:t>Vue Run</a:t>
                       </a:r>
                     </a:p>
                   </a:txBody>
@@ -8308,7 +8396,7 @@
                             <a:srgbClr val="1B252C"/>
                           </a:solidFill>
                         </a:rPr>
-                        <a:t>Canal équipe réussite étudiante / DSI</a:t>
+                        <a:t>Dashboard Grafana : disponibilité, débit, statuts, latence p95</a:t>
                       </a:r>
                     </a:p>
                   </a:txBody>
@@ -8380,7 +8468,7 @@
                             <a:srgbClr val="1B252C"/>
                           </a:solidFill>
                         </a:rPr>
-                        <a:t>Heartbeat externe absent : scoring / drift / purge</a:t>
+                        <a:t>Heartbeat absent : contrôle de dérive / réentraînement</a:t>
                       </a:r>
                     </a:p>
                   </a:txBody>
@@ -8493,6 +8581,7 @@
           <a:lstStyle xmlns:a="http://schemas.openxmlformats.org/drawingml/2006/main"/>
           <a:p xmlns:a="http://schemas.openxmlformats.org/drawingml/2006/main">
             <a:pPr>
+              <a:buNone/>
               <a:defRPr sz="1500" b="1">
                 <a:solidFill>
                   <a:srgbClr val="B95D48"/>
@@ -8572,6 +8661,7 @@
           <a:lstStyle xmlns:a="http://schemas.openxmlformats.org/drawingml/2006/main"/>
           <a:p xmlns:a="http://schemas.openxmlformats.org/drawingml/2006/main">
             <a:pPr>
+              <a:buNone/>
               <a:defRPr sz="2700" b="1">
                 <a:solidFill>
                   <a:srgbClr val="173B57"/>
@@ -8653,6 +8743,7 @@
           <a:lstStyle xmlns:a="http://schemas.openxmlformats.org/drawingml/2006/main"/>
           <a:p xmlns:a="http://schemas.openxmlformats.org/drawingml/2006/main">
             <a:pPr algn="r">
+              <a:buNone/>
               <a:defRPr sz="900">
                 <a:solidFill>
                   <a:srgbClr val="85929B"/>
@@ -8703,6 +8794,7 @@
           <a:lstStyle xmlns:a="http://schemas.openxmlformats.org/drawingml/2006/main"/>
           <a:p xmlns:a="http://schemas.openxmlformats.org/drawingml/2006/main">
             <a:pPr>
+              <a:buNone/>
               <a:defRPr sz="2250" b="1">
                 <a:solidFill>
                   <a:srgbClr val="2E6F9E"/>
@@ -8753,6 +8845,7 @@
           <a:lstStyle xmlns:a="http://schemas.openxmlformats.org/drawingml/2006/main"/>
           <a:p xmlns:a="http://schemas.openxmlformats.org/drawingml/2006/main">
             <a:pPr>
+              <a:buNone/>
               <a:defRPr sz="1725" b="1">
                 <a:solidFill>
                   <a:srgbClr val="1B252C"/>
@@ -8834,6 +8927,7 @@
           <a:lstStyle xmlns:a="http://schemas.openxmlformats.org/drawingml/2006/main"/>
           <a:p xmlns:a="http://schemas.openxmlformats.org/drawingml/2006/main">
             <a:pPr>
+              <a:buNone/>
               <a:defRPr sz="2250" b="1">
                 <a:solidFill>
                   <a:srgbClr val="2E6F9E"/>
@@ -8884,6 +8978,7 @@
           <a:lstStyle xmlns:a="http://schemas.openxmlformats.org/drawingml/2006/main"/>
           <a:p xmlns:a="http://schemas.openxmlformats.org/drawingml/2006/main">
             <a:pPr>
+              <a:buNone/>
               <a:defRPr sz="1725" b="1">
                 <a:solidFill>
                   <a:srgbClr val="1B252C"/>
@@ -8965,6 +9060,7 @@
           <a:lstStyle xmlns:a="http://schemas.openxmlformats.org/drawingml/2006/main"/>
           <a:p xmlns:a="http://schemas.openxmlformats.org/drawingml/2006/main">
             <a:pPr>
+              <a:buNone/>
               <a:defRPr sz="2250" b="1">
                 <a:solidFill>
                   <a:srgbClr val="2E6F9E"/>
@@ -9015,6 +9111,7 @@
           <a:lstStyle xmlns:a="http://schemas.openxmlformats.org/drawingml/2006/main"/>
           <a:p xmlns:a="http://schemas.openxmlformats.org/drawingml/2006/main">
             <a:pPr>
+              <a:buNone/>
               <a:defRPr sz="1725" b="1">
                 <a:solidFill>
                   <a:srgbClr val="1B252C"/>
@@ -9096,6 +9193,7 @@
           <a:lstStyle xmlns:a="http://schemas.openxmlformats.org/drawingml/2006/main"/>
           <a:p xmlns:a="http://schemas.openxmlformats.org/drawingml/2006/main">
             <a:pPr>
+              <a:buNone/>
               <a:defRPr sz="2250" b="1">
                 <a:solidFill>
                   <a:srgbClr val="2E6F9E"/>
@@ -9146,6 +9244,7 @@
           <a:lstStyle xmlns:a="http://schemas.openxmlformats.org/drawingml/2006/main"/>
           <a:p xmlns:a="http://schemas.openxmlformats.org/drawingml/2006/main">
             <a:pPr>
+              <a:buNone/>
               <a:defRPr sz="1725" b="1">
                 <a:solidFill>
                   <a:srgbClr val="1B252C"/>
@@ -9227,6 +9326,7 @@
           <a:lstStyle xmlns:a="http://schemas.openxmlformats.org/drawingml/2006/main"/>
           <a:p xmlns:a="http://schemas.openxmlformats.org/drawingml/2006/main">
             <a:pPr>
+              <a:buNone/>
               <a:defRPr sz="2250" b="1">
                 <a:solidFill>
                   <a:srgbClr val="2E6F9E"/>
@@ -9277,6 +9377,7 @@
           <a:lstStyle xmlns:a="http://schemas.openxmlformats.org/drawingml/2006/main"/>
           <a:p xmlns:a="http://schemas.openxmlformats.org/drawingml/2006/main">
             <a:pPr>
+              <a:buNone/>
               <a:defRPr sz="1725" b="1">
                 <a:solidFill>
                   <a:srgbClr val="1B252C"/>
@@ -9358,6 +9459,7 @@
           <a:lstStyle xmlns:a="http://schemas.openxmlformats.org/drawingml/2006/main"/>
           <a:p xmlns:a="http://schemas.openxmlformats.org/drawingml/2006/main">
             <a:pPr>
+              <a:buNone/>
               <a:defRPr sz="2250" b="1">
                 <a:solidFill>
                   <a:srgbClr val="2E6F9E"/>
@@ -9408,6 +9510,7 @@
           <a:lstStyle xmlns:a="http://schemas.openxmlformats.org/drawingml/2006/main"/>
           <a:p xmlns:a="http://schemas.openxmlformats.org/drawingml/2006/main">
             <a:pPr>
+              <a:buNone/>
               <a:defRPr sz="1725" b="1">
                 <a:solidFill>
                   <a:srgbClr val="1B252C"/>
@@ -9518,6 +9621,7 @@
           <a:lstStyle xmlns:a="http://schemas.openxmlformats.org/drawingml/2006/main"/>
           <a:p xmlns:a="http://schemas.openxmlformats.org/drawingml/2006/main">
             <a:pPr>
+              <a:buNone/>
               <a:defRPr sz="975" b="1">
                 <a:solidFill>
                   <a:srgbClr val="2E6F9E"/>
@@ -9568,6 +9672,7 @@
           <a:lstStyle xmlns:a="http://schemas.openxmlformats.org/drawingml/2006/main"/>
           <a:p xmlns:a="http://schemas.openxmlformats.org/drawingml/2006/main">
             <a:pPr>
+              <a:buNone/>
               <a:defRPr sz="2700" b="1">
                 <a:solidFill>
                   <a:srgbClr val="173B57"/>
@@ -9649,6 +9754,7 @@
           <a:lstStyle xmlns:a="http://schemas.openxmlformats.org/drawingml/2006/main"/>
           <a:p xmlns:a="http://schemas.openxmlformats.org/drawingml/2006/main">
             <a:pPr algn="r">
+              <a:buNone/>
               <a:defRPr sz="900">
                 <a:solidFill>
                   <a:srgbClr val="85929B"/>
@@ -9699,6 +9805,7 @@
           <a:lstStyle xmlns:a="http://schemas.openxmlformats.org/drawingml/2006/main"/>
           <a:p xmlns:a="http://schemas.openxmlformats.org/drawingml/2006/main">
             <a:pPr>
+              <a:buNone/>
               <a:defRPr sz="3750" b="1">
                 <a:solidFill>
                   <a:srgbClr val="2E6F9E"/>
@@ -9749,6 +9856,7 @@
           <a:lstStyle xmlns:a="http://schemas.openxmlformats.org/drawingml/2006/main"/>
           <a:p xmlns:a="http://schemas.openxmlformats.org/drawingml/2006/main">
             <a:pPr>
+              <a:buNone/>
               <a:defRPr sz="1725">
                 <a:solidFill>
                   <a:srgbClr val="1B252C"/>
@@ -9830,6 +9938,7 @@
           <a:lstStyle xmlns:a="http://schemas.openxmlformats.org/drawingml/2006/main"/>
           <a:p xmlns:a="http://schemas.openxmlformats.org/drawingml/2006/main">
             <a:pPr>
+              <a:buNone/>
               <a:defRPr sz="1800" b="1">
                 <a:solidFill>
                   <a:srgbClr val="2F7D67"/>
@@ -9880,6 +9989,7 @@
           <a:lstStyle xmlns:a="http://schemas.openxmlformats.org/drawingml/2006/main"/>
           <a:p xmlns:a="http://schemas.openxmlformats.org/drawingml/2006/main">
             <a:pPr>
+              <a:buNone/>
               <a:defRPr sz="2550" b="1">
                 <a:solidFill>
                   <a:srgbClr val="173B57"/>
@@ -9897,6 +10007,7 @@
           </a:p>
           <a:p xmlns:a="http://schemas.openxmlformats.org/drawingml/2006/main">
             <a:pPr>
+              <a:buNone/>
               <a:defRPr sz="2550" b="1">
                 <a:solidFill>
                   <a:srgbClr val="173B57"/>
@@ -10076,6 +10187,7 @@
           <a:lstStyle xmlns:a="http://schemas.openxmlformats.org/drawingml/2006/main"/>
           <a:p xmlns:a="http://schemas.openxmlformats.org/drawingml/2006/main">
             <a:pPr>
+              <a:buNone/>
               <a:defRPr sz="1500" b="1">
                 <a:solidFill>
                   <a:srgbClr val="B95D48"/>
@@ -10155,6 +10267,7 @@
           <a:lstStyle xmlns:a="http://schemas.openxmlformats.org/drawingml/2006/main"/>
           <a:p xmlns:a="http://schemas.openxmlformats.org/drawingml/2006/main">
             <a:pPr>
+              <a:buNone/>
               <a:defRPr sz="2700" b="1">
                 <a:solidFill>
                   <a:srgbClr val="173B57"/>
@@ -10236,6 +10349,7 @@
           <a:lstStyle xmlns:a="http://schemas.openxmlformats.org/drawingml/2006/main"/>
           <a:p xmlns:a="http://schemas.openxmlformats.org/drawingml/2006/main">
             <a:pPr algn="r">
+              <a:buNone/>
               <a:defRPr sz="900">
                 <a:solidFill>
                   <a:srgbClr val="85929B"/>
@@ -10457,6 +10571,7 @@
           <a:lstStyle xmlns:a="http://schemas.openxmlformats.org/drawingml/2006/main"/>
           <a:p xmlns:a="http://schemas.openxmlformats.org/drawingml/2006/main">
             <a:pPr>
+              <a:buNone/>
               <a:defRPr sz="1500" b="1">
                 <a:solidFill>
                   <a:srgbClr val="2F7D67"/>
@@ -10536,6 +10651,7 @@
           <a:lstStyle xmlns:a="http://schemas.openxmlformats.org/drawingml/2006/main"/>
           <a:p xmlns:a="http://schemas.openxmlformats.org/drawingml/2006/main">
             <a:pPr>
+              <a:buNone/>
               <a:defRPr sz="2700" b="1">
                 <a:solidFill>
                   <a:srgbClr val="173B57"/>
@@ -10617,6 +10733,7 @@
           <a:lstStyle xmlns:a="http://schemas.openxmlformats.org/drawingml/2006/main"/>
           <a:p xmlns:a="http://schemas.openxmlformats.org/drawingml/2006/main">
             <a:pPr algn="r">
+              <a:buNone/>
               <a:defRPr sz="900">
                 <a:solidFill>
                   <a:srgbClr val="85929B"/>
@@ -10746,7 +10863,23 @@
                   <a:srgbClr val="1B252C"/>
                 </a:solidFill>
               </a:rPr>
-              <a:t>• Run maîtrisé : HTTPS, métriques, alertes, heartbeat, promotion et rollback.</a:t>
+              <a:t>• </a:t>
+            </a:r>
+            <a:r>
+              <a:rPr sz="1725">
+                <a:solidFill>
+                  <a:srgbClr val="1B252C"/>
+                </a:solidFill>
+              </a:rPr>
+              <a:t>Prototype Run vérifiable</a:t>
+            </a:r>
+            <a:r>
+              <a:rPr sz="1725">
+                <a:solidFill>
+                  <a:srgbClr val="1B252C"/>
+                </a:solidFill>
+              </a:rPr>
+              <a:t> : HTTPS, métriques, alertes, heartbeat, promotion et rollback.</a:t>
             </a:r>
           </a:p>
         </p:txBody>
@@ -10784,6 +10917,7 @@
           <a:lstStyle xmlns:a="http://schemas.openxmlformats.org/drawingml/2006/main"/>
           <a:p xmlns:a="http://schemas.openxmlformats.org/drawingml/2006/main">
             <a:pPr algn="ctr">
+              <a:buNone/>
               <a:defRPr sz="2100" b="1">
                 <a:solidFill>
                   <a:srgbClr val="173B57"/>
@@ -10834,6 +10968,7 @@
           <a:lstStyle xmlns:a="http://schemas.openxmlformats.org/drawingml/2006/main"/>
           <a:p xmlns:a="http://schemas.openxmlformats.org/drawingml/2006/main">
             <a:pPr algn="ctr">
+              <a:buNone/>
               <a:defRPr sz="1800">
                 <a:solidFill>
                   <a:srgbClr val="2E6F9E"/>
@@ -10913,6 +11048,7 @@
           <a:lstStyle xmlns:a="http://schemas.openxmlformats.org/drawingml/2006/main"/>
           <a:p xmlns:a="http://schemas.openxmlformats.org/drawingml/2006/main">
             <a:pPr>
+              <a:buNone/>
               <a:defRPr sz="2700" b="1">
                 <a:solidFill>
                   <a:srgbClr val="173B57"/>
@@ -10994,6 +11130,7 @@
           <a:lstStyle xmlns:a="http://schemas.openxmlformats.org/drawingml/2006/main"/>
           <a:p xmlns:a="http://schemas.openxmlformats.org/drawingml/2006/main">
             <a:pPr algn="r">
+              <a:buNone/>
               <a:defRPr sz="900">
                 <a:solidFill>
                   <a:srgbClr val="85929B"/>
@@ -11351,6 +11488,7 @@
           <a:lstStyle xmlns:a="http://schemas.openxmlformats.org/drawingml/2006/main"/>
           <a:p xmlns:a="http://schemas.openxmlformats.org/drawingml/2006/main">
             <a:pPr algn="ctr">
+              <a:buNone/>
               <a:defRPr sz="1275" i="1">
                 <a:solidFill>
                   <a:srgbClr val="5D6B76"/>
@@ -11430,6 +11568,7 @@
           <a:lstStyle xmlns:a="http://schemas.openxmlformats.org/drawingml/2006/main"/>
           <a:p xmlns:a="http://schemas.openxmlformats.org/drawingml/2006/main">
             <a:pPr>
+              <a:buNone/>
               <a:defRPr sz="2700" b="1">
                 <a:solidFill>
                   <a:srgbClr val="173B57"/>
@@ -11511,6 +11650,7 @@
           <a:lstStyle xmlns:a="http://schemas.openxmlformats.org/drawingml/2006/main"/>
           <a:p xmlns:a="http://schemas.openxmlformats.org/drawingml/2006/main">
             <a:pPr algn="r">
+              <a:buNone/>
               <a:defRPr sz="900">
                 <a:solidFill>
                   <a:srgbClr val="85929B"/>
@@ -11561,6 +11701,7 @@
           <a:lstStyle xmlns:a="http://schemas.openxmlformats.org/drawingml/2006/main"/>
           <a:p xmlns:a="http://schemas.openxmlformats.org/drawingml/2006/main">
             <a:pPr>
+              <a:buNone/>
               <a:defRPr sz="5700" b="1">
                 <a:solidFill>
                   <a:srgbClr val="B95D48"/>
@@ -11611,6 +11752,7 @@
           <a:lstStyle xmlns:a="http://schemas.openxmlformats.org/drawingml/2006/main"/>
           <a:p xmlns:a="http://schemas.openxmlformats.org/drawingml/2006/main">
             <a:pPr>
+              <a:buNone/>
               <a:defRPr sz="1800">
                 <a:solidFill>
                   <a:srgbClr val="5D6B76"/>
@@ -11628,6 +11770,7 @@
           </a:p>
           <a:p xmlns:a="http://schemas.openxmlformats.org/drawingml/2006/main">
             <a:pPr>
+              <a:buNone/>
               <a:defRPr sz="1800">
                 <a:solidFill>
                   <a:srgbClr val="5D6B76"/>
@@ -11807,6 +11950,7 @@
           <a:lstStyle xmlns:a="http://schemas.openxmlformats.org/drawingml/2006/main"/>
           <a:p xmlns:a="http://schemas.openxmlformats.org/drawingml/2006/main">
             <a:pPr>
+              <a:buNone/>
               <a:defRPr sz="1500" b="1">
                 <a:solidFill>
                   <a:srgbClr val="173B57"/>
@@ -11886,6 +12030,7 @@
           <a:lstStyle xmlns:a="http://schemas.openxmlformats.org/drawingml/2006/main"/>
           <a:p xmlns:a="http://schemas.openxmlformats.org/drawingml/2006/main">
             <a:pPr>
+              <a:buNone/>
               <a:defRPr sz="2700" b="1">
                 <a:solidFill>
                   <a:srgbClr val="173B57"/>
@@ -11967,6 +12112,7 @@
           <a:lstStyle xmlns:a="http://schemas.openxmlformats.org/drawingml/2006/main"/>
           <a:p xmlns:a="http://schemas.openxmlformats.org/drawingml/2006/main">
             <a:pPr algn="r">
+              <a:buNone/>
               <a:defRPr sz="900">
                 <a:solidFill>
                   <a:srgbClr val="85929B"/>
@@ -11986,7 +12132,7 @@
       </p:sp>
       <p:graphicFrame>
         <p:nvGraphicFramePr>
-          <p:cNvPr id="10" name=""/>
+          <p:cNvPr id="12" name=""/>
           <p:cNvGraphicFramePr/>
           <p:nvPr/>
         </p:nvGraphicFramePr>
@@ -12244,6 +12390,7 @@
           <a:lstStyle xmlns:a="http://schemas.openxmlformats.org/drawingml/2006/main"/>
           <a:p xmlns:a="http://schemas.openxmlformats.org/drawingml/2006/main">
             <a:pPr>
+              <a:buNone/>
               <a:defRPr sz="1500" b="1">
                 <a:solidFill>
                   <a:srgbClr val="2F7D67"/>
@@ -12323,6 +12470,7 @@
           <a:lstStyle xmlns:a="http://schemas.openxmlformats.org/drawingml/2006/main"/>
           <a:p xmlns:a="http://schemas.openxmlformats.org/drawingml/2006/main">
             <a:pPr>
+              <a:buNone/>
               <a:defRPr sz="2700" b="1">
                 <a:solidFill>
                   <a:srgbClr val="173B57"/>
@@ -12404,6 +12552,7 @@
           <a:lstStyle xmlns:a="http://schemas.openxmlformats.org/drawingml/2006/main"/>
           <a:p xmlns:a="http://schemas.openxmlformats.org/drawingml/2006/main">
             <a:pPr algn="r">
+              <a:buNone/>
               <a:defRPr sz="900">
                 <a:solidFill>
                   <a:srgbClr val="85929B"/>
@@ -12454,6 +12603,7 @@
           <a:lstStyle xmlns:a="http://schemas.openxmlformats.org/drawingml/2006/main"/>
           <a:p xmlns:a="http://schemas.openxmlformats.org/drawingml/2006/main">
             <a:pPr>
+              <a:buNone/>
               <a:defRPr sz="1500">
                 <a:solidFill>
                   <a:srgbClr val="5D6B76"/>
@@ -12473,7 +12623,7 @@
       </p:sp>
       <p:graphicFrame>
         <p:nvGraphicFramePr>
-          <p:cNvPr id="12" name=""/>
+          <p:cNvPr id="14" name=""/>
           <p:cNvGraphicFramePr/>
           <p:nvPr/>
         </p:nvGraphicFramePr>
@@ -12784,6 +12934,7 @@
           <a:lstStyle xmlns:a="http://schemas.openxmlformats.org/drawingml/2006/main"/>
           <a:p xmlns:a="http://schemas.openxmlformats.org/drawingml/2006/main">
             <a:pPr>
+              <a:buNone/>
               <a:defRPr sz="1500" b="1">
                 <a:solidFill>
                   <a:srgbClr val="B95D48"/>
@@ -12863,6 +13014,7 @@
           <a:lstStyle xmlns:a="http://schemas.openxmlformats.org/drawingml/2006/main"/>
           <a:p xmlns:a="http://schemas.openxmlformats.org/drawingml/2006/main">
             <a:pPr>
+              <a:buNone/>
               <a:defRPr sz="2700" b="1">
                 <a:solidFill>
                   <a:srgbClr val="173B57"/>
@@ -12944,6 +13096,7 @@
           <a:lstStyle xmlns:a="http://schemas.openxmlformats.org/drawingml/2006/main"/>
           <a:p xmlns:a="http://schemas.openxmlformats.org/drawingml/2006/main">
             <a:pPr algn="r">
+              <a:buNone/>
               <a:defRPr sz="900">
                 <a:solidFill>
                   <a:srgbClr val="85929B"/>
@@ -13165,6 +13318,7 @@
           <a:lstStyle xmlns:a="http://schemas.openxmlformats.org/drawingml/2006/main"/>
           <a:p xmlns:a="http://schemas.openxmlformats.org/drawingml/2006/main">
             <a:pPr>
+              <a:buNone/>
               <a:defRPr sz="1500" b="1">
                 <a:solidFill>
                   <a:srgbClr val="2F7D67"/>
@@ -13244,6 +13398,7 @@
           <a:lstStyle xmlns:a="http://schemas.openxmlformats.org/drawingml/2006/main"/>
           <a:p xmlns:a="http://schemas.openxmlformats.org/drawingml/2006/main">
             <a:pPr>
+              <a:buNone/>
               <a:defRPr sz="2700" b="1">
                 <a:solidFill>
                   <a:srgbClr val="173B57"/>
@@ -13325,6 +13480,7 @@
           <a:lstStyle xmlns:a="http://schemas.openxmlformats.org/drawingml/2006/main"/>
           <a:p xmlns:a="http://schemas.openxmlformats.org/drawingml/2006/main">
             <a:pPr algn="r">
+              <a:buNone/>
               <a:defRPr sz="900">
                 <a:solidFill>
                   <a:srgbClr val="85929B"/>
@@ -13408,6 +13564,7 @@
           <a:lstStyle xmlns:a="http://schemas.openxmlformats.org/drawingml/2006/main"/>
           <a:p xmlns:a="http://schemas.openxmlformats.org/drawingml/2006/main">
             <a:pPr>
+              <a:buNone/>
               <a:defRPr sz="1875" b="1">
                 <a:solidFill>
                   <a:srgbClr val="B95D48"/>
@@ -13458,6 +13615,7 @@
           <a:lstStyle xmlns:a="http://schemas.openxmlformats.org/drawingml/2006/main"/>
           <a:p xmlns:a="http://schemas.openxmlformats.org/drawingml/2006/main">
             <a:pPr>
+              <a:buNone/>
               <a:defRPr sz="1650">
                 <a:solidFill>
                   <a:srgbClr val="1B252C"/>
@@ -13475,6 +13633,7 @@
           </a:p>
           <a:p xmlns:a="http://schemas.openxmlformats.org/drawingml/2006/main">
             <a:pPr>
+              <a:buNone/>
               <a:defRPr sz="1650">
                 <a:solidFill>
                   <a:srgbClr val="1B252C"/>
@@ -13492,6 +13651,7 @@
           </a:p>
           <a:p xmlns:a="http://schemas.openxmlformats.org/drawingml/2006/main">
             <a:pPr>
+              <a:buNone/>
               <a:defRPr sz="1650">
                 <a:solidFill>
                   <a:srgbClr val="1B252C"/>
@@ -13575,6 +13735,7 @@
           <a:lstStyle xmlns:a="http://schemas.openxmlformats.org/drawingml/2006/main"/>
           <a:p xmlns:a="http://schemas.openxmlformats.org/drawingml/2006/main">
             <a:pPr>
+              <a:buNone/>
               <a:defRPr sz="1875" b="1">
                 <a:solidFill>
                   <a:srgbClr val="2E6F9E"/>
@@ -13625,6 +13786,7 @@
           <a:lstStyle xmlns:a="http://schemas.openxmlformats.org/drawingml/2006/main"/>
           <a:p xmlns:a="http://schemas.openxmlformats.org/drawingml/2006/main">
             <a:pPr>
+              <a:buNone/>
               <a:defRPr sz="1650">
                 <a:solidFill>
                   <a:srgbClr val="1B252C"/>
@@ -13642,6 +13804,7 @@
           </a:p>
           <a:p xmlns:a="http://schemas.openxmlformats.org/drawingml/2006/main">
             <a:pPr>
+              <a:buNone/>
               <a:defRPr sz="1650">
                 <a:solidFill>
                   <a:srgbClr val="1B252C"/>
@@ -13659,6 +13822,7 @@
           </a:p>
           <a:p xmlns:a="http://schemas.openxmlformats.org/drawingml/2006/main">
             <a:pPr>
+              <a:buNone/>
               <a:defRPr sz="1650">
                 <a:solidFill>
                   <a:srgbClr val="1B252C"/>
@@ -13742,6 +13906,7 @@
           <a:lstStyle xmlns:a="http://schemas.openxmlformats.org/drawingml/2006/main"/>
           <a:p xmlns:a="http://schemas.openxmlformats.org/drawingml/2006/main">
             <a:pPr>
+              <a:buNone/>
               <a:defRPr sz="1875" b="1">
                 <a:solidFill>
                   <a:srgbClr val="2F7D67"/>
@@ -13792,6 +13957,7 @@
           <a:lstStyle xmlns:a="http://schemas.openxmlformats.org/drawingml/2006/main"/>
           <a:p xmlns:a="http://schemas.openxmlformats.org/drawingml/2006/main">
             <a:pPr>
+              <a:buNone/>
               <a:defRPr sz="1650">
                 <a:solidFill>
                   <a:srgbClr val="1B252C"/>
@@ -13809,6 +13975,7 @@
           </a:p>
           <a:p xmlns:a="http://schemas.openxmlformats.org/drawingml/2006/main">
             <a:pPr>
+              <a:buNone/>
               <a:defRPr sz="1650">
                 <a:solidFill>
                   <a:srgbClr val="1B252C"/>
@@ -13826,6 +13993,7 @@
           </a:p>
           <a:p xmlns:a="http://schemas.openxmlformats.org/drawingml/2006/main">
             <a:pPr>
+              <a:buNone/>
               <a:defRPr sz="1650">
                 <a:solidFill>
                   <a:srgbClr val="1B252C"/>
@@ -13876,6 +14044,7 @@
           <a:lstStyle xmlns:a="http://schemas.openxmlformats.org/drawingml/2006/main"/>
           <a:p xmlns:a="http://schemas.openxmlformats.org/drawingml/2006/main">
             <a:pPr algn="ctr">
+              <a:buNone/>
               <a:defRPr sz="1500" b="1">
                 <a:solidFill>
                   <a:srgbClr val="173B57"/>
@@ -13955,6 +14124,7 @@
           <a:lstStyle xmlns:a="http://schemas.openxmlformats.org/drawingml/2006/main"/>
           <a:p xmlns:a="http://schemas.openxmlformats.org/drawingml/2006/main">
             <a:pPr>
+              <a:buNone/>
               <a:defRPr sz="2700" b="1">
                 <a:solidFill>
                   <a:srgbClr val="173B57"/>
@@ -14036,6 +14206,7 @@
           <a:lstStyle xmlns:a="http://schemas.openxmlformats.org/drawingml/2006/main"/>
           <a:p xmlns:a="http://schemas.openxmlformats.org/drawingml/2006/main">
             <a:pPr algn="r">
+              <a:buNone/>
               <a:defRPr sz="900">
                 <a:solidFill>
                   <a:srgbClr val="85929B"/>
@@ -14055,14 +14226,14 @@
       </p:sp>
       <p:pic>
         <p:nvPicPr>
-          <p:cNvPr id="9" name=""/>
+          <p:cNvPr id="11" name=""/>
           <p:cNvPicPr>
             <a:picLocks xmlns:a="http://schemas.openxmlformats.org/drawingml/2006/main" noChangeAspect="1"/>
           </p:cNvPicPr>
           <p:nvPr/>
         </p:nvPicPr>
         <p:blipFill>
-          <a:blip xmlns:r="http://schemas.openxmlformats.org/officeDocument/2006/relationships" xmlns:a="http://schemas.openxmlformats.org/drawingml/2006/main" r:embed="Rc0cc7c4215c34275"/>
+          <a:blip xmlns:r="http://schemas.openxmlformats.org/officeDocument/2006/relationships" xmlns:a="http://schemas.openxmlformats.org/drawingml/2006/main" r:embed="Rf732f8c640b2458b"/>
           <a:stretch xmlns:a="http://schemas.openxmlformats.org/drawingml/2006/main"/>
         </p:blipFill>
         <p:spPr>
@@ -14233,6 +14404,7 @@
           <a:lstStyle xmlns:a="http://schemas.openxmlformats.org/drawingml/2006/main"/>
           <a:p xmlns:a="http://schemas.openxmlformats.org/drawingml/2006/main">
             <a:pPr>
+              <a:buNone/>
               <a:defRPr sz="2700" b="1">
                 <a:solidFill>
                   <a:srgbClr val="173B57"/>
@@ -14314,6 +14486,7 @@
           <a:lstStyle xmlns:a="http://schemas.openxmlformats.org/drawingml/2006/main"/>
           <a:p xmlns:a="http://schemas.openxmlformats.org/drawingml/2006/main">
             <a:pPr algn="r">
+              <a:buNone/>
               <a:defRPr sz="900">
                 <a:solidFill>
                   <a:srgbClr val="85929B"/>
@@ -14333,14 +14506,14 @@
       </p:sp>
       <p:pic>
         <p:nvPicPr>
-          <p:cNvPr id="12" name=""/>
+          <p:cNvPr id="14" name=""/>
           <p:cNvPicPr>
             <a:picLocks xmlns:a="http://schemas.openxmlformats.org/drawingml/2006/main" noChangeAspect="1"/>
           </p:cNvPicPr>
           <p:nvPr/>
         </p:nvPicPr>
         <p:blipFill>
-          <a:blip xmlns:r="http://schemas.openxmlformats.org/officeDocument/2006/relationships" xmlns:a="http://schemas.openxmlformats.org/drawingml/2006/main" r:embed="R8c0a4b9db5104060"/>
+          <a:blip xmlns:r="http://schemas.openxmlformats.org/officeDocument/2006/relationships" xmlns:a="http://schemas.openxmlformats.org/drawingml/2006/main" r:embed="Rb3a4563851e74141"/>
           <a:stretch xmlns:a="http://schemas.openxmlformats.org/drawingml/2006/main"/>
         </p:blipFill>
         <p:spPr>
@@ -14386,6 +14559,7 @@
           <a:lstStyle xmlns:a="http://schemas.openxmlformats.org/drawingml/2006/main"/>
           <a:p xmlns:a="http://schemas.openxmlformats.org/drawingml/2006/main">
             <a:pPr>
+              <a:buNone/>
               <a:defRPr sz="2550" b="1">
                 <a:solidFill>
                   <a:srgbClr val="173B57"/>
@@ -14403,6 +14577,7 @@
           </a:p>
           <a:p xmlns:a="http://schemas.openxmlformats.org/drawingml/2006/main">
             <a:pPr>
+              <a:buNone/>
               <a:defRPr sz="2550" b="1">
                 <a:solidFill>
                   <a:srgbClr val="173B57"/>
@@ -14582,6 +14757,7 @@
           <a:lstStyle xmlns:a="http://schemas.openxmlformats.org/drawingml/2006/main"/>
           <a:p xmlns:a="http://schemas.openxmlformats.org/drawingml/2006/main">
             <a:pPr>
+              <a:buNone/>
               <a:defRPr sz="1500" b="1">
                 <a:solidFill>
                   <a:srgbClr val="2F7D67"/>

</xml_diff>

<commit_message>
docs(soutenance): add docker runtime evidence
</commit_message>
<xml_diff>
--- a/reports/SUPPORT_SOUTENANCE.pptx
+++ b/reports/SUPPORT_SOUTENANCE.pptx
@@ -2,35 +2,38 @@
 <file path=ppt/presentation.xml><?xml version="1.0" encoding="utf-8"?>
 <p:presentation xmlns:p="http://schemas.openxmlformats.org/presentationml/2006/main">
   <p:sldMasterIdLst>
-    <p:sldMasterId xmlns:r="http://schemas.openxmlformats.org/officeDocument/2006/relationships" id="2147483648" r:id="Rdd59805a9aa9457b"/>
+    <p:sldMasterId xmlns:r="http://schemas.openxmlformats.org/officeDocument/2006/relationships" id="2147483648" r:id="Rbae71c62ba024916"/>
   </p:sldMasterIdLst>
   <p:notesMasterIdLst>
-    <p:notesMasterId xmlns:r="http://schemas.openxmlformats.org/officeDocument/2006/relationships" r:id="R3ffa92acb5a744e4"/>
+    <p:notesMasterId xmlns:r="http://schemas.openxmlformats.org/officeDocument/2006/relationships" r:id="Rd5bec46d883b4d93"/>
   </p:notesMasterIdLst>
   <p:sldIdLst>
-    <p:sldId xmlns:r="http://schemas.openxmlformats.org/officeDocument/2006/relationships" id="256" r:id="R69f8e32e8bbc4237"/>
-    <p:sldId xmlns:r="http://schemas.openxmlformats.org/officeDocument/2006/relationships" id="257" r:id="R59e0b009420a4cfa"/>
-    <p:sldId xmlns:r="http://schemas.openxmlformats.org/officeDocument/2006/relationships" id="258" r:id="Rc62e8974654b44d0"/>
-    <p:sldId xmlns:r="http://schemas.openxmlformats.org/officeDocument/2006/relationships" id="259" r:id="Rec25ff73d7de4dd4"/>
-    <p:sldId xmlns:r="http://schemas.openxmlformats.org/officeDocument/2006/relationships" id="260" r:id="R396284be50e9430a"/>
-    <p:sldId xmlns:r="http://schemas.openxmlformats.org/officeDocument/2006/relationships" id="261" r:id="R8baf8c3f1d594a5d"/>
-    <p:sldId xmlns:r="http://schemas.openxmlformats.org/officeDocument/2006/relationships" id="262" r:id="Rc7207b6857ec454c"/>
-    <p:sldId xmlns:r="http://schemas.openxmlformats.org/officeDocument/2006/relationships" id="263" r:id="R47c81d080baf4cab"/>
-    <p:sldId xmlns:r="http://schemas.openxmlformats.org/officeDocument/2006/relationships" id="264" r:id="R3a523b68bbe7485f"/>
-    <p:sldId xmlns:r="http://schemas.openxmlformats.org/officeDocument/2006/relationships" id="265" r:id="R7dc060ea6f664bb4"/>
-    <p:sldId xmlns:r="http://schemas.openxmlformats.org/officeDocument/2006/relationships" id="266" r:id="R8895282395764129"/>
-    <p:sldId xmlns:r="http://schemas.openxmlformats.org/officeDocument/2006/relationships" id="267" r:id="R40f649687e194452"/>
-    <p:sldId xmlns:r="http://schemas.openxmlformats.org/officeDocument/2006/relationships" id="268" r:id="R7d4714b553464e10"/>
-    <p:sldId xmlns:r="http://schemas.openxmlformats.org/officeDocument/2006/relationships" id="269" r:id="Rd45ac69715c244e0"/>
-    <p:sldId xmlns:r="http://schemas.openxmlformats.org/officeDocument/2006/relationships" id="270" r:id="Rb8c1282fcd1443ea"/>
-    <p:sldId xmlns:r="http://schemas.openxmlformats.org/officeDocument/2006/relationships" id="271" r:id="Rac93d79357434ba6"/>
-    <p:sldId xmlns:r="http://schemas.openxmlformats.org/officeDocument/2006/relationships" id="272" r:id="Rb421fc63bb6f4ed7"/>
-    <p:sldId xmlns:r="http://schemas.openxmlformats.org/officeDocument/2006/relationships" id="273" r:id="R6384e1b1532849db"/>
-    <p:sldId xmlns:r="http://schemas.openxmlformats.org/officeDocument/2006/relationships" id="274" r:id="R60c136e8d4ae4080"/>
-    <p:sldId xmlns:r="http://schemas.openxmlformats.org/officeDocument/2006/relationships" id="275" r:id="Rb2e5f95925e449a3"/>
-    <p:sldId xmlns:r="http://schemas.openxmlformats.org/officeDocument/2006/relationships" id="276" r:id="R92aec4f7e92944cf"/>
-    <p:sldId xmlns:r="http://schemas.openxmlformats.org/officeDocument/2006/relationships" id="277" r:id="R03e1a8b2dec44a08"/>
-    <p:sldId xmlns:r="http://schemas.openxmlformats.org/officeDocument/2006/relationships" id="278" r:id="R97033922fb6e4f32"/>
+    <p:sldId xmlns:r="http://schemas.openxmlformats.org/officeDocument/2006/relationships" id="256" r:id="Rc201d5a0eb274666"/>
+    <p:sldId xmlns:r="http://schemas.openxmlformats.org/officeDocument/2006/relationships" id="257" r:id="Rc1015eecb4224d7c"/>
+    <p:sldId xmlns:r="http://schemas.openxmlformats.org/officeDocument/2006/relationships" id="258" r:id="R59d9f3bda7b246b6"/>
+    <p:sldId xmlns:r="http://schemas.openxmlformats.org/officeDocument/2006/relationships" id="259" r:id="R66197c7ac0b34159"/>
+    <p:sldId xmlns:r="http://schemas.openxmlformats.org/officeDocument/2006/relationships" id="260" r:id="Rb58960fa96de4cfa"/>
+    <p:sldId xmlns:r="http://schemas.openxmlformats.org/officeDocument/2006/relationships" id="261" r:id="R9b400aa91e364069"/>
+    <p:sldId xmlns:r="http://schemas.openxmlformats.org/officeDocument/2006/relationships" id="262" r:id="R2d718e1a83dc4923"/>
+    <p:sldId xmlns:r="http://schemas.openxmlformats.org/officeDocument/2006/relationships" id="263" r:id="R4336961366a84cb6"/>
+    <p:sldId xmlns:r="http://schemas.openxmlformats.org/officeDocument/2006/relationships" id="264" r:id="R83b3e3ea4ed447a3"/>
+    <p:sldId xmlns:r="http://schemas.openxmlformats.org/officeDocument/2006/relationships" id="265" r:id="R6a951fd55a214a29"/>
+    <p:sldId xmlns:r="http://schemas.openxmlformats.org/officeDocument/2006/relationships" id="266" r:id="R353535bba7fd4565"/>
+    <p:sldId xmlns:r="http://schemas.openxmlformats.org/officeDocument/2006/relationships" id="267" r:id="R749baf3fcf394eee"/>
+    <p:sldId xmlns:r="http://schemas.openxmlformats.org/officeDocument/2006/relationships" id="268" r:id="Rc9171f168ba14622"/>
+    <p:sldId xmlns:r="http://schemas.openxmlformats.org/officeDocument/2006/relationships" id="269" r:id="R5a5fc4be9b9f455f"/>
+    <p:sldId xmlns:r="http://schemas.openxmlformats.org/officeDocument/2006/relationships" id="270" r:id="R8291897159b946ef"/>
+    <p:sldId xmlns:r="http://schemas.openxmlformats.org/officeDocument/2006/relationships" id="271" r:id="R2d8a8f40f5bd44ae"/>
+    <p:sldId xmlns:r="http://schemas.openxmlformats.org/officeDocument/2006/relationships" id="272" r:id="Re0c7e29deb41423e"/>
+    <p:sldId xmlns:r="http://schemas.openxmlformats.org/officeDocument/2006/relationships" id="273" r:id="Ra6bae566d38d43d9"/>
+    <p:sldId xmlns:r="http://schemas.openxmlformats.org/officeDocument/2006/relationships" id="274" r:id="R44e8ebbec4264922"/>
+    <p:sldId xmlns:r="http://schemas.openxmlformats.org/officeDocument/2006/relationships" id="275" r:id="R1c45ed2576784f9c"/>
+    <p:sldId xmlns:r="http://schemas.openxmlformats.org/officeDocument/2006/relationships" id="276" r:id="R9c857370449a4fc3"/>
+    <p:sldId xmlns:r="http://schemas.openxmlformats.org/officeDocument/2006/relationships" id="277" r:id="R14765cda962e4504"/>
+    <p:sldId xmlns:r="http://schemas.openxmlformats.org/officeDocument/2006/relationships" id="278" r:id="R63dc25cadfde49da"/>
+    <p:sldId xmlns:r="http://schemas.openxmlformats.org/officeDocument/2006/relationships" id="279" r:id="Rdb87320dcce04292"/>
+    <p:sldId xmlns:r="http://schemas.openxmlformats.org/officeDocument/2006/relationships" id="280" r:id="R921a0bfe23e74c15"/>
+    <p:sldId xmlns:r="http://schemas.openxmlformats.org/officeDocument/2006/relationships" id="281" r:id="Rad3a0e655a73432a"/>
   </p:sldIdLst>
   <p:sldSz cx="12192000" cy="6858000"/>
   <p:notesSz cx="6858000" cy="9144000"/>
@@ -1564,17 +1567,27 @@
           <a:lstStyle xmlns:a="http://schemas.openxmlformats.org/drawingml/2006/main"/>
           <a:p xmlns:a="http://schemas.openxmlformats.org/drawingml/2006/main">
             <a:r>
-              <a:t>[1:30] Adapter le ROI industriel au contexte éducatif. On ne dispose pas d'un</a:t>
-            </a:r>
-          </a:p>
-          <a:p xmlns:a="http://schemas.openxmlformats.org/drawingml/2006/main">
-            <a:r>
-              <a:t>coût officiel du décrochage ni de l'uplift causal de l'accompagnement. La bonne</a:t>
-            </a:r>
-          </a:p>
-          <a:p xmlns:a="http://schemas.openxmlformats.org/drawingml/2006/main">
-            <a:r>
-              <a:t>réponse est de proposer la méthode de mesure, pas de fabriquer un chiffre.</a:t>
+              <a:t>[2:00] Montrer le graphe des densités par classe (présence, LMS, rendus...).</a:t>
+            </a:r>
+          </a:p>
+          <a:p xmlns:a="http://schemas.openxmlformats.org/drawingml/2006/main">
+            <a:r>
+              <a:t>« On voit visuellement que les signaux d'engagement séparent bien les deux</a:t>
+            </a:r>
+          </a:p>
+          <a:p xmlns:a="http://schemas.openxmlformats.org/drawingml/2006/main">
+            <a:r>
+              <a:t>groupes. » Puis mentionner le graphe des leurres (eda_leurres.png) : « et voici</a:t>
+            </a:r>
+          </a:p>
+          <a:p xmlns:a="http://schemas.openxmlformats.org/drawingml/2006/main">
+            <a:r>
+              <a:t>la preuve que les leurres n'apportent rien. » Tu peux mettre eda_leurres.png en</a:t>
+            </a:r>
+          </a:p>
+          <a:p xmlns:a="http://schemas.openxmlformats.org/drawingml/2006/main">
+            <a:r>
+              <a:t>2e image si la place le permet.</a:t>
             </a:r>
           </a:p>
         </p:txBody>
@@ -1644,22 +1657,17 @@
           <a:lstStyle xmlns:a="http://schemas.openxmlformats.org/drawingml/2006/main"/>
           <a:p xmlns:a="http://schemas.openxmlformats.org/drawingml/2006/main">
             <a:r>
-              <a:t>[1:30] Montrer de la lucidité — le jury valorise un candidat qui connaît les</a:t>
-            </a:r>
-          </a:p>
-          <a:p xmlns:a="http://schemas.openxmlformats.org/drawingml/2006/main">
-            <a:r>
-              <a:t>limites de son travail. NE PAS survendre. « Ce que j'ai construit est une</a:t>
-            </a:r>
-          </a:p>
-          <a:p xmlns:a="http://schemas.openxmlformats.org/drawingml/2006/main">
-            <a:r>
-              <a:t>démarche solide et reproductible ; sa validité en production reste à confirmer</a:t>
-            </a:r>
-          </a:p>
-          <a:p xmlns:a="http://schemas.openxmlformats.org/drawingml/2006/main">
-            <a:r>
-              <a:t>sur données réelles. »</a:t>
+              <a:t>[1:30] Montrer qu'on va « du notebook au service puis au Run » : le notebook</a:t>
+            </a:r>
+          </a:p>
+          <a:p xmlns:a="http://schemas.openxmlformats.org/drawingml/2006/main">
+            <a:r>
+              <a:t>explique, le package exécute, et le registre permet de maîtriser les versions.</a:t>
+            </a:r>
+          </a:p>
+          <a:p xmlns:a="http://schemas.openxmlformats.org/drawingml/2006/main">
+            <a:r>
+              <a:t>Mentionner train, predict, drift-report, model-register/promote/rollback.</a:t>
             </a:r>
           </a:p>
         </p:txBody>
@@ -1729,17 +1737,27 @@
           <a:lstStyle xmlns:a="http://schemas.openxmlformats.org/drawingml/2006/main"/>
           <a:p xmlns:a="http://schemas.openxmlformats.org/drawingml/2006/main">
             <a:r>
-              <a:t>[1:00] Résumer en 30 s les 5 messages. Terminer par la valeur métier : « une</a:t>
-            </a:r>
-          </a:p>
-          <a:p xmlns:a="http://schemas.openxmlformats.org/drawingml/2006/main">
-            <a:r>
-              <a:t>aide concrète pour accompagner à temps les étudiants à risque. » Enchaîner sur</a:t>
-            </a:r>
-          </a:p>
-          <a:p xmlns:a="http://schemas.openxmlformats.org/drawingml/2006/main">
-            <a:r>
-              <a:t>les questions avec assurance.</a:t>
+              <a:t>[2:00] Montrer le graphe des densités par classe (présence, LMS, rendus...).</a:t>
+            </a:r>
+          </a:p>
+          <a:p xmlns:a="http://schemas.openxmlformats.org/drawingml/2006/main">
+            <a:r>
+              <a:t>« On voit visuellement que les signaux d'engagement séparent bien les deux</a:t>
+            </a:r>
+          </a:p>
+          <a:p xmlns:a="http://schemas.openxmlformats.org/drawingml/2006/main">
+            <a:r>
+              <a:t>groupes. » Puis mentionner le graphe des leurres (eda_leurres.png) : « et voici</a:t>
+            </a:r>
+          </a:p>
+          <a:p xmlns:a="http://schemas.openxmlformats.org/drawingml/2006/main">
+            <a:r>
+              <a:t>la preuve que les leurres n'apportent rien. » Tu peux mettre eda_leurres.png en</a:t>
+            </a:r>
+          </a:p>
+          <a:p xmlns:a="http://schemas.openxmlformats.org/drawingml/2006/main">
+            <a:r>
+              <a:t>2e image si la place le permet.</a:t>
             </a:r>
           </a:p>
         </p:txBody>
@@ -1770,6 +1788,251 @@
 </file>
 
 <file path=ppt/notesSlides/notesSlide23.xml><?xml version="1.0" encoding="utf-8"?>
+<p:notes xmlns:p="http://schemas.openxmlformats.org/presentationml/2006/main">
+  <p:cSld>
+    <p:spTree>
+      <p:nvGrpSpPr>
+        <p:cNvPr id="1" name=""/>
+        <p:cNvGrpSpPr/>
+        <p:nvPr/>
+      </p:nvGrpSpPr>
+      <p:grpSpPr>
+        <a:xfrm xmlns:a="http://schemas.openxmlformats.org/drawingml/2006/main"/>
+      </p:grpSpPr>
+      <p:sp>
+        <p:nvSpPr>
+          <p:cNvPr id="2" name="Slide Image Placeholder 1"/>
+          <p:cNvSpPr>
+            <a:spLocks xmlns:a="http://schemas.openxmlformats.org/drawingml/2006/main" noGrp="1"/>
+          </p:cNvSpPr>
+          <p:nvPr>
+            <p:ph type="sldImg" idx="0"/>
+          </p:nvPr>
+        </p:nvSpPr>
+        <p:spPr/>
+      </p:sp>
+      <p:sp>
+        <p:nvSpPr>
+          <p:cNvPr id="3" name="Notes Placeholder 2"/>
+          <p:cNvSpPr>
+            <a:spLocks xmlns:a="http://schemas.openxmlformats.org/drawingml/2006/main" noGrp="1"/>
+          </p:cNvSpPr>
+          <p:nvPr>
+            <p:ph type="body" idx="1"/>
+          </p:nvPr>
+        </p:nvSpPr>
+        <p:spPr/>
+        <p:txBody>
+          <a:bodyPr xmlns:a="http://schemas.openxmlformats.org/drawingml/2006/main"/>
+          <a:lstStyle xmlns:a="http://schemas.openxmlformats.org/drawingml/2006/main"/>
+          <a:p xmlns:a="http://schemas.openxmlformats.org/drawingml/2006/main">
+            <a:r>
+              <a:t>[1:30] Adapter le ROI industriel au contexte éducatif. On ne dispose pas d'un</a:t>
+            </a:r>
+          </a:p>
+          <a:p xmlns:a="http://schemas.openxmlformats.org/drawingml/2006/main">
+            <a:r>
+              <a:t>coût officiel du décrochage ni de l'uplift causal de l'accompagnement. La bonne</a:t>
+            </a:r>
+          </a:p>
+          <a:p xmlns:a="http://schemas.openxmlformats.org/drawingml/2006/main">
+            <a:r>
+              <a:t>réponse est de proposer la méthode de mesure, pas de fabriquer un chiffre.</a:t>
+            </a:r>
+          </a:p>
+        </p:txBody>
+      </p:sp>
+      <p:sp>
+        <p:nvSpPr>
+          <p:cNvPr id="4" name="Slide Number Placeholder 3"/>
+          <p:cNvSpPr>
+            <a:spLocks xmlns:a="http://schemas.openxmlformats.org/drawingml/2006/main" noGrp="1"/>
+          </p:cNvSpPr>
+          <p:nvPr>
+            <p:ph type="sldNum" idx="5"/>
+          </p:nvPr>
+        </p:nvSpPr>
+        <p:spPr/>
+        <p:txBody>
+          <a:bodyPr xmlns:a="http://schemas.openxmlformats.org/drawingml/2006/main"/>
+          <a:lstStyle xmlns:a="http://schemas.openxmlformats.org/drawingml/2006/main"/>
+          <a:p xmlns:a="http://schemas.openxmlformats.org/drawingml/2006/main"/>
+        </p:txBody>
+      </p:sp>
+    </p:spTree>
+  </p:cSld>
+  <p:clrMapOvr>
+    <a:masterClrMapping xmlns:a="http://schemas.openxmlformats.org/drawingml/2006/main"/>
+  </p:clrMapOvr>
+</p:notes>
+</file>
+
+<file path=ppt/notesSlides/notesSlide24.xml><?xml version="1.0" encoding="utf-8"?>
+<p:notes xmlns:p="http://schemas.openxmlformats.org/presentationml/2006/main">
+  <p:cSld>
+    <p:spTree>
+      <p:nvGrpSpPr>
+        <p:cNvPr id="1" name=""/>
+        <p:cNvGrpSpPr/>
+        <p:nvPr/>
+      </p:nvGrpSpPr>
+      <p:grpSpPr>
+        <a:xfrm xmlns:a="http://schemas.openxmlformats.org/drawingml/2006/main"/>
+      </p:grpSpPr>
+      <p:sp>
+        <p:nvSpPr>
+          <p:cNvPr id="2" name="Slide Image Placeholder 1"/>
+          <p:cNvSpPr>
+            <a:spLocks xmlns:a="http://schemas.openxmlformats.org/drawingml/2006/main" noGrp="1"/>
+          </p:cNvSpPr>
+          <p:nvPr>
+            <p:ph type="sldImg" idx="0"/>
+          </p:nvPr>
+        </p:nvSpPr>
+        <p:spPr/>
+      </p:sp>
+      <p:sp>
+        <p:nvSpPr>
+          <p:cNvPr id="3" name="Notes Placeholder 2"/>
+          <p:cNvSpPr>
+            <a:spLocks xmlns:a="http://schemas.openxmlformats.org/drawingml/2006/main" noGrp="1"/>
+          </p:cNvSpPr>
+          <p:nvPr>
+            <p:ph type="body" idx="1"/>
+          </p:nvPr>
+        </p:nvSpPr>
+        <p:spPr/>
+        <p:txBody>
+          <a:bodyPr xmlns:a="http://schemas.openxmlformats.org/drawingml/2006/main"/>
+          <a:lstStyle xmlns:a="http://schemas.openxmlformats.org/drawingml/2006/main"/>
+          <a:p xmlns:a="http://schemas.openxmlformats.org/drawingml/2006/main">
+            <a:r>
+              <a:t>[1:30] Montrer de la lucidité — le jury valorise un candidat qui connaît les</a:t>
+            </a:r>
+          </a:p>
+          <a:p xmlns:a="http://schemas.openxmlformats.org/drawingml/2006/main">
+            <a:r>
+              <a:t>limites de son travail. NE PAS survendre. « Ce que j'ai construit est une</a:t>
+            </a:r>
+          </a:p>
+          <a:p xmlns:a="http://schemas.openxmlformats.org/drawingml/2006/main">
+            <a:r>
+              <a:t>démarche solide et reproductible ; sa validité en production reste à confirmer</a:t>
+            </a:r>
+          </a:p>
+          <a:p xmlns:a="http://schemas.openxmlformats.org/drawingml/2006/main">
+            <a:r>
+              <a:t>sur données réelles. »</a:t>
+            </a:r>
+          </a:p>
+        </p:txBody>
+      </p:sp>
+      <p:sp>
+        <p:nvSpPr>
+          <p:cNvPr id="4" name="Slide Number Placeholder 3"/>
+          <p:cNvSpPr>
+            <a:spLocks xmlns:a="http://schemas.openxmlformats.org/drawingml/2006/main" noGrp="1"/>
+          </p:cNvSpPr>
+          <p:nvPr>
+            <p:ph type="sldNum" idx="5"/>
+          </p:nvPr>
+        </p:nvSpPr>
+        <p:spPr/>
+        <p:txBody>
+          <a:bodyPr xmlns:a="http://schemas.openxmlformats.org/drawingml/2006/main"/>
+          <a:lstStyle xmlns:a="http://schemas.openxmlformats.org/drawingml/2006/main"/>
+          <a:p xmlns:a="http://schemas.openxmlformats.org/drawingml/2006/main"/>
+        </p:txBody>
+      </p:sp>
+    </p:spTree>
+  </p:cSld>
+  <p:clrMapOvr>
+    <a:masterClrMapping xmlns:a="http://schemas.openxmlformats.org/drawingml/2006/main"/>
+  </p:clrMapOvr>
+</p:notes>
+</file>
+
+<file path=ppt/notesSlides/notesSlide25.xml><?xml version="1.0" encoding="utf-8"?>
+<p:notes xmlns:p="http://schemas.openxmlformats.org/presentationml/2006/main">
+  <p:cSld>
+    <p:spTree>
+      <p:nvGrpSpPr>
+        <p:cNvPr id="1" name=""/>
+        <p:cNvGrpSpPr/>
+        <p:nvPr/>
+      </p:nvGrpSpPr>
+      <p:grpSpPr>
+        <a:xfrm xmlns:a="http://schemas.openxmlformats.org/drawingml/2006/main"/>
+      </p:grpSpPr>
+      <p:sp>
+        <p:nvSpPr>
+          <p:cNvPr id="2" name="Slide Image Placeholder 1"/>
+          <p:cNvSpPr>
+            <a:spLocks xmlns:a="http://schemas.openxmlformats.org/drawingml/2006/main" noGrp="1"/>
+          </p:cNvSpPr>
+          <p:nvPr>
+            <p:ph type="sldImg" idx="0"/>
+          </p:nvPr>
+        </p:nvSpPr>
+        <p:spPr/>
+      </p:sp>
+      <p:sp>
+        <p:nvSpPr>
+          <p:cNvPr id="3" name="Notes Placeholder 2"/>
+          <p:cNvSpPr>
+            <a:spLocks xmlns:a="http://schemas.openxmlformats.org/drawingml/2006/main" noGrp="1"/>
+          </p:cNvSpPr>
+          <p:nvPr>
+            <p:ph type="body" idx="1"/>
+          </p:nvPr>
+        </p:nvSpPr>
+        <p:spPr/>
+        <p:txBody>
+          <a:bodyPr xmlns:a="http://schemas.openxmlformats.org/drawingml/2006/main"/>
+          <a:lstStyle xmlns:a="http://schemas.openxmlformats.org/drawingml/2006/main"/>
+          <a:p xmlns:a="http://schemas.openxmlformats.org/drawingml/2006/main">
+            <a:r>
+              <a:t>[1:00] Résumer en 30 s les 5 messages. Terminer par la valeur métier : « une</a:t>
+            </a:r>
+          </a:p>
+          <a:p xmlns:a="http://schemas.openxmlformats.org/drawingml/2006/main">
+            <a:r>
+              <a:t>aide concrète pour accompagner à temps les étudiants à risque. » Enchaîner sur</a:t>
+            </a:r>
+          </a:p>
+          <a:p xmlns:a="http://schemas.openxmlformats.org/drawingml/2006/main">
+            <a:r>
+              <a:t>les questions avec assurance.</a:t>
+            </a:r>
+          </a:p>
+        </p:txBody>
+      </p:sp>
+      <p:sp>
+        <p:nvSpPr>
+          <p:cNvPr id="4" name="Slide Number Placeholder 3"/>
+          <p:cNvSpPr>
+            <a:spLocks xmlns:a="http://schemas.openxmlformats.org/drawingml/2006/main" noGrp="1"/>
+          </p:cNvSpPr>
+          <p:nvPr>
+            <p:ph type="sldNum" idx="5"/>
+          </p:nvPr>
+        </p:nvSpPr>
+        <p:spPr/>
+        <p:txBody>
+          <a:bodyPr xmlns:a="http://schemas.openxmlformats.org/drawingml/2006/main"/>
+          <a:lstStyle xmlns:a="http://schemas.openxmlformats.org/drawingml/2006/main"/>
+          <a:p xmlns:a="http://schemas.openxmlformats.org/drawingml/2006/main"/>
+        </p:txBody>
+      </p:sp>
+    </p:spTree>
+  </p:cSld>
+  <p:clrMapOvr>
+    <a:masterClrMapping xmlns:a="http://schemas.openxmlformats.org/drawingml/2006/main"/>
+  </p:clrMapOvr>
+</p:notes>
+</file>
+
+<file path=ppt/notesSlides/notesSlide26.xml><?xml version="1.0" encoding="utf-8"?>
 <p:notes xmlns:p="http://schemas.openxmlformats.org/presentationml/2006/main">
   <p:cSld>
     <p:spTree>
@@ -2517,7 +2780,7 @@
   </p:cSld>
   <p:clrMap bg1="lt1" tx1="dk1" bg2="lt2" tx2="dk2" accent1="accent1" accent2="accent2" accent3="accent3" accent4="accent4" accent5="accent5" accent6="accent6" hlink="hlink" folHlink="folHlink"/>
   <p:sldLayoutIdLst>
-    <p:sldLayoutId xmlns:r="http://schemas.openxmlformats.org/officeDocument/2006/relationships" id="2147483649" r:id="R1264ab96f56449b7"/>
+    <p:sldLayoutId xmlns:r="http://schemas.openxmlformats.org/officeDocument/2006/relationships" id="2147483649" r:id="R73e9b6792bf243db"/>
   </p:sldLayoutIdLst>
   <p:txStyles>
     <p:titleStyle>
@@ -3922,7 +4185,7 @@
           <p:nvPr/>
         </p:nvPicPr>
         <p:blipFill>
-          <a:blip xmlns:r="http://schemas.openxmlformats.org/officeDocument/2006/relationships" xmlns:a="http://schemas.openxmlformats.org/drawingml/2006/main" r:embed="Rdc9129b817c3465d"/>
+          <a:blip xmlns:r="http://schemas.openxmlformats.org/officeDocument/2006/relationships" xmlns:a="http://schemas.openxmlformats.org/drawingml/2006/main" r:embed="R8f06b78971e74045"/>
           <a:stretch xmlns:a="http://schemas.openxmlformats.org/drawingml/2006/main"/>
         </p:blipFill>
         <p:spPr>
@@ -4253,7 +4516,7 @@
           <p:nvPr/>
         </p:nvPicPr>
         <p:blipFill>
-          <a:blip xmlns:r="http://schemas.openxmlformats.org/officeDocument/2006/relationships" xmlns:a="http://schemas.openxmlformats.org/drawingml/2006/main" r:embed="R9a5a9464c3344f03"/>
+          <a:blip xmlns:r="http://schemas.openxmlformats.org/officeDocument/2006/relationships" xmlns:a="http://schemas.openxmlformats.org/drawingml/2006/main" r:embed="Rf37780a5783a46ee"/>
           <a:stretch xmlns:a="http://schemas.openxmlformats.org/drawingml/2006/main"/>
         </p:blipFill>
         <p:spPr>
@@ -4695,7 +4958,7 @@
           <p:nvPr/>
         </p:nvPicPr>
         <p:blipFill>
-          <a:blip xmlns:r="http://schemas.openxmlformats.org/officeDocument/2006/relationships" xmlns:a="http://schemas.openxmlformats.org/drawingml/2006/main" r:embed="R6b208a89258e4b9f"/>
+          <a:blip xmlns:r="http://schemas.openxmlformats.org/officeDocument/2006/relationships" xmlns:a="http://schemas.openxmlformats.org/drawingml/2006/main" r:embed="Red6d524cce8244bf"/>
           <a:stretch xmlns:a="http://schemas.openxmlformats.org/drawingml/2006/main"/>
         </p:blipFill>
         <p:spPr>
@@ -4996,7 +5259,7 @@
           <p:nvPr/>
         </p:nvPicPr>
         <p:blipFill>
-          <a:blip xmlns:r="http://schemas.openxmlformats.org/officeDocument/2006/relationships" xmlns:a="http://schemas.openxmlformats.org/drawingml/2006/main" r:embed="R71dac04ae46441e0"/>
+          <a:blip xmlns:r="http://schemas.openxmlformats.org/officeDocument/2006/relationships" xmlns:a="http://schemas.openxmlformats.org/drawingml/2006/main" r:embed="R3094ea6076314501"/>
           <a:stretch xmlns:a="http://schemas.openxmlformats.org/drawingml/2006/main"/>
         </p:blipFill>
         <p:spPr>
@@ -9590,22 +9853,22 @@
       </p:grpSpPr>
       <p:sp>
         <p:nvSpPr>
-          <p:cNvPr id="13" name="">
-            <a:extLst xmlns:a="http://schemas.openxmlformats.org/drawingml/2006/main">
-              <a:ext uri="{FF2B5EF4-FFF2-40B4-BE49-F238E27FC236}">
-                <a16:creationId xmlns:a16="http://schemas.microsoft.com/office/drawing/2014/main" id="{08E5B9D7-38EE-457C-8A4A-0FADE80FEED4}"/>
-              </a:ext>
-            </a:extLst>
-          </p:cNvPr>
-          <p:cNvSpPr>
-            <a:spLocks xmlns:a="http://schemas.openxmlformats.org/drawingml/2006/main" noGrp="1"/>
-          </p:cNvSpPr>
-          <p:nvPr/>
-        </p:nvSpPr>
-        <p:spPr>
-          <a:xfrm xmlns:a="http://schemas.openxmlformats.org/drawingml/2006/main">
-            <a:off x="609600" y="323850"/>
-            <a:ext cx="4000500" cy="228600"/>
+          <p:cNvPr id="6" name="">
+            <a:extLst xmlns:a="http://schemas.openxmlformats.org/drawingml/2006/main">
+              <a:ext uri="{FF2B5EF4-FFF2-40B4-BE49-F238E27FC236}">
+                <a16:creationId xmlns:a16="http://schemas.microsoft.com/office/drawing/2014/main" id="{15A800B8-4593-4948-9C95-68C9C6B148C5}"/>
+              </a:ext>
+            </a:extLst>
+          </p:cNvPr>
+          <p:cNvSpPr>
+            <a:spLocks xmlns:a="http://schemas.openxmlformats.org/drawingml/2006/main" noGrp="1"/>
+          </p:cNvSpPr>
+          <p:nvPr/>
+        </p:nvSpPr>
+        <p:spPr>
+          <a:xfrm xmlns:a="http://schemas.openxmlformats.org/drawingml/2006/main">
+            <a:off x="609600" y="438150"/>
+            <a:ext cx="10953750" cy="552450"/>
           </a:xfrm>
           <a:prstGeom xmlns:a="http://schemas.openxmlformats.org/drawingml/2006/main" prst="rect">
             <a:avLst/>
@@ -9622,19 +9885,19 @@
           <a:p xmlns:a="http://schemas.openxmlformats.org/drawingml/2006/main">
             <a:pPr>
               <a:buNone/>
-              <a:defRPr sz="975" b="1">
-                <a:solidFill>
-                  <a:srgbClr val="2E6F9E"/>
-                </a:solidFill>
-              </a:defRPr>
-            </a:pPr>
-            <a:r>
-              <a:rPr sz="975" b="1">
-                <a:solidFill>
-                  <a:srgbClr val="2E6F9E"/>
-                </a:solidFill>
-              </a:rPr>
-              <a:t>RUN</a:t>
+              <a:defRPr sz="2700" b="1">
+                <a:solidFill>
+                  <a:srgbClr val="173B57"/>
+                </a:solidFill>
+              </a:defRPr>
+            </a:pPr>
+            <a:r>
+              <a:rPr sz="2700" b="1">
+                <a:solidFill>
+                  <a:srgbClr val="173B57"/>
+                </a:solidFill>
+              </a:rPr>
+              <a:t>17.1 Grafana confirme un service disponible</a:t>
             </a:r>
           </a:p>
         </p:txBody>
@@ -9644,69 +9907,18 @@
           <p:cNvPr id="2" name="">
             <a:extLst xmlns:a="http://schemas.openxmlformats.org/drawingml/2006/main">
               <a:ext uri="{FF2B5EF4-FFF2-40B4-BE49-F238E27FC236}">
-                <a16:creationId xmlns:a16="http://schemas.microsoft.com/office/drawing/2014/main" id="{407216D8-1468-4494-9489-2281004F2869}"/>
-              </a:ext>
-            </a:extLst>
-          </p:cNvPr>
-          <p:cNvSpPr>
-            <a:spLocks xmlns:a="http://schemas.openxmlformats.org/drawingml/2006/main" noGrp="1"/>
-          </p:cNvSpPr>
-          <p:nvPr/>
-        </p:nvSpPr>
-        <p:spPr>
-          <a:xfrm xmlns:a="http://schemas.openxmlformats.org/drawingml/2006/main">
-            <a:off x="609600" y="590550"/>
-            <a:ext cx="10953750" cy="552450"/>
-          </a:xfrm>
-          <a:prstGeom xmlns:a="http://schemas.openxmlformats.org/drawingml/2006/main" prst="rect">
-            <a:avLst/>
-          </a:prstGeom>
-          <a:noFill xmlns:a="http://schemas.openxmlformats.org/drawingml/2006/main"/>
-          <a:ln xmlns:a="http://schemas.openxmlformats.org/drawingml/2006/main" w="0">
-            <a:noFill/>
-            <a:prstDash val="solid"/>
-          </a:ln>
-        </p:spPr>
-        <p:txBody>
-          <a:bodyPr xmlns:a="http://schemas.openxmlformats.org/drawingml/2006/main" anchor="t"/>
-          <a:lstStyle xmlns:a="http://schemas.openxmlformats.org/drawingml/2006/main"/>
-          <a:p xmlns:a="http://schemas.openxmlformats.org/drawingml/2006/main">
-            <a:pPr>
-              <a:buNone/>
-              <a:defRPr sz="2700" b="1">
-                <a:solidFill>
-                  <a:srgbClr val="173B57"/>
-                </a:solidFill>
-              </a:defRPr>
-            </a:pPr>
-            <a:r>
-              <a:rPr sz="2700" b="1">
-                <a:solidFill>
-                  <a:srgbClr val="173B57"/>
-                </a:solidFill>
-              </a:rPr>
-              <a:t>18. TCO &amp; valeur du pilote — C7 / C9</a:t>
-            </a:r>
-          </a:p>
-        </p:txBody>
-      </p:sp>
-      <p:sp>
-        <p:nvSpPr>
-          <p:cNvPr id="3" name="">
-            <a:extLst xmlns:a="http://schemas.openxmlformats.org/drawingml/2006/main">
-              <a:ext uri="{FF2B5EF4-FFF2-40B4-BE49-F238E27FC236}">
-                <a16:creationId xmlns:a16="http://schemas.microsoft.com/office/drawing/2014/main" id="{5A350BB4-D686-490A-8D2F-F263F9C1B696}"/>
-              </a:ext>
-            </a:extLst>
-          </p:cNvPr>
-          <p:cNvSpPr>
-            <a:spLocks xmlns:a="http://schemas.openxmlformats.org/drawingml/2006/main" noGrp="1"/>
-          </p:cNvSpPr>
-          <p:nvPr/>
-        </p:nvSpPr>
-        <p:spPr>
-          <a:xfrm xmlns:a="http://schemas.openxmlformats.org/drawingml/2006/main">
-            <a:off x="609600" y="1162050"/>
+                <a16:creationId xmlns:a16="http://schemas.microsoft.com/office/drawing/2014/main" id="{C0A8533F-D901-4DA0-9C20-3276CBE07897}"/>
+              </a:ext>
+            </a:extLst>
+          </p:cNvPr>
+          <p:cNvSpPr>
+            <a:spLocks xmlns:a="http://schemas.openxmlformats.org/drawingml/2006/main" noGrp="1"/>
+          </p:cNvSpPr>
+          <p:nvPr/>
+        </p:nvSpPr>
+        <p:spPr>
+          <a:xfrm xmlns:a="http://schemas.openxmlformats.org/drawingml/2006/main">
+            <a:off x="609600" y="1028700"/>
             <a:ext cx="10972800" cy="19050"/>
           </a:xfrm>
           <a:prstGeom xmlns:a="http://schemas.openxmlformats.org/drawingml/2006/main" prst="rect">
@@ -9723,10 +9935,10 @@
       </p:sp>
       <p:sp>
         <p:nvSpPr>
-          <p:cNvPr id="4" name="">
-            <a:extLst xmlns:a="http://schemas.openxmlformats.org/drawingml/2006/main">
-              <a:ext uri="{FF2B5EF4-FFF2-40B4-BE49-F238E27FC236}">
-                <a16:creationId xmlns:a16="http://schemas.microsoft.com/office/drawing/2014/main" id="{D84B452A-4055-4478-8C17-CD03ADC6FD08}"/>
+          <p:cNvPr id="3" name="">
+            <a:extLst xmlns:a="http://schemas.openxmlformats.org/drawingml/2006/main">
+              <a:ext uri="{FF2B5EF4-FFF2-40B4-BE49-F238E27FC236}">
+                <a16:creationId xmlns:a16="http://schemas.microsoft.com/office/drawing/2014/main" id="{E0E4AEBD-DB51-43FC-8F15-37FF41E0C260}"/>
               </a:ext>
             </a:extLst>
           </p:cNvPr>
@@ -9777,272 +9989,19 @@
           <p:cNvPr id="5" name="">
             <a:extLst xmlns:a="http://schemas.openxmlformats.org/drawingml/2006/main">
               <a:ext uri="{FF2B5EF4-FFF2-40B4-BE49-F238E27FC236}">
-                <a16:creationId xmlns:a16="http://schemas.microsoft.com/office/drawing/2014/main" id="{3CB13EF8-6241-418B-B648-E2B10A90F0DF}"/>
-              </a:ext>
-            </a:extLst>
-          </p:cNvPr>
-          <p:cNvSpPr>
-            <a:spLocks xmlns:a="http://schemas.openxmlformats.org/drawingml/2006/main" noGrp="1"/>
-          </p:cNvSpPr>
-          <p:nvPr/>
-        </p:nvSpPr>
-        <p:spPr>
-          <a:xfrm xmlns:a="http://schemas.openxmlformats.org/drawingml/2006/main">
-            <a:off x="781050" y="1571625"/>
-            <a:ext cx="2000250" cy="666750"/>
-          </a:xfrm>
-          <a:prstGeom xmlns:a="http://schemas.openxmlformats.org/drawingml/2006/main" prst="rect">
-            <a:avLst/>
-          </a:prstGeom>
-          <a:noFill xmlns:a="http://schemas.openxmlformats.org/drawingml/2006/main"/>
-          <a:ln xmlns:a="http://schemas.openxmlformats.org/drawingml/2006/main" w="0">
-            <a:noFill/>
-            <a:prstDash val="solid"/>
-          </a:ln>
-        </p:spPr>
-        <p:txBody>
-          <a:bodyPr xmlns:a="http://schemas.openxmlformats.org/drawingml/2006/main" anchor="t"/>
-          <a:lstStyle xmlns:a="http://schemas.openxmlformats.org/drawingml/2006/main"/>
-          <a:p xmlns:a="http://schemas.openxmlformats.org/drawingml/2006/main">
-            <a:pPr>
-              <a:buNone/>
-              <a:defRPr sz="3750" b="1">
-                <a:solidFill>
-                  <a:srgbClr val="2E6F9E"/>
-                </a:solidFill>
-              </a:defRPr>
-            </a:pPr>
-            <a:r>
-              <a:rPr sz="3750" b="1">
-                <a:solidFill>
-                  <a:srgbClr val="2E6F9E"/>
-                </a:solidFill>
-              </a:rPr>
-              <a:t>TCO</a:t>
-            </a:r>
-          </a:p>
-        </p:txBody>
-      </p:sp>
-      <p:sp>
-        <p:nvSpPr>
-          <p:cNvPr id="6" name="">
-            <a:extLst xmlns:a="http://schemas.openxmlformats.org/drawingml/2006/main">
-              <a:ext uri="{FF2B5EF4-FFF2-40B4-BE49-F238E27FC236}">
-                <a16:creationId xmlns:a16="http://schemas.microsoft.com/office/drawing/2014/main" id="{B9905803-6BBE-402C-9A83-ADC024E712F4}"/>
-              </a:ext>
-            </a:extLst>
-          </p:cNvPr>
-          <p:cNvSpPr>
-            <a:spLocks xmlns:a="http://schemas.openxmlformats.org/drawingml/2006/main" noGrp="1"/>
-          </p:cNvSpPr>
-          <p:nvPr/>
-        </p:nvSpPr>
-        <p:spPr>
-          <a:xfrm xmlns:a="http://schemas.openxmlformats.org/drawingml/2006/main">
-            <a:off x="2857500" y="1695450"/>
-            <a:ext cx="8096250" cy="590550"/>
-          </a:xfrm>
-          <a:prstGeom xmlns:a="http://schemas.openxmlformats.org/drawingml/2006/main" prst="rect">
-            <a:avLst/>
-          </a:prstGeom>
-          <a:noFill xmlns:a="http://schemas.openxmlformats.org/drawingml/2006/main"/>
-          <a:ln xmlns:a="http://schemas.openxmlformats.org/drawingml/2006/main" w="0">
-            <a:noFill/>
-            <a:prstDash val="solid"/>
-          </a:ln>
-        </p:spPr>
-        <p:txBody>
-          <a:bodyPr xmlns:a="http://schemas.openxmlformats.org/drawingml/2006/main" anchor="t"/>
-          <a:lstStyle xmlns:a="http://schemas.openxmlformats.org/drawingml/2006/main"/>
-          <a:p xmlns:a="http://schemas.openxmlformats.org/drawingml/2006/main">
-            <a:pPr>
-              <a:buNone/>
-              <a:defRPr sz="1725">
-                <a:solidFill>
-                  <a:srgbClr val="1B252C"/>
-                </a:solidFill>
-              </a:defRPr>
-            </a:pPr>
-            <a:r>
-              <a:rPr sz="1725">
-                <a:solidFill>
-                  <a:srgbClr val="1B252C"/>
-                </a:solidFill>
-              </a:rPr>
-              <a:t>hébergement + sauvegardes + temps DSI/DPO + revue modèle + interventions</a:t>
-            </a:r>
-          </a:p>
-        </p:txBody>
-      </p:sp>
-      <p:sp>
-        <p:nvSpPr>
-          <p:cNvPr id="7" name="">
-            <a:extLst xmlns:a="http://schemas.openxmlformats.org/drawingml/2006/main">
-              <a:ext uri="{FF2B5EF4-FFF2-40B4-BE49-F238E27FC236}">
-                <a16:creationId xmlns:a16="http://schemas.microsoft.com/office/drawing/2014/main" id="{45AC8204-DF35-4EB4-907D-DC5E173B4515}"/>
-              </a:ext>
-            </a:extLst>
-          </p:cNvPr>
-          <p:cNvSpPr>
-            <a:spLocks xmlns:a="http://schemas.openxmlformats.org/drawingml/2006/main" noGrp="1"/>
-          </p:cNvSpPr>
-          <p:nvPr/>
-        </p:nvSpPr>
-        <p:spPr>
-          <a:xfrm xmlns:a="http://schemas.openxmlformats.org/drawingml/2006/main">
-            <a:off x="781050" y="2571750"/>
-            <a:ext cx="10382250" cy="19050"/>
-          </a:xfrm>
-          <a:prstGeom xmlns:a="http://schemas.openxmlformats.org/drawingml/2006/main" prst="rect">
-            <a:avLst/>
-          </a:prstGeom>
-          <a:solidFill xmlns:a="http://schemas.openxmlformats.org/drawingml/2006/main">
-            <a:srgbClr val="CFDCE5"/>
-          </a:solidFill>
-          <a:ln xmlns:a="http://schemas.openxmlformats.org/drawingml/2006/main" w="0">
-            <a:noFill/>
-            <a:prstDash val="solid"/>
-          </a:ln>
-        </p:spPr>
-      </p:sp>
-      <p:sp>
-        <p:nvSpPr>
-          <p:cNvPr id="8" name="">
-            <a:extLst xmlns:a="http://schemas.openxmlformats.org/drawingml/2006/main">
-              <a:ext uri="{FF2B5EF4-FFF2-40B4-BE49-F238E27FC236}">
-                <a16:creationId xmlns:a16="http://schemas.microsoft.com/office/drawing/2014/main" id="{CECD97E2-724E-495C-A39F-C0868400BD0F}"/>
-              </a:ext>
-            </a:extLst>
-          </p:cNvPr>
-          <p:cNvSpPr>
-            <a:spLocks xmlns:a="http://schemas.openxmlformats.org/drawingml/2006/main" noGrp="1"/>
-          </p:cNvSpPr>
-          <p:nvPr/>
-        </p:nvSpPr>
-        <p:spPr>
-          <a:xfrm xmlns:a="http://schemas.openxmlformats.org/drawingml/2006/main">
-            <a:off x="781050" y="2905125"/>
-            <a:ext cx="3333750" cy="400050"/>
-          </a:xfrm>
-          <a:prstGeom xmlns:a="http://schemas.openxmlformats.org/drawingml/2006/main" prst="rect">
-            <a:avLst/>
-          </a:prstGeom>
-          <a:noFill xmlns:a="http://schemas.openxmlformats.org/drawingml/2006/main"/>
-          <a:ln xmlns:a="http://schemas.openxmlformats.org/drawingml/2006/main" w="0">
-            <a:noFill/>
-            <a:prstDash val="solid"/>
-          </a:ln>
-        </p:spPr>
-        <p:txBody>
-          <a:bodyPr xmlns:a="http://schemas.openxmlformats.org/drawingml/2006/main" anchor="t"/>
-          <a:lstStyle xmlns:a="http://schemas.openxmlformats.org/drawingml/2006/main"/>
-          <a:p xmlns:a="http://schemas.openxmlformats.org/drawingml/2006/main">
-            <a:pPr>
-              <a:buNone/>
-              <a:defRPr sz="1800" b="1">
-                <a:solidFill>
-                  <a:srgbClr val="2F7D67"/>
-                </a:solidFill>
-              </a:defRPr>
-            </a:pPr>
-            <a:r>
-              <a:rPr sz="1800" b="1">
-                <a:solidFill>
-                  <a:srgbClr val="2F7D67"/>
-                </a:solidFill>
-              </a:rPr>
-              <a:t>VALEUR DU PILOTE</a:t>
-            </a:r>
-          </a:p>
-        </p:txBody>
-      </p:sp>
-      <p:sp>
-        <p:nvSpPr>
-          <p:cNvPr id="9" name="">
-            <a:extLst xmlns:a="http://schemas.openxmlformats.org/drawingml/2006/main">
-              <a:ext uri="{FF2B5EF4-FFF2-40B4-BE49-F238E27FC236}">
-                <a16:creationId xmlns:a16="http://schemas.microsoft.com/office/drawing/2014/main" id="{5FE46928-A66E-4687-983D-46F6A2277407}"/>
-              </a:ext>
-            </a:extLst>
-          </p:cNvPr>
-          <p:cNvSpPr>
-            <a:spLocks xmlns:a="http://schemas.openxmlformats.org/drawingml/2006/main" noGrp="1"/>
-          </p:cNvSpPr>
-          <p:nvPr/>
-        </p:nvSpPr>
-        <p:spPr>
-          <a:xfrm xmlns:a="http://schemas.openxmlformats.org/drawingml/2006/main">
-            <a:off x="781050" y="3476625"/>
-            <a:ext cx="5905500" cy="1000125"/>
-          </a:xfrm>
-          <a:prstGeom xmlns:a="http://schemas.openxmlformats.org/drawingml/2006/main" prst="rect">
-            <a:avLst/>
-          </a:prstGeom>
-          <a:noFill xmlns:a="http://schemas.openxmlformats.org/drawingml/2006/main"/>
-          <a:ln xmlns:a="http://schemas.openxmlformats.org/drawingml/2006/main" w="0">
-            <a:noFill/>
-            <a:prstDash val="solid"/>
-          </a:ln>
-        </p:spPr>
-        <p:txBody>
-          <a:bodyPr xmlns:a="http://schemas.openxmlformats.org/drawingml/2006/main" anchor="t"/>
-          <a:lstStyle xmlns:a="http://schemas.openxmlformats.org/drawingml/2006/main"/>
-          <a:p xmlns:a="http://schemas.openxmlformats.org/drawingml/2006/main">
-            <a:pPr>
-              <a:buNone/>
-              <a:defRPr sz="2550" b="1">
-                <a:solidFill>
-                  <a:srgbClr val="173B57"/>
-                </a:solidFill>
-              </a:defRPr>
-            </a:pPr>
-            <a:r>
-              <a:rPr sz="2550" b="1">
-                <a:solidFill>
-                  <a:srgbClr val="173B57"/>
-                </a:solidFill>
-              </a:rPr>
-              <a:t>étudiants utilement accompagnés</a:t>
-            </a:r>
-          </a:p>
-          <a:p xmlns:a="http://schemas.openxmlformats.org/drawingml/2006/main">
-            <a:pPr>
-              <a:buNone/>
-              <a:defRPr sz="2550" b="1">
-                <a:solidFill>
-                  <a:srgbClr val="173B57"/>
-                </a:solidFill>
-              </a:defRPr>
-            </a:pPr>
-            <a:r>
-              <a:rPr sz="2550" b="1">
-                <a:solidFill>
-                  <a:srgbClr val="173B57"/>
-                </a:solidFill>
-              </a:rPr>
-              <a:t>× effet causal du dispositif</a:t>
-            </a:r>
-          </a:p>
-        </p:txBody>
-      </p:sp>
-      <p:sp>
-        <p:nvSpPr>
-          <p:cNvPr id="10" name="">
-            <a:extLst xmlns:a="http://schemas.openxmlformats.org/drawingml/2006/main">
-              <a:ext uri="{FF2B5EF4-FFF2-40B4-BE49-F238E27FC236}">
-                <a16:creationId xmlns:a16="http://schemas.microsoft.com/office/drawing/2014/main" id="{AF18EA22-E80B-46F4-BC2C-D50D40CB99A6}"/>
-              </a:ext>
-            </a:extLst>
-          </p:cNvPr>
-          <p:cNvSpPr>
-            <a:spLocks xmlns:a="http://schemas.openxmlformats.org/drawingml/2006/main" noGrp="1"/>
-          </p:cNvSpPr>
-          <p:nvPr/>
-        </p:nvSpPr>
-        <p:spPr>
-          <a:xfrm xmlns:a="http://schemas.openxmlformats.org/drawingml/2006/main">
-            <a:off x="7239000" y="3095625"/>
-            <a:ext cx="4000500" cy="1809750"/>
+                <a16:creationId xmlns:a16="http://schemas.microsoft.com/office/drawing/2014/main" id="{50FB363C-F907-4B56-932C-915A561E4B7E}"/>
+              </a:ext>
+            </a:extLst>
+          </p:cNvPr>
+          <p:cNvSpPr>
+            <a:spLocks xmlns:a="http://schemas.openxmlformats.org/drawingml/2006/main" noGrp="1"/>
+          </p:cNvSpPr>
+          <p:nvPr/>
+        </p:nvSpPr>
+        <p:spPr>
+          <a:xfrm xmlns:a="http://schemas.openxmlformats.org/drawingml/2006/main">
+            <a:off x="8143875" y="1809750"/>
+            <a:ext cx="3333750" cy="2667000"/>
           </a:xfrm>
           <a:prstGeom xmlns:a="http://schemas.openxmlformats.org/drawingml/2006/main" prst="rect">
             <a:avLst/>
@@ -10074,7 +10033,7 @@
                   <a:srgbClr val="1B252C"/>
                 </a:solidFill>
               </a:rPr>
-              <a:t>• L'AUC ne mesure pas l'impact du tutorat.</a:t>
+              <a:t>• Service disponible en temps réel.</a:t>
             </a:r>
           </a:p>
           <a:p xmlns:a="http://schemas.openxmlformats.org/drawingml/2006/main">
@@ -10095,7 +10054,7 @@
                   <a:srgbClr val="1B252C"/>
                 </a:solidFill>
               </a:rPr>
-              <a:t>• Pilote progressif / A-B test nécessaire.</a:t>
+              <a:t>• Débit, erreurs 5xx et latence p95.</a:t>
             </a:r>
           </a:p>
           <a:p xmlns:a="http://schemas.openxmlformats.org/drawingml/2006/main">
@@ -10116,99 +10075,37 @@
                   <a:srgbClr val="1B252C"/>
                 </a:solidFill>
               </a:rPr>
-              <a:t>• Capacité des tuteurs et faux positifs intégrés au coût.</a:t>
-            </a:r>
-          </a:p>
-        </p:txBody>
-      </p:sp>
-      <p:sp>
-        <p:nvSpPr>
-          <p:cNvPr id="11" name="">
-            <a:extLst xmlns:a="http://schemas.openxmlformats.org/drawingml/2006/main">
-              <a:ext uri="{FF2B5EF4-FFF2-40B4-BE49-F238E27FC236}">
-                <a16:creationId xmlns:a16="http://schemas.microsoft.com/office/drawing/2014/main" id="{246CB9C7-47D3-4877-ACF2-AC6D9671432C}"/>
-              </a:ext>
-            </a:extLst>
-          </p:cNvPr>
-          <p:cNvSpPr>
-            <a:spLocks xmlns:a="http://schemas.openxmlformats.org/drawingml/2006/main" noGrp="1"/>
-          </p:cNvSpPr>
-          <p:nvPr/>
-        </p:nvSpPr>
-        <p:spPr>
-          <a:xfrm xmlns:a="http://schemas.openxmlformats.org/drawingml/2006/main">
-            <a:off x="1619250" y="5286375"/>
-            <a:ext cx="8953500" cy="723900"/>
-          </a:xfrm>
-          <a:prstGeom xmlns:a="http://schemas.openxmlformats.org/drawingml/2006/main" prst="rect">
-            <a:avLst/>
-          </a:prstGeom>
-          <a:solidFill xmlns:a="http://schemas.openxmlformats.org/drawingml/2006/main">
-            <a:srgbClr val="F8ECE8"/>
-          </a:solidFill>
-          <a:ln xmlns:a="http://schemas.openxmlformats.org/drawingml/2006/main" w="9525">
-            <a:solidFill>
-              <a:srgbClr val="B95D48"/>
-            </a:solidFill>
-            <a:prstDash val="solid"/>
-          </a:ln>
-        </p:spPr>
-      </p:sp>
-      <p:sp>
-        <p:nvSpPr>
-          <p:cNvPr id="12" name="">
-            <a:extLst xmlns:a="http://schemas.openxmlformats.org/drawingml/2006/main">
-              <a:ext uri="{FF2B5EF4-FFF2-40B4-BE49-F238E27FC236}">
-                <a16:creationId xmlns:a16="http://schemas.microsoft.com/office/drawing/2014/main" id="{4EBBC361-A596-4B17-8B12-B7D53D57EAEE}"/>
-              </a:ext>
-            </a:extLst>
-          </p:cNvPr>
-          <p:cNvSpPr>
-            <a:spLocks xmlns:a="http://schemas.openxmlformats.org/drawingml/2006/main" noGrp="1"/>
-          </p:cNvSpPr>
-          <p:nvPr/>
-        </p:nvSpPr>
-        <p:spPr>
-          <a:xfrm xmlns:a="http://schemas.openxmlformats.org/drawingml/2006/main">
-            <a:off x="1790700" y="5400675"/>
-            <a:ext cx="8610600" cy="495300"/>
-          </a:xfrm>
-          <a:prstGeom xmlns:a="http://schemas.openxmlformats.org/drawingml/2006/main" prst="rect">
-            <a:avLst/>
-          </a:prstGeom>
-          <a:noFill xmlns:a="http://schemas.openxmlformats.org/drawingml/2006/main"/>
-          <a:ln xmlns:a="http://schemas.openxmlformats.org/drawingml/2006/main" w="0">
-            <a:noFill/>
-            <a:prstDash val="solid"/>
-          </a:ln>
-        </p:spPr>
-        <p:txBody>
-          <a:bodyPr xmlns:a="http://schemas.openxmlformats.org/drawingml/2006/main" anchor="ctr"/>
-          <a:lstStyle xmlns:a="http://schemas.openxmlformats.org/drawingml/2006/main"/>
-          <a:p xmlns:a="http://schemas.openxmlformats.org/drawingml/2006/main">
-            <a:pPr>
-              <a:buNone/>
-              <a:defRPr sz="1500" b="1">
-                <a:solidFill>
-                  <a:srgbClr val="B95D48"/>
-                </a:solidFill>
-              </a:defRPr>
-            </a:pPr>
-            <a:r>
-              <a:rPr sz="1500" b="1">
-                <a:solidFill>
-                  <a:srgbClr val="B95D48"/>
-                </a:solidFill>
-              </a:rPr>
-              <a:t>Aucun gain financier inventé : hypothèses à valider avec l'université.</a:t>
-            </a:r>
-          </a:p>
-        </p:txBody>
-      </p:sp>
+              <a:t>• Mesures issues du conteneur API.</a:t>
+            </a:r>
+          </a:p>
+        </p:txBody>
+      </p:sp>
+      <p:pic>
+        <p:nvPicPr>
+          <p:cNvPr id="12" name=""/>
+          <p:cNvPicPr>
+            <a:picLocks xmlns:a="http://schemas.openxmlformats.org/drawingml/2006/main" noChangeAspect="1"/>
+          </p:cNvPicPr>
+          <p:nvPr/>
+        </p:nvPicPr>
+        <p:blipFill>
+          <a:blip xmlns:r="http://schemas.openxmlformats.org/officeDocument/2006/relationships" xmlns:a="http://schemas.openxmlformats.org/drawingml/2006/main" r:embed="Rf996cb0834ec49bd"/>
+          <a:stretch xmlns:a="http://schemas.openxmlformats.org/drawingml/2006/main"/>
+        </p:blipFill>
+        <p:spPr>
+          <a:xfrm xmlns:a="http://schemas.openxmlformats.org/drawingml/2006/main">
+            <a:off x="1087882" y="1664494"/>
+            <a:ext cx="6358636" cy="3576733"/>
+          </a:xfrm>
+          <a:prstGeom xmlns:a="http://schemas.openxmlformats.org/drawingml/2006/main" prst="rect">
+            <a:avLst/>
+          </a:prstGeom>
+        </p:spPr>
+      </p:pic>
     </p:spTree>
     <p:extLst>
       <p:ext uri="{BB962C8B-B14F-4D97-AF65-F5344CB8AC3E}">
-        <p14:creationId xmlns:p14="http://schemas.microsoft.com/office/powerpoint/2010/main" val="893676865"/>
+        <p14:creationId xmlns:p14="http://schemas.microsoft.com/office/powerpoint/2010/main" val="940859376"/>
       </p:ext>
     </p:extLst>
   </p:cSld>
@@ -10236,10 +10133,10 @@
       </p:grpSpPr>
       <p:sp>
         <p:nvSpPr>
-          <p:cNvPr id="7" name="">
-            <a:extLst xmlns:a="http://schemas.openxmlformats.org/drawingml/2006/main">
-              <a:ext uri="{FF2B5EF4-FFF2-40B4-BE49-F238E27FC236}">
-                <a16:creationId xmlns:a16="http://schemas.microsoft.com/office/drawing/2014/main" id="{18A77E1C-2B23-4094-9236-BEC86DCE8B41}"/>
+          <p:cNvPr id="11" name="">
+            <a:extLst xmlns:a="http://schemas.openxmlformats.org/drawingml/2006/main">
+              <a:ext uri="{FF2B5EF4-FFF2-40B4-BE49-F238E27FC236}">
+                <a16:creationId xmlns:a16="http://schemas.microsoft.com/office/drawing/2014/main" id="{C0F84F96-DCE5-4BD5-BAA2-08D5DA4624EF}"/>
               </a:ext>
             </a:extLst>
           </p:cNvPr>
@@ -10280,7 +10177,7 @@
                   <a:srgbClr val="173B57"/>
                 </a:solidFill>
               </a:rPr>
-              <a:t>19. Limites &amp; recommandations</a:t>
+              <a:t>17.2 Prometheus collecte, Grafana alerte</a:t>
             </a:r>
           </a:p>
         </p:txBody>
@@ -10290,7 +10187,7 @@
           <p:cNvPr id="2" name="">
             <a:extLst xmlns:a="http://schemas.openxmlformats.org/drawingml/2006/main">
               <a:ext uri="{FF2B5EF4-FFF2-40B4-BE49-F238E27FC236}">
-                <a16:creationId xmlns:a16="http://schemas.microsoft.com/office/drawing/2014/main" id="{AAC52D35-FD95-46AD-B4E5-E2594CD9E567}"/>
+                <a16:creationId xmlns:a16="http://schemas.microsoft.com/office/drawing/2014/main" id="{17F6FFD8-D804-4B2D-BA50-9FB64F02AD8C}"/>
               </a:ext>
             </a:extLst>
           </p:cNvPr>
@@ -10321,7 +10218,7 @@
           <p:cNvPr id="3" name="">
             <a:extLst xmlns:a="http://schemas.openxmlformats.org/drawingml/2006/main">
               <a:ext uri="{FF2B5EF4-FFF2-40B4-BE49-F238E27FC236}">
-                <a16:creationId xmlns:a16="http://schemas.microsoft.com/office/drawing/2014/main" id="{66992DBB-B67F-4143-BBCD-9C63D33D7EBF}"/>
+                <a16:creationId xmlns:a16="http://schemas.microsoft.com/office/drawing/2014/main" id="{1AE78E61-F697-472B-9FA0-E07EB801849D}"/>
               </a:ext>
             </a:extLst>
           </p:cNvPr>
@@ -10372,19 +10269,19 @@
           <p:cNvPr id="4" name="">
             <a:extLst xmlns:a="http://schemas.openxmlformats.org/drawingml/2006/main">
               <a:ext uri="{FF2B5EF4-FFF2-40B4-BE49-F238E27FC236}">
-                <a16:creationId xmlns:a16="http://schemas.microsoft.com/office/drawing/2014/main" id="{EB912D26-5B00-4C7C-AFE8-09DFA87E9904}"/>
-              </a:ext>
-            </a:extLst>
-          </p:cNvPr>
-          <p:cNvSpPr>
-            <a:spLocks xmlns:a="http://schemas.openxmlformats.org/drawingml/2006/main" noGrp="1"/>
-          </p:cNvSpPr>
-          <p:nvPr/>
-        </p:nvSpPr>
-        <p:spPr>
-          <a:xfrm xmlns:a="http://schemas.openxmlformats.org/drawingml/2006/main">
-            <a:off x="904875" y="1571625"/>
-            <a:ext cx="10287000" cy="3333750"/>
+                <a16:creationId xmlns:a16="http://schemas.microsoft.com/office/drawing/2014/main" id="{4A7C5D84-94EE-46B6-8E14-A64D959DE56F}"/>
+              </a:ext>
+            </a:extLst>
+          </p:cNvPr>
+          <p:cNvSpPr>
+            <a:spLocks xmlns:a="http://schemas.openxmlformats.org/drawingml/2006/main" noGrp="1"/>
+          </p:cNvSpPr>
+          <p:nvPr/>
+        </p:nvSpPr>
+        <p:spPr>
+          <a:xfrm xmlns:a="http://schemas.openxmlformats.org/drawingml/2006/main">
+            <a:off x="857250" y="1524000"/>
+            <a:ext cx="2095500" cy="361950"/>
           </a:xfrm>
           <a:prstGeom xmlns:a="http://schemas.openxmlformats.org/drawingml/2006/main" prst="rect">
             <a:avLst/>
@@ -10400,129 +10297,124 @@
           <a:lstStyle xmlns:a="http://schemas.openxmlformats.org/drawingml/2006/main"/>
           <a:p xmlns:a="http://schemas.openxmlformats.org/drawingml/2006/main">
             <a:pPr>
-              <a:lnSpc>
-                <a:spcPct val="122000"/>
-              </a:lnSpc>
-              <a:buNone/>
-              <a:defRPr sz="1650">
-                <a:solidFill>
-                  <a:srgbClr val="1B252C"/>
-                </a:solidFill>
-              </a:defRPr>
-            </a:pPr>
-            <a:r>
-              <a:rPr sz="1650">
-                <a:solidFill>
-                  <a:srgbClr val="1B252C"/>
-                </a:solidFill>
-              </a:rPr>
-              <a:t>• Données synthétiques : performance à revalider sur des cohortes réelles.</a:t>
-            </a:r>
-          </a:p>
-          <a:p xmlns:a="http://schemas.openxmlformats.org/drawingml/2006/main">
-            <a:pPr>
-              <a:lnSpc>
-                <a:spcPct val="122000"/>
-              </a:lnSpc>
-              <a:buNone/>
-              <a:defRPr sz="1650">
-                <a:solidFill>
-                  <a:srgbClr val="1B252C"/>
-                </a:solidFill>
-              </a:defRPr>
-            </a:pPr>
-            <a:r>
-              <a:rPr sz="1650">
-                <a:solidFill>
-                  <a:srgbClr val="1B252C"/>
-                </a:solidFill>
-              </a:rPr>
-              <a:t>• Corrélation ≠ causalité : mesurer l'effet du dispositif par pilote.</a:t>
-            </a:r>
-          </a:p>
-          <a:p xmlns:a="http://schemas.openxmlformats.org/drawingml/2006/main">
-            <a:pPr>
-              <a:lnSpc>
-                <a:spcPct val="122000"/>
-              </a:lnSpc>
-              <a:buNone/>
-              <a:defRPr sz="1650">
-                <a:solidFill>
-                  <a:srgbClr val="1B252C"/>
-                </a:solidFill>
-              </a:defRPr>
-            </a:pPr>
-            <a:r>
-              <a:rPr sz="1650">
-                <a:solidFill>
-                  <a:srgbClr val="1B252C"/>
-                </a:solidFill>
-              </a:rPr>
-              <a:t>• Production réelle : DPO, DPIA/AIPD, RBAC, coffre de secrets, sauvegardes testées.</a:t>
-            </a:r>
-          </a:p>
-          <a:p xmlns:a="http://schemas.openxmlformats.org/drawingml/2006/main">
-            <a:pPr>
-              <a:lnSpc>
-                <a:spcPct val="122000"/>
-              </a:lnSpc>
-              <a:buNone/>
-              <a:defRPr sz="1650">
-                <a:solidFill>
-                  <a:srgbClr val="1B252C"/>
-                </a:solidFill>
-              </a:defRPr>
-            </a:pPr>
-            <a:r>
-              <a:rPr sz="1650">
-                <a:solidFill>
-                  <a:srgbClr val="1B252C"/>
-                </a:solidFill>
-              </a:rPr>
-              <a:t>• Run réel : confirmer le TCO, brancher le canal d'alerte et planifier les jobs.</a:t>
-            </a:r>
-          </a:p>
-          <a:p xmlns:a="http://schemas.openxmlformats.org/drawingml/2006/main">
-            <a:pPr>
-              <a:lnSpc>
-                <a:spcPct val="122000"/>
-              </a:lnSpc>
-              <a:buNone/>
-              <a:defRPr sz="1650">
-                <a:solidFill>
-                  <a:srgbClr val="1B252C"/>
-                </a:solidFill>
-              </a:defRPr>
-            </a:pPr>
-            <a:r>
-              <a:rPr sz="1650">
-                <a:solidFill>
-                  <a:srgbClr val="1B252C"/>
-                </a:solidFill>
-              </a:rPr>
-              <a:t>• Éthique : équité continue, explication, recours et formulation non stigmatisante.</a:t>
-            </a:r>
-          </a:p>
-        </p:txBody>
-      </p:sp>
-      <p:sp>
-        <p:nvSpPr>
-          <p:cNvPr id="5" name="">
-            <a:extLst xmlns:a="http://schemas.openxmlformats.org/drawingml/2006/main">
-              <a:ext uri="{FF2B5EF4-FFF2-40B4-BE49-F238E27FC236}">
-                <a16:creationId xmlns:a16="http://schemas.microsoft.com/office/drawing/2014/main" id="{93B0E887-5075-4E9D-BD88-37AFE440B410}"/>
-              </a:ext>
-            </a:extLst>
-          </p:cNvPr>
-          <p:cNvSpPr>
-            <a:spLocks xmlns:a="http://schemas.openxmlformats.org/drawingml/2006/main" noGrp="1"/>
-          </p:cNvSpPr>
-          <p:nvPr/>
-        </p:nvSpPr>
-        <p:spPr>
-          <a:xfrm xmlns:a="http://schemas.openxmlformats.org/drawingml/2006/main">
-            <a:off x="1381125" y="5095875"/>
-            <a:ext cx="9429750" cy="742950"/>
+              <a:buNone/>
+              <a:defRPr sz="1875" b="1">
+                <a:solidFill>
+                  <a:srgbClr val="2E6F9E"/>
+                </a:solidFill>
+              </a:defRPr>
+            </a:pPr>
+            <a:r>
+              <a:rPr sz="1875" b="1">
+                <a:solidFill>
+                  <a:srgbClr val="2E6F9E"/>
+                </a:solidFill>
+              </a:rPr>
+              <a:t>PROMETHEUS</a:t>
+            </a:r>
+          </a:p>
+        </p:txBody>
+      </p:sp>
+      <p:sp>
+        <p:nvSpPr>
+          <p:cNvPr id="6" name="">
+            <a:extLst xmlns:a="http://schemas.openxmlformats.org/drawingml/2006/main">
+              <a:ext uri="{FF2B5EF4-FFF2-40B4-BE49-F238E27FC236}">
+                <a16:creationId xmlns:a16="http://schemas.microsoft.com/office/drawing/2014/main" id="{4AE283F0-FEBC-45F2-8948-22FAE3E8CE62}"/>
+              </a:ext>
+            </a:extLst>
+          </p:cNvPr>
+          <p:cNvSpPr>
+            <a:spLocks xmlns:a="http://schemas.openxmlformats.org/drawingml/2006/main" noGrp="1"/>
+          </p:cNvSpPr>
+          <p:nvPr/>
+        </p:nvSpPr>
+        <p:spPr>
+          <a:xfrm xmlns:a="http://schemas.openxmlformats.org/drawingml/2006/main">
+            <a:off x="5905500" y="1476375"/>
+            <a:ext cx="19050" cy="3381375"/>
+          </a:xfrm>
+          <a:prstGeom xmlns:a="http://schemas.openxmlformats.org/drawingml/2006/main" prst="rect">
+            <a:avLst/>
+          </a:prstGeom>
+          <a:solidFill xmlns:a="http://schemas.openxmlformats.org/drawingml/2006/main">
+            <a:srgbClr val="CFDCE5"/>
+          </a:solidFill>
+          <a:ln xmlns:a="http://schemas.openxmlformats.org/drawingml/2006/main" w="0">
+            <a:noFill/>
+            <a:prstDash val="solid"/>
+          </a:ln>
+        </p:spPr>
+      </p:sp>
+      <p:sp>
+        <p:nvSpPr>
+          <p:cNvPr id="7" name="">
+            <a:extLst xmlns:a="http://schemas.openxmlformats.org/drawingml/2006/main">
+              <a:ext uri="{FF2B5EF4-FFF2-40B4-BE49-F238E27FC236}">
+                <a16:creationId xmlns:a16="http://schemas.microsoft.com/office/drawing/2014/main" id="{8F79C5A4-4E68-47FF-9E18-BC077548DB19}"/>
+              </a:ext>
+            </a:extLst>
+          </p:cNvPr>
+          <p:cNvSpPr>
+            <a:spLocks xmlns:a="http://schemas.openxmlformats.org/drawingml/2006/main" noGrp="1"/>
+          </p:cNvSpPr>
+          <p:nvPr/>
+        </p:nvSpPr>
+        <p:spPr>
+          <a:xfrm xmlns:a="http://schemas.openxmlformats.org/drawingml/2006/main">
+            <a:off x="6477000" y="1524000"/>
+            <a:ext cx="2857500" cy="361950"/>
+          </a:xfrm>
+          <a:prstGeom xmlns:a="http://schemas.openxmlformats.org/drawingml/2006/main" prst="rect">
+            <a:avLst/>
+          </a:prstGeom>
+          <a:noFill xmlns:a="http://schemas.openxmlformats.org/drawingml/2006/main"/>
+          <a:ln xmlns:a="http://schemas.openxmlformats.org/drawingml/2006/main" w="0">
+            <a:noFill/>
+            <a:prstDash val="solid"/>
+          </a:ln>
+        </p:spPr>
+        <p:txBody>
+          <a:bodyPr xmlns:a="http://schemas.openxmlformats.org/drawingml/2006/main" anchor="t"/>
+          <a:lstStyle xmlns:a="http://schemas.openxmlformats.org/drawingml/2006/main"/>
+          <a:p xmlns:a="http://schemas.openxmlformats.org/drawingml/2006/main">
+            <a:pPr>
+              <a:buNone/>
+              <a:defRPr sz="1875" b="1">
+                <a:solidFill>
+                  <a:srgbClr val="2F7D67"/>
+                </a:solidFill>
+              </a:defRPr>
+            </a:pPr>
+            <a:r>
+              <a:rPr sz="1875" b="1">
+                <a:solidFill>
+                  <a:srgbClr val="2F7D67"/>
+                </a:solidFill>
+              </a:rPr>
+              <a:t>ALERTES GRAFANA</a:t>
+            </a:r>
+          </a:p>
+        </p:txBody>
+      </p:sp>
+      <p:sp>
+        <p:nvSpPr>
+          <p:cNvPr id="9" name="">
+            <a:extLst xmlns:a="http://schemas.openxmlformats.org/drawingml/2006/main">
+              <a:ext uri="{FF2B5EF4-FFF2-40B4-BE49-F238E27FC236}">
+                <a16:creationId xmlns:a16="http://schemas.microsoft.com/office/drawing/2014/main" id="{9AFA22ED-214C-4781-8343-5630D5CAAEF3}"/>
+              </a:ext>
+            </a:extLst>
+          </p:cNvPr>
+          <p:cNvSpPr>
+            <a:spLocks xmlns:a="http://schemas.openxmlformats.org/drawingml/2006/main" noGrp="1"/>
+          </p:cNvSpPr>
+          <p:nvPr/>
+        </p:nvSpPr>
+        <p:spPr>
+          <a:xfrm xmlns:a="http://schemas.openxmlformats.org/drawingml/2006/main">
+            <a:off x="1714500" y="5238750"/>
+            <a:ext cx="8763000" cy="666750"/>
           </a:xfrm>
           <a:prstGeom xmlns:a="http://schemas.openxmlformats.org/drawingml/2006/main" prst="rect">
             <a:avLst/>
@@ -10540,22 +10432,22 @@
       </p:sp>
       <p:sp>
         <p:nvSpPr>
-          <p:cNvPr id="6" name="">
-            <a:extLst xmlns:a="http://schemas.openxmlformats.org/drawingml/2006/main">
-              <a:ext uri="{FF2B5EF4-FFF2-40B4-BE49-F238E27FC236}">
-                <a16:creationId xmlns:a16="http://schemas.microsoft.com/office/drawing/2014/main" id="{665FCA75-547D-494B-85C1-D42DEE2646CF}"/>
-              </a:ext>
-            </a:extLst>
-          </p:cNvPr>
-          <p:cNvSpPr>
-            <a:spLocks xmlns:a="http://schemas.openxmlformats.org/drawingml/2006/main" noGrp="1"/>
-          </p:cNvSpPr>
-          <p:nvPr/>
-        </p:nvSpPr>
-        <p:spPr>
-          <a:xfrm xmlns:a="http://schemas.openxmlformats.org/drawingml/2006/main">
-            <a:off x="1552575" y="5210175"/>
-            <a:ext cx="9086850" cy="514350"/>
+          <p:cNvPr id="10" name="">
+            <a:extLst xmlns:a="http://schemas.openxmlformats.org/drawingml/2006/main">
+              <a:ext uri="{FF2B5EF4-FFF2-40B4-BE49-F238E27FC236}">
+                <a16:creationId xmlns:a16="http://schemas.microsoft.com/office/drawing/2014/main" id="{07EE7146-C173-4983-915C-AFA41CF3A391}"/>
+              </a:ext>
+            </a:extLst>
+          </p:cNvPr>
+          <p:cNvSpPr>
+            <a:spLocks xmlns:a="http://schemas.openxmlformats.org/drawingml/2006/main" noGrp="1"/>
+          </p:cNvSpPr>
+          <p:nvPr/>
+        </p:nvSpPr>
+        <p:spPr>
+          <a:xfrm xmlns:a="http://schemas.openxmlformats.org/drawingml/2006/main">
+            <a:off x="1885950" y="5353050"/>
+            <a:ext cx="8420100" cy="438150"/>
           </a:xfrm>
           <a:prstGeom xmlns:a="http://schemas.openxmlformats.org/drawingml/2006/main" prst="rect">
             <a:avLst/>
@@ -10584,15 +10476,59 @@
                   <a:srgbClr val="2F7D67"/>
                 </a:solidFill>
               </a:rPr>
-              <a:t>Le score priorise l'accompagnement ; il ne décide jamais du parcours d'un étudiant.</a:t>
-            </a:r>
-          </a:p>
-        </p:txBody>
-      </p:sp>
+              <a:t>La collecte et l’évaluation s’exécutent dans Docker, hors du notebook.</a:t>
+            </a:r>
+          </a:p>
+        </p:txBody>
+      </p:sp>
+      <p:pic>
+        <p:nvPicPr>
+          <p:cNvPr id="22" name=""/>
+          <p:cNvPicPr>
+            <a:picLocks xmlns:a="http://schemas.openxmlformats.org/drawingml/2006/main" noChangeAspect="1"/>
+          </p:cNvPicPr>
+          <p:nvPr/>
+        </p:nvPicPr>
+        <p:blipFill>
+          <a:blip xmlns:r="http://schemas.openxmlformats.org/officeDocument/2006/relationships" xmlns:a="http://schemas.openxmlformats.org/drawingml/2006/main" r:embed="Rfb314a8f77004fc0"/>
+          <a:stretch xmlns:a="http://schemas.openxmlformats.org/drawingml/2006/main"/>
+        </p:blipFill>
+        <p:spPr>
+          <a:xfrm xmlns:a="http://schemas.openxmlformats.org/drawingml/2006/main">
+            <a:off x="857250" y="2090208"/>
+            <a:ext cx="4476750" cy="2487083"/>
+          </a:xfrm>
+          <a:prstGeom xmlns:a="http://schemas.openxmlformats.org/drawingml/2006/main" prst="rect">
+            <a:avLst/>
+          </a:prstGeom>
+        </p:spPr>
+      </p:pic>
+      <p:pic>
+        <p:nvPicPr>
+          <p:cNvPr id="23" name=""/>
+          <p:cNvPicPr>
+            <a:picLocks xmlns:a="http://schemas.openxmlformats.org/drawingml/2006/main" noChangeAspect="1"/>
+          </p:cNvPicPr>
+          <p:nvPr/>
+        </p:nvPicPr>
+        <p:blipFill>
+          <a:blip xmlns:r="http://schemas.openxmlformats.org/officeDocument/2006/relationships" xmlns:a="http://schemas.openxmlformats.org/drawingml/2006/main" r:embed="Rd8c744faa38c4dfd"/>
+          <a:stretch xmlns:a="http://schemas.openxmlformats.org/drawingml/2006/main"/>
+        </p:blipFill>
+        <p:spPr>
+          <a:xfrm xmlns:a="http://schemas.openxmlformats.org/drawingml/2006/main">
+            <a:off x="6477000" y="2445869"/>
+            <a:ext cx="4762500" cy="1775761"/>
+          </a:xfrm>
+          <a:prstGeom xmlns:a="http://schemas.openxmlformats.org/drawingml/2006/main" prst="rect">
+            <a:avLst/>
+          </a:prstGeom>
+        </p:spPr>
+      </p:pic>
     </p:spTree>
     <p:extLst>
       <p:ext uri="{BB962C8B-B14F-4D97-AF65-F5344CB8AC3E}">
-        <p14:creationId xmlns:p14="http://schemas.microsoft.com/office/powerpoint/2010/main" val="1218725923"/>
+        <p14:creationId xmlns:p14="http://schemas.microsoft.com/office/powerpoint/2010/main" val="1488909031"/>
       </p:ext>
     </p:extLst>
   </p:cSld>
@@ -10620,10 +10556,10 @@
       </p:grpSpPr>
       <p:sp>
         <p:nvSpPr>
-          <p:cNvPr id="7" name="">
-            <a:extLst xmlns:a="http://schemas.openxmlformats.org/drawingml/2006/main">
-              <a:ext uri="{FF2B5EF4-FFF2-40B4-BE49-F238E27FC236}">
-                <a16:creationId xmlns:a16="http://schemas.microsoft.com/office/drawing/2014/main" id="{94FD13DA-5461-453B-B426-F31AEE47BA61}"/>
+          <p:cNvPr id="6" name="">
+            <a:extLst xmlns:a="http://schemas.openxmlformats.org/drawingml/2006/main">
+              <a:ext uri="{FF2B5EF4-FFF2-40B4-BE49-F238E27FC236}">
+                <a16:creationId xmlns:a16="http://schemas.microsoft.com/office/drawing/2014/main" id="{15A800B8-4593-4948-9C95-68C9C6B148C5}"/>
               </a:ext>
             </a:extLst>
           </p:cNvPr>
@@ -10664,7 +10600,7 @@
                   <a:srgbClr val="173B57"/>
                 </a:solidFill>
               </a:rPr>
-              <a:t>20. Conclusion — du modèle au Run, C1→C9</a:t>
+              <a:t>17.3 Caddy expose l’API en HTTPS</a:t>
             </a:r>
           </a:p>
         </p:txBody>
@@ -10674,7 +10610,7 @@
           <p:cNvPr id="2" name="">
             <a:extLst xmlns:a="http://schemas.openxmlformats.org/drawingml/2006/main">
               <a:ext uri="{FF2B5EF4-FFF2-40B4-BE49-F238E27FC236}">
-                <a16:creationId xmlns:a16="http://schemas.microsoft.com/office/drawing/2014/main" id="{10EAF760-C659-4364-8793-21891BDC6BD0}"/>
+                <a16:creationId xmlns:a16="http://schemas.microsoft.com/office/drawing/2014/main" id="{C0A8533F-D901-4DA0-9C20-3276CBE07897}"/>
               </a:ext>
             </a:extLst>
           </p:cNvPr>
@@ -10705,7 +10641,7 @@
           <p:cNvPr id="3" name="">
             <a:extLst xmlns:a="http://schemas.openxmlformats.org/drawingml/2006/main">
               <a:ext uri="{FF2B5EF4-FFF2-40B4-BE49-F238E27FC236}">
-                <a16:creationId xmlns:a16="http://schemas.microsoft.com/office/drawing/2014/main" id="{4FED1F7F-F033-479D-B6AB-3E80B816FCEF}"/>
+                <a16:creationId xmlns:a16="http://schemas.microsoft.com/office/drawing/2014/main" id="{E0E4AEBD-DB51-43FC-8F15-37FF41E0C260}"/>
               </a:ext>
             </a:extLst>
           </p:cNvPr>
@@ -10753,22 +10689,22 @@
       </p:sp>
       <p:sp>
         <p:nvSpPr>
-          <p:cNvPr id="4" name="">
-            <a:extLst xmlns:a="http://schemas.openxmlformats.org/drawingml/2006/main">
-              <a:ext uri="{FF2B5EF4-FFF2-40B4-BE49-F238E27FC236}">
-                <a16:creationId xmlns:a16="http://schemas.microsoft.com/office/drawing/2014/main" id="{CCA343F9-98D8-412B-9C24-F9BC838BE751}"/>
-              </a:ext>
-            </a:extLst>
-          </p:cNvPr>
-          <p:cNvSpPr>
-            <a:spLocks xmlns:a="http://schemas.openxmlformats.org/drawingml/2006/main" noGrp="1"/>
-          </p:cNvSpPr>
-          <p:nvPr/>
-        </p:nvSpPr>
-        <p:spPr>
-          <a:xfrm xmlns:a="http://schemas.openxmlformats.org/drawingml/2006/main">
-            <a:off x="1000125" y="1666875"/>
-            <a:ext cx="10096500" cy="2857500"/>
+          <p:cNvPr id="5" name="">
+            <a:extLst xmlns:a="http://schemas.openxmlformats.org/drawingml/2006/main">
+              <a:ext uri="{FF2B5EF4-FFF2-40B4-BE49-F238E27FC236}">
+                <a16:creationId xmlns:a16="http://schemas.microsoft.com/office/drawing/2014/main" id="{50FB363C-F907-4B56-932C-915A561E4B7E}"/>
+              </a:ext>
+            </a:extLst>
+          </p:cNvPr>
+          <p:cNvSpPr>
+            <a:spLocks xmlns:a="http://schemas.openxmlformats.org/drawingml/2006/main" noGrp="1"/>
+          </p:cNvSpPr>
+          <p:nvPr/>
+        </p:nvSpPr>
+        <p:spPr>
+          <a:xfrm xmlns:a="http://schemas.openxmlformats.org/drawingml/2006/main">
+            <a:off x="8143875" y="1809750"/>
+            <a:ext cx="3333750" cy="2667000"/>
           </a:xfrm>
           <a:prstGeom xmlns:a="http://schemas.openxmlformats.org/drawingml/2006/main" prst="rect">
             <a:avLst/>
@@ -10788,19 +10724,19 @@
                 <a:spcPct val="122000"/>
               </a:lnSpc>
               <a:buNone/>
-              <a:defRPr sz="1725">
-                <a:solidFill>
-                  <a:srgbClr val="1B252C"/>
-                </a:solidFill>
-              </a:defRPr>
-            </a:pPr>
-            <a:r>
-              <a:rPr sz="1725">
-                <a:solidFill>
-                  <a:srgbClr val="1B252C"/>
-                </a:solidFill>
-              </a:rPr>
-              <a:t>• Rigueur anti-fuite : trois pièges neutralisés et garde-fou codé.</a:t>
+              <a:defRPr sz="1500">
+                <a:solidFill>
+                  <a:srgbClr val="1B252C"/>
+                </a:solidFill>
+              </a:defRPr>
+            </a:pPr>
+            <a:r>
+              <a:rPr sz="1500">
+                <a:solidFill>
+                  <a:srgbClr val="1B252C"/>
+                </a:solidFill>
+              </a:rPr>
+              <a:t>• Terminaison HTTPS par Caddy.</a:t>
             </a:r>
           </a:p>
           <a:p xmlns:a="http://schemas.openxmlformats.org/drawingml/2006/main">
@@ -10809,19 +10745,19 @@
                 <a:spcPct val="122000"/>
               </a:lnSpc>
               <a:buNone/>
-              <a:defRPr sz="1725">
-                <a:solidFill>
-                  <a:srgbClr val="1B252C"/>
-                </a:solidFill>
-              </a:defRPr>
-            </a:pPr>
-            <a:r>
-              <a:rPr sz="1725">
-                <a:solidFill>
-                  <a:srgbClr val="1B252C"/>
-                </a:solidFill>
-              </a:rPr>
-              <a:t>• Modèle explicable : AUC 0,95, rappel 95,9 %, seuil métier assumé.</a:t>
+              <a:defRPr sz="1500">
+                <a:solidFill>
+                  <a:srgbClr val="1B252C"/>
+                </a:solidFill>
+              </a:defRPr>
+            </a:pPr>
+            <a:r>
+              <a:rPr sz="1500">
+                <a:solidFill>
+                  <a:srgbClr val="1B252C"/>
+                </a:solidFill>
+              </a:rPr>
+              <a:t>• Reverse proxy vers l’API.</a:t>
             </a:r>
           </a:p>
           <a:p xmlns:a="http://schemas.openxmlformats.org/drawingml/2006/main">
@@ -10830,166 +10766,49 @@
                 <a:spcPct val="122000"/>
               </a:lnSpc>
               <a:buNone/>
-              <a:defRPr sz="1725">
-                <a:solidFill>
-                  <a:srgbClr val="1B252C"/>
-                </a:solidFill>
-              </a:defRPr>
-            </a:pPr>
-            <a:r>
-              <a:rPr sz="1725">
-                <a:solidFill>
-                  <a:srgbClr val="1B252C"/>
-                </a:solidFill>
-              </a:rPr>
-              <a:t>• Architecture responsable : RGPD, médaillon, décision humaine.</a:t>
-            </a:r>
-          </a:p>
-          <a:p xmlns:a="http://schemas.openxmlformats.org/drawingml/2006/main">
-            <a:pPr>
-              <a:lnSpc>
-                <a:spcPct val="122000"/>
-              </a:lnSpc>
-              <a:buNone/>
-              <a:defRPr sz="1725">
-                <a:solidFill>
-                  <a:srgbClr val="1B252C"/>
-                </a:solidFill>
-              </a:defRPr>
-            </a:pPr>
-            <a:r>
-              <a:rPr sz="1725">
-                <a:solidFill>
-                  <a:srgbClr val="1B252C"/>
-                </a:solidFill>
-              </a:rPr>
-              <a:t>• </a:t>
-            </a:r>
-            <a:r>
-              <a:rPr sz="1725">
-                <a:solidFill>
-                  <a:srgbClr val="1B252C"/>
-                </a:solidFill>
-              </a:rPr>
-              <a:t>Prototype Run vérifiable</a:t>
-            </a:r>
-            <a:r>
-              <a:rPr sz="1725">
-                <a:solidFill>
-                  <a:srgbClr val="1B252C"/>
-                </a:solidFill>
-              </a:rPr>
-              <a:t> : HTTPS, métriques, alertes, heartbeat, promotion et rollback.</a:t>
-            </a:r>
-          </a:p>
-        </p:txBody>
-      </p:sp>
-      <p:sp>
-        <p:nvSpPr>
-          <p:cNvPr id="5" name="">
-            <a:extLst xmlns:a="http://schemas.openxmlformats.org/drawingml/2006/main">
-              <a:ext uri="{FF2B5EF4-FFF2-40B4-BE49-F238E27FC236}">
-                <a16:creationId xmlns:a16="http://schemas.microsoft.com/office/drawing/2014/main" id="{1E9F2FE7-2AC6-495F-A0A2-7078D9454534}"/>
-              </a:ext>
-            </a:extLst>
-          </p:cNvPr>
-          <p:cNvSpPr>
-            <a:spLocks xmlns:a="http://schemas.openxmlformats.org/drawingml/2006/main" noGrp="1"/>
-          </p:cNvSpPr>
-          <p:nvPr/>
-        </p:nvSpPr>
-        <p:spPr>
-          <a:xfrm xmlns:a="http://schemas.openxmlformats.org/drawingml/2006/main">
-            <a:off x="1143000" y="4857750"/>
-            <a:ext cx="9906000" cy="552450"/>
-          </a:xfrm>
-          <a:prstGeom xmlns:a="http://schemas.openxmlformats.org/drawingml/2006/main" prst="rect">
-            <a:avLst/>
-          </a:prstGeom>
-          <a:noFill xmlns:a="http://schemas.openxmlformats.org/drawingml/2006/main"/>
-          <a:ln xmlns:a="http://schemas.openxmlformats.org/drawingml/2006/main" w="0">
-            <a:noFill/>
-            <a:prstDash val="solid"/>
-          </a:ln>
-        </p:spPr>
-        <p:txBody>
-          <a:bodyPr xmlns:a="http://schemas.openxmlformats.org/drawingml/2006/main" anchor="t"/>
-          <a:lstStyle xmlns:a="http://schemas.openxmlformats.org/drawingml/2006/main"/>
-          <a:p xmlns:a="http://schemas.openxmlformats.org/drawingml/2006/main">
-            <a:pPr algn="ctr">
-              <a:buNone/>
-              <a:defRPr sz="2100" b="1">
-                <a:solidFill>
-                  <a:srgbClr val="173B57"/>
-                </a:solidFill>
-              </a:defRPr>
-            </a:pPr>
-            <a:r>
-              <a:rPr sz="2100" b="1">
-                <a:solidFill>
-                  <a:srgbClr val="173B57"/>
-                </a:solidFill>
-              </a:rPr>
-              <a:t>Une aide concrète pour accompagner à temps les étudiants à risque.</a:t>
-            </a:r>
-          </a:p>
-        </p:txBody>
-      </p:sp>
-      <p:sp>
-        <p:nvSpPr>
-          <p:cNvPr id="6" name="">
-            <a:extLst xmlns:a="http://schemas.openxmlformats.org/drawingml/2006/main">
-              <a:ext uri="{FF2B5EF4-FFF2-40B4-BE49-F238E27FC236}">
-                <a16:creationId xmlns:a16="http://schemas.microsoft.com/office/drawing/2014/main" id="{A64D75A9-DA66-4759-B2CC-DB1AD74B0DC2}"/>
-              </a:ext>
-            </a:extLst>
-          </p:cNvPr>
-          <p:cNvSpPr>
-            <a:spLocks xmlns:a="http://schemas.openxmlformats.org/drawingml/2006/main" noGrp="1"/>
-          </p:cNvSpPr>
-          <p:nvPr/>
-        </p:nvSpPr>
-        <p:spPr>
-          <a:xfrm xmlns:a="http://schemas.openxmlformats.org/drawingml/2006/main">
-            <a:off x="1143000" y="5695950"/>
-            <a:ext cx="9906000" cy="428625"/>
-          </a:xfrm>
-          <a:prstGeom xmlns:a="http://schemas.openxmlformats.org/drawingml/2006/main" prst="rect">
-            <a:avLst/>
-          </a:prstGeom>
-          <a:noFill xmlns:a="http://schemas.openxmlformats.org/drawingml/2006/main"/>
-          <a:ln xmlns:a="http://schemas.openxmlformats.org/drawingml/2006/main" w="0">
-            <a:noFill/>
-            <a:prstDash val="solid"/>
-          </a:ln>
-        </p:spPr>
-        <p:txBody>
-          <a:bodyPr xmlns:a="http://schemas.openxmlformats.org/drawingml/2006/main" anchor="t"/>
-          <a:lstStyle xmlns:a="http://schemas.openxmlformats.org/drawingml/2006/main"/>
-          <a:p xmlns:a="http://schemas.openxmlformats.org/drawingml/2006/main">
-            <a:pPr algn="ctr">
-              <a:buNone/>
-              <a:defRPr sz="1800">
-                <a:solidFill>
-                  <a:srgbClr val="2E6F9E"/>
-                </a:solidFill>
-              </a:defRPr>
-            </a:pPr>
-            <a:r>
-              <a:rPr sz="1800">
-                <a:solidFill>
-                  <a:srgbClr val="2E6F9E"/>
-                </a:solidFill>
-              </a:rPr>
-              <a:t>Merci — vos questions ?</a:t>
-            </a:r>
-          </a:p>
-        </p:txBody>
-      </p:sp>
+              <a:defRPr sz="1500">
+                <a:solidFill>
+                  <a:srgbClr val="1B252C"/>
+                </a:solidFill>
+              </a:defRPr>
+            </a:pPr>
+            <a:r>
+              <a:rPr sz="1500">
+                <a:solidFill>
+                  <a:srgbClr val="1B252C"/>
+                </a:solidFill>
+              </a:rPr>
+              <a:t>• En-têtes de sécurité actifs.</a:t>
+            </a:r>
+          </a:p>
+        </p:txBody>
+      </p:sp>
+      <p:pic>
+        <p:nvPicPr>
+          <p:cNvPr id="12" name=""/>
+          <p:cNvPicPr>
+            <a:picLocks xmlns:a="http://schemas.openxmlformats.org/drawingml/2006/main" noChangeAspect="1"/>
+          </p:cNvPicPr>
+          <p:nvPr/>
+        </p:nvPicPr>
+        <p:blipFill>
+          <a:blip xmlns:r="http://schemas.openxmlformats.org/officeDocument/2006/relationships" xmlns:a="http://schemas.openxmlformats.org/drawingml/2006/main" r:embed="R7e1a1583dc4541f6"/>
+          <a:stretch xmlns:a="http://schemas.openxmlformats.org/drawingml/2006/main"/>
+        </p:blipFill>
+        <p:spPr>
+          <a:xfrm xmlns:a="http://schemas.openxmlformats.org/drawingml/2006/main">
+            <a:off x="1087882" y="1664494"/>
+            <a:ext cx="6358636" cy="3576733"/>
+          </a:xfrm>
+          <a:prstGeom xmlns:a="http://schemas.openxmlformats.org/drawingml/2006/main" prst="rect">
+            <a:avLst/>
+          </a:prstGeom>
+        </p:spPr>
+      </p:pic>
     </p:spTree>
     <p:extLst>
       <p:ext uri="{BB962C8B-B14F-4D97-AF65-F5344CB8AC3E}">
-        <p14:creationId xmlns:p14="http://schemas.microsoft.com/office/powerpoint/2010/main" val="447710926"/>
+        <p14:creationId xmlns:p14="http://schemas.microsoft.com/office/powerpoint/2010/main" val="940859376"/>
       </p:ext>
     </p:extLst>
   </p:cSld>
@@ -11017,21 +10836,72 @@
       </p:grpSpPr>
       <p:sp>
         <p:nvSpPr>
-          <p:cNvPr id="8" name="">
-            <a:extLst xmlns:a="http://schemas.openxmlformats.org/drawingml/2006/main">
-              <a:ext uri="{FF2B5EF4-FFF2-40B4-BE49-F238E27FC236}">
-                <a16:creationId xmlns:a16="http://schemas.microsoft.com/office/drawing/2014/main" id="{8FE78200-8E93-43F2-9CE9-454429C9A537}"/>
-              </a:ext>
-            </a:extLst>
-          </p:cNvPr>
-          <p:cNvSpPr>
-            <a:spLocks xmlns:a="http://schemas.openxmlformats.org/drawingml/2006/main" noGrp="1"/>
-          </p:cNvSpPr>
-          <p:nvPr/>
-        </p:nvSpPr>
-        <p:spPr>
-          <a:xfrm xmlns:a="http://schemas.openxmlformats.org/drawingml/2006/main">
-            <a:off x="609600" y="438150"/>
+          <p:cNvPr id="13" name="">
+            <a:extLst xmlns:a="http://schemas.openxmlformats.org/drawingml/2006/main">
+              <a:ext uri="{FF2B5EF4-FFF2-40B4-BE49-F238E27FC236}">
+                <a16:creationId xmlns:a16="http://schemas.microsoft.com/office/drawing/2014/main" id="{08E5B9D7-38EE-457C-8A4A-0FADE80FEED4}"/>
+              </a:ext>
+            </a:extLst>
+          </p:cNvPr>
+          <p:cNvSpPr>
+            <a:spLocks xmlns:a="http://schemas.openxmlformats.org/drawingml/2006/main" noGrp="1"/>
+          </p:cNvSpPr>
+          <p:nvPr/>
+        </p:nvSpPr>
+        <p:spPr>
+          <a:xfrm xmlns:a="http://schemas.openxmlformats.org/drawingml/2006/main">
+            <a:off x="609600" y="323850"/>
+            <a:ext cx="4000500" cy="228600"/>
+          </a:xfrm>
+          <a:prstGeom xmlns:a="http://schemas.openxmlformats.org/drawingml/2006/main" prst="rect">
+            <a:avLst/>
+          </a:prstGeom>
+          <a:noFill xmlns:a="http://schemas.openxmlformats.org/drawingml/2006/main"/>
+          <a:ln xmlns:a="http://schemas.openxmlformats.org/drawingml/2006/main" w="0">
+            <a:noFill/>
+            <a:prstDash val="solid"/>
+          </a:ln>
+        </p:spPr>
+        <p:txBody>
+          <a:bodyPr xmlns:a="http://schemas.openxmlformats.org/drawingml/2006/main" anchor="t"/>
+          <a:lstStyle xmlns:a="http://schemas.openxmlformats.org/drawingml/2006/main"/>
+          <a:p xmlns:a="http://schemas.openxmlformats.org/drawingml/2006/main">
+            <a:pPr>
+              <a:buNone/>
+              <a:defRPr sz="975" b="1">
+                <a:solidFill>
+                  <a:srgbClr val="2E6F9E"/>
+                </a:solidFill>
+              </a:defRPr>
+            </a:pPr>
+            <a:r>
+              <a:rPr sz="975" b="1">
+                <a:solidFill>
+                  <a:srgbClr val="2E6F9E"/>
+                </a:solidFill>
+              </a:rPr>
+              <a:t>RUN</a:t>
+            </a:r>
+          </a:p>
+        </p:txBody>
+      </p:sp>
+      <p:sp>
+        <p:nvSpPr>
+          <p:cNvPr id="2" name="">
+            <a:extLst xmlns:a="http://schemas.openxmlformats.org/drawingml/2006/main">
+              <a:ext uri="{FF2B5EF4-FFF2-40B4-BE49-F238E27FC236}">
+                <a16:creationId xmlns:a16="http://schemas.microsoft.com/office/drawing/2014/main" id="{407216D8-1468-4494-9489-2281004F2869}"/>
+              </a:ext>
+            </a:extLst>
+          </p:cNvPr>
+          <p:cNvSpPr>
+            <a:spLocks xmlns:a="http://schemas.openxmlformats.org/drawingml/2006/main" noGrp="1"/>
+          </p:cNvSpPr>
+          <p:nvPr/>
+        </p:nvSpPr>
+        <p:spPr>
+          <a:xfrm xmlns:a="http://schemas.openxmlformats.org/drawingml/2006/main">
+            <a:off x="609600" y="590550"/>
             <a:ext cx="10953750" cy="552450"/>
           </a:xfrm>
           <a:prstGeom xmlns:a="http://schemas.openxmlformats.org/drawingml/2006/main" prst="rect">
@@ -11061,28 +10931,28 @@
                   <a:srgbClr val="173B57"/>
                 </a:solidFill>
               </a:rPr>
-              <a:t>Backup — questions probables du jury</a:t>
-            </a:r>
-          </a:p>
-        </p:txBody>
-      </p:sp>
-      <p:sp>
-        <p:nvSpPr>
-          <p:cNvPr id="2" name="">
-            <a:extLst xmlns:a="http://schemas.openxmlformats.org/drawingml/2006/main">
-              <a:ext uri="{FF2B5EF4-FFF2-40B4-BE49-F238E27FC236}">
-                <a16:creationId xmlns:a16="http://schemas.microsoft.com/office/drawing/2014/main" id="{880BE2F1-5B0C-407D-8AC6-AB571CAC4CAA}"/>
-              </a:ext>
-            </a:extLst>
-          </p:cNvPr>
-          <p:cNvSpPr>
-            <a:spLocks xmlns:a="http://schemas.openxmlformats.org/drawingml/2006/main" noGrp="1"/>
-          </p:cNvSpPr>
-          <p:nvPr/>
-        </p:nvSpPr>
-        <p:spPr>
-          <a:xfrm xmlns:a="http://schemas.openxmlformats.org/drawingml/2006/main">
-            <a:off x="609600" y="1028700"/>
+              <a:t>18. TCO &amp; valeur du pilote — C7 / C9</a:t>
+            </a:r>
+          </a:p>
+        </p:txBody>
+      </p:sp>
+      <p:sp>
+        <p:nvSpPr>
+          <p:cNvPr id="3" name="">
+            <a:extLst xmlns:a="http://schemas.openxmlformats.org/drawingml/2006/main">
+              <a:ext uri="{FF2B5EF4-FFF2-40B4-BE49-F238E27FC236}">
+                <a16:creationId xmlns:a16="http://schemas.microsoft.com/office/drawing/2014/main" id="{5A350BB4-D686-490A-8D2F-F263F9C1B696}"/>
+              </a:ext>
+            </a:extLst>
+          </p:cNvPr>
+          <p:cNvSpPr>
+            <a:spLocks xmlns:a="http://schemas.openxmlformats.org/drawingml/2006/main" noGrp="1"/>
+          </p:cNvSpPr>
+          <p:nvPr/>
+        </p:nvSpPr>
+        <p:spPr>
+          <a:xfrm xmlns:a="http://schemas.openxmlformats.org/drawingml/2006/main">
+            <a:off x="609600" y="1162050"/>
             <a:ext cx="10972800" cy="19050"/>
           </a:xfrm>
           <a:prstGeom xmlns:a="http://schemas.openxmlformats.org/drawingml/2006/main" prst="rect">
@@ -11099,10 +10969,10 @@
       </p:sp>
       <p:sp>
         <p:nvSpPr>
-          <p:cNvPr id="3" name="">
-            <a:extLst xmlns:a="http://schemas.openxmlformats.org/drawingml/2006/main">
-              <a:ext uri="{FF2B5EF4-FFF2-40B4-BE49-F238E27FC236}">
-                <a16:creationId xmlns:a16="http://schemas.microsoft.com/office/drawing/2014/main" id="{FBED50F1-8926-4612-8E4F-79B7F90FFA8A}"/>
+          <p:cNvPr id="4" name="">
+            <a:extLst xmlns:a="http://schemas.openxmlformats.org/drawingml/2006/main">
+              <a:ext uri="{FF2B5EF4-FFF2-40B4-BE49-F238E27FC236}">
+                <a16:creationId xmlns:a16="http://schemas.microsoft.com/office/drawing/2014/main" id="{D84B452A-4055-4478-8C17-CD03ADC6FD08}"/>
               </a:ext>
             </a:extLst>
           </p:cNvPr>
@@ -11144,6 +11014,1382 @@
                 </a:solidFill>
               </a:rPr>
               <a:t>23</a:t>
+            </a:r>
+          </a:p>
+        </p:txBody>
+      </p:sp>
+      <p:sp>
+        <p:nvSpPr>
+          <p:cNvPr id="5" name="">
+            <a:extLst xmlns:a="http://schemas.openxmlformats.org/drawingml/2006/main">
+              <a:ext uri="{FF2B5EF4-FFF2-40B4-BE49-F238E27FC236}">
+                <a16:creationId xmlns:a16="http://schemas.microsoft.com/office/drawing/2014/main" id="{3CB13EF8-6241-418B-B648-E2B10A90F0DF}"/>
+              </a:ext>
+            </a:extLst>
+          </p:cNvPr>
+          <p:cNvSpPr>
+            <a:spLocks xmlns:a="http://schemas.openxmlformats.org/drawingml/2006/main" noGrp="1"/>
+          </p:cNvSpPr>
+          <p:nvPr/>
+        </p:nvSpPr>
+        <p:spPr>
+          <a:xfrm xmlns:a="http://schemas.openxmlformats.org/drawingml/2006/main">
+            <a:off x="781050" y="1571625"/>
+            <a:ext cx="2000250" cy="666750"/>
+          </a:xfrm>
+          <a:prstGeom xmlns:a="http://schemas.openxmlformats.org/drawingml/2006/main" prst="rect">
+            <a:avLst/>
+          </a:prstGeom>
+          <a:noFill xmlns:a="http://schemas.openxmlformats.org/drawingml/2006/main"/>
+          <a:ln xmlns:a="http://schemas.openxmlformats.org/drawingml/2006/main" w="0">
+            <a:noFill/>
+            <a:prstDash val="solid"/>
+          </a:ln>
+        </p:spPr>
+        <p:txBody>
+          <a:bodyPr xmlns:a="http://schemas.openxmlformats.org/drawingml/2006/main" anchor="t"/>
+          <a:lstStyle xmlns:a="http://schemas.openxmlformats.org/drawingml/2006/main"/>
+          <a:p xmlns:a="http://schemas.openxmlformats.org/drawingml/2006/main">
+            <a:pPr>
+              <a:buNone/>
+              <a:defRPr sz="3750" b="1">
+                <a:solidFill>
+                  <a:srgbClr val="2E6F9E"/>
+                </a:solidFill>
+              </a:defRPr>
+            </a:pPr>
+            <a:r>
+              <a:rPr sz="3750" b="1">
+                <a:solidFill>
+                  <a:srgbClr val="2E6F9E"/>
+                </a:solidFill>
+              </a:rPr>
+              <a:t>TCO</a:t>
+            </a:r>
+          </a:p>
+        </p:txBody>
+      </p:sp>
+      <p:sp>
+        <p:nvSpPr>
+          <p:cNvPr id="6" name="">
+            <a:extLst xmlns:a="http://schemas.openxmlformats.org/drawingml/2006/main">
+              <a:ext uri="{FF2B5EF4-FFF2-40B4-BE49-F238E27FC236}">
+                <a16:creationId xmlns:a16="http://schemas.microsoft.com/office/drawing/2014/main" id="{B9905803-6BBE-402C-9A83-ADC024E712F4}"/>
+              </a:ext>
+            </a:extLst>
+          </p:cNvPr>
+          <p:cNvSpPr>
+            <a:spLocks xmlns:a="http://schemas.openxmlformats.org/drawingml/2006/main" noGrp="1"/>
+          </p:cNvSpPr>
+          <p:nvPr/>
+        </p:nvSpPr>
+        <p:spPr>
+          <a:xfrm xmlns:a="http://schemas.openxmlformats.org/drawingml/2006/main">
+            <a:off x="2857500" y="1695450"/>
+            <a:ext cx="8096250" cy="590550"/>
+          </a:xfrm>
+          <a:prstGeom xmlns:a="http://schemas.openxmlformats.org/drawingml/2006/main" prst="rect">
+            <a:avLst/>
+          </a:prstGeom>
+          <a:noFill xmlns:a="http://schemas.openxmlformats.org/drawingml/2006/main"/>
+          <a:ln xmlns:a="http://schemas.openxmlformats.org/drawingml/2006/main" w="0">
+            <a:noFill/>
+            <a:prstDash val="solid"/>
+          </a:ln>
+        </p:spPr>
+        <p:txBody>
+          <a:bodyPr xmlns:a="http://schemas.openxmlformats.org/drawingml/2006/main" anchor="t"/>
+          <a:lstStyle xmlns:a="http://schemas.openxmlformats.org/drawingml/2006/main"/>
+          <a:p xmlns:a="http://schemas.openxmlformats.org/drawingml/2006/main">
+            <a:pPr>
+              <a:buNone/>
+              <a:defRPr sz="1725">
+                <a:solidFill>
+                  <a:srgbClr val="1B252C"/>
+                </a:solidFill>
+              </a:defRPr>
+            </a:pPr>
+            <a:r>
+              <a:rPr sz="1725">
+                <a:solidFill>
+                  <a:srgbClr val="1B252C"/>
+                </a:solidFill>
+              </a:rPr>
+              <a:t>hébergement + sauvegardes + temps DSI/DPO + revue modèle + interventions</a:t>
+            </a:r>
+          </a:p>
+        </p:txBody>
+      </p:sp>
+      <p:sp>
+        <p:nvSpPr>
+          <p:cNvPr id="7" name="">
+            <a:extLst xmlns:a="http://schemas.openxmlformats.org/drawingml/2006/main">
+              <a:ext uri="{FF2B5EF4-FFF2-40B4-BE49-F238E27FC236}">
+                <a16:creationId xmlns:a16="http://schemas.microsoft.com/office/drawing/2014/main" id="{45AC8204-DF35-4EB4-907D-DC5E173B4515}"/>
+              </a:ext>
+            </a:extLst>
+          </p:cNvPr>
+          <p:cNvSpPr>
+            <a:spLocks xmlns:a="http://schemas.openxmlformats.org/drawingml/2006/main" noGrp="1"/>
+          </p:cNvSpPr>
+          <p:nvPr/>
+        </p:nvSpPr>
+        <p:spPr>
+          <a:xfrm xmlns:a="http://schemas.openxmlformats.org/drawingml/2006/main">
+            <a:off x="781050" y="2571750"/>
+            <a:ext cx="10382250" cy="19050"/>
+          </a:xfrm>
+          <a:prstGeom xmlns:a="http://schemas.openxmlformats.org/drawingml/2006/main" prst="rect">
+            <a:avLst/>
+          </a:prstGeom>
+          <a:solidFill xmlns:a="http://schemas.openxmlformats.org/drawingml/2006/main">
+            <a:srgbClr val="CFDCE5"/>
+          </a:solidFill>
+          <a:ln xmlns:a="http://schemas.openxmlformats.org/drawingml/2006/main" w="0">
+            <a:noFill/>
+            <a:prstDash val="solid"/>
+          </a:ln>
+        </p:spPr>
+      </p:sp>
+      <p:sp>
+        <p:nvSpPr>
+          <p:cNvPr id="8" name="">
+            <a:extLst xmlns:a="http://schemas.openxmlformats.org/drawingml/2006/main">
+              <a:ext uri="{FF2B5EF4-FFF2-40B4-BE49-F238E27FC236}">
+                <a16:creationId xmlns:a16="http://schemas.microsoft.com/office/drawing/2014/main" id="{CECD97E2-724E-495C-A39F-C0868400BD0F}"/>
+              </a:ext>
+            </a:extLst>
+          </p:cNvPr>
+          <p:cNvSpPr>
+            <a:spLocks xmlns:a="http://schemas.openxmlformats.org/drawingml/2006/main" noGrp="1"/>
+          </p:cNvSpPr>
+          <p:nvPr/>
+        </p:nvSpPr>
+        <p:spPr>
+          <a:xfrm xmlns:a="http://schemas.openxmlformats.org/drawingml/2006/main">
+            <a:off x="781050" y="2905125"/>
+            <a:ext cx="3333750" cy="400050"/>
+          </a:xfrm>
+          <a:prstGeom xmlns:a="http://schemas.openxmlformats.org/drawingml/2006/main" prst="rect">
+            <a:avLst/>
+          </a:prstGeom>
+          <a:noFill xmlns:a="http://schemas.openxmlformats.org/drawingml/2006/main"/>
+          <a:ln xmlns:a="http://schemas.openxmlformats.org/drawingml/2006/main" w="0">
+            <a:noFill/>
+            <a:prstDash val="solid"/>
+          </a:ln>
+        </p:spPr>
+        <p:txBody>
+          <a:bodyPr xmlns:a="http://schemas.openxmlformats.org/drawingml/2006/main" anchor="t"/>
+          <a:lstStyle xmlns:a="http://schemas.openxmlformats.org/drawingml/2006/main"/>
+          <a:p xmlns:a="http://schemas.openxmlformats.org/drawingml/2006/main">
+            <a:pPr>
+              <a:buNone/>
+              <a:defRPr sz="1800" b="1">
+                <a:solidFill>
+                  <a:srgbClr val="2F7D67"/>
+                </a:solidFill>
+              </a:defRPr>
+            </a:pPr>
+            <a:r>
+              <a:rPr sz="1800" b="1">
+                <a:solidFill>
+                  <a:srgbClr val="2F7D67"/>
+                </a:solidFill>
+              </a:rPr>
+              <a:t>VALEUR DU PILOTE</a:t>
+            </a:r>
+          </a:p>
+        </p:txBody>
+      </p:sp>
+      <p:sp>
+        <p:nvSpPr>
+          <p:cNvPr id="9" name="">
+            <a:extLst xmlns:a="http://schemas.openxmlformats.org/drawingml/2006/main">
+              <a:ext uri="{FF2B5EF4-FFF2-40B4-BE49-F238E27FC236}">
+                <a16:creationId xmlns:a16="http://schemas.microsoft.com/office/drawing/2014/main" id="{5FE46928-A66E-4687-983D-46F6A2277407}"/>
+              </a:ext>
+            </a:extLst>
+          </p:cNvPr>
+          <p:cNvSpPr>
+            <a:spLocks xmlns:a="http://schemas.openxmlformats.org/drawingml/2006/main" noGrp="1"/>
+          </p:cNvSpPr>
+          <p:nvPr/>
+        </p:nvSpPr>
+        <p:spPr>
+          <a:xfrm xmlns:a="http://schemas.openxmlformats.org/drawingml/2006/main">
+            <a:off x="781050" y="3476625"/>
+            <a:ext cx="5905500" cy="1000125"/>
+          </a:xfrm>
+          <a:prstGeom xmlns:a="http://schemas.openxmlformats.org/drawingml/2006/main" prst="rect">
+            <a:avLst/>
+          </a:prstGeom>
+          <a:noFill xmlns:a="http://schemas.openxmlformats.org/drawingml/2006/main"/>
+          <a:ln xmlns:a="http://schemas.openxmlformats.org/drawingml/2006/main" w="0">
+            <a:noFill/>
+            <a:prstDash val="solid"/>
+          </a:ln>
+        </p:spPr>
+        <p:txBody>
+          <a:bodyPr xmlns:a="http://schemas.openxmlformats.org/drawingml/2006/main" anchor="t"/>
+          <a:lstStyle xmlns:a="http://schemas.openxmlformats.org/drawingml/2006/main"/>
+          <a:p xmlns:a="http://schemas.openxmlformats.org/drawingml/2006/main">
+            <a:pPr>
+              <a:buNone/>
+              <a:defRPr sz="2550" b="1">
+                <a:solidFill>
+                  <a:srgbClr val="173B57"/>
+                </a:solidFill>
+              </a:defRPr>
+            </a:pPr>
+            <a:r>
+              <a:rPr sz="2550" b="1">
+                <a:solidFill>
+                  <a:srgbClr val="173B57"/>
+                </a:solidFill>
+              </a:rPr>
+              <a:t>étudiants utilement accompagnés</a:t>
+            </a:r>
+          </a:p>
+          <a:p xmlns:a="http://schemas.openxmlformats.org/drawingml/2006/main">
+            <a:pPr>
+              <a:buNone/>
+              <a:defRPr sz="2550" b="1">
+                <a:solidFill>
+                  <a:srgbClr val="173B57"/>
+                </a:solidFill>
+              </a:defRPr>
+            </a:pPr>
+            <a:r>
+              <a:rPr sz="2550" b="1">
+                <a:solidFill>
+                  <a:srgbClr val="173B57"/>
+                </a:solidFill>
+              </a:rPr>
+              <a:t>× effet causal du dispositif</a:t>
+            </a:r>
+          </a:p>
+        </p:txBody>
+      </p:sp>
+      <p:sp>
+        <p:nvSpPr>
+          <p:cNvPr id="10" name="">
+            <a:extLst xmlns:a="http://schemas.openxmlformats.org/drawingml/2006/main">
+              <a:ext uri="{FF2B5EF4-FFF2-40B4-BE49-F238E27FC236}">
+                <a16:creationId xmlns:a16="http://schemas.microsoft.com/office/drawing/2014/main" id="{AF18EA22-E80B-46F4-BC2C-D50D40CB99A6}"/>
+              </a:ext>
+            </a:extLst>
+          </p:cNvPr>
+          <p:cNvSpPr>
+            <a:spLocks xmlns:a="http://schemas.openxmlformats.org/drawingml/2006/main" noGrp="1"/>
+          </p:cNvSpPr>
+          <p:nvPr/>
+        </p:nvSpPr>
+        <p:spPr>
+          <a:xfrm xmlns:a="http://schemas.openxmlformats.org/drawingml/2006/main">
+            <a:off x="7239000" y="3095625"/>
+            <a:ext cx="4000500" cy="1809750"/>
+          </a:xfrm>
+          <a:prstGeom xmlns:a="http://schemas.openxmlformats.org/drawingml/2006/main" prst="rect">
+            <a:avLst/>
+          </a:prstGeom>
+          <a:noFill xmlns:a="http://schemas.openxmlformats.org/drawingml/2006/main"/>
+          <a:ln xmlns:a="http://schemas.openxmlformats.org/drawingml/2006/main" w="0">
+            <a:noFill/>
+            <a:prstDash val="solid"/>
+          </a:ln>
+        </p:spPr>
+        <p:txBody>
+          <a:bodyPr xmlns:a="http://schemas.openxmlformats.org/drawingml/2006/main" anchor="t"/>
+          <a:lstStyle xmlns:a="http://schemas.openxmlformats.org/drawingml/2006/main"/>
+          <a:p xmlns:a="http://schemas.openxmlformats.org/drawingml/2006/main">
+            <a:pPr>
+              <a:lnSpc>
+                <a:spcPct val="122000"/>
+              </a:lnSpc>
+              <a:buNone/>
+              <a:defRPr sz="1500">
+                <a:solidFill>
+                  <a:srgbClr val="1B252C"/>
+                </a:solidFill>
+              </a:defRPr>
+            </a:pPr>
+            <a:r>
+              <a:rPr sz="1500">
+                <a:solidFill>
+                  <a:srgbClr val="1B252C"/>
+                </a:solidFill>
+              </a:rPr>
+              <a:t>• L'AUC ne mesure pas l'impact du tutorat.</a:t>
+            </a:r>
+          </a:p>
+          <a:p xmlns:a="http://schemas.openxmlformats.org/drawingml/2006/main">
+            <a:pPr>
+              <a:lnSpc>
+                <a:spcPct val="122000"/>
+              </a:lnSpc>
+              <a:buNone/>
+              <a:defRPr sz="1500">
+                <a:solidFill>
+                  <a:srgbClr val="1B252C"/>
+                </a:solidFill>
+              </a:defRPr>
+            </a:pPr>
+            <a:r>
+              <a:rPr sz="1500">
+                <a:solidFill>
+                  <a:srgbClr val="1B252C"/>
+                </a:solidFill>
+              </a:rPr>
+              <a:t>• Pilote progressif / A-B test nécessaire.</a:t>
+            </a:r>
+          </a:p>
+          <a:p xmlns:a="http://schemas.openxmlformats.org/drawingml/2006/main">
+            <a:pPr>
+              <a:lnSpc>
+                <a:spcPct val="122000"/>
+              </a:lnSpc>
+              <a:buNone/>
+              <a:defRPr sz="1500">
+                <a:solidFill>
+                  <a:srgbClr val="1B252C"/>
+                </a:solidFill>
+              </a:defRPr>
+            </a:pPr>
+            <a:r>
+              <a:rPr sz="1500">
+                <a:solidFill>
+                  <a:srgbClr val="1B252C"/>
+                </a:solidFill>
+              </a:rPr>
+              <a:t>• Capacité des tuteurs et faux positifs intégrés au coût.</a:t>
+            </a:r>
+          </a:p>
+        </p:txBody>
+      </p:sp>
+      <p:sp>
+        <p:nvSpPr>
+          <p:cNvPr id="11" name="">
+            <a:extLst xmlns:a="http://schemas.openxmlformats.org/drawingml/2006/main">
+              <a:ext uri="{FF2B5EF4-FFF2-40B4-BE49-F238E27FC236}">
+                <a16:creationId xmlns:a16="http://schemas.microsoft.com/office/drawing/2014/main" id="{246CB9C7-47D3-4877-ACF2-AC6D9671432C}"/>
+              </a:ext>
+            </a:extLst>
+          </p:cNvPr>
+          <p:cNvSpPr>
+            <a:spLocks xmlns:a="http://schemas.openxmlformats.org/drawingml/2006/main" noGrp="1"/>
+          </p:cNvSpPr>
+          <p:nvPr/>
+        </p:nvSpPr>
+        <p:spPr>
+          <a:xfrm xmlns:a="http://schemas.openxmlformats.org/drawingml/2006/main">
+            <a:off x="1619250" y="5286375"/>
+            <a:ext cx="8953500" cy="723900"/>
+          </a:xfrm>
+          <a:prstGeom xmlns:a="http://schemas.openxmlformats.org/drawingml/2006/main" prst="rect">
+            <a:avLst/>
+          </a:prstGeom>
+          <a:solidFill xmlns:a="http://schemas.openxmlformats.org/drawingml/2006/main">
+            <a:srgbClr val="F8ECE8"/>
+          </a:solidFill>
+          <a:ln xmlns:a="http://schemas.openxmlformats.org/drawingml/2006/main" w="9525">
+            <a:solidFill>
+              <a:srgbClr val="B95D48"/>
+            </a:solidFill>
+            <a:prstDash val="solid"/>
+          </a:ln>
+        </p:spPr>
+      </p:sp>
+      <p:sp>
+        <p:nvSpPr>
+          <p:cNvPr id="12" name="">
+            <a:extLst xmlns:a="http://schemas.openxmlformats.org/drawingml/2006/main">
+              <a:ext uri="{FF2B5EF4-FFF2-40B4-BE49-F238E27FC236}">
+                <a16:creationId xmlns:a16="http://schemas.microsoft.com/office/drawing/2014/main" id="{4EBBC361-A596-4B17-8B12-B7D53D57EAEE}"/>
+              </a:ext>
+            </a:extLst>
+          </p:cNvPr>
+          <p:cNvSpPr>
+            <a:spLocks xmlns:a="http://schemas.openxmlformats.org/drawingml/2006/main" noGrp="1"/>
+          </p:cNvSpPr>
+          <p:nvPr/>
+        </p:nvSpPr>
+        <p:spPr>
+          <a:xfrm xmlns:a="http://schemas.openxmlformats.org/drawingml/2006/main">
+            <a:off x="1790700" y="5400675"/>
+            <a:ext cx="8610600" cy="495300"/>
+          </a:xfrm>
+          <a:prstGeom xmlns:a="http://schemas.openxmlformats.org/drawingml/2006/main" prst="rect">
+            <a:avLst/>
+          </a:prstGeom>
+          <a:noFill xmlns:a="http://schemas.openxmlformats.org/drawingml/2006/main"/>
+          <a:ln xmlns:a="http://schemas.openxmlformats.org/drawingml/2006/main" w="0">
+            <a:noFill/>
+            <a:prstDash val="solid"/>
+          </a:ln>
+        </p:spPr>
+        <p:txBody>
+          <a:bodyPr xmlns:a="http://schemas.openxmlformats.org/drawingml/2006/main" anchor="ctr"/>
+          <a:lstStyle xmlns:a="http://schemas.openxmlformats.org/drawingml/2006/main"/>
+          <a:p xmlns:a="http://schemas.openxmlformats.org/drawingml/2006/main">
+            <a:pPr>
+              <a:buNone/>
+              <a:defRPr sz="1500" b="1">
+                <a:solidFill>
+                  <a:srgbClr val="B95D48"/>
+                </a:solidFill>
+              </a:defRPr>
+            </a:pPr>
+            <a:r>
+              <a:rPr sz="1500" b="1">
+                <a:solidFill>
+                  <a:srgbClr val="B95D48"/>
+                </a:solidFill>
+              </a:rPr>
+              <a:t>Aucun gain financier inventé : hypothèses à valider avec l'université.</a:t>
+            </a:r>
+          </a:p>
+        </p:txBody>
+      </p:sp>
+    </p:spTree>
+    <p:extLst>
+      <p:ext uri="{BB962C8B-B14F-4D97-AF65-F5344CB8AC3E}">
+        <p14:creationId xmlns:p14="http://schemas.microsoft.com/office/powerpoint/2010/main" val="893676865"/>
+      </p:ext>
+    </p:extLst>
+  </p:cSld>
+</p:sld>
+</file>
+
+<file path=ppt/slides/slide24.xml><?xml version="1.0" encoding="utf-8"?>
+<p:sld xmlns:p="http://schemas.openxmlformats.org/presentationml/2006/main">
+  <p:cSld>
+    <p:bg>
+      <p:bgPr>
+        <a:solidFill xmlns:a="http://schemas.openxmlformats.org/drawingml/2006/main">
+          <a:srgbClr val="FFFFFF"/>
+        </a:solidFill>
+      </p:bgPr>
+    </p:bg>
+    <p:spTree>
+      <p:nvGrpSpPr>
+        <p:cNvPr id="1" name=""/>
+        <p:cNvGrpSpPr/>
+        <p:nvPr/>
+      </p:nvGrpSpPr>
+      <p:grpSpPr>
+        <a:xfrm xmlns:a="http://schemas.openxmlformats.org/drawingml/2006/main"/>
+      </p:grpSpPr>
+      <p:sp>
+        <p:nvSpPr>
+          <p:cNvPr id="7" name="">
+            <a:extLst xmlns:a="http://schemas.openxmlformats.org/drawingml/2006/main">
+              <a:ext uri="{FF2B5EF4-FFF2-40B4-BE49-F238E27FC236}">
+                <a16:creationId xmlns:a16="http://schemas.microsoft.com/office/drawing/2014/main" id="{18A77E1C-2B23-4094-9236-BEC86DCE8B41}"/>
+              </a:ext>
+            </a:extLst>
+          </p:cNvPr>
+          <p:cNvSpPr>
+            <a:spLocks xmlns:a="http://schemas.openxmlformats.org/drawingml/2006/main" noGrp="1"/>
+          </p:cNvSpPr>
+          <p:nvPr/>
+        </p:nvSpPr>
+        <p:spPr>
+          <a:xfrm xmlns:a="http://schemas.openxmlformats.org/drawingml/2006/main">
+            <a:off x="609600" y="438150"/>
+            <a:ext cx="10953750" cy="552450"/>
+          </a:xfrm>
+          <a:prstGeom xmlns:a="http://schemas.openxmlformats.org/drawingml/2006/main" prst="rect">
+            <a:avLst/>
+          </a:prstGeom>
+          <a:noFill xmlns:a="http://schemas.openxmlformats.org/drawingml/2006/main"/>
+          <a:ln xmlns:a="http://schemas.openxmlformats.org/drawingml/2006/main" w="0">
+            <a:noFill/>
+            <a:prstDash val="solid"/>
+          </a:ln>
+        </p:spPr>
+        <p:txBody>
+          <a:bodyPr xmlns:a="http://schemas.openxmlformats.org/drawingml/2006/main" anchor="t"/>
+          <a:lstStyle xmlns:a="http://schemas.openxmlformats.org/drawingml/2006/main"/>
+          <a:p xmlns:a="http://schemas.openxmlformats.org/drawingml/2006/main">
+            <a:pPr>
+              <a:buNone/>
+              <a:defRPr sz="2700" b="1">
+                <a:solidFill>
+                  <a:srgbClr val="173B57"/>
+                </a:solidFill>
+              </a:defRPr>
+            </a:pPr>
+            <a:r>
+              <a:rPr sz="2700" b="1">
+                <a:solidFill>
+                  <a:srgbClr val="173B57"/>
+                </a:solidFill>
+              </a:rPr>
+              <a:t>19. Limites &amp; recommandations</a:t>
+            </a:r>
+          </a:p>
+        </p:txBody>
+      </p:sp>
+      <p:sp>
+        <p:nvSpPr>
+          <p:cNvPr id="2" name="">
+            <a:extLst xmlns:a="http://schemas.openxmlformats.org/drawingml/2006/main">
+              <a:ext uri="{FF2B5EF4-FFF2-40B4-BE49-F238E27FC236}">
+                <a16:creationId xmlns:a16="http://schemas.microsoft.com/office/drawing/2014/main" id="{AAC52D35-FD95-46AD-B4E5-E2594CD9E567}"/>
+              </a:ext>
+            </a:extLst>
+          </p:cNvPr>
+          <p:cNvSpPr>
+            <a:spLocks xmlns:a="http://schemas.openxmlformats.org/drawingml/2006/main" noGrp="1"/>
+          </p:cNvSpPr>
+          <p:nvPr/>
+        </p:nvSpPr>
+        <p:spPr>
+          <a:xfrm xmlns:a="http://schemas.openxmlformats.org/drawingml/2006/main">
+            <a:off x="609600" y="1028700"/>
+            <a:ext cx="10972800" cy="19050"/>
+          </a:xfrm>
+          <a:prstGeom xmlns:a="http://schemas.openxmlformats.org/drawingml/2006/main" prst="rect">
+            <a:avLst/>
+          </a:prstGeom>
+          <a:solidFill xmlns:a="http://schemas.openxmlformats.org/drawingml/2006/main">
+            <a:srgbClr val="CFDCE5"/>
+          </a:solidFill>
+          <a:ln xmlns:a="http://schemas.openxmlformats.org/drawingml/2006/main" w="0">
+            <a:noFill/>
+            <a:prstDash val="solid"/>
+          </a:ln>
+        </p:spPr>
+      </p:sp>
+      <p:sp>
+        <p:nvSpPr>
+          <p:cNvPr id="3" name="">
+            <a:extLst xmlns:a="http://schemas.openxmlformats.org/drawingml/2006/main">
+              <a:ext uri="{FF2B5EF4-FFF2-40B4-BE49-F238E27FC236}">
+                <a16:creationId xmlns:a16="http://schemas.microsoft.com/office/drawing/2014/main" id="{66992DBB-B67F-4143-BBCD-9C63D33D7EBF}"/>
+              </a:ext>
+            </a:extLst>
+          </p:cNvPr>
+          <p:cNvSpPr>
+            <a:spLocks xmlns:a="http://schemas.openxmlformats.org/drawingml/2006/main" noGrp="1"/>
+          </p:cNvSpPr>
+          <p:nvPr/>
+        </p:nvSpPr>
+        <p:spPr>
+          <a:xfrm xmlns:a="http://schemas.openxmlformats.org/drawingml/2006/main">
+            <a:off x="11144250" y="6438900"/>
+            <a:ext cx="438150" cy="190500"/>
+          </a:xfrm>
+          <a:prstGeom xmlns:a="http://schemas.openxmlformats.org/drawingml/2006/main" prst="rect">
+            <a:avLst/>
+          </a:prstGeom>
+          <a:noFill xmlns:a="http://schemas.openxmlformats.org/drawingml/2006/main"/>
+          <a:ln xmlns:a="http://schemas.openxmlformats.org/drawingml/2006/main" w="0">
+            <a:noFill/>
+            <a:prstDash val="solid"/>
+          </a:ln>
+        </p:spPr>
+        <p:txBody>
+          <a:bodyPr xmlns:a="http://schemas.openxmlformats.org/drawingml/2006/main" anchor="t"/>
+          <a:lstStyle xmlns:a="http://schemas.openxmlformats.org/drawingml/2006/main"/>
+          <a:p xmlns:a="http://schemas.openxmlformats.org/drawingml/2006/main">
+            <a:pPr algn="r">
+              <a:buNone/>
+              <a:defRPr sz="900">
+                <a:solidFill>
+                  <a:srgbClr val="85929B"/>
+                </a:solidFill>
+              </a:defRPr>
+            </a:pPr>
+            <a:r>
+              <a:rPr sz="900">
+                <a:solidFill>
+                  <a:srgbClr val="85929B"/>
+                </a:solidFill>
+              </a:rPr>
+              <a:t>24</a:t>
+            </a:r>
+          </a:p>
+        </p:txBody>
+      </p:sp>
+      <p:sp>
+        <p:nvSpPr>
+          <p:cNvPr id="4" name="">
+            <a:extLst xmlns:a="http://schemas.openxmlformats.org/drawingml/2006/main">
+              <a:ext uri="{FF2B5EF4-FFF2-40B4-BE49-F238E27FC236}">
+                <a16:creationId xmlns:a16="http://schemas.microsoft.com/office/drawing/2014/main" id="{EB912D26-5B00-4C7C-AFE8-09DFA87E9904}"/>
+              </a:ext>
+            </a:extLst>
+          </p:cNvPr>
+          <p:cNvSpPr>
+            <a:spLocks xmlns:a="http://schemas.openxmlformats.org/drawingml/2006/main" noGrp="1"/>
+          </p:cNvSpPr>
+          <p:nvPr/>
+        </p:nvSpPr>
+        <p:spPr>
+          <a:xfrm xmlns:a="http://schemas.openxmlformats.org/drawingml/2006/main">
+            <a:off x="904875" y="1571625"/>
+            <a:ext cx="10287000" cy="3333750"/>
+          </a:xfrm>
+          <a:prstGeom xmlns:a="http://schemas.openxmlformats.org/drawingml/2006/main" prst="rect">
+            <a:avLst/>
+          </a:prstGeom>
+          <a:noFill xmlns:a="http://schemas.openxmlformats.org/drawingml/2006/main"/>
+          <a:ln xmlns:a="http://schemas.openxmlformats.org/drawingml/2006/main" w="0">
+            <a:noFill/>
+            <a:prstDash val="solid"/>
+          </a:ln>
+        </p:spPr>
+        <p:txBody>
+          <a:bodyPr xmlns:a="http://schemas.openxmlformats.org/drawingml/2006/main" anchor="t"/>
+          <a:lstStyle xmlns:a="http://schemas.openxmlformats.org/drawingml/2006/main"/>
+          <a:p xmlns:a="http://schemas.openxmlformats.org/drawingml/2006/main">
+            <a:pPr>
+              <a:lnSpc>
+                <a:spcPct val="122000"/>
+              </a:lnSpc>
+              <a:buNone/>
+              <a:defRPr sz="1650">
+                <a:solidFill>
+                  <a:srgbClr val="1B252C"/>
+                </a:solidFill>
+              </a:defRPr>
+            </a:pPr>
+            <a:r>
+              <a:rPr sz="1650">
+                <a:solidFill>
+                  <a:srgbClr val="1B252C"/>
+                </a:solidFill>
+              </a:rPr>
+              <a:t>• Données synthétiques : performance à revalider sur des cohortes réelles.</a:t>
+            </a:r>
+          </a:p>
+          <a:p xmlns:a="http://schemas.openxmlformats.org/drawingml/2006/main">
+            <a:pPr>
+              <a:lnSpc>
+                <a:spcPct val="122000"/>
+              </a:lnSpc>
+              <a:buNone/>
+              <a:defRPr sz="1650">
+                <a:solidFill>
+                  <a:srgbClr val="1B252C"/>
+                </a:solidFill>
+              </a:defRPr>
+            </a:pPr>
+            <a:r>
+              <a:rPr sz="1650">
+                <a:solidFill>
+                  <a:srgbClr val="1B252C"/>
+                </a:solidFill>
+              </a:rPr>
+              <a:t>• Corrélation ≠ causalité : mesurer l'effet du dispositif par pilote.</a:t>
+            </a:r>
+          </a:p>
+          <a:p xmlns:a="http://schemas.openxmlformats.org/drawingml/2006/main">
+            <a:pPr>
+              <a:lnSpc>
+                <a:spcPct val="122000"/>
+              </a:lnSpc>
+              <a:buNone/>
+              <a:defRPr sz="1650">
+                <a:solidFill>
+                  <a:srgbClr val="1B252C"/>
+                </a:solidFill>
+              </a:defRPr>
+            </a:pPr>
+            <a:r>
+              <a:rPr sz="1650">
+                <a:solidFill>
+                  <a:srgbClr val="1B252C"/>
+                </a:solidFill>
+              </a:rPr>
+              <a:t>• Production réelle : DPO, DPIA/AIPD, RBAC, coffre de secrets, sauvegardes testées.</a:t>
+            </a:r>
+          </a:p>
+          <a:p xmlns:a="http://schemas.openxmlformats.org/drawingml/2006/main">
+            <a:pPr>
+              <a:lnSpc>
+                <a:spcPct val="122000"/>
+              </a:lnSpc>
+              <a:buNone/>
+              <a:defRPr sz="1650">
+                <a:solidFill>
+                  <a:srgbClr val="1B252C"/>
+                </a:solidFill>
+              </a:defRPr>
+            </a:pPr>
+            <a:r>
+              <a:rPr sz="1650">
+                <a:solidFill>
+                  <a:srgbClr val="1B252C"/>
+                </a:solidFill>
+              </a:rPr>
+              <a:t>• Run réel : confirmer le TCO, brancher le canal d'alerte et planifier les jobs.</a:t>
+            </a:r>
+          </a:p>
+          <a:p xmlns:a="http://schemas.openxmlformats.org/drawingml/2006/main">
+            <a:pPr>
+              <a:lnSpc>
+                <a:spcPct val="122000"/>
+              </a:lnSpc>
+              <a:buNone/>
+              <a:defRPr sz="1650">
+                <a:solidFill>
+                  <a:srgbClr val="1B252C"/>
+                </a:solidFill>
+              </a:defRPr>
+            </a:pPr>
+            <a:r>
+              <a:rPr sz="1650">
+                <a:solidFill>
+                  <a:srgbClr val="1B252C"/>
+                </a:solidFill>
+              </a:rPr>
+              <a:t>• Éthique : équité continue, explication, recours et formulation non stigmatisante.</a:t>
+            </a:r>
+          </a:p>
+        </p:txBody>
+      </p:sp>
+      <p:sp>
+        <p:nvSpPr>
+          <p:cNvPr id="5" name="">
+            <a:extLst xmlns:a="http://schemas.openxmlformats.org/drawingml/2006/main">
+              <a:ext uri="{FF2B5EF4-FFF2-40B4-BE49-F238E27FC236}">
+                <a16:creationId xmlns:a16="http://schemas.microsoft.com/office/drawing/2014/main" id="{93B0E887-5075-4E9D-BD88-37AFE440B410}"/>
+              </a:ext>
+            </a:extLst>
+          </p:cNvPr>
+          <p:cNvSpPr>
+            <a:spLocks xmlns:a="http://schemas.openxmlformats.org/drawingml/2006/main" noGrp="1"/>
+          </p:cNvSpPr>
+          <p:nvPr/>
+        </p:nvSpPr>
+        <p:spPr>
+          <a:xfrm xmlns:a="http://schemas.openxmlformats.org/drawingml/2006/main">
+            <a:off x="1381125" y="5095875"/>
+            <a:ext cx="9429750" cy="742950"/>
+          </a:xfrm>
+          <a:prstGeom xmlns:a="http://schemas.openxmlformats.org/drawingml/2006/main" prst="rect">
+            <a:avLst/>
+          </a:prstGeom>
+          <a:solidFill xmlns:a="http://schemas.openxmlformats.org/drawingml/2006/main">
+            <a:srgbClr val="E8F3EF"/>
+          </a:solidFill>
+          <a:ln xmlns:a="http://schemas.openxmlformats.org/drawingml/2006/main" w="9525">
+            <a:solidFill>
+              <a:srgbClr val="2F7D67"/>
+            </a:solidFill>
+            <a:prstDash val="solid"/>
+          </a:ln>
+        </p:spPr>
+      </p:sp>
+      <p:sp>
+        <p:nvSpPr>
+          <p:cNvPr id="6" name="">
+            <a:extLst xmlns:a="http://schemas.openxmlformats.org/drawingml/2006/main">
+              <a:ext uri="{FF2B5EF4-FFF2-40B4-BE49-F238E27FC236}">
+                <a16:creationId xmlns:a16="http://schemas.microsoft.com/office/drawing/2014/main" id="{665FCA75-547D-494B-85C1-D42DEE2646CF}"/>
+              </a:ext>
+            </a:extLst>
+          </p:cNvPr>
+          <p:cNvSpPr>
+            <a:spLocks xmlns:a="http://schemas.openxmlformats.org/drawingml/2006/main" noGrp="1"/>
+          </p:cNvSpPr>
+          <p:nvPr/>
+        </p:nvSpPr>
+        <p:spPr>
+          <a:xfrm xmlns:a="http://schemas.openxmlformats.org/drawingml/2006/main">
+            <a:off x="1552575" y="5210175"/>
+            <a:ext cx="9086850" cy="514350"/>
+          </a:xfrm>
+          <a:prstGeom xmlns:a="http://schemas.openxmlformats.org/drawingml/2006/main" prst="rect">
+            <a:avLst/>
+          </a:prstGeom>
+          <a:noFill xmlns:a="http://schemas.openxmlformats.org/drawingml/2006/main"/>
+          <a:ln xmlns:a="http://schemas.openxmlformats.org/drawingml/2006/main" w="0">
+            <a:noFill/>
+            <a:prstDash val="solid"/>
+          </a:ln>
+        </p:spPr>
+        <p:txBody>
+          <a:bodyPr xmlns:a="http://schemas.openxmlformats.org/drawingml/2006/main" anchor="ctr"/>
+          <a:lstStyle xmlns:a="http://schemas.openxmlformats.org/drawingml/2006/main"/>
+          <a:p xmlns:a="http://schemas.openxmlformats.org/drawingml/2006/main">
+            <a:pPr>
+              <a:buNone/>
+              <a:defRPr sz="1500" b="1">
+                <a:solidFill>
+                  <a:srgbClr val="2F7D67"/>
+                </a:solidFill>
+              </a:defRPr>
+            </a:pPr>
+            <a:r>
+              <a:rPr sz="1500" b="1">
+                <a:solidFill>
+                  <a:srgbClr val="2F7D67"/>
+                </a:solidFill>
+              </a:rPr>
+              <a:t>Le score priorise l'accompagnement ; il ne décide jamais du parcours d'un étudiant.</a:t>
+            </a:r>
+          </a:p>
+        </p:txBody>
+      </p:sp>
+    </p:spTree>
+    <p:extLst>
+      <p:ext uri="{BB962C8B-B14F-4D97-AF65-F5344CB8AC3E}">
+        <p14:creationId xmlns:p14="http://schemas.microsoft.com/office/powerpoint/2010/main" val="1218725923"/>
+      </p:ext>
+    </p:extLst>
+  </p:cSld>
+</p:sld>
+</file>
+
+<file path=ppt/slides/slide25.xml><?xml version="1.0" encoding="utf-8"?>
+<p:sld xmlns:p="http://schemas.openxmlformats.org/presentationml/2006/main">
+  <p:cSld>
+    <p:bg>
+      <p:bgPr>
+        <a:solidFill xmlns:a="http://schemas.openxmlformats.org/drawingml/2006/main">
+          <a:srgbClr val="FFFFFF"/>
+        </a:solidFill>
+      </p:bgPr>
+    </p:bg>
+    <p:spTree>
+      <p:nvGrpSpPr>
+        <p:cNvPr id="1" name=""/>
+        <p:cNvGrpSpPr/>
+        <p:nvPr/>
+      </p:nvGrpSpPr>
+      <p:grpSpPr>
+        <a:xfrm xmlns:a="http://schemas.openxmlformats.org/drawingml/2006/main"/>
+      </p:grpSpPr>
+      <p:sp>
+        <p:nvSpPr>
+          <p:cNvPr id="7" name="">
+            <a:extLst xmlns:a="http://schemas.openxmlformats.org/drawingml/2006/main">
+              <a:ext uri="{FF2B5EF4-FFF2-40B4-BE49-F238E27FC236}">
+                <a16:creationId xmlns:a16="http://schemas.microsoft.com/office/drawing/2014/main" id="{94FD13DA-5461-453B-B426-F31AEE47BA61}"/>
+              </a:ext>
+            </a:extLst>
+          </p:cNvPr>
+          <p:cNvSpPr>
+            <a:spLocks xmlns:a="http://schemas.openxmlformats.org/drawingml/2006/main" noGrp="1"/>
+          </p:cNvSpPr>
+          <p:nvPr/>
+        </p:nvSpPr>
+        <p:spPr>
+          <a:xfrm xmlns:a="http://schemas.openxmlformats.org/drawingml/2006/main">
+            <a:off x="609600" y="438150"/>
+            <a:ext cx="10953750" cy="552450"/>
+          </a:xfrm>
+          <a:prstGeom xmlns:a="http://schemas.openxmlformats.org/drawingml/2006/main" prst="rect">
+            <a:avLst/>
+          </a:prstGeom>
+          <a:noFill xmlns:a="http://schemas.openxmlformats.org/drawingml/2006/main"/>
+          <a:ln xmlns:a="http://schemas.openxmlformats.org/drawingml/2006/main" w="0">
+            <a:noFill/>
+            <a:prstDash val="solid"/>
+          </a:ln>
+        </p:spPr>
+        <p:txBody>
+          <a:bodyPr xmlns:a="http://schemas.openxmlformats.org/drawingml/2006/main" anchor="t"/>
+          <a:lstStyle xmlns:a="http://schemas.openxmlformats.org/drawingml/2006/main"/>
+          <a:p xmlns:a="http://schemas.openxmlformats.org/drawingml/2006/main">
+            <a:pPr>
+              <a:buNone/>
+              <a:defRPr sz="2700" b="1">
+                <a:solidFill>
+                  <a:srgbClr val="173B57"/>
+                </a:solidFill>
+              </a:defRPr>
+            </a:pPr>
+            <a:r>
+              <a:rPr sz="2700" b="1">
+                <a:solidFill>
+                  <a:srgbClr val="173B57"/>
+                </a:solidFill>
+              </a:rPr>
+              <a:t>20. Conclusion — du modèle au Run, C1→C9</a:t>
+            </a:r>
+          </a:p>
+        </p:txBody>
+      </p:sp>
+      <p:sp>
+        <p:nvSpPr>
+          <p:cNvPr id="2" name="">
+            <a:extLst xmlns:a="http://schemas.openxmlformats.org/drawingml/2006/main">
+              <a:ext uri="{FF2B5EF4-FFF2-40B4-BE49-F238E27FC236}">
+                <a16:creationId xmlns:a16="http://schemas.microsoft.com/office/drawing/2014/main" id="{10EAF760-C659-4364-8793-21891BDC6BD0}"/>
+              </a:ext>
+            </a:extLst>
+          </p:cNvPr>
+          <p:cNvSpPr>
+            <a:spLocks xmlns:a="http://schemas.openxmlformats.org/drawingml/2006/main" noGrp="1"/>
+          </p:cNvSpPr>
+          <p:nvPr/>
+        </p:nvSpPr>
+        <p:spPr>
+          <a:xfrm xmlns:a="http://schemas.openxmlformats.org/drawingml/2006/main">
+            <a:off x="609600" y="1028700"/>
+            <a:ext cx="10972800" cy="19050"/>
+          </a:xfrm>
+          <a:prstGeom xmlns:a="http://schemas.openxmlformats.org/drawingml/2006/main" prst="rect">
+            <a:avLst/>
+          </a:prstGeom>
+          <a:solidFill xmlns:a="http://schemas.openxmlformats.org/drawingml/2006/main">
+            <a:srgbClr val="CFDCE5"/>
+          </a:solidFill>
+          <a:ln xmlns:a="http://schemas.openxmlformats.org/drawingml/2006/main" w="0">
+            <a:noFill/>
+            <a:prstDash val="solid"/>
+          </a:ln>
+        </p:spPr>
+      </p:sp>
+      <p:sp>
+        <p:nvSpPr>
+          <p:cNvPr id="3" name="">
+            <a:extLst xmlns:a="http://schemas.openxmlformats.org/drawingml/2006/main">
+              <a:ext uri="{FF2B5EF4-FFF2-40B4-BE49-F238E27FC236}">
+                <a16:creationId xmlns:a16="http://schemas.microsoft.com/office/drawing/2014/main" id="{4FED1F7F-F033-479D-B6AB-3E80B816FCEF}"/>
+              </a:ext>
+            </a:extLst>
+          </p:cNvPr>
+          <p:cNvSpPr>
+            <a:spLocks xmlns:a="http://schemas.openxmlformats.org/drawingml/2006/main" noGrp="1"/>
+          </p:cNvSpPr>
+          <p:nvPr/>
+        </p:nvSpPr>
+        <p:spPr>
+          <a:xfrm xmlns:a="http://schemas.openxmlformats.org/drawingml/2006/main">
+            <a:off x="11144250" y="6438900"/>
+            <a:ext cx="438150" cy="190500"/>
+          </a:xfrm>
+          <a:prstGeom xmlns:a="http://schemas.openxmlformats.org/drawingml/2006/main" prst="rect">
+            <a:avLst/>
+          </a:prstGeom>
+          <a:noFill xmlns:a="http://schemas.openxmlformats.org/drawingml/2006/main"/>
+          <a:ln xmlns:a="http://schemas.openxmlformats.org/drawingml/2006/main" w="0">
+            <a:noFill/>
+            <a:prstDash val="solid"/>
+          </a:ln>
+        </p:spPr>
+        <p:txBody>
+          <a:bodyPr xmlns:a="http://schemas.openxmlformats.org/drawingml/2006/main" anchor="t"/>
+          <a:lstStyle xmlns:a="http://schemas.openxmlformats.org/drawingml/2006/main"/>
+          <a:p xmlns:a="http://schemas.openxmlformats.org/drawingml/2006/main">
+            <a:pPr algn="r">
+              <a:buNone/>
+              <a:defRPr sz="900">
+                <a:solidFill>
+                  <a:srgbClr val="85929B"/>
+                </a:solidFill>
+              </a:defRPr>
+            </a:pPr>
+            <a:r>
+              <a:rPr sz="900">
+                <a:solidFill>
+                  <a:srgbClr val="85929B"/>
+                </a:solidFill>
+              </a:rPr>
+              <a:t>25</a:t>
+            </a:r>
+          </a:p>
+        </p:txBody>
+      </p:sp>
+      <p:sp>
+        <p:nvSpPr>
+          <p:cNvPr id="4" name="">
+            <a:extLst xmlns:a="http://schemas.openxmlformats.org/drawingml/2006/main">
+              <a:ext uri="{FF2B5EF4-FFF2-40B4-BE49-F238E27FC236}">
+                <a16:creationId xmlns:a16="http://schemas.microsoft.com/office/drawing/2014/main" id="{CCA343F9-98D8-412B-9C24-F9BC838BE751}"/>
+              </a:ext>
+            </a:extLst>
+          </p:cNvPr>
+          <p:cNvSpPr>
+            <a:spLocks xmlns:a="http://schemas.openxmlformats.org/drawingml/2006/main" noGrp="1"/>
+          </p:cNvSpPr>
+          <p:nvPr/>
+        </p:nvSpPr>
+        <p:spPr>
+          <a:xfrm xmlns:a="http://schemas.openxmlformats.org/drawingml/2006/main">
+            <a:off x="1000125" y="1666875"/>
+            <a:ext cx="10096500" cy="2857500"/>
+          </a:xfrm>
+          <a:prstGeom xmlns:a="http://schemas.openxmlformats.org/drawingml/2006/main" prst="rect">
+            <a:avLst/>
+          </a:prstGeom>
+          <a:noFill xmlns:a="http://schemas.openxmlformats.org/drawingml/2006/main"/>
+          <a:ln xmlns:a="http://schemas.openxmlformats.org/drawingml/2006/main" w="0">
+            <a:noFill/>
+            <a:prstDash val="solid"/>
+          </a:ln>
+        </p:spPr>
+        <p:txBody>
+          <a:bodyPr xmlns:a="http://schemas.openxmlformats.org/drawingml/2006/main" anchor="t"/>
+          <a:lstStyle xmlns:a="http://schemas.openxmlformats.org/drawingml/2006/main"/>
+          <a:p xmlns:a="http://schemas.openxmlformats.org/drawingml/2006/main">
+            <a:pPr>
+              <a:lnSpc>
+                <a:spcPct val="122000"/>
+              </a:lnSpc>
+              <a:buNone/>
+              <a:defRPr sz="1725">
+                <a:solidFill>
+                  <a:srgbClr val="1B252C"/>
+                </a:solidFill>
+              </a:defRPr>
+            </a:pPr>
+            <a:r>
+              <a:rPr sz="1725">
+                <a:solidFill>
+                  <a:srgbClr val="1B252C"/>
+                </a:solidFill>
+              </a:rPr>
+              <a:t>• Rigueur anti-fuite : trois pièges neutralisés et garde-fou codé.</a:t>
+            </a:r>
+          </a:p>
+          <a:p xmlns:a="http://schemas.openxmlformats.org/drawingml/2006/main">
+            <a:pPr>
+              <a:lnSpc>
+                <a:spcPct val="122000"/>
+              </a:lnSpc>
+              <a:buNone/>
+              <a:defRPr sz="1725">
+                <a:solidFill>
+                  <a:srgbClr val="1B252C"/>
+                </a:solidFill>
+              </a:defRPr>
+            </a:pPr>
+            <a:r>
+              <a:rPr sz="1725">
+                <a:solidFill>
+                  <a:srgbClr val="1B252C"/>
+                </a:solidFill>
+              </a:rPr>
+              <a:t>• Modèle explicable : AUC 0,95, rappel 95,9 %, seuil métier assumé.</a:t>
+            </a:r>
+          </a:p>
+          <a:p xmlns:a="http://schemas.openxmlformats.org/drawingml/2006/main">
+            <a:pPr>
+              <a:lnSpc>
+                <a:spcPct val="122000"/>
+              </a:lnSpc>
+              <a:buNone/>
+              <a:defRPr sz="1725">
+                <a:solidFill>
+                  <a:srgbClr val="1B252C"/>
+                </a:solidFill>
+              </a:defRPr>
+            </a:pPr>
+            <a:r>
+              <a:rPr sz="1725">
+                <a:solidFill>
+                  <a:srgbClr val="1B252C"/>
+                </a:solidFill>
+              </a:rPr>
+              <a:t>• Architecture responsable : RGPD, médaillon, décision humaine.</a:t>
+            </a:r>
+          </a:p>
+          <a:p xmlns:a="http://schemas.openxmlformats.org/drawingml/2006/main">
+            <a:pPr>
+              <a:lnSpc>
+                <a:spcPct val="122000"/>
+              </a:lnSpc>
+              <a:buNone/>
+              <a:defRPr sz="1725">
+                <a:solidFill>
+                  <a:srgbClr val="1B252C"/>
+                </a:solidFill>
+              </a:defRPr>
+            </a:pPr>
+            <a:r>
+              <a:rPr sz="1725">
+                <a:solidFill>
+                  <a:srgbClr val="1B252C"/>
+                </a:solidFill>
+              </a:rPr>
+              <a:t>• </a:t>
+            </a:r>
+            <a:r>
+              <a:rPr sz="1725">
+                <a:solidFill>
+                  <a:srgbClr val="1B252C"/>
+                </a:solidFill>
+              </a:rPr>
+              <a:t>Prototype Run vérifiable</a:t>
+            </a:r>
+            <a:r>
+              <a:rPr sz="1725">
+                <a:solidFill>
+                  <a:srgbClr val="1B252C"/>
+                </a:solidFill>
+              </a:rPr>
+              <a:t> : HTTPS, métriques, alertes, heartbeat, promotion et rollback.</a:t>
+            </a:r>
+          </a:p>
+        </p:txBody>
+      </p:sp>
+      <p:sp>
+        <p:nvSpPr>
+          <p:cNvPr id="5" name="">
+            <a:extLst xmlns:a="http://schemas.openxmlformats.org/drawingml/2006/main">
+              <a:ext uri="{FF2B5EF4-FFF2-40B4-BE49-F238E27FC236}">
+                <a16:creationId xmlns:a16="http://schemas.microsoft.com/office/drawing/2014/main" id="{1E9F2FE7-2AC6-495F-A0A2-7078D9454534}"/>
+              </a:ext>
+            </a:extLst>
+          </p:cNvPr>
+          <p:cNvSpPr>
+            <a:spLocks xmlns:a="http://schemas.openxmlformats.org/drawingml/2006/main" noGrp="1"/>
+          </p:cNvSpPr>
+          <p:nvPr/>
+        </p:nvSpPr>
+        <p:spPr>
+          <a:xfrm xmlns:a="http://schemas.openxmlformats.org/drawingml/2006/main">
+            <a:off x="1143000" y="4857750"/>
+            <a:ext cx="9906000" cy="552450"/>
+          </a:xfrm>
+          <a:prstGeom xmlns:a="http://schemas.openxmlformats.org/drawingml/2006/main" prst="rect">
+            <a:avLst/>
+          </a:prstGeom>
+          <a:noFill xmlns:a="http://schemas.openxmlformats.org/drawingml/2006/main"/>
+          <a:ln xmlns:a="http://schemas.openxmlformats.org/drawingml/2006/main" w="0">
+            <a:noFill/>
+            <a:prstDash val="solid"/>
+          </a:ln>
+        </p:spPr>
+        <p:txBody>
+          <a:bodyPr xmlns:a="http://schemas.openxmlformats.org/drawingml/2006/main" anchor="t"/>
+          <a:lstStyle xmlns:a="http://schemas.openxmlformats.org/drawingml/2006/main"/>
+          <a:p xmlns:a="http://schemas.openxmlformats.org/drawingml/2006/main">
+            <a:pPr algn="ctr">
+              <a:buNone/>
+              <a:defRPr sz="2100" b="1">
+                <a:solidFill>
+                  <a:srgbClr val="173B57"/>
+                </a:solidFill>
+              </a:defRPr>
+            </a:pPr>
+            <a:r>
+              <a:rPr sz="2100" b="1">
+                <a:solidFill>
+                  <a:srgbClr val="173B57"/>
+                </a:solidFill>
+              </a:rPr>
+              <a:t>Une aide concrète pour accompagner à temps les étudiants à risque.</a:t>
+            </a:r>
+          </a:p>
+        </p:txBody>
+      </p:sp>
+      <p:sp>
+        <p:nvSpPr>
+          <p:cNvPr id="6" name="">
+            <a:extLst xmlns:a="http://schemas.openxmlformats.org/drawingml/2006/main">
+              <a:ext uri="{FF2B5EF4-FFF2-40B4-BE49-F238E27FC236}">
+                <a16:creationId xmlns:a16="http://schemas.microsoft.com/office/drawing/2014/main" id="{A64D75A9-DA66-4759-B2CC-DB1AD74B0DC2}"/>
+              </a:ext>
+            </a:extLst>
+          </p:cNvPr>
+          <p:cNvSpPr>
+            <a:spLocks xmlns:a="http://schemas.openxmlformats.org/drawingml/2006/main" noGrp="1"/>
+          </p:cNvSpPr>
+          <p:nvPr/>
+        </p:nvSpPr>
+        <p:spPr>
+          <a:xfrm xmlns:a="http://schemas.openxmlformats.org/drawingml/2006/main">
+            <a:off x="1143000" y="5695950"/>
+            <a:ext cx="9906000" cy="428625"/>
+          </a:xfrm>
+          <a:prstGeom xmlns:a="http://schemas.openxmlformats.org/drawingml/2006/main" prst="rect">
+            <a:avLst/>
+          </a:prstGeom>
+          <a:noFill xmlns:a="http://schemas.openxmlformats.org/drawingml/2006/main"/>
+          <a:ln xmlns:a="http://schemas.openxmlformats.org/drawingml/2006/main" w="0">
+            <a:noFill/>
+            <a:prstDash val="solid"/>
+          </a:ln>
+        </p:spPr>
+        <p:txBody>
+          <a:bodyPr xmlns:a="http://schemas.openxmlformats.org/drawingml/2006/main" anchor="t"/>
+          <a:lstStyle xmlns:a="http://schemas.openxmlformats.org/drawingml/2006/main"/>
+          <a:p xmlns:a="http://schemas.openxmlformats.org/drawingml/2006/main">
+            <a:pPr algn="ctr">
+              <a:buNone/>
+              <a:defRPr sz="1800">
+                <a:solidFill>
+                  <a:srgbClr val="2E6F9E"/>
+                </a:solidFill>
+              </a:defRPr>
+            </a:pPr>
+            <a:r>
+              <a:rPr sz="1800">
+                <a:solidFill>
+                  <a:srgbClr val="2E6F9E"/>
+                </a:solidFill>
+              </a:rPr>
+              <a:t>Merci — vos questions ?</a:t>
+            </a:r>
+          </a:p>
+        </p:txBody>
+      </p:sp>
+    </p:spTree>
+    <p:extLst>
+      <p:ext uri="{BB962C8B-B14F-4D97-AF65-F5344CB8AC3E}">
+        <p14:creationId xmlns:p14="http://schemas.microsoft.com/office/powerpoint/2010/main" val="447710926"/>
+      </p:ext>
+    </p:extLst>
+  </p:cSld>
+</p:sld>
+</file>
+
+<file path=ppt/slides/slide26.xml><?xml version="1.0" encoding="utf-8"?>
+<p:sld xmlns:p="http://schemas.openxmlformats.org/presentationml/2006/main">
+  <p:cSld>
+    <p:bg>
+      <p:bgPr>
+        <a:solidFill xmlns:a="http://schemas.openxmlformats.org/drawingml/2006/main">
+          <a:srgbClr val="FFFFFF"/>
+        </a:solidFill>
+      </p:bgPr>
+    </p:bg>
+    <p:spTree>
+      <p:nvGrpSpPr>
+        <p:cNvPr id="1" name=""/>
+        <p:cNvGrpSpPr/>
+        <p:nvPr/>
+      </p:nvGrpSpPr>
+      <p:grpSpPr>
+        <a:xfrm xmlns:a="http://schemas.openxmlformats.org/drawingml/2006/main"/>
+      </p:grpSpPr>
+      <p:sp>
+        <p:nvSpPr>
+          <p:cNvPr id="8" name="">
+            <a:extLst xmlns:a="http://schemas.openxmlformats.org/drawingml/2006/main">
+              <a:ext uri="{FF2B5EF4-FFF2-40B4-BE49-F238E27FC236}">
+                <a16:creationId xmlns:a16="http://schemas.microsoft.com/office/drawing/2014/main" id="{8FE78200-8E93-43F2-9CE9-454429C9A537}"/>
+              </a:ext>
+            </a:extLst>
+          </p:cNvPr>
+          <p:cNvSpPr>
+            <a:spLocks xmlns:a="http://schemas.openxmlformats.org/drawingml/2006/main" noGrp="1"/>
+          </p:cNvSpPr>
+          <p:nvPr/>
+        </p:nvSpPr>
+        <p:spPr>
+          <a:xfrm xmlns:a="http://schemas.openxmlformats.org/drawingml/2006/main">
+            <a:off x="609600" y="438150"/>
+            <a:ext cx="10953750" cy="552450"/>
+          </a:xfrm>
+          <a:prstGeom xmlns:a="http://schemas.openxmlformats.org/drawingml/2006/main" prst="rect">
+            <a:avLst/>
+          </a:prstGeom>
+          <a:noFill xmlns:a="http://schemas.openxmlformats.org/drawingml/2006/main"/>
+          <a:ln xmlns:a="http://schemas.openxmlformats.org/drawingml/2006/main" w="0">
+            <a:noFill/>
+            <a:prstDash val="solid"/>
+          </a:ln>
+        </p:spPr>
+        <p:txBody>
+          <a:bodyPr xmlns:a="http://schemas.openxmlformats.org/drawingml/2006/main" anchor="t"/>
+          <a:lstStyle xmlns:a="http://schemas.openxmlformats.org/drawingml/2006/main"/>
+          <a:p xmlns:a="http://schemas.openxmlformats.org/drawingml/2006/main">
+            <a:pPr>
+              <a:buNone/>
+              <a:defRPr sz="2700" b="1">
+                <a:solidFill>
+                  <a:srgbClr val="173B57"/>
+                </a:solidFill>
+              </a:defRPr>
+            </a:pPr>
+            <a:r>
+              <a:rPr sz="2700" b="1">
+                <a:solidFill>
+                  <a:srgbClr val="173B57"/>
+                </a:solidFill>
+              </a:rPr>
+              <a:t>Backup — questions probables du jury</a:t>
+            </a:r>
+          </a:p>
+        </p:txBody>
+      </p:sp>
+      <p:sp>
+        <p:nvSpPr>
+          <p:cNvPr id="2" name="">
+            <a:extLst xmlns:a="http://schemas.openxmlformats.org/drawingml/2006/main">
+              <a:ext uri="{FF2B5EF4-FFF2-40B4-BE49-F238E27FC236}">
+                <a16:creationId xmlns:a16="http://schemas.microsoft.com/office/drawing/2014/main" id="{880BE2F1-5B0C-407D-8AC6-AB571CAC4CAA}"/>
+              </a:ext>
+            </a:extLst>
+          </p:cNvPr>
+          <p:cNvSpPr>
+            <a:spLocks xmlns:a="http://schemas.openxmlformats.org/drawingml/2006/main" noGrp="1"/>
+          </p:cNvSpPr>
+          <p:nvPr/>
+        </p:nvSpPr>
+        <p:spPr>
+          <a:xfrm xmlns:a="http://schemas.openxmlformats.org/drawingml/2006/main">
+            <a:off x="609600" y="1028700"/>
+            <a:ext cx="10972800" cy="19050"/>
+          </a:xfrm>
+          <a:prstGeom xmlns:a="http://schemas.openxmlformats.org/drawingml/2006/main" prst="rect">
+            <a:avLst/>
+          </a:prstGeom>
+          <a:solidFill xmlns:a="http://schemas.openxmlformats.org/drawingml/2006/main">
+            <a:srgbClr val="CFDCE5"/>
+          </a:solidFill>
+          <a:ln xmlns:a="http://schemas.openxmlformats.org/drawingml/2006/main" w="0">
+            <a:noFill/>
+            <a:prstDash val="solid"/>
+          </a:ln>
+        </p:spPr>
+      </p:sp>
+      <p:sp>
+        <p:nvSpPr>
+          <p:cNvPr id="3" name="">
+            <a:extLst xmlns:a="http://schemas.openxmlformats.org/drawingml/2006/main">
+              <a:ext uri="{FF2B5EF4-FFF2-40B4-BE49-F238E27FC236}">
+                <a16:creationId xmlns:a16="http://schemas.microsoft.com/office/drawing/2014/main" id="{FBED50F1-8926-4612-8E4F-79B7F90FFA8A}"/>
+              </a:ext>
+            </a:extLst>
+          </p:cNvPr>
+          <p:cNvSpPr>
+            <a:spLocks xmlns:a="http://schemas.openxmlformats.org/drawingml/2006/main" noGrp="1"/>
+          </p:cNvSpPr>
+          <p:nvPr/>
+        </p:nvSpPr>
+        <p:spPr>
+          <a:xfrm xmlns:a="http://schemas.openxmlformats.org/drawingml/2006/main">
+            <a:off x="11144250" y="6438900"/>
+            <a:ext cx="438150" cy="190500"/>
+          </a:xfrm>
+          <a:prstGeom xmlns:a="http://schemas.openxmlformats.org/drawingml/2006/main" prst="rect">
+            <a:avLst/>
+          </a:prstGeom>
+          <a:noFill xmlns:a="http://schemas.openxmlformats.org/drawingml/2006/main"/>
+          <a:ln xmlns:a="http://schemas.openxmlformats.org/drawingml/2006/main" w="0">
+            <a:noFill/>
+            <a:prstDash val="solid"/>
+          </a:ln>
+        </p:spPr>
+        <p:txBody>
+          <a:bodyPr xmlns:a="http://schemas.openxmlformats.org/drawingml/2006/main" anchor="t"/>
+          <a:lstStyle xmlns:a="http://schemas.openxmlformats.org/drawingml/2006/main"/>
+          <a:p xmlns:a="http://schemas.openxmlformats.org/drawingml/2006/main">
+            <a:pPr algn="r">
+              <a:buNone/>
+              <a:defRPr sz="900">
+                <a:solidFill>
+                  <a:srgbClr val="85929B"/>
+                </a:solidFill>
+              </a:defRPr>
+            </a:pPr>
+            <a:r>
+              <a:rPr sz="900">
+                <a:solidFill>
+                  <a:srgbClr val="85929B"/>
+                </a:solidFill>
+              </a:rPr>
+              <a:t>26</a:t>
             </a:r>
           </a:p>
         </p:txBody>
@@ -14233,7 +15479,7 @@
           <p:nvPr/>
         </p:nvPicPr>
         <p:blipFill>
-          <a:blip xmlns:r="http://schemas.openxmlformats.org/officeDocument/2006/relationships" xmlns:a="http://schemas.openxmlformats.org/drawingml/2006/main" r:embed="Rf732f8c640b2458b"/>
+          <a:blip xmlns:r="http://schemas.openxmlformats.org/officeDocument/2006/relationships" xmlns:a="http://schemas.openxmlformats.org/drawingml/2006/main" r:embed="R2ac645e9c744411f"/>
           <a:stretch xmlns:a="http://schemas.openxmlformats.org/drawingml/2006/main"/>
         </p:blipFill>
         <p:spPr>
@@ -14513,7 +15759,7 @@
           <p:nvPr/>
         </p:nvPicPr>
         <p:blipFill>
-          <a:blip xmlns:r="http://schemas.openxmlformats.org/officeDocument/2006/relationships" xmlns:a="http://schemas.openxmlformats.org/drawingml/2006/main" r:embed="Rb3a4563851e74141"/>
+          <a:blip xmlns:r="http://schemas.openxmlformats.org/officeDocument/2006/relationships" xmlns:a="http://schemas.openxmlformats.org/drawingml/2006/main" r:embed="R98cd639614874d1e"/>
           <a:stretch xmlns:a="http://schemas.openxmlformats.org/drawingml/2006/main"/>
         </p:blipFill>
         <p:spPr>

</xml_diff>

<commit_message>
feat(mlops): operationalize mlflow and structured logs
</commit_message>
<xml_diff>
--- a/reports/SUPPORT_SOUTENANCE.pptx
+++ b/reports/SUPPORT_SOUTENANCE.pptx
@@ -2,38 +2,41 @@
 <file path=ppt/presentation.xml><?xml version="1.0" encoding="utf-8"?>
 <p:presentation xmlns:p="http://schemas.openxmlformats.org/presentationml/2006/main">
   <p:sldMasterIdLst>
-    <p:sldMasterId xmlns:r="http://schemas.openxmlformats.org/officeDocument/2006/relationships" id="2147483648" r:id="Rbae71c62ba024916"/>
+    <p:sldMasterId xmlns:r="http://schemas.openxmlformats.org/officeDocument/2006/relationships" id="2147483648" r:id="R0913af8214bf4b49"/>
   </p:sldMasterIdLst>
   <p:notesMasterIdLst>
-    <p:notesMasterId xmlns:r="http://schemas.openxmlformats.org/officeDocument/2006/relationships" r:id="Rd5bec46d883b4d93"/>
+    <p:notesMasterId xmlns:r="http://schemas.openxmlformats.org/officeDocument/2006/relationships" r:id="R04c9eb37dfa04606"/>
   </p:notesMasterIdLst>
   <p:sldIdLst>
-    <p:sldId xmlns:r="http://schemas.openxmlformats.org/officeDocument/2006/relationships" id="256" r:id="Rc201d5a0eb274666"/>
-    <p:sldId xmlns:r="http://schemas.openxmlformats.org/officeDocument/2006/relationships" id="257" r:id="Rc1015eecb4224d7c"/>
-    <p:sldId xmlns:r="http://schemas.openxmlformats.org/officeDocument/2006/relationships" id="258" r:id="R59d9f3bda7b246b6"/>
-    <p:sldId xmlns:r="http://schemas.openxmlformats.org/officeDocument/2006/relationships" id="259" r:id="R66197c7ac0b34159"/>
-    <p:sldId xmlns:r="http://schemas.openxmlformats.org/officeDocument/2006/relationships" id="260" r:id="Rb58960fa96de4cfa"/>
-    <p:sldId xmlns:r="http://schemas.openxmlformats.org/officeDocument/2006/relationships" id="261" r:id="R9b400aa91e364069"/>
-    <p:sldId xmlns:r="http://schemas.openxmlformats.org/officeDocument/2006/relationships" id="262" r:id="R2d718e1a83dc4923"/>
-    <p:sldId xmlns:r="http://schemas.openxmlformats.org/officeDocument/2006/relationships" id="263" r:id="R4336961366a84cb6"/>
-    <p:sldId xmlns:r="http://schemas.openxmlformats.org/officeDocument/2006/relationships" id="264" r:id="R83b3e3ea4ed447a3"/>
-    <p:sldId xmlns:r="http://schemas.openxmlformats.org/officeDocument/2006/relationships" id="265" r:id="R6a951fd55a214a29"/>
-    <p:sldId xmlns:r="http://schemas.openxmlformats.org/officeDocument/2006/relationships" id="266" r:id="R353535bba7fd4565"/>
-    <p:sldId xmlns:r="http://schemas.openxmlformats.org/officeDocument/2006/relationships" id="267" r:id="R749baf3fcf394eee"/>
-    <p:sldId xmlns:r="http://schemas.openxmlformats.org/officeDocument/2006/relationships" id="268" r:id="Rc9171f168ba14622"/>
-    <p:sldId xmlns:r="http://schemas.openxmlformats.org/officeDocument/2006/relationships" id="269" r:id="R5a5fc4be9b9f455f"/>
-    <p:sldId xmlns:r="http://schemas.openxmlformats.org/officeDocument/2006/relationships" id="270" r:id="R8291897159b946ef"/>
-    <p:sldId xmlns:r="http://schemas.openxmlformats.org/officeDocument/2006/relationships" id="271" r:id="R2d8a8f40f5bd44ae"/>
-    <p:sldId xmlns:r="http://schemas.openxmlformats.org/officeDocument/2006/relationships" id="272" r:id="Re0c7e29deb41423e"/>
-    <p:sldId xmlns:r="http://schemas.openxmlformats.org/officeDocument/2006/relationships" id="273" r:id="Ra6bae566d38d43d9"/>
-    <p:sldId xmlns:r="http://schemas.openxmlformats.org/officeDocument/2006/relationships" id="274" r:id="R44e8ebbec4264922"/>
-    <p:sldId xmlns:r="http://schemas.openxmlformats.org/officeDocument/2006/relationships" id="275" r:id="R1c45ed2576784f9c"/>
-    <p:sldId xmlns:r="http://schemas.openxmlformats.org/officeDocument/2006/relationships" id="276" r:id="R9c857370449a4fc3"/>
-    <p:sldId xmlns:r="http://schemas.openxmlformats.org/officeDocument/2006/relationships" id="277" r:id="R14765cda962e4504"/>
-    <p:sldId xmlns:r="http://schemas.openxmlformats.org/officeDocument/2006/relationships" id="278" r:id="R63dc25cadfde49da"/>
-    <p:sldId xmlns:r="http://schemas.openxmlformats.org/officeDocument/2006/relationships" id="279" r:id="Rdb87320dcce04292"/>
-    <p:sldId xmlns:r="http://schemas.openxmlformats.org/officeDocument/2006/relationships" id="280" r:id="R921a0bfe23e74c15"/>
-    <p:sldId xmlns:r="http://schemas.openxmlformats.org/officeDocument/2006/relationships" id="281" r:id="Rad3a0e655a73432a"/>
+    <p:sldId xmlns:r="http://schemas.openxmlformats.org/officeDocument/2006/relationships" id="256" r:id="Rf13875fca1394755"/>
+    <p:sldId xmlns:r="http://schemas.openxmlformats.org/officeDocument/2006/relationships" id="257" r:id="R990b6b364a484a59"/>
+    <p:sldId xmlns:r="http://schemas.openxmlformats.org/officeDocument/2006/relationships" id="258" r:id="Re920494198754b99"/>
+    <p:sldId xmlns:r="http://schemas.openxmlformats.org/officeDocument/2006/relationships" id="259" r:id="R1f95fcad121c496d"/>
+    <p:sldId xmlns:r="http://schemas.openxmlformats.org/officeDocument/2006/relationships" id="260" r:id="R2f442899c08f418e"/>
+    <p:sldId xmlns:r="http://schemas.openxmlformats.org/officeDocument/2006/relationships" id="261" r:id="R3a78991d277f4241"/>
+    <p:sldId xmlns:r="http://schemas.openxmlformats.org/officeDocument/2006/relationships" id="262" r:id="R57b87e67be264cae"/>
+    <p:sldId xmlns:r="http://schemas.openxmlformats.org/officeDocument/2006/relationships" id="263" r:id="Rc93f1bf8ab4f43fb"/>
+    <p:sldId xmlns:r="http://schemas.openxmlformats.org/officeDocument/2006/relationships" id="264" r:id="R1f5a5beea0e8440d"/>
+    <p:sldId xmlns:r="http://schemas.openxmlformats.org/officeDocument/2006/relationships" id="265" r:id="Rc2fa8d66acab4861"/>
+    <p:sldId xmlns:r="http://schemas.openxmlformats.org/officeDocument/2006/relationships" id="266" r:id="R5fa5bdc153374708"/>
+    <p:sldId xmlns:r="http://schemas.openxmlformats.org/officeDocument/2006/relationships" id="267" r:id="R261f6b298d254450"/>
+    <p:sldId xmlns:r="http://schemas.openxmlformats.org/officeDocument/2006/relationships" id="268" r:id="Rfa6be0c32e6d4b91"/>
+    <p:sldId xmlns:r="http://schemas.openxmlformats.org/officeDocument/2006/relationships" id="269" r:id="R994c1990c3ed46ca"/>
+    <p:sldId xmlns:r="http://schemas.openxmlformats.org/officeDocument/2006/relationships" id="270" r:id="R626870adfcd74752"/>
+    <p:sldId xmlns:r="http://schemas.openxmlformats.org/officeDocument/2006/relationships" id="271" r:id="R29fdf0e6ade04547"/>
+    <p:sldId xmlns:r="http://schemas.openxmlformats.org/officeDocument/2006/relationships" id="272" r:id="Rd6176ce85a5e4d3e"/>
+    <p:sldId xmlns:r="http://schemas.openxmlformats.org/officeDocument/2006/relationships" id="273" r:id="R04f6333517bc4325"/>
+    <p:sldId xmlns:r="http://schemas.openxmlformats.org/officeDocument/2006/relationships" id="274" r:id="R90578fb22b924d3f"/>
+    <p:sldId xmlns:r="http://schemas.openxmlformats.org/officeDocument/2006/relationships" id="275" r:id="R2df71844940d43dc"/>
+    <p:sldId xmlns:r="http://schemas.openxmlformats.org/officeDocument/2006/relationships" id="276" r:id="Rc607880feaae47c6"/>
+    <p:sldId xmlns:r="http://schemas.openxmlformats.org/officeDocument/2006/relationships" id="277" r:id="R4ad1d8f97fc74e16"/>
+    <p:sldId xmlns:r="http://schemas.openxmlformats.org/officeDocument/2006/relationships" id="278" r:id="R154dd6e28eb34f6d"/>
+    <p:sldId xmlns:r="http://schemas.openxmlformats.org/officeDocument/2006/relationships" id="279" r:id="R31bd3bb5ab504ffc"/>
+    <p:sldId xmlns:r="http://schemas.openxmlformats.org/officeDocument/2006/relationships" id="280" r:id="R0bcf649aa0c44601"/>
+    <p:sldId xmlns:r="http://schemas.openxmlformats.org/officeDocument/2006/relationships" id="281" r:id="Re73aa3a9a7c44610"/>
+    <p:sldId xmlns:r="http://schemas.openxmlformats.org/officeDocument/2006/relationships" id="282" r:id="Ra9c6510cd27249b1"/>
+    <p:sldId xmlns:r="http://schemas.openxmlformats.org/officeDocument/2006/relationships" id="283" r:id="R6857903624164050"/>
+    <p:sldId xmlns:r="http://schemas.openxmlformats.org/officeDocument/2006/relationships" id="284" r:id="R3b877b09f428408e"/>
   </p:sldIdLst>
   <p:sldSz cx="12192000" cy="6858000"/>
   <p:notesSz cx="6858000" cy="9144000"/>
@@ -1825,21 +1828,7 @@
         <p:txBody>
           <a:bodyPr xmlns:a="http://schemas.openxmlformats.org/drawingml/2006/main"/>
           <a:lstStyle xmlns:a="http://schemas.openxmlformats.org/drawingml/2006/main"/>
-          <a:p xmlns:a="http://schemas.openxmlformats.org/drawingml/2006/main">
-            <a:r>
-              <a:t>[1:30] Adapter le ROI industriel au contexte éducatif. On ne dispose pas d'un</a:t>
-            </a:r>
-          </a:p>
-          <a:p xmlns:a="http://schemas.openxmlformats.org/drawingml/2006/main">
-            <a:r>
-              <a:t>coût officiel du décrochage ni de l'uplift causal de l'accompagnement. La bonne</a:t>
-            </a:r>
-          </a:p>
-          <a:p xmlns:a="http://schemas.openxmlformats.org/drawingml/2006/main">
-            <a:r>
-              <a:t>réponse est de proposer la méthode de mesure, pas de fabriquer un chiffre.</a:t>
-            </a:r>
-          </a:p>
+          <a:p xmlns:a="http://schemas.openxmlformats.org/drawingml/2006/main"/>
         </p:txBody>
       </p:sp>
       <p:sp>
@@ -1905,26 +1894,7 @@
         <p:txBody>
           <a:bodyPr xmlns:a="http://schemas.openxmlformats.org/drawingml/2006/main"/>
           <a:lstStyle xmlns:a="http://schemas.openxmlformats.org/drawingml/2006/main"/>
-          <a:p xmlns:a="http://schemas.openxmlformats.org/drawingml/2006/main">
-            <a:r>
-              <a:t>[1:30] Montrer de la lucidité — le jury valorise un candidat qui connaît les</a:t>
-            </a:r>
-          </a:p>
-          <a:p xmlns:a="http://schemas.openxmlformats.org/drawingml/2006/main">
-            <a:r>
-              <a:t>limites de son travail. NE PAS survendre. « Ce que j'ai construit est une</a:t>
-            </a:r>
-          </a:p>
-          <a:p xmlns:a="http://schemas.openxmlformats.org/drawingml/2006/main">
-            <a:r>
-              <a:t>démarche solide et reproductible ; sa validité en production reste à confirmer</a:t>
-            </a:r>
-          </a:p>
-          <a:p xmlns:a="http://schemas.openxmlformats.org/drawingml/2006/main">
-            <a:r>
-              <a:t>sur données réelles. »</a:t>
-            </a:r>
-          </a:p>
+          <a:p xmlns:a="http://schemas.openxmlformats.org/drawingml/2006/main"/>
         </p:txBody>
       </p:sp>
       <p:sp>
@@ -1990,21 +1960,7 @@
         <p:txBody>
           <a:bodyPr xmlns:a="http://schemas.openxmlformats.org/drawingml/2006/main"/>
           <a:lstStyle xmlns:a="http://schemas.openxmlformats.org/drawingml/2006/main"/>
-          <a:p xmlns:a="http://schemas.openxmlformats.org/drawingml/2006/main">
-            <a:r>
-              <a:t>[1:00] Résumer en 30 s les 5 messages. Terminer par la valeur métier : « une</a:t>
-            </a:r>
-          </a:p>
-          <a:p xmlns:a="http://schemas.openxmlformats.org/drawingml/2006/main">
-            <a:r>
-              <a:t>aide concrète pour accompagner à temps les étudiants à risque. » Enchaîner sur</a:t>
-            </a:r>
-          </a:p>
-          <a:p xmlns:a="http://schemas.openxmlformats.org/drawingml/2006/main">
-            <a:r>
-              <a:t>les questions avec assurance.</a:t>
-            </a:r>
-          </a:p>
+          <a:p xmlns:a="http://schemas.openxmlformats.org/drawingml/2006/main"/>
         </p:txBody>
       </p:sp>
       <p:sp>
@@ -2033,6 +1989,251 @@
 </file>
 
 <file path=ppt/notesSlides/notesSlide26.xml><?xml version="1.0" encoding="utf-8"?>
+<p:notes xmlns:p="http://schemas.openxmlformats.org/presentationml/2006/main">
+  <p:cSld>
+    <p:spTree>
+      <p:nvGrpSpPr>
+        <p:cNvPr id="1" name=""/>
+        <p:cNvGrpSpPr/>
+        <p:nvPr/>
+      </p:nvGrpSpPr>
+      <p:grpSpPr>
+        <a:xfrm xmlns:a="http://schemas.openxmlformats.org/drawingml/2006/main"/>
+      </p:grpSpPr>
+      <p:sp>
+        <p:nvSpPr>
+          <p:cNvPr id="2" name="Slide Image Placeholder 1"/>
+          <p:cNvSpPr>
+            <a:spLocks xmlns:a="http://schemas.openxmlformats.org/drawingml/2006/main" noGrp="1"/>
+          </p:cNvSpPr>
+          <p:nvPr>
+            <p:ph type="sldImg" idx="0"/>
+          </p:nvPr>
+        </p:nvSpPr>
+        <p:spPr/>
+      </p:sp>
+      <p:sp>
+        <p:nvSpPr>
+          <p:cNvPr id="3" name="Notes Placeholder 2"/>
+          <p:cNvSpPr>
+            <a:spLocks xmlns:a="http://schemas.openxmlformats.org/drawingml/2006/main" noGrp="1"/>
+          </p:cNvSpPr>
+          <p:nvPr>
+            <p:ph type="body" idx="1"/>
+          </p:nvPr>
+        </p:nvSpPr>
+        <p:spPr/>
+        <p:txBody>
+          <a:bodyPr xmlns:a="http://schemas.openxmlformats.org/drawingml/2006/main"/>
+          <a:lstStyle xmlns:a="http://schemas.openxmlformats.org/drawingml/2006/main"/>
+          <a:p xmlns:a="http://schemas.openxmlformats.org/drawingml/2006/main">
+            <a:r>
+              <a:t>[1:30] Adapter le ROI industriel au contexte éducatif. On ne dispose pas d'un</a:t>
+            </a:r>
+          </a:p>
+          <a:p xmlns:a="http://schemas.openxmlformats.org/drawingml/2006/main">
+            <a:r>
+              <a:t>coût officiel du décrochage ni de l'uplift causal de l'accompagnement. La bonne</a:t>
+            </a:r>
+          </a:p>
+          <a:p xmlns:a="http://schemas.openxmlformats.org/drawingml/2006/main">
+            <a:r>
+              <a:t>réponse est de proposer la méthode de mesure, pas de fabriquer un chiffre.</a:t>
+            </a:r>
+          </a:p>
+        </p:txBody>
+      </p:sp>
+      <p:sp>
+        <p:nvSpPr>
+          <p:cNvPr id="4" name="Slide Number Placeholder 3"/>
+          <p:cNvSpPr>
+            <a:spLocks xmlns:a="http://schemas.openxmlformats.org/drawingml/2006/main" noGrp="1"/>
+          </p:cNvSpPr>
+          <p:nvPr>
+            <p:ph type="sldNum" idx="5"/>
+          </p:nvPr>
+        </p:nvSpPr>
+        <p:spPr/>
+        <p:txBody>
+          <a:bodyPr xmlns:a="http://schemas.openxmlformats.org/drawingml/2006/main"/>
+          <a:lstStyle xmlns:a="http://schemas.openxmlformats.org/drawingml/2006/main"/>
+          <a:p xmlns:a="http://schemas.openxmlformats.org/drawingml/2006/main"/>
+        </p:txBody>
+      </p:sp>
+    </p:spTree>
+  </p:cSld>
+  <p:clrMapOvr>
+    <a:masterClrMapping xmlns:a="http://schemas.openxmlformats.org/drawingml/2006/main"/>
+  </p:clrMapOvr>
+</p:notes>
+</file>
+
+<file path=ppt/notesSlides/notesSlide27.xml><?xml version="1.0" encoding="utf-8"?>
+<p:notes xmlns:p="http://schemas.openxmlformats.org/presentationml/2006/main">
+  <p:cSld>
+    <p:spTree>
+      <p:nvGrpSpPr>
+        <p:cNvPr id="1" name=""/>
+        <p:cNvGrpSpPr/>
+        <p:nvPr/>
+      </p:nvGrpSpPr>
+      <p:grpSpPr>
+        <a:xfrm xmlns:a="http://schemas.openxmlformats.org/drawingml/2006/main"/>
+      </p:grpSpPr>
+      <p:sp>
+        <p:nvSpPr>
+          <p:cNvPr id="2" name="Slide Image Placeholder 1"/>
+          <p:cNvSpPr>
+            <a:spLocks xmlns:a="http://schemas.openxmlformats.org/drawingml/2006/main" noGrp="1"/>
+          </p:cNvSpPr>
+          <p:nvPr>
+            <p:ph type="sldImg" idx="0"/>
+          </p:nvPr>
+        </p:nvSpPr>
+        <p:spPr/>
+      </p:sp>
+      <p:sp>
+        <p:nvSpPr>
+          <p:cNvPr id="3" name="Notes Placeholder 2"/>
+          <p:cNvSpPr>
+            <a:spLocks xmlns:a="http://schemas.openxmlformats.org/drawingml/2006/main" noGrp="1"/>
+          </p:cNvSpPr>
+          <p:nvPr>
+            <p:ph type="body" idx="1"/>
+          </p:nvPr>
+        </p:nvSpPr>
+        <p:spPr/>
+        <p:txBody>
+          <a:bodyPr xmlns:a="http://schemas.openxmlformats.org/drawingml/2006/main"/>
+          <a:lstStyle xmlns:a="http://schemas.openxmlformats.org/drawingml/2006/main"/>
+          <a:p xmlns:a="http://schemas.openxmlformats.org/drawingml/2006/main">
+            <a:r>
+              <a:t>[1:30] Montrer de la lucidité — le jury valorise un candidat qui connaît les</a:t>
+            </a:r>
+          </a:p>
+          <a:p xmlns:a="http://schemas.openxmlformats.org/drawingml/2006/main">
+            <a:r>
+              <a:t>limites de son travail. NE PAS survendre. « Ce que j'ai construit est une</a:t>
+            </a:r>
+          </a:p>
+          <a:p xmlns:a="http://schemas.openxmlformats.org/drawingml/2006/main">
+            <a:r>
+              <a:t>démarche solide et reproductible ; sa validité en production reste à confirmer</a:t>
+            </a:r>
+          </a:p>
+          <a:p xmlns:a="http://schemas.openxmlformats.org/drawingml/2006/main">
+            <a:r>
+              <a:t>sur données réelles. »</a:t>
+            </a:r>
+          </a:p>
+        </p:txBody>
+      </p:sp>
+      <p:sp>
+        <p:nvSpPr>
+          <p:cNvPr id="4" name="Slide Number Placeholder 3"/>
+          <p:cNvSpPr>
+            <a:spLocks xmlns:a="http://schemas.openxmlformats.org/drawingml/2006/main" noGrp="1"/>
+          </p:cNvSpPr>
+          <p:nvPr>
+            <p:ph type="sldNum" idx="5"/>
+          </p:nvPr>
+        </p:nvSpPr>
+        <p:spPr/>
+        <p:txBody>
+          <a:bodyPr xmlns:a="http://schemas.openxmlformats.org/drawingml/2006/main"/>
+          <a:lstStyle xmlns:a="http://schemas.openxmlformats.org/drawingml/2006/main"/>
+          <a:p xmlns:a="http://schemas.openxmlformats.org/drawingml/2006/main"/>
+        </p:txBody>
+      </p:sp>
+    </p:spTree>
+  </p:cSld>
+  <p:clrMapOvr>
+    <a:masterClrMapping xmlns:a="http://schemas.openxmlformats.org/drawingml/2006/main"/>
+  </p:clrMapOvr>
+</p:notes>
+</file>
+
+<file path=ppt/notesSlides/notesSlide28.xml><?xml version="1.0" encoding="utf-8"?>
+<p:notes xmlns:p="http://schemas.openxmlformats.org/presentationml/2006/main">
+  <p:cSld>
+    <p:spTree>
+      <p:nvGrpSpPr>
+        <p:cNvPr id="1" name=""/>
+        <p:cNvGrpSpPr/>
+        <p:nvPr/>
+      </p:nvGrpSpPr>
+      <p:grpSpPr>
+        <a:xfrm xmlns:a="http://schemas.openxmlformats.org/drawingml/2006/main"/>
+      </p:grpSpPr>
+      <p:sp>
+        <p:nvSpPr>
+          <p:cNvPr id="2" name="Slide Image Placeholder 1"/>
+          <p:cNvSpPr>
+            <a:spLocks xmlns:a="http://schemas.openxmlformats.org/drawingml/2006/main" noGrp="1"/>
+          </p:cNvSpPr>
+          <p:nvPr>
+            <p:ph type="sldImg" idx="0"/>
+          </p:nvPr>
+        </p:nvSpPr>
+        <p:spPr/>
+      </p:sp>
+      <p:sp>
+        <p:nvSpPr>
+          <p:cNvPr id="3" name="Notes Placeholder 2"/>
+          <p:cNvSpPr>
+            <a:spLocks xmlns:a="http://schemas.openxmlformats.org/drawingml/2006/main" noGrp="1"/>
+          </p:cNvSpPr>
+          <p:nvPr>
+            <p:ph type="body" idx="1"/>
+          </p:nvPr>
+        </p:nvSpPr>
+        <p:spPr/>
+        <p:txBody>
+          <a:bodyPr xmlns:a="http://schemas.openxmlformats.org/drawingml/2006/main"/>
+          <a:lstStyle xmlns:a="http://schemas.openxmlformats.org/drawingml/2006/main"/>
+          <a:p xmlns:a="http://schemas.openxmlformats.org/drawingml/2006/main">
+            <a:r>
+              <a:t>[1:00] Résumer en 30 s les 5 messages. Terminer par la valeur métier : « une</a:t>
+            </a:r>
+          </a:p>
+          <a:p xmlns:a="http://schemas.openxmlformats.org/drawingml/2006/main">
+            <a:r>
+              <a:t>aide concrète pour accompagner à temps les étudiants à risque. » Enchaîner sur</a:t>
+            </a:r>
+          </a:p>
+          <a:p xmlns:a="http://schemas.openxmlformats.org/drawingml/2006/main">
+            <a:r>
+              <a:t>les questions avec assurance.</a:t>
+            </a:r>
+          </a:p>
+        </p:txBody>
+      </p:sp>
+      <p:sp>
+        <p:nvSpPr>
+          <p:cNvPr id="4" name="Slide Number Placeholder 3"/>
+          <p:cNvSpPr>
+            <a:spLocks xmlns:a="http://schemas.openxmlformats.org/drawingml/2006/main" noGrp="1"/>
+          </p:cNvSpPr>
+          <p:nvPr>
+            <p:ph type="sldNum" idx="5"/>
+          </p:nvPr>
+        </p:nvSpPr>
+        <p:spPr/>
+        <p:txBody>
+          <a:bodyPr xmlns:a="http://schemas.openxmlformats.org/drawingml/2006/main"/>
+          <a:lstStyle xmlns:a="http://schemas.openxmlformats.org/drawingml/2006/main"/>
+          <a:p xmlns:a="http://schemas.openxmlformats.org/drawingml/2006/main"/>
+        </p:txBody>
+      </p:sp>
+    </p:spTree>
+  </p:cSld>
+  <p:clrMapOvr>
+    <a:masterClrMapping xmlns:a="http://schemas.openxmlformats.org/drawingml/2006/main"/>
+  </p:clrMapOvr>
+</p:notes>
+</file>
+
+<file path=ppt/notesSlides/notesSlide29.xml><?xml version="1.0" encoding="utf-8"?>
 <p:notes xmlns:p="http://schemas.openxmlformats.org/presentationml/2006/main">
   <p:cSld>
     <p:spTree>
@@ -2780,7 +2981,7 @@
   </p:cSld>
   <p:clrMap bg1="lt1" tx1="dk1" bg2="lt2" tx2="dk2" accent1="accent1" accent2="accent2" accent3="accent3" accent4="accent4" accent5="accent5" accent6="accent6" hlink="hlink" folHlink="folHlink"/>
   <p:sldLayoutIdLst>
-    <p:sldLayoutId xmlns:r="http://schemas.openxmlformats.org/officeDocument/2006/relationships" id="2147483649" r:id="R73e9b6792bf243db"/>
+    <p:sldLayoutId xmlns:r="http://schemas.openxmlformats.org/officeDocument/2006/relationships" id="2147483649" r:id="R5b95af854bea499d"/>
   </p:sldLayoutIdLst>
   <p:txStyles>
     <p:titleStyle>
@@ -4185,7 +4386,7 @@
           <p:nvPr/>
         </p:nvPicPr>
         <p:blipFill>
-          <a:blip xmlns:r="http://schemas.openxmlformats.org/officeDocument/2006/relationships" xmlns:a="http://schemas.openxmlformats.org/drawingml/2006/main" r:embed="R8f06b78971e74045"/>
+          <a:blip xmlns:r="http://schemas.openxmlformats.org/officeDocument/2006/relationships" xmlns:a="http://schemas.openxmlformats.org/drawingml/2006/main" r:embed="Rf9e92aeb09b04af7"/>
           <a:stretch xmlns:a="http://schemas.openxmlformats.org/drawingml/2006/main"/>
         </p:blipFill>
         <p:spPr>
@@ -4516,7 +4717,7 @@
           <p:nvPr/>
         </p:nvPicPr>
         <p:blipFill>
-          <a:blip xmlns:r="http://schemas.openxmlformats.org/officeDocument/2006/relationships" xmlns:a="http://schemas.openxmlformats.org/drawingml/2006/main" r:embed="Rf37780a5783a46ee"/>
+          <a:blip xmlns:r="http://schemas.openxmlformats.org/officeDocument/2006/relationships" xmlns:a="http://schemas.openxmlformats.org/drawingml/2006/main" r:embed="Re031af8eb41e4dc6"/>
           <a:stretch xmlns:a="http://schemas.openxmlformats.org/drawingml/2006/main"/>
         </p:blipFill>
         <p:spPr>
@@ -4958,7 +5159,7 @@
           <p:nvPr/>
         </p:nvPicPr>
         <p:blipFill>
-          <a:blip xmlns:r="http://schemas.openxmlformats.org/officeDocument/2006/relationships" xmlns:a="http://schemas.openxmlformats.org/drawingml/2006/main" r:embed="Red6d524cce8244bf"/>
+          <a:blip xmlns:r="http://schemas.openxmlformats.org/officeDocument/2006/relationships" xmlns:a="http://schemas.openxmlformats.org/drawingml/2006/main" r:embed="R07789bd8257e4034"/>
           <a:stretch xmlns:a="http://schemas.openxmlformats.org/drawingml/2006/main"/>
         </p:blipFill>
         <p:spPr>
@@ -5259,7 +5460,7 @@
           <p:nvPr/>
         </p:nvPicPr>
         <p:blipFill>
-          <a:blip xmlns:r="http://schemas.openxmlformats.org/officeDocument/2006/relationships" xmlns:a="http://schemas.openxmlformats.org/drawingml/2006/main" r:embed="R3094ea6076314501"/>
+          <a:blip xmlns:r="http://schemas.openxmlformats.org/officeDocument/2006/relationships" xmlns:a="http://schemas.openxmlformats.org/drawingml/2006/main" r:embed="R3525f95efaf648ef"/>
           <a:stretch xmlns:a="http://schemas.openxmlformats.org/drawingml/2006/main"/>
         </p:blipFill>
         <p:spPr>
@@ -10089,7 +10290,7 @@
           <p:nvPr/>
         </p:nvPicPr>
         <p:blipFill>
-          <a:blip xmlns:r="http://schemas.openxmlformats.org/officeDocument/2006/relationships" xmlns:a="http://schemas.openxmlformats.org/drawingml/2006/main" r:embed="Rf996cb0834ec49bd"/>
+          <a:blip xmlns:r="http://schemas.openxmlformats.org/officeDocument/2006/relationships" xmlns:a="http://schemas.openxmlformats.org/drawingml/2006/main" r:embed="Rc4af3264b667440a"/>
           <a:stretch xmlns:a="http://schemas.openxmlformats.org/drawingml/2006/main"/>
         </p:blipFill>
         <p:spPr>
@@ -10490,7 +10691,7 @@
           <p:nvPr/>
         </p:nvPicPr>
         <p:blipFill>
-          <a:blip xmlns:r="http://schemas.openxmlformats.org/officeDocument/2006/relationships" xmlns:a="http://schemas.openxmlformats.org/drawingml/2006/main" r:embed="Rfb314a8f77004fc0"/>
+          <a:blip xmlns:r="http://schemas.openxmlformats.org/officeDocument/2006/relationships" xmlns:a="http://schemas.openxmlformats.org/drawingml/2006/main" r:embed="R70caa08996804c62"/>
           <a:stretch xmlns:a="http://schemas.openxmlformats.org/drawingml/2006/main"/>
         </p:blipFill>
         <p:spPr>
@@ -10512,7 +10713,7 @@
           <p:nvPr/>
         </p:nvPicPr>
         <p:blipFill>
-          <a:blip xmlns:r="http://schemas.openxmlformats.org/officeDocument/2006/relationships" xmlns:a="http://schemas.openxmlformats.org/drawingml/2006/main" r:embed="Rd8c744faa38c4dfd"/>
+          <a:blip xmlns:r="http://schemas.openxmlformats.org/officeDocument/2006/relationships" xmlns:a="http://schemas.openxmlformats.org/drawingml/2006/main" r:embed="R6236cb4c3b424f58"/>
           <a:stretch xmlns:a="http://schemas.openxmlformats.org/drawingml/2006/main"/>
         </p:blipFill>
         <p:spPr>
@@ -10792,7 +10993,7 @@
           <p:nvPr/>
         </p:nvPicPr>
         <p:blipFill>
-          <a:blip xmlns:r="http://schemas.openxmlformats.org/officeDocument/2006/relationships" xmlns:a="http://schemas.openxmlformats.org/drawingml/2006/main" r:embed="R7e1a1583dc4541f6"/>
+          <a:blip xmlns:r="http://schemas.openxmlformats.org/officeDocument/2006/relationships" xmlns:a="http://schemas.openxmlformats.org/drawingml/2006/main" r:embed="R1709610fae794954"/>
           <a:stretch xmlns:a="http://schemas.openxmlformats.org/drawingml/2006/main"/>
         </p:blipFill>
         <p:spPr>
@@ -10818,13 +11019,6 @@
 <file path=ppt/slides/slide23.xml><?xml version="1.0" encoding="utf-8"?>
 <p:sld xmlns:p="http://schemas.openxmlformats.org/presentationml/2006/main">
   <p:cSld>
-    <p:bg>
-      <p:bgPr>
-        <a:solidFill xmlns:a="http://schemas.openxmlformats.org/drawingml/2006/main">
-          <a:srgbClr val="FFFFFF"/>
-        </a:solidFill>
-      </p:bgPr>
-    </p:bg>
     <p:spTree>
       <p:nvGrpSpPr>
         <p:cNvPr id="1" name=""/>
@@ -10836,22 +11030,53 @@
       </p:grpSpPr>
       <p:sp>
         <p:nvSpPr>
-          <p:cNvPr id="13" name="">
-            <a:extLst xmlns:a="http://schemas.openxmlformats.org/drawingml/2006/main">
-              <a:ext uri="{FF2B5EF4-FFF2-40B4-BE49-F238E27FC236}">
-                <a16:creationId xmlns:a16="http://schemas.microsoft.com/office/drawing/2014/main" id="{08E5B9D7-38EE-457C-8A4A-0FADE80FEED4}"/>
-              </a:ext>
-            </a:extLst>
-          </p:cNvPr>
-          <p:cNvSpPr>
-            <a:spLocks xmlns:a="http://schemas.openxmlformats.org/drawingml/2006/main" noGrp="1"/>
-          </p:cNvSpPr>
-          <p:nvPr/>
-        </p:nvSpPr>
-        <p:spPr>
-          <a:xfrm xmlns:a="http://schemas.openxmlformats.org/drawingml/2006/main">
-            <a:off x="609600" y="323850"/>
-            <a:ext cx="4000500" cy="228600"/>
+          <p:cNvPr id="8" name="">
+            <a:extLst xmlns:a="http://schemas.openxmlformats.org/drawingml/2006/main">
+              <a:ext uri="{FF2B5EF4-FFF2-40B4-BE49-F238E27FC236}">
+                <a16:creationId xmlns:a16="http://schemas.microsoft.com/office/drawing/2014/main" id="{FEEF4890-9B9D-49B8-8E66-C8B95DB9203C}"/>
+              </a:ext>
+            </a:extLst>
+          </p:cNvPr>
+          <p:cNvSpPr>
+            <a:spLocks xmlns:a="http://schemas.openxmlformats.org/drawingml/2006/main" noGrp="1"/>
+          </p:cNvSpPr>
+          <p:nvPr/>
+        </p:nvSpPr>
+        <p:spPr>
+          <a:xfrm xmlns:a="http://schemas.openxmlformats.org/drawingml/2006/main">
+            <a:off x="0" y="0"/>
+            <a:ext cx="12192000" cy="6858000"/>
+          </a:xfrm>
+          <a:prstGeom xmlns:a="http://schemas.openxmlformats.org/drawingml/2006/main" prst="rect">
+            <a:avLst/>
+          </a:prstGeom>
+          <a:solidFill xmlns:a="http://schemas.openxmlformats.org/drawingml/2006/main">
+            <a:srgbClr val="FFFFFF"/>
+          </a:solidFill>
+          <a:ln xmlns:a="http://schemas.openxmlformats.org/drawingml/2006/main" w="0">
+            <a:noFill/>
+            <a:prstDash val="solid"/>
+          </a:ln>
+        </p:spPr>
+      </p:sp>
+      <p:sp>
+        <p:nvSpPr>
+          <p:cNvPr id="2" name="">
+            <a:extLst xmlns:a="http://schemas.openxmlformats.org/drawingml/2006/main">
+              <a:ext uri="{FF2B5EF4-FFF2-40B4-BE49-F238E27FC236}">
+                <a16:creationId xmlns:a16="http://schemas.microsoft.com/office/drawing/2014/main" id="{8907ED5F-E122-445D-A3DB-8D1E7D3017D2}"/>
+              </a:ext>
+            </a:extLst>
+          </p:cNvPr>
+          <p:cNvSpPr>
+            <a:spLocks xmlns:a="http://schemas.openxmlformats.org/drawingml/2006/main" noGrp="1"/>
+          </p:cNvSpPr>
+          <p:nvPr/>
+        </p:nvSpPr>
+        <p:spPr>
+          <a:xfrm xmlns:a="http://schemas.openxmlformats.org/drawingml/2006/main">
+            <a:off x="609600" y="438150"/>
+            <a:ext cx="10953750" cy="552450"/>
           </a:xfrm>
           <a:prstGeom xmlns:a="http://schemas.openxmlformats.org/drawingml/2006/main" prst="rect">
             <a:avLst/>
@@ -10863,66 +11088,17 @@
           </a:ln>
         </p:spPr>
         <p:txBody>
-          <a:bodyPr xmlns:a="http://schemas.openxmlformats.org/drawingml/2006/main" anchor="t"/>
-          <a:lstStyle xmlns:a="http://schemas.openxmlformats.org/drawingml/2006/main"/>
-          <a:p xmlns:a="http://schemas.openxmlformats.org/drawingml/2006/main">
-            <a:pPr>
-              <a:buNone/>
-              <a:defRPr sz="975" b="1">
-                <a:solidFill>
-                  <a:srgbClr val="2E6F9E"/>
-                </a:solidFill>
-              </a:defRPr>
-            </a:pPr>
-            <a:r>
-              <a:rPr sz="975" b="1">
-                <a:solidFill>
-                  <a:srgbClr val="2E6F9E"/>
-                </a:solidFill>
-              </a:rPr>
-              <a:t>RUN</a:t>
-            </a:r>
-          </a:p>
-        </p:txBody>
-      </p:sp>
-      <p:sp>
-        <p:nvSpPr>
-          <p:cNvPr id="2" name="">
-            <a:extLst xmlns:a="http://schemas.openxmlformats.org/drawingml/2006/main">
-              <a:ext uri="{FF2B5EF4-FFF2-40B4-BE49-F238E27FC236}">
-                <a16:creationId xmlns:a16="http://schemas.microsoft.com/office/drawing/2014/main" id="{407216D8-1468-4494-9489-2281004F2869}"/>
-              </a:ext>
-            </a:extLst>
-          </p:cNvPr>
-          <p:cNvSpPr>
-            <a:spLocks xmlns:a="http://schemas.openxmlformats.org/drawingml/2006/main" noGrp="1"/>
-          </p:cNvSpPr>
-          <p:nvPr/>
-        </p:nvSpPr>
-        <p:spPr>
-          <a:xfrm xmlns:a="http://schemas.openxmlformats.org/drawingml/2006/main">
-            <a:off x="609600" y="590550"/>
-            <a:ext cx="10953750" cy="552450"/>
-          </a:xfrm>
-          <a:prstGeom xmlns:a="http://schemas.openxmlformats.org/drawingml/2006/main" prst="rect">
-            <a:avLst/>
-          </a:prstGeom>
-          <a:noFill xmlns:a="http://schemas.openxmlformats.org/drawingml/2006/main"/>
-          <a:ln xmlns:a="http://schemas.openxmlformats.org/drawingml/2006/main" w="0">
-            <a:noFill/>
-            <a:prstDash val="solid"/>
-          </a:ln>
-        </p:spPr>
-        <p:txBody>
-          <a:bodyPr xmlns:a="http://schemas.openxmlformats.org/drawingml/2006/main" anchor="t"/>
-          <a:lstStyle xmlns:a="http://schemas.openxmlformats.org/drawingml/2006/main"/>
-          <a:p xmlns:a="http://schemas.openxmlformats.org/drawingml/2006/main">
-            <a:pPr>
-              <a:buNone/>
+          <a:bodyPr xmlns:a="http://schemas.openxmlformats.org/drawingml/2006/main"/>
+          <a:lstStyle xmlns:a="http://schemas.openxmlformats.org/drawingml/2006/main"/>
+          <a:p xmlns:a="http://schemas.openxmlformats.org/drawingml/2006/main">
+            <a:pPr>
               <a:defRPr sz="2700" b="1">
                 <a:solidFill>
                   <a:srgbClr val="173B57"/>
                 </a:solidFill>
+                <a:latin typeface="Calibri"/>
+                <a:ea typeface="Calibri"/>
+                <a:cs typeface="Calibri"/>
               </a:defRPr>
             </a:pPr>
             <a:r>
@@ -10930,8 +11106,11 @@
                 <a:solidFill>
                   <a:srgbClr val="173B57"/>
                 </a:solidFill>
-              </a:rPr>
-              <a:t>18. TCO &amp; valeur du pilote — C7 / C9</a:t>
+                <a:latin typeface="Calibri"/>
+                <a:ea typeface="Calibri"/>
+                <a:cs typeface="Calibri"/>
+              </a:rPr>
+              <a:t>17.4 MLflow trace les entraînements</a:t>
             </a:r>
           </a:p>
         </p:txBody>
@@ -10941,18 +11120,18 @@
           <p:cNvPr id="3" name="">
             <a:extLst xmlns:a="http://schemas.openxmlformats.org/drawingml/2006/main">
               <a:ext uri="{FF2B5EF4-FFF2-40B4-BE49-F238E27FC236}">
-                <a16:creationId xmlns:a16="http://schemas.microsoft.com/office/drawing/2014/main" id="{5A350BB4-D686-490A-8D2F-F263F9C1B696}"/>
-              </a:ext>
-            </a:extLst>
-          </p:cNvPr>
-          <p:cNvSpPr>
-            <a:spLocks xmlns:a="http://schemas.openxmlformats.org/drawingml/2006/main" noGrp="1"/>
-          </p:cNvSpPr>
-          <p:nvPr/>
-        </p:nvSpPr>
-        <p:spPr>
-          <a:xfrm xmlns:a="http://schemas.openxmlformats.org/drawingml/2006/main">
-            <a:off x="609600" y="1162050"/>
+                <a16:creationId xmlns:a16="http://schemas.microsoft.com/office/drawing/2014/main" id="{287CD27F-F725-4817-9758-4574DEEC20E5}"/>
+              </a:ext>
+            </a:extLst>
+          </p:cNvPr>
+          <p:cNvSpPr>
+            <a:spLocks xmlns:a="http://schemas.openxmlformats.org/drawingml/2006/main" noGrp="1"/>
+          </p:cNvSpPr>
+          <p:nvPr/>
+        </p:nvSpPr>
+        <p:spPr>
+          <a:xfrm xmlns:a="http://schemas.openxmlformats.org/drawingml/2006/main">
+            <a:off x="609600" y="1028700"/>
             <a:ext cx="10972800" cy="19050"/>
           </a:xfrm>
           <a:prstGeom xmlns:a="http://schemas.openxmlformats.org/drawingml/2006/main" prst="rect">
@@ -10972,7 +11151,7 @@
           <p:cNvPr id="4" name="">
             <a:extLst xmlns:a="http://schemas.openxmlformats.org/drawingml/2006/main">
               <a:ext uri="{FF2B5EF4-FFF2-40B4-BE49-F238E27FC236}">
-                <a16:creationId xmlns:a16="http://schemas.microsoft.com/office/drawing/2014/main" id="{D84B452A-4055-4478-8C17-CD03ADC6FD08}"/>
+                <a16:creationId xmlns:a16="http://schemas.microsoft.com/office/drawing/2014/main" id="{057C2388-3E61-4948-8C05-7A26EFD14E09}"/>
               </a:ext>
             </a:extLst>
           </p:cNvPr>
@@ -10996,15 +11175,17 @@
           </a:ln>
         </p:spPr>
         <p:txBody>
-          <a:bodyPr xmlns:a="http://schemas.openxmlformats.org/drawingml/2006/main" anchor="t"/>
+          <a:bodyPr xmlns:a="http://schemas.openxmlformats.org/drawingml/2006/main"/>
           <a:lstStyle xmlns:a="http://schemas.openxmlformats.org/drawingml/2006/main"/>
           <a:p xmlns:a="http://schemas.openxmlformats.org/drawingml/2006/main">
             <a:pPr algn="r">
-              <a:buNone/>
               <a:defRPr sz="900">
                 <a:solidFill>
                   <a:srgbClr val="85929B"/>
                 </a:solidFill>
+                <a:latin typeface="Calibri"/>
+                <a:ea typeface="Calibri"/>
+                <a:cs typeface="Calibri"/>
               </a:defRPr>
             </a:pPr>
             <a:r>
@@ -11012,30 +11193,55 @@
                 <a:solidFill>
                   <a:srgbClr val="85929B"/>
                 </a:solidFill>
+                <a:latin typeface="Calibri"/>
+                <a:ea typeface="Calibri"/>
+                <a:cs typeface="Calibri"/>
               </a:rPr>
               <a:t>23</a:t>
             </a:r>
           </a:p>
         </p:txBody>
       </p:sp>
-      <p:sp>
-        <p:nvSpPr>
-          <p:cNvPr id="5" name="">
-            <a:extLst xmlns:a="http://schemas.openxmlformats.org/drawingml/2006/main">
-              <a:ext uri="{FF2B5EF4-FFF2-40B4-BE49-F238E27FC236}">
-                <a16:creationId xmlns:a16="http://schemas.microsoft.com/office/drawing/2014/main" id="{3CB13EF8-6241-418B-B648-E2B10A90F0DF}"/>
-              </a:ext>
-            </a:extLst>
-          </p:cNvPr>
-          <p:cNvSpPr>
-            <a:spLocks xmlns:a="http://schemas.openxmlformats.org/drawingml/2006/main" noGrp="1"/>
-          </p:cNvSpPr>
-          <p:nvPr/>
-        </p:nvSpPr>
-        <p:spPr>
-          <a:xfrm xmlns:a="http://schemas.openxmlformats.org/drawingml/2006/main">
-            <a:off x="781050" y="1571625"/>
-            <a:ext cx="2000250" cy="666750"/>
+      <p:pic>
+        <p:nvPicPr>
+          <p:cNvPr id="12" name=""/>
+          <p:cNvPicPr>
+            <a:picLocks xmlns:a="http://schemas.openxmlformats.org/drawingml/2006/main" noChangeAspect="1"/>
+          </p:cNvPicPr>
+          <p:nvPr/>
+        </p:nvPicPr>
+        <p:blipFill>
+          <a:blip xmlns:r="http://schemas.openxmlformats.org/officeDocument/2006/relationships" xmlns:a="http://schemas.openxmlformats.org/drawingml/2006/main" r:embed="R48487068ba464352"/>
+          <a:stretch xmlns:a="http://schemas.openxmlformats.org/drawingml/2006/main"/>
+        </p:blipFill>
+        <p:spPr>
+          <a:xfrm xmlns:a="http://schemas.openxmlformats.org/drawingml/2006/main">
+            <a:off x="609600" y="1432322"/>
+            <a:ext cx="7810500" cy="4393406"/>
+          </a:xfrm>
+          <a:prstGeom xmlns:a="http://schemas.openxmlformats.org/drawingml/2006/main" prst="rect">
+            <a:avLst/>
+          </a:prstGeom>
+        </p:spPr>
+      </p:pic>
+      <p:sp>
+        <p:nvSpPr>
+          <p:cNvPr id="6" name="">
+            <a:extLst xmlns:a="http://schemas.openxmlformats.org/drawingml/2006/main">
+              <a:ext uri="{FF2B5EF4-FFF2-40B4-BE49-F238E27FC236}">
+                <a16:creationId xmlns:a16="http://schemas.microsoft.com/office/drawing/2014/main" id="{641721F2-3104-4973-A3A5-BB006390EE80}"/>
+              </a:ext>
+            </a:extLst>
+          </p:cNvPr>
+          <p:cNvSpPr>
+            <a:spLocks xmlns:a="http://schemas.openxmlformats.org/drawingml/2006/main" noGrp="1"/>
+          </p:cNvSpPr>
+          <p:nvPr/>
+        </p:nvSpPr>
+        <p:spPr>
+          <a:xfrm xmlns:a="http://schemas.openxmlformats.org/drawingml/2006/main">
+            <a:off x="8715375" y="1809750"/>
+            <a:ext cx="2762250" cy="2857500"/>
           </a:xfrm>
           <a:prstGeom xmlns:a="http://schemas.openxmlformats.org/drawingml/2006/main" prst="rect">
             <a:avLst/>
@@ -11047,46 +11253,107 @@
           </a:ln>
         </p:spPr>
         <p:txBody>
-          <a:bodyPr xmlns:a="http://schemas.openxmlformats.org/drawingml/2006/main" anchor="t"/>
-          <a:lstStyle xmlns:a="http://schemas.openxmlformats.org/drawingml/2006/main"/>
-          <a:p xmlns:a="http://schemas.openxmlformats.org/drawingml/2006/main">
-            <a:pPr>
-              <a:buNone/>
-              <a:defRPr sz="3750" b="1">
-                <a:solidFill>
-                  <a:srgbClr val="2E6F9E"/>
-                </a:solidFill>
-              </a:defRPr>
-            </a:pPr>
-            <a:r>
-              <a:rPr sz="3750" b="1">
-                <a:solidFill>
-                  <a:srgbClr val="2E6F9E"/>
-                </a:solidFill>
-              </a:rPr>
-              <a:t>TCO</a:t>
-            </a:r>
-          </a:p>
-        </p:txBody>
-      </p:sp>
-      <p:sp>
-        <p:nvSpPr>
-          <p:cNvPr id="6" name="">
-            <a:extLst xmlns:a="http://schemas.openxmlformats.org/drawingml/2006/main">
-              <a:ext uri="{FF2B5EF4-FFF2-40B4-BE49-F238E27FC236}">
-                <a16:creationId xmlns:a16="http://schemas.microsoft.com/office/drawing/2014/main" id="{B9905803-6BBE-402C-9A83-ADC024E712F4}"/>
-              </a:ext>
-            </a:extLst>
-          </p:cNvPr>
-          <p:cNvSpPr>
-            <a:spLocks xmlns:a="http://schemas.openxmlformats.org/drawingml/2006/main" noGrp="1"/>
-          </p:cNvSpPr>
-          <p:nvPr/>
-        </p:nvSpPr>
-        <p:spPr>
-          <a:xfrm xmlns:a="http://schemas.openxmlformats.org/drawingml/2006/main">
-            <a:off x="2857500" y="1695450"/>
-            <a:ext cx="8096250" cy="590550"/>
+          <a:bodyPr xmlns:a="http://schemas.openxmlformats.org/drawingml/2006/main"/>
+          <a:lstStyle xmlns:a="http://schemas.openxmlformats.org/drawingml/2006/main"/>
+          <a:p xmlns:a="http://schemas.openxmlformats.org/drawingml/2006/main">
+            <a:pPr>
+              <a:defRPr sz="1500">
+                <a:solidFill>
+                  <a:srgbClr val="1B252C"/>
+                </a:solidFill>
+                <a:latin typeface="Calibri"/>
+                <a:ea typeface="Calibri"/>
+                <a:cs typeface="Calibri"/>
+              </a:defRPr>
+            </a:pPr>
+            <a:r>
+              <a:rPr sz="1500">
+                <a:solidFill>
+                  <a:srgbClr val="1B252C"/>
+                </a:solidFill>
+                <a:latin typeface="Calibri"/>
+                <a:ea typeface="Calibri"/>
+                <a:cs typeface="Calibri"/>
+              </a:rPr>
+              <a:t>• Paramètres et métriques.</a:t>
+            </a:r>
+          </a:p>
+          <a:p xmlns:a="http://schemas.openxmlformats.org/drawingml/2006/main">
+            <a:r>
+              <a:t/>
+            </a:r>
+          </a:p>
+          <a:p xmlns:a="http://schemas.openxmlformats.org/drawingml/2006/main">
+            <a:pPr>
+              <a:defRPr sz="1500">
+                <a:solidFill>
+                  <a:srgbClr val="1B252C"/>
+                </a:solidFill>
+                <a:latin typeface="Calibri"/>
+                <a:ea typeface="Calibri"/>
+                <a:cs typeface="Calibri"/>
+              </a:defRPr>
+            </a:pPr>
+            <a:r>
+              <a:rPr sz="1500">
+                <a:solidFill>
+                  <a:srgbClr val="1B252C"/>
+                </a:solidFill>
+                <a:latin typeface="Calibri"/>
+                <a:ea typeface="Calibri"/>
+                <a:cs typeface="Calibri"/>
+              </a:rPr>
+              <a:t>• Rapport JSON et bundle.</a:t>
+            </a:r>
+          </a:p>
+          <a:p xmlns:a="http://schemas.openxmlformats.org/drawingml/2006/main">
+            <a:r>
+              <a:t/>
+            </a:r>
+          </a:p>
+          <a:p xmlns:a="http://schemas.openxmlformats.org/drawingml/2006/main">
+            <a:pPr>
+              <a:defRPr sz="1500">
+                <a:solidFill>
+                  <a:srgbClr val="1B252C"/>
+                </a:solidFill>
+                <a:latin typeface="Calibri"/>
+                <a:ea typeface="Calibri"/>
+                <a:cs typeface="Calibri"/>
+              </a:defRPr>
+            </a:pPr>
+            <a:r>
+              <a:rPr sz="1500">
+                <a:solidFill>
+                  <a:srgbClr val="1B252C"/>
+                </a:solidFill>
+                <a:latin typeface="Calibri"/>
+                <a:ea typeface="Calibri"/>
+                <a:cs typeface="Calibri"/>
+              </a:rPr>
+              <a:t>• Deux exécutions indépendantes.</a:t>
+            </a:r>
+          </a:p>
+        </p:txBody>
+      </p:sp>
+      <p:sp>
+        <p:nvSpPr>
+          <p:cNvPr id="7" name="">
+            <a:extLst xmlns:a="http://schemas.openxmlformats.org/drawingml/2006/main">
+              <a:ext uri="{FF2B5EF4-FFF2-40B4-BE49-F238E27FC236}">
+                <a16:creationId xmlns:a16="http://schemas.microsoft.com/office/drawing/2014/main" id="{23F38D49-5C51-40F5-8A88-070335254383}"/>
+              </a:ext>
+            </a:extLst>
+          </p:cNvPr>
+          <p:cNvSpPr>
+            <a:spLocks xmlns:a="http://schemas.openxmlformats.org/drawingml/2006/main" noGrp="1"/>
+          </p:cNvSpPr>
+          <p:nvPr/>
+        </p:nvSpPr>
+        <p:spPr>
+          <a:xfrm xmlns:a="http://schemas.openxmlformats.org/drawingml/2006/main">
+            <a:off x="8572500" y="4857750"/>
+            <a:ext cx="2952750" cy="762000"/>
           </a:xfrm>
           <a:prstGeom xmlns:a="http://schemas.openxmlformats.org/drawingml/2006/main" prst="rect">
             <a:avLst/>
@@ -11098,355 +11365,29 @@
           </a:ln>
         </p:spPr>
         <p:txBody>
-          <a:bodyPr xmlns:a="http://schemas.openxmlformats.org/drawingml/2006/main" anchor="t"/>
-          <a:lstStyle xmlns:a="http://schemas.openxmlformats.org/drawingml/2006/main"/>
-          <a:p xmlns:a="http://schemas.openxmlformats.org/drawingml/2006/main">
-            <a:pPr>
-              <a:buNone/>
-              <a:defRPr sz="1725">
-                <a:solidFill>
-                  <a:srgbClr val="1B252C"/>
-                </a:solidFill>
-              </a:defRPr>
-            </a:pPr>
-            <a:r>
-              <a:rPr sz="1725">
-                <a:solidFill>
-                  <a:srgbClr val="1B252C"/>
-                </a:solidFill>
-              </a:rPr>
-              <a:t>hébergement + sauvegardes + temps DSI/DPO + revue modèle + interventions</a:t>
-            </a:r>
-          </a:p>
-        </p:txBody>
-      </p:sp>
-      <p:sp>
-        <p:nvSpPr>
-          <p:cNvPr id="7" name="">
-            <a:extLst xmlns:a="http://schemas.openxmlformats.org/drawingml/2006/main">
-              <a:ext uri="{FF2B5EF4-FFF2-40B4-BE49-F238E27FC236}">
-                <a16:creationId xmlns:a16="http://schemas.microsoft.com/office/drawing/2014/main" id="{45AC8204-DF35-4EB4-907D-DC5E173B4515}"/>
-              </a:ext>
-            </a:extLst>
-          </p:cNvPr>
-          <p:cNvSpPr>
-            <a:spLocks xmlns:a="http://schemas.openxmlformats.org/drawingml/2006/main" noGrp="1"/>
-          </p:cNvSpPr>
-          <p:nvPr/>
-        </p:nvSpPr>
-        <p:spPr>
-          <a:xfrm xmlns:a="http://schemas.openxmlformats.org/drawingml/2006/main">
-            <a:off x="781050" y="2571750"/>
-            <a:ext cx="10382250" cy="19050"/>
-          </a:xfrm>
-          <a:prstGeom xmlns:a="http://schemas.openxmlformats.org/drawingml/2006/main" prst="rect">
-            <a:avLst/>
-          </a:prstGeom>
-          <a:solidFill xmlns:a="http://schemas.openxmlformats.org/drawingml/2006/main">
-            <a:srgbClr val="CFDCE5"/>
-          </a:solidFill>
-          <a:ln xmlns:a="http://schemas.openxmlformats.org/drawingml/2006/main" w="0">
-            <a:noFill/>
-            <a:prstDash val="solid"/>
-          </a:ln>
-        </p:spPr>
-      </p:sp>
-      <p:sp>
-        <p:nvSpPr>
-          <p:cNvPr id="8" name="">
-            <a:extLst xmlns:a="http://schemas.openxmlformats.org/drawingml/2006/main">
-              <a:ext uri="{FF2B5EF4-FFF2-40B4-BE49-F238E27FC236}">
-                <a16:creationId xmlns:a16="http://schemas.microsoft.com/office/drawing/2014/main" id="{CECD97E2-724E-495C-A39F-C0868400BD0F}"/>
-              </a:ext>
-            </a:extLst>
-          </p:cNvPr>
-          <p:cNvSpPr>
-            <a:spLocks xmlns:a="http://schemas.openxmlformats.org/drawingml/2006/main" noGrp="1"/>
-          </p:cNvSpPr>
-          <p:nvPr/>
-        </p:nvSpPr>
-        <p:spPr>
-          <a:xfrm xmlns:a="http://schemas.openxmlformats.org/drawingml/2006/main">
-            <a:off x="781050" y="2905125"/>
-            <a:ext cx="3333750" cy="400050"/>
-          </a:xfrm>
-          <a:prstGeom xmlns:a="http://schemas.openxmlformats.org/drawingml/2006/main" prst="rect">
-            <a:avLst/>
-          </a:prstGeom>
-          <a:noFill xmlns:a="http://schemas.openxmlformats.org/drawingml/2006/main"/>
-          <a:ln xmlns:a="http://schemas.openxmlformats.org/drawingml/2006/main" w="0">
-            <a:noFill/>
-            <a:prstDash val="solid"/>
-          </a:ln>
-        </p:spPr>
-        <p:txBody>
-          <a:bodyPr xmlns:a="http://schemas.openxmlformats.org/drawingml/2006/main" anchor="t"/>
-          <a:lstStyle xmlns:a="http://schemas.openxmlformats.org/drawingml/2006/main"/>
-          <a:p xmlns:a="http://schemas.openxmlformats.org/drawingml/2006/main">
-            <a:pPr>
-              <a:buNone/>
-              <a:defRPr sz="1800" b="1">
-                <a:solidFill>
-                  <a:srgbClr val="2F7D67"/>
-                </a:solidFill>
-              </a:defRPr>
-            </a:pPr>
-            <a:r>
-              <a:rPr sz="1800" b="1">
-                <a:solidFill>
-                  <a:srgbClr val="2F7D67"/>
-                </a:solidFill>
-              </a:rPr>
-              <a:t>VALEUR DU PILOTE</a:t>
-            </a:r>
-          </a:p>
-        </p:txBody>
-      </p:sp>
-      <p:sp>
-        <p:nvSpPr>
-          <p:cNvPr id="9" name="">
-            <a:extLst xmlns:a="http://schemas.openxmlformats.org/drawingml/2006/main">
-              <a:ext uri="{FF2B5EF4-FFF2-40B4-BE49-F238E27FC236}">
-                <a16:creationId xmlns:a16="http://schemas.microsoft.com/office/drawing/2014/main" id="{5FE46928-A66E-4687-983D-46F6A2277407}"/>
-              </a:ext>
-            </a:extLst>
-          </p:cNvPr>
-          <p:cNvSpPr>
-            <a:spLocks xmlns:a="http://schemas.openxmlformats.org/drawingml/2006/main" noGrp="1"/>
-          </p:cNvSpPr>
-          <p:nvPr/>
-        </p:nvSpPr>
-        <p:spPr>
-          <a:xfrm xmlns:a="http://schemas.openxmlformats.org/drawingml/2006/main">
-            <a:off x="781050" y="3476625"/>
-            <a:ext cx="5905500" cy="1000125"/>
-          </a:xfrm>
-          <a:prstGeom xmlns:a="http://schemas.openxmlformats.org/drawingml/2006/main" prst="rect">
-            <a:avLst/>
-          </a:prstGeom>
-          <a:noFill xmlns:a="http://schemas.openxmlformats.org/drawingml/2006/main"/>
-          <a:ln xmlns:a="http://schemas.openxmlformats.org/drawingml/2006/main" w="0">
-            <a:noFill/>
-            <a:prstDash val="solid"/>
-          </a:ln>
-        </p:spPr>
-        <p:txBody>
-          <a:bodyPr xmlns:a="http://schemas.openxmlformats.org/drawingml/2006/main" anchor="t"/>
-          <a:lstStyle xmlns:a="http://schemas.openxmlformats.org/drawingml/2006/main"/>
-          <a:p xmlns:a="http://schemas.openxmlformats.org/drawingml/2006/main">
-            <a:pPr>
-              <a:buNone/>
-              <a:defRPr sz="2550" b="1">
-                <a:solidFill>
-                  <a:srgbClr val="173B57"/>
-                </a:solidFill>
-              </a:defRPr>
-            </a:pPr>
-            <a:r>
-              <a:rPr sz="2550" b="1">
-                <a:solidFill>
-                  <a:srgbClr val="173B57"/>
-                </a:solidFill>
-              </a:rPr>
-              <a:t>étudiants utilement accompagnés</a:t>
-            </a:r>
-          </a:p>
-          <a:p xmlns:a="http://schemas.openxmlformats.org/drawingml/2006/main">
-            <a:pPr>
-              <a:buNone/>
-              <a:defRPr sz="2550" b="1">
-                <a:solidFill>
-                  <a:srgbClr val="173B57"/>
-                </a:solidFill>
-              </a:defRPr>
-            </a:pPr>
-            <a:r>
-              <a:rPr sz="2550" b="1">
-                <a:solidFill>
-                  <a:srgbClr val="173B57"/>
-                </a:solidFill>
-              </a:rPr>
-              <a:t>× effet causal du dispositif</a:t>
-            </a:r>
-          </a:p>
-        </p:txBody>
-      </p:sp>
-      <p:sp>
-        <p:nvSpPr>
-          <p:cNvPr id="10" name="">
-            <a:extLst xmlns:a="http://schemas.openxmlformats.org/drawingml/2006/main">
-              <a:ext uri="{FF2B5EF4-FFF2-40B4-BE49-F238E27FC236}">
-                <a16:creationId xmlns:a16="http://schemas.microsoft.com/office/drawing/2014/main" id="{AF18EA22-E80B-46F4-BC2C-D50D40CB99A6}"/>
-              </a:ext>
-            </a:extLst>
-          </p:cNvPr>
-          <p:cNvSpPr>
-            <a:spLocks xmlns:a="http://schemas.openxmlformats.org/drawingml/2006/main" noGrp="1"/>
-          </p:cNvSpPr>
-          <p:nvPr/>
-        </p:nvSpPr>
-        <p:spPr>
-          <a:xfrm xmlns:a="http://schemas.openxmlformats.org/drawingml/2006/main">
-            <a:off x="7239000" y="3095625"/>
-            <a:ext cx="4000500" cy="1809750"/>
-          </a:xfrm>
-          <a:prstGeom xmlns:a="http://schemas.openxmlformats.org/drawingml/2006/main" prst="rect">
-            <a:avLst/>
-          </a:prstGeom>
-          <a:noFill xmlns:a="http://schemas.openxmlformats.org/drawingml/2006/main"/>
-          <a:ln xmlns:a="http://schemas.openxmlformats.org/drawingml/2006/main" w="0">
-            <a:noFill/>
-            <a:prstDash val="solid"/>
-          </a:ln>
-        </p:spPr>
-        <p:txBody>
-          <a:bodyPr xmlns:a="http://schemas.openxmlformats.org/drawingml/2006/main" anchor="t"/>
-          <a:lstStyle xmlns:a="http://schemas.openxmlformats.org/drawingml/2006/main"/>
-          <a:p xmlns:a="http://schemas.openxmlformats.org/drawingml/2006/main">
-            <a:pPr>
-              <a:lnSpc>
-                <a:spcPct val="122000"/>
-              </a:lnSpc>
-              <a:buNone/>
-              <a:defRPr sz="1500">
-                <a:solidFill>
-                  <a:srgbClr val="1B252C"/>
-                </a:solidFill>
-              </a:defRPr>
-            </a:pPr>
-            <a:r>
-              <a:rPr sz="1500">
-                <a:solidFill>
-                  <a:srgbClr val="1B252C"/>
-                </a:solidFill>
-              </a:rPr>
-              <a:t>• L'AUC ne mesure pas l'impact du tutorat.</a:t>
-            </a:r>
-          </a:p>
-          <a:p xmlns:a="http://schemas.openxmlformats.org/drawingml/2006/main">
-            <a:pPr>
-              <a:lnSpc>
-                <a:spcPct val="122000"/>
-              </a:lnSpc>
-              <a:buNone/>
-              <a:defRPr sz="1500">
-                <a:solidFill>
-                  <a:srgbClr val="1B252C"/>
-                </a:solidFill>
-              </a:defRPr>
-            </a:pPr>
-            <a:r>
-              <a:rPr sz="1500">
-                <a:solidFill>
-                  <a:srgbClr val="1B252C"/>
-                </a:solidFill>
-              </a:rPr>
-              <a:t>• Pilote progressif / A-B test nécessaire.</a:t>
-            </a:r>
-          </a:p>
-          <a:p xmlns:a="http://schemas.openxmlformats.org/drawingml/2006/main">
-            <a:pPr>
-              <a:lnSpc>
-                <a:spcPct val="122000"/>
-              </a:lnSpc>
-              <a:buNone/>
-              <a:defRPr sz="1500">
-                <a:solidFill>
-                  <a:srgbClr val="1B252C"/>
-                </a:solidFill>
-              </a:defRPr>
-            </a:pPr>
-            <a:r>
-              <a:rPr sz="1500">
-                <a:solidFill>
-                  <a:srgbClr val="1B252C"/>
-                </a:solidFill>
-              </a:rPr>
-              <a:t>• Capacité des tuteurs et faux positifs intégrés au coût.</a:t>
-            </a:r>
-          </a:p>
-        </p:txBody>
-      </p:sp>
-      <p:sp>
-        <p:nvSpPr>
-          <p:cNvPr id="11" name="">
-            <a:extLst xmlns:a="http://schemas.openxmlformats.org/drawingml/2006/main">
-              <a:ext uri="{FF2B5EF4-FFF2-40B4-BE49-F238E27FC236}">
-                <a16:creationId xmlns:a16="http://schemas.microsoft.com/office/drawing/2014/main" id="{246CB9C7-47D3-4877-ACF2-AC6D9671432C}"/>
-              </a:ext>
-            </a:extLst>
-          </p:cNvPr>
-          <p:cNvSpPr>
-            <a:spLocks xmlns:a="http://schemas.openxmlformats.org/drawingml/2006/main" noGrp="1"/>
-          </p:cNvSpPr>
-          <p:nvPr/>
-        </p:nvSpPr>
-        <p:spPr>
-          <a:xfrm xmlns:a="http://schemas.openxmlformats.org/drawingml/2006/main">
-            <a:off x="1619250" y="5286375"/>
-            <a:ext cx="8953500" cy="723900"/>
-          </a:xfrm>
-          <a:prstGeom xmlns:a="http://schemas.openxmlformats.org/drawingml/2006/main" prst="rect">
-            <a:avLst/>
-          </a:prstGeom>
-          <a:solidFill xmlns:a="http://schemas.openxmlformats.org/drawingml/2006/main">
-            <a:srgbClr val="F8ECE8"/>
-          </a:solidFill>
-          <a:ln xmlns:a="http://schemas.openxmlformats.org/drawingml/2006/main" w="9525">
-            <a:solidFill>
-              <a:srgbClr val="B95D48"/>
-            </a:solidFill>
-            <a:prstDash val="solid"/>
-          </a:ln>
-        </p:spPr>
-      </p:sp>
-      <p:sp>
-        <p:nvSpPr>
-          <p:cNvPr id="12" name="">
-            <a:extLst xmlns:a="http://schemas.openxmlformats.org/drawingml/2006/main">
-              <a:ext uri="{FF2B5EF4-FFF2-40B4-BE49-F238E27FC236}">
-                <a16:creationId xmlns:a16="http://schemas.microsoft.com/office/drawing/2014/main" id="{4EBBC361-A596-4B17-8B12-B7D53D57EAEE}"/>
-              </a:ext>
-            </a:extLst>
-          </p:cNvPr>
-          <p:cNvSpPr>
-            <a:spLocks xmlns:a="http://schemas.openxmlformats.org/drawingml/2006/main" noGrp="1"/>
-          </p:cNvSpPr>
-          <p:nvPr/>
-        </p:nvSpPr>
-        <p:spPr>
-          <a:xfrm xmlns:a="http://schemas.openxmlformats.org/drawingml/2006/main">
-            <a:off x="1790700" y="5400675"/>
-            <a:ext cx="8610600" cy="495300"/>
-          </a:xfrm>
-          <a:prstGeom xmlns:a="http://schemas.openxmlformats.org/drawingml/2006/main" prst="rect">
-            <a:avLst/>
-          </a:prstGeom>
-          <a:noFill xmlns:a="http://schemas.openxmlformats.org/drawingml/2006/main"/>
-          <a:ln xmlns:a="http://schemas.openxmlformats.org/drawingml/2006/main" w="0">
-            <a:noFill/>
-            <a:prstDash val="solid"/>
-          </a:ln>
-        </p:spPr>
-        <p:txBody>
-          <a:bodyPr xmlns:a="http://schemas.openxmlformats.org/drawingml/2006/main" anchor="ctr"/>
-          <a:lstStyle xmlns:a="http://schemas.openxmlformats.org/drawingml/2006/main"/>
-          <a:p xmlns:a="http://schemas.openxmlformats.org/drawingml/2006/main">
-            <a:pPr>
-              <a:buNone/>
-              <a:defRPr sz="1500" b="1">
-                <a:solidFill>
-                  <a:srgbClr val="B95D48"/>
-                </a:solidFill>
-              </a:defRPr>
-            </a:pPr>
-            <a:r>
-              <a:rPr sz="1500" b="1">
-                <a:solidFill>
-                  <a:srgbClr val="B95D48"/>
-                </a:solidFill>
-              </a:rPr>
-              <a:t>Aucun gain financier inventé : hypothèses à valider avec l'université.</a:t>
+          <a:bodyPr xmlns:a="http://schemas.openxmlformats.org/drawingml/2006/main"/>
+          <a:lstStyle xmlns:a="http://schemas.openxmlformats.org/drawingml/2006/main"/>
+          <a:p xmlns:a="http://schemas.openxmlformats.org/drawingml/2006/main">
+            <a:pPr>
+              <a:defRPr sz="1350" b="1">
+                <a:solidFill>
+                  <a:srgbClr val="2B7F6E"/>
+                </a:solidFill>
+                <a:latin typeface="Calibri"/>
+                <a:ea typeface="Calibri"/>
+                <a:cs typeface="Calibri"/>
+              </a:defRPr>
+            </a:pPr>
+            <a:r>
+              <a:rPr sz="1350" b="1">
+                <a:solidFill>
+                  <a:srgbClr val="2B7F6E"/>
+                </a:solidFill>
+                <a:latin typeface="Calibri"/>
+                <a:ea typeface="Calibri"/>
+                <a:cs typeface="Calibri"/>
+              </a:rPr>
+              <a:t>Chaque version reste reliée au run qui a produit son artefact.</a:t>
             </a:r>
           </a:p>
         </p:txBody>
@@ -11454,7 +11395,7 @@
     </p:spTree>
     <p:extLst>
       <p:ext uri="{BB962C8B-B14F-4D97-AF65-F5344CB8AC3E}">
-        <p14:creationId xmlns:p14="http://schemas.microsoft.com/office/powerpoint/2010/main" val="893676865"/>
+        <p14:creationId xmlns:p14="http://schemas.microsoft.com/office/powerpoint/2010/main" val="1096449478"/>
       </p:ext>
     </p:extLst>
   </p:cSld>
@@ -11464,13 +11405,6 @@
 <file path=ppt/slides/slide24.xml><?xml version="1.0" encoding="utf-8"?>
 <p:sld xmlns:p="http://schemas.openxmlformats.org/presentationml/2006/main">
   <p:cSld>
-    <p:bg>
-      <p:bgPr>
-        <a:solidFill xmlns:a="http://schemas.openxmlformats.org/drawingml/2006/main">
-          <a:srgbClr val="FFFFFF"/>
-        </a:solidFill>
-      </p:bgPr>
-    </p:bg>
     <p:spTree>
       <p:nvGrpSpPr>
         <p:cNvPr id="1" name=""/>
@@ -11482,10 +11416,41 @@
       </p:grpSpPr>
       <p:sp>
         <p:nvSpPr>
-          <p:cNvPr id="7" name="">
-            <a:extLst xmlns:a="http://schemas.openxmlformats.org/drawingml/2006/main">
-              <a:ext uri="{FF2B5EF4-FFF2-40B4-BE49-F238E27FC236}">
-                <a16:creationId xmlns:a16="http://schemas.microsoft.com/office/drawing/2014/main" id="{18A77E1C-2B23-4094-9236-BEC86DCE8B41}"/>
+          <p:cNvPr id="6" name="">
+            <a:extLst xmlns:a="http://schemas.openxmlformats.org/drawingml/2006/main">
+              <a:ext uri="{FF2B5EF4-FFF2-40B4-BE49-F238E27FC236}">
+                <a16:creationId xmlns:a16="http://schemas.microsoft.com/office/drawing/2014/main" id="{ED92F17D-E081-4B50-9B1B-EAABECA7597D}"/>
+              </a:ext>
+            </a:extLst>
+          </p:cNvPr>
+          <p:cNvSpPr>
+            <a:spLocks xmlns:a="http://schemas.openxmlformats.org/drawingml/2006/main" noGrp="1"/>
+          </p:cNvSpPr>
+          <p:nvPr/>
+        </p:nvSpPr>
+        <p:spPr>
+          <a:xfrm xmlns:a="http://schemas.openxmlformats.org/drawingml/2006/main">
+            <a:off x="0" y="0"/>
+            <a:ext cx="12192000" cy="6858000"/>
+          </a:xfrm>
+          <a:prstGeom xmlns:a="http://schemas.openxmlformats.org/drawingml/2006/main" prst="rect">
+            <a:avLst/>
+          </a:prstGeom>
+          <a:solidFill xmlns:a="http://schemas.openxmlformats.org/drawingml/2006/main">
+            <a:srgbClr val="FFFFFF"/>
+          </a:solidFill>
+          <a:ln xmlns:a="http://schemas.openxmlformats.org/drawingml/2006/main" w="0">
+            <a:noFill/>
+            <a:prstDash val="solid"/>
+          </a:ln>
+        </p:spPr>
+      </p:sp>
+      <p:sp>
+        <p:nvSpPr>
+          <p:cNvPr id="2" name="">
+            <a:extLst xmlns:a="http://schemas.openxmlformats.org/drawingml/2006/main">
+              <a:ext uri="{FF2B5EF4-FFF2-40B4-BE49-F238E27FC236}">
+                <a16:creationId xmlns:a16="http://schemas.microsoft.com/office/drawing/2014/main" id="{93CFA318-C193-4927-B603-BE769175F67E}"/>
               </a:ext>
             </a:extLst>
           </p:cNvPr>
@@ -11509,15 +11474,17 @@
           </a:ln>
         </p:spPr>
         <p:txBody>
-          <a:bodyPr xmlns:a="http://schemas.openxmlformats.org/drawingml/2006/main" anchor="t"/>
-          <a:lstStyle xmlns:a="http://schemas.openxmlformats.org/drawingml/2006/main"/>
-          <a:p xmlns:a="http://schemas.openxmlformats.org/drawingml/2006/main">
-            <a:pPr>
-              <a:buNone/>
+          <a:bodyPr xmlns:a="http://schemas.openxmlformats.org/drawingml/2006/main"/>
+          <a:lstStyle xmlns:a="http://schemas.openxmlformats.org/drawingml/2006/main"/>
+          <a:p xmlns:a="http://schemas.openxmlformats.org/drawingml/2006/main">
+            <a:pPr>
               <a:defRPr sz="2700" b="1">
                 <a:solidFill>
                   <a:srgbClr val="173B57"/>
                 </a:solidFill>
+                <a:latin typeface="Calibri"/>
+                <a:ea typeface="Calibri"/>
+                <a:cs typeface="Calibri"/>
               </a:defRPr>
             </a:pPr>
             <a:r>
@@ -11525,18 +11492,21 @@
                 <a:solidFill>
                   <a:srgbClr val="173B57"/>
                 </a:solidFill>
-              </a:rPr>
-              <a:t>19. Limites &amp; recommandations</a:t>
-            </a:r>
-          </a:p>
-        </p:txBody>
-      </p:sp>
-      <p:sp>
-        <p:nvSpPr>
-          <p:cNvPr id="2" name="">
-            <a:extLst xmlns:a="http://schemas.openxmlformats.org/drawingml/2006/main">
-              <a:ext uri="{FF2B5EF4-FFF2-40B4-BE49-F238E27FC236}">
-                <a16:creationId xmlns:a16="http://schemas.microsoft.com/office/drawing/2014/main" id="{AAC52D35-FD95-46AD-B4E5-E2594CD9E567}"/>
+                <a:latin typeface="Calibri"/>
+                <a:ea typeface="Calibri"/>
+                <a:cs typeface="Calibri"/>
+              </a:rPr>
+              <a:t>17.5 Versions, promotion et rollback</a:t>
+            </a:r>
+          </a:p>
+        </p:txBody>
+      </p:sp>
+      <p:sp>
+        <p:nvSpPr>
+          <p:cNvPr id="3" name="">
+            <a:extLst xmlns:a="http://schemas.openxmlformats.org/drawingml/2006/main">
+              <a:ext uri="{FF2B5EF4-FFF2-40B4-BE49-F238E27FC236}">
+                <a16:creationId xmlns:a16="http://schemas.microsoft.com/office/drawing/2014/main" id="{60FAFF25-972A-43FA-8046-72DF3C825136}"/>
               </a:ext>
             </a:extLst>
           </p:cNvPr>
@@ -11564,10 +11534,10 @@
       </p:sp>
       <p:sp>
         <p:nvSpPr>
-          <p:cNvPr id="3" name="">
-            <a:extLst xmlns:a="http://schemas.openxmlformats.org/drawingml/2006/main">
-              <a:ext uri="{FF2B5EF4-FFF2-40B4-BE49-F238E27FC236}">
-                <a16:creationId xmlns:a16="http://schemas.microsoft.com/office/drawing/2014/main" id="{66992DBB-B67F-4143-BBCD-9C63D33D7EBF}"/>
+          <p:cNvPr id="4" name="">
+            <a:extLst xmlns:a="http://schemas.openxmlformats.org/drawingml/2006/main">
+              <a:ext uri="{FF2B5EF4-FFF2-40B4-BE49-F238E27FC236}">
+                <a16:creationId xmlns:a16="http://schemas.microsoft.com/office/drawing/2014/main" id="{ED2A7313-DB3F-4B9A-8809-098C58ADC9E5}"/>
               </a:ext>
             </a:extLst>
           </p:cNvPr>
@@ -11591,15 +11561,17 @@
           </a:ln>
         </p:spPr>
         <p:txBody>
-          <a:bodyPr xmlns:a="http://schemas.openxmlformats.org/drawingml/2006/main" anchor="t"/>
+          <a:bodyPr xmlns:a="http://schemas.openxmlformats.org/drawingml/2006/main"/>
           <a:lstStyle xmlns:a="http://schemas.openxmlformats.org/drawingml/2006/main"/>
           <a:p xmlns:a="http://schemas.openxmlformats.org/drawingml/2006/main">
             <a:pPr algn="r">
-              <a:buNone/>
               <a:defRPr sz="900">
                 <a:solidFill>
                   <a:srgbClr val="85929B"/>
                 </a:solidFill>
+                <a:latin typeface="Calibri"/>
+                <a:ea typeface="Calibri"/>
+                <a:cs typeface="Calibri"/>
               </a:defRPr>
             </a:pPr>
             <a:r>
@@ -11607,238 +11579,41 @@
                 <a:solidFill>
                   <a:srgbClr val="85929B"/>
                 </a:solidFill>
+                <a:latin typeface="Calibri"/>
+                <a:ea typeface="Calibri"/>
+                <a:cs typeface="Calibri"/>
               </a:rPr>
               <a:t>24</a:t>
             </a:r>
           </a:p>
         </p:txBody>
       </p:sp>
-      <p:sp>
-        <p:nvSpPr>
-          <p:cNvPr id="4" name="">
-            <a:extLst xmlns:a="http://schemas.openxmlformats.org/drawingml/2006/main">
-              <a:ext uri="{FF2B5EF4-FFF2-40B4-BE49-F238E27FC236}">
-                <a16:creationId xmlns:a16="http://schemas.microsoft.com/office/drawing/2014/main" id="{EB912D26-5B00-4C7C-AFE8-09DFA87E9904}"/>
-              </a:ext>
-            </a:extLst>
-          </p:cNvPr>
-          <p:cNvSpPr>
-            <a:spLocks xmlns:a="http://schemas.openxmlformats.org/drawingml/2006/main" noGrp="1"/>
-          </p:cNvSpPr>
-          <p:nvPr/>
-        </p:nvSpPr>
-        <p:spPr>
-          <a:xfrm xmlns:a="http://schemas.openxmlformats.org/drawingml/2006/main">
-            <a:off x="904875" y="1571625"/>
-            <a:ext cx="10287000" cy="3333750"/>
-          </a:xfrm>
-          <a:prstGeom xmlns:a="http://schemas.openxmlformats.org/drawingml/2006/main" prst="rect">
-            <a:avLst/>
-          </a:prstGeom>
-          <a:noFill xmlns:a="http://schemas.openxmlformats.org/drawingml/2006/main"/>
-          <a:ln xmlns:a="http://schemas.openxmlformats.org/drawingml/2006/main" w="0">
-            <a:noFill/>
-            <a:prstDash val="solid"/>
-          </a:ln>
-        </p:spPr>
-        <p:txBody>
-          <a:bodyPr xmlns:a="http://schemas.openxmlformats.org/drawingml/2006/main" anchor="t"/>
-          <a:lstStyle xmlns:a="http://schemas.openxmlformats.org/drawingml/2006/main"/>
-          <a:p xmlns:a="http://schemas.openxmlformats.org/drawingml/2006/main">
-            <a:pPr>
-              <a:lnSpc>
-                <a:spcPct val="122000"/>
-              </a:lnSpc>
-              <a:buNone/>
-              <a:defRPr sz="1650">
-                <a:solidFill>
-                  <a:srgbClr val="1B252C"/>
-                </a:solidFill>
-              </a:defRPr>
-            </a:pPr>
-            <a:r>
-              <a:rPr sz="1650">
-                <a:solidFill>
-                  <a:srgbClr val="1B252C"/>
-                </a:solidFill>
-              </a:rPr>
-              <a:t>• Données synthétiques : performance à revalider sur des cohortes réelles.</a:t>
-            </a:r>
-          </a:p>
-          <a:p xmlns:a="http://schemas.openxmlformats.org/drawingml/2006/main">
-            <a:pPr>
-              <a:lnSpc>
-                <a:spcPct val="122000"/>
-              </a:lnSpc>
-              <a:buNone/>
-              <a:defRPr sz="1650">
-                <a:solidFill>
-                  <a:srgbClr val="1B252C"/>
-                </a:solidFill>
-              </a:defRPr>
-            </a:pPr>
-            <a:r>
-              <a:rPr sz="1650">
-                <a:solidFill>
-                  <a:srgbClr val="1B252C"/>
-                </a:solidFill>
-              </a:rPr>
-              <a:t>• Corrélation ≠ causalité : mesurer l'effet du dispositif par pilote.</a:t>
-            </a:r>
-          </a:p>
-          <a:p xmlns:a="http://schemas.openxmlformats.org/drawingml/2006/main">
-            <a:pPr>
-              <a:lnSpc>
-                <a:spcPct val="122000"/>
-              </a:lnSpc>
-              <a:buNone/>
-              <a:defRPr sz="1650">
-                <a:solidFill>
-                  <a:srgbClr val="1B252C"/>
-                </a:solidFill>
-              </a:defRPr>
-            </a:pPr>
-            <a:r>
-              <a:rPr sz="1650">
-                <a:solidFill>
-                  <a:srgbClr val="1B252C"/>
-                </a:solidFill>
-              </a:rPr>
-              <a:t>• Production réelle : DPO, DPIA/AIPD, RBAC, coffre de secrets, sauvegardes testées.</a:t>
-            </a:r>
-          </a:p>
-          <a:p xmlns:a="http://schemas.openxmlformats.org/drawingml/2006/main">
-            <a:pPr>
-              <a:lnSpc>
-                <a:spcPct val="122000"/>
-              </a:lnSpc>
-              <a:buNone/>
-              <a:defRPr sz="1650">
-                <a:solidFill>
-                  <a:srgbClr val="1B252C"/>
-                </a:solidFill>
-              </a:defRPr>
-            </a:pPr>
-            <a:r>
-              <a:rPr sz="1650">
-                <a:solidFill>
-                  <a:srgbClr val="1B252C"/>
-                </a:solidFill>
-              </a:rPr>
-              <a:t>• Run réel : confirmer le TCO, brancher le canal d'alerte et planifier les jobs.</a:t>
-            </a:r>
-          </a:p>
-          <a:p xmlns:a="http://schemas.openxmlformats.org/drawingml/2006/main">
-            <a:pPr>
-              <a:lnSpc>
-                <a:spcPct val="122000"/>
-              </a:lnSpc>
-              <a:buNone/>
-              <a:defRPr sz="1650">
-                <a:solidFill>
-                  <a:srgbClr val="1B252C"/>
-                </a:solidFill>
-              </a:defRPr>
-            </a:pPr>
-            <a:r>
-              <a:rPr sz="1650">
-                <a:solidFill>
-                  <a:srgbClr val="1B252C"/>
-                </a:solidFill>
-              </a:rPr>
-              <a:t>• Éthique : équité continue, explication, recours et formulation non stigmatisante.</a:t>
-            </a:r>
-          </a:p>
-        </p:txBody>
-      </p:sp>
-      <p:sp>
-        <p:nvSpPr>
-          <p:cNvPr id="5" name="">
-            <a:extLst xmlns:a="http://schemas.openxmlformats.org/drawingml/2006/main">
-              <a:ext uri="{FF2B5EF4-FFF2-40B4-BE49-F238E27FC236}">
-                <a16:creationId xmlns:a16="http://schemas.microsoft.com/office/drawing/2014/main" id="{93B0E887-5075-4E9D-BD88-37AFE440B410}"/>
-              </a:ext>
-            </a:extLst>
-          </p:cNvPr>
-          <p:cNvSpPr>
-            <a:spLocks xmlns:a="http://schemas.openxmlformats.org/drawingml/2006/main" noGrp="1"/>
-          </p:cNvSpPr>
-          <p:nvPr/>
-        </p:nvSpPr>
-        <p:spPr>
-          <a:xfrm xmlns:a="http://schemas.openxmlformats.org/drawingml/2006/main">
-            <a:off x="1381125" y="5095875"/>
-            <a:ext cx="9429750" cy="742950"/>
-          </a:xfrm>
-          <a:prstGeom xmlns:a="http://schemas.openxmlformats.org/drawingml/2006/main" prst="rect">
-            <a:avLst/>
-          </a:prstGeom>
-          <a:solidFill xmlns:a="http://schemas.openxmlformats.org/drawingml/2006/main">
-            <a:srgbClr val="E8F3EF"/>
-          </a:solidFill>
-          <a:ln xmlns:a="http://schemas.openxmlformats.org/drawingml/2006/main" w="9525">
-            <a:solidFill>
-              <a:srgbClr val="2F7D67"/>
-            </a:solidFill>
-            <a:prstDash val="solid"/>
-          </a:ln>
-        </p:spPr>
-      </p:sp>
-      <p:sp>
-        <p:nvSpPr>
-          <p:cNvPr id="6" name="">
-            <a:extLst xmlns:a="http://schemas.openxmlformats.org/drawingml/2006/main">
-              <a:ext uri="{FF2B5EF4-FFF2-40B4-BE49-F238E27FC236}">
-                <a16:creationId xmlns:a16="http://schemas.microsoft.com/office/drawing/2014/main" id="{665FCA75-547D-494B-85C1-D42DEE2646CF}"/>
-              </a:ext>
-            </a:extLst>
-          </p:cNvPr>
-          <p:cNvSpPr>
-            <a:spLocks xmlns:a="http://schemas.openxmlformats.org/drawingml/2006/main" noGrp="1"/>
-          </p:cNvSpPr>
-          <p:nvPr/>
-        </p:nvSpPr>
-        <p:spPr>
-          <a:xfrm xmlns:a="http://schemas.openxmlformats.org/drawingml/2006/main">
-            <a:off x="1552575" y="5210175"/>
-            <a:ext cx="9086850" cy="514350"/>
-          </a:xfrm>
-          <a:prstGeom xmlns:a="http://schemas.openxmlformats.org/drawingml/2006/main" prst="rect">
-            <a:avLst/>
-          </a:prstGeom>
-          <a:noFill xmlns:a="http://schemas.openxmlformats.org/drawingml/2006/main"/>
-          <a:ln xmlns:a="http://schemas.openxmlformats.org/drawingml/2006/main" w="0">
-            <a:noFill/>
-            <a:prstDash val="solid"/>
-          </a:ln>
-        </p:spPr>
-        <p:txBody>
-          <a:bodyPr xmlns:a="http://schemas.openxmlformats.org/drawingml/2006/main" anchor="ctr"/>
-          <a:lstStyle xmlns:a="http://schemas.openxmlformats.org/drawingml/2006/main"/>
-          <a:p xmlns:a="http://schemas.openxmlformats.org/drawingml/2006/main">
-            <a:pPr>
-              <a:buNone/>
-              <a:defRPr sz="1500" b="1">
-                <a:solidFill>
-                  <a:srgbClr val="2F7D67"/>
-                </a:solidFill>
-              </a:defRPr>
-            </a:pPr>
-            <a:r>
-              <a:rPr sz="1500" b="1">
-                <a:solidFill>
-                  <a:srgbClr val="2F7D67"/>
-                </a:solidFill>
-              </a:rPr>
-              <a:t>Le score priorise l'accompagnement ; il ne décide jamais du parcours d'un étudiant.</a:t>
-            </a:r>
-          </a:p>
-        </p:txBody>
-      </p:sp>
+      <p:pic>
+        <p:nvPicPr>
+          <p:cNvPr id="10" name=""/>
+          <p:cNvPicPr>
+            <a:picLocks xmlns:a="http://schemas.openxmlformats.org/drawingml/2006/main" noChangeAspect="1"/>
+          </p:cNvPicPr>
+          <p:nvPr/>
+        </p:nvPicPr>
+        <p:blipFill>
+          <a:blip xmlns:r="http://schemas.openxmlformats.org/officeDocument/2006/relationships" xmlns:a="http://schemas.openxmlformats.org/drawingml/2006/main" r:embed="R3b930f7f3bf84910"/>
+          <a:stretch xmlns:a="http://schemas.openxmlformats.org/drawingml/2006/main"/>
+        </p:blipFill>
+        <p:spPr>
+          <a:xfrm xmlns:a="http://schemas.openxmlformats.org/drawingml/2006/main">
+            <a:off x="1693333" y="1219200"/>
+            <a:ext cx="8805333" cy="4953000"/>
+          </a:xfrm>
+          <a:prstGeom xmlns:a="http://schemas.openxmlformats.org/drawingml/2006/main" prst="rect">
+            <a:avLst/>
+          </a:prstGeom>
+        </p:spPr>
+      </p:pic>
     </p:spTree>
     <p:extLst>
       <p:ext uri="{BB962C8B-B14F-4D97-AF65-F5344CB8AC3E}">
-        <p14:creationId xmlns:p14="http://schemas.microsoft.com/office/powerpoint/2010/main" val="1218725923"/>
+        <p14:creationId xmlns:p14="http://schemas.microsoft.com/office/powerpoint/2010/main" val="1923342835"/>
       </p:ext>
     </p:extLst>
   </p:cSld>
@@ -11848,13 +11623,6 @@
 <file path=ppt/slides/slide25.xml><?xml version="1.0" encoding="utf-8"?>
 <p:sld xmlns:p="http://schemas.openxmlformats.org/presentationml/2006/main">
   <p:cSld>
-    <p:bg>
-      <p:bgPr>
-        <a:solidFill xmlns:a="http://schemas.openxmlformats.org/drawingml/2006/main">
-          <a:srgbClr val="FFFFFF"/>
-        </a:solidFill>
-      </p:bgPr>
-    </p:bg>
     <p:spTree>
       <p:nvGrpSpPr>
         <p:cNvPr id="1" name=""/>
@@ -11866,10 +11634,41 @@
       </p:grpSpPr>
       <p:sp>
         <p:nvSpPr>
-          <p:cNvPr id="7" name="">
-            <a:extLst xmlns:a="http://schemas.openxmlformats.org/drawingml/2006/main">
-              <a:ext uri="{FF2B5EF4-FFF2-40B4-BE49-F238E27FC236}">
-                <a16:creationId xmlns:a16="http://schemas.microsoft.com/office/drawing/2014/main" id="{94FD13DA-5461-453B-B426-F31AEE47BA61}"/>
+          <p:cNvPr id="9" name="">
+            <a:extLst xmlns:a="http://schemas.openxmlformats.org/drawingml/2006/main">
+              <a:ext uri="{FF2B5EF4-FFF2-40B4-BE49-F238E27FC236}">
+                <a16:creationId xmlns:a16="http://schemas.microsoft.com/office/drawing/2014/main" id="{03C4E374-7307-4EC7-A406-D5DD65D0319F}"/>
+              </a:ext>
+            </a:extLst>
+          </p:cNvPr>
+          <p:cNvSpPr>
+            <a:spLocks xmlns:a="http://schemas.openxmlformats.org/drawingml/2006/main" noGrp="1"/>
+          </p:cNvSpPr>
+          <p:nvPr/>
+        </p:nvSpPr>
+        <p:spPr>
+          <a:xfrm xmlns:a="http://schemas.openxmlformats.org/drawingml/2006/main">
+            <a:off x="0" y="0"/>
+            <a:ext cx="12192000" cy="6858000"/>
+          </a:xfrm>
+          <a:prstGeom xmlns:a="http://schemas.openxmlformats.org/drawingml/2006/main" prst="rect">
+            <a:avLst/>
+          </a:prstGeom>
+          <a:solidFill xmlns:a="http://schemas.openxmlformats.org/drawingml/2006/main">
+            <a:srgbClr val="FFFFFF"/>
+          </a:solidFill>
+          <a:ln xmlns:a="http://schemas.openxmlformats.org/drawingml/2006/main" w="0">
+            <a:noFill/>
+            <a:prstDash val="solid"/>
+          </a:ln>
+        </p:spPr>
+      </p:sp>
+      <p:sp>
+        <p:nvSpPr>
+          <p:cNvPr id="2" name="">
+            <a:extLst xmlns:a="http://schemas.openxmlformats.org/drawingml/2006/main">
+              <a:ext uri="{FF2B5EF4-FFF2-40B4-BE49-F238E27FC236}">
+                <a16:creationId xmlns:a16="http://schemas.microsoft.com/office/drawing/2014/main" id="{180C839B-462F-44ED-A424-3D27C65376FD}"/>
               </a:ext>
             </a:extLst>
           </p:cNvPr>
@@ -11893,15 +11692,17 @@
           </a:ln>
         </p:spPr>
         <p:txBody>
-          <a:bodyPr xmlns:a="http://schemas.openxmlformats.org/drawingml/2006/main" anchor="t"/>
-          <a:lstStyle xmlns:a="http://schemas.openxmlformats.org/drawingml/2006/main"/>
-          <a:p xmlns:a="http://schemas.openxmlformats.org/drawingml/2006/main">
-            <a:pPr>
-              <a:buNone/>
+          <a:bodyPr xmlns:a="http://schemas.openxmlformats.org/drawingml/2006/main"/>
+          <a:lstStyle xmlns:a="http://schemas.openxmlformats.org/drawingml/2006/main"/>
+          <a:p xmlns:a="http://schemas.openxmlformats.org/drawingml/2006/main">
+            <a:pPr>
               <a:defRPr sz="2700" b="1">
                 <a:solidFill>
                   <a:srgbClr val="173B57"/>
                 </a:solidFill>
+                <a:latin typeface="Calibri"/>
+                <a:ea typeface="Calibri"/>
+                <a:cs typeface="Calibri"/>
               </a:defRPr>
             </a:pPr>
             <a:r>
@@ -11909,18 +11710,21 @@
                 <a:solidFill>
                   <a:srgbClr val="173B57"/>
                 </a:solidFill>
-              </a:rPr>
-              <a:t>20. Conclusion — du modèle au Run, C1→C9</a:t>
-            </a:r>
-          </a:p>
-        </p:txBody>
-      </p:sp>
-      <p:sp>
-        <p:nvSpPr>
-          <p:cNvPr id="2" name="">
-            <a:extLst xmlns:a="http://schemas.openxmlformats.org/drawingml/2006/main">
-              <a:ext uri="{FF2B5EF4-FFF2-40B4-BE49-F238E27FC236}">
-                <a16:creationId xmlns:a16="http://schemas.microsoft.com/office/drawing/2014/main" id="{10EAF760-C659-4364-8793-21891BDC6BD0}"/>
+                <a:latin typeface="Calibri"/>
+                <a:ea typeface="Calibri"/>
+                <a:cs typeface="Calibri"/>
+              </a:rPr>
+              <a:t>17.6 Journaux JSON corrélés et bornés</a:t>
+            </a:r>
+          </a:p>
+        </p:txBody>
+      </p:sp>
+      <p:sp>
+        <p:nvSpPr>
+          <p:cNvPr id="3" name="">
+            <a:extLst xmlns:a="http://schemas.openxmlformats.org/drawingml/2006/main">
+              <a:ext uri="{FF2B5EF4-FFF2-40B4-BE49-F238E27FC236}">
+                <a16:creationId xmlns:a16="http://schemas.microsoft.com/office/drawing/2014/main" id="{612DD19E-7DAB-4C41-9FFC-B8351A3A067C}"/>
               </a:ext>
             </a:extLst>
           </p:cNvPr>
@@ -11948,10 +11752,10 @@
       </p:sp>
       <p:sp>
         <p:nvSpPr>
-          <p:cNvPr id="3" name="">
-            <a:extLst xmlns:a="http://schemas.openxmlformats.org/drawingml/2006/main">
-              <a:ext uri="{FF2B5EF4-FFF2-40B4-BE49-F238E27FC236}">
-                <a16:creationId xmlns:a16="http://schemas.microsoft.com/office/drawing/2014/main" id="{4FED1F7F-F033-479D-B6AB-3E80B816FCEF}"/>
+          <p:cNvPr id="4" name="">
+            <a:extLst xmlns:a="http://schemas.openxmlformats.org/drawingml/2006/main">
+              <a:ext uri="{FF2B5EF4-FFF2-40B4-BE49-F238E27FC236}">
+                <a16:creationId xmlns:a16="http://schemas.microsoft.com/office/drawing/2014/main" id="{80F21DB0-7635-4347-B2DF-7A4AFD57105A}"/>
               </a:ext>
             </a:extLst>
           </p:cNvPr>
@@ -11975,15 +11779,17 @@
           </a:ln>
         </p:spPr>
         <p:txBody>
-          <a:bodyPr xmlns:a="http://schemas.openxmlformats.org/drawingml/2006/main" anchor="t"/>
+          <a:bodyPr xmlns:a="http://schemas.openxmlformats.org/drawingml/2006/main"/>
           <a:lstStyle xmlns:a="http://schemas.openxmlformats.org/drawingml/2006/main"/>
           <a:p xmlns:a="http://schemas.openxmlformats.org/drawingml/2006/main">
             <a:pPr algn="r">
-              <a:buNone/>
               <a:defRPr sz="900">
                 <a:solidFill>
                   <a:srgbClr val="85929B"/>
                 </a:solidFill>
+                <a:latin typeface="Calibri"/>
+                <a:ea typeface="Calibri"/>
+                <a:cs typeface="Calibri"/>
               </a:defRPr>
             </a:pPr>
             <a:r>
@@ -11991,6 +11797,9 @@
                 <a:solidFill>
                   <a:srgbClr val="85929B"/>
                 </a:solidFill>
+                <a:latin typeface="Calibri"/>
+                <a:ea typeface="Calibri"/>
+                <a:cs typeface="Calibri"/>
               </a:rPr>
               <a:t>25</a:t>
             </a:r>
@@ -11999,22 +11808,22 @@
       </p:sp>
       <p:sp>
         <p:nvSpPr>
-          <p:cNvPr id="4" name="">
-            <a:extLst xmlns:a="http://schemas.openxmlformats.org/drawingml/2006/main">
-              <a:ext uri="{FF2B5EF4-FFF2-40B4-BE49-F238E27FC236}">
-                <a16:creationId xmlns:a16="http://schemas.microsoft.com/office/drawing/2014/main" id="{CCA343F9-98D8-412B-9C24-F9BC838BE751}"/>
-              </a:ext>
-            </a:extLst>
-          </p:cNvPr>
-          <p:cNvSpPr>
-            <a:spLocks xmlns:a="http://schemas.openxmlformats.org/drawingml/2006/main" noGrp="1"/>
-          </p:cNvSpPr>
-          <p:nvPr/>
-        </p:nvSpPr>
-        <p:spPr>
-          <a:xfrm xmlns:a="http://schemas.openxmlformats.org/drawingml/2006/main">
-            <a:off x="1000125" y="1666875"/>
-            <a:ext cx="10096500" cy="2857500"/>
+          <p:cNvPr id="5" name="">
+            <a:extLst xmlns:a="http://schemas.openxmlformats.org/drawingml/2006/main">
+              <a:ext uri="{FF2B5EF4-FFF2-40B4-BE49-F238E27FC236}">
+                <a16:creationId xmlns:a16="http://schemas.microsoft.com/office/drawing/2014/main" id="{A89265A3-1CA4-4BA4-A153-87AAC5E1B0A2}"/>
+              </a:ext>
+            </a:extLst>
+          </p:cNvPr>
+          <p:cNvSpPr>
+            <a:spLocks xmlns:a="http://schemas.openxmlformats.org/drawingml/2006/main" noGrp="1"/>
+          </p:cNvSpPr>
+          <p:nvPr/>
+        </p:nvSpPr>
+        <p:spPr>
+          <a:xfrm xmlns:a="http://schemas.openxmlformats.org/drawingml/2006/main">
+            <a:off x="762000" y="1381125"/>
+            <a:ext cx="3429000" cy="323850"/>
           </a:xfrm>
           <a:prstGeom xmlns:a="http://schemas.openxmlformats.org/drawingml/2006/main" prst="rect">
             <a:avLst/>
@@ -12026,128 +11835,203 @@
           </a:ln>
         </p:spPr>
         <p:txBody>
-          <a:bodyPr xmlns:a="http://schemas.openxmlformats.org/drawingml/2006/main" anchor="t"/>
-          <a:lstStyle xmlns:a="http://schemas.openxmlformats.org/drawingml/2006/main"/>
-          <a:p xmlns:a="http://schemas.openxmlformats.org/drawingml/2006/main">
-            <a:pPr>
-              <a:lnSpc>
-                <a:spcPct val="122000"/>
-              </a:lnSpc>
-              <a:buNone/>
-              <a:defRPr sz="1725">
-                <a:solidFill>
-                  <a:srgbClr val="1B252C"/>
-                </a:solidFill>
-              </a:defRPr>
-            </a:pPr>
-            <a:r>
-              <a:rPr sz="1725">
-                <a:solidFill>
-                  <a:srgbClr val="1B252C"/>
-                </a:solidFill>
-              </a:rPr>
-              <a:t>• Rigueur anti-fuite : trois pièges neutralisés et garde-fou codé.</a:t>
-            </a:r>
-          </a:p>
-          <a:p xmlns:a="http://schemas.openxmlformats.org/drawingml/2006/main">
-            <a:pPr>
-              <a:lnSpc>
-                <a:spcPct val="122000"/>
-              </a:lnSpc>
-              <a:buNone/>
-              <a:defRPr sz="1725">
-                <a:solidFill>
-                  <a:srgbClr val="1B252C"/>
-                </a:solidFill>
-              </a:defRPr>
-            </a:pPr>
-            <a:r>
-              <a:rPr sz="1725">
-                <a:solidFill>
-                  <a:srgbClr val="1B252C"/>
-                </a:solidFill>
-              </a:rPr>
-              <a:t>• Modèle explicable : AUC 0,95, rappel 95,9 %, seuil métier assumé.</a:t>
-            </a:r>
-          </a:p>
-          <a:p xmlns:a="http://schemas.openxmlformats.org/drawingml/2006/main">
-            <a:pPr>
-              <a:lnSpc>
-                <a:spcPct val="122000"/>
-              </a:lnSpc>
-              <a:buNone/>
-              <a:defRPr sz="1725">
-                <a:solidFill>
-                  <a:srgbClr val="1B252C"/>
-                </a:solidFill>
-              </a:defRPr>
-            </a:pPr>
-            <a:r>
-              <a:rPr sz="1725">
-                <a:solidFill>
-                  <a:srgbClr val="1B252C"/>
-                </a:solidFill>
-              </a:rPr>
-              <a:t>• Architecture responsable : RGPD, médaillon, décision humaine.</a:t>
-            </a:r>
-          </a:p>
-          <a:p xmlns:a="http://schemas.openxmlformats.org/drawingml/2006/main">
-            <a:pPr>
-              <a:lnSpc>
-                <a:spcPct val="122000"/>
-              </a:lnSpc>
-              <a:buNone/>
-              <a:defRPr sz="1725">
-                <a:solidFill>
-                  <a:srgbClr val="1B252C"/>
-                </a:solidFill>
-              </a:defRPr>
-            </a:pPr>
-            <a:r>
-              <a:rPr sz="1725">
-                <a:solidFill>
-                  <a:srgbClr val="1B252C"/>
-                </a:solidFill>
-              </a:rPr>
-              <a:t>• </a:t>
-            </a:r>
-            <a:r>
-              <a:rPr sz="1725">
-                <a:solidFill>
-                  <a:srgbClr val="1B252C"/>
-                </a:solidFill>
-              </a:rPr>
-              <a:t>Prototype Run vérifiable</a:t>
-            </a:r>
-            <a:r>
-              <a:rPr sz="1725">
-                <a:solidFill>
-                  <a:srgbClr val="1B252C"/>
-                </a:solidFill>
-              </a:rPr>
-              <a:t> : HTTPS, métriques, alertes, heartbeat, promotion et rollback.</a:t>
-            </a:r>
-          </a:p>
-        </p:txBody>
-      </p:sp>
-      <p:sp>
-        <p:nvSpPr>
-          <p:cNvPr id="5" name="">
-            <a:extLst xmlns:a="http://schemas.openxmlformats.org/drawingml/2006/main">
-              <a:ext uri="{FF2B5EF4-FFF2-40B4-BE49-F238E27FC236}">
-                <a16:creationId xmlns:a16="http://schemas.microsoft.com/office/drawing/2014/main" id="{1E9F2FE7-2AC6-495F-A0A2-7078D9454534}"/>
-              </a:ext>
-            </a:extLst>
-          </p:cNvPr>
-          <p:cNvSpPr>
-            <a:spLocks xmlns:a="http://schemas.openxmlformats.org/drawingml/2006/main" noGrp="1"/>
-          </p:cNvSpPr>
-          <p:nvPr/>
-        </p:nvSpPr>
-        <p:spPr>
-          <a:xfrm xmlns:a="http://schemas.openxmlformats.org/drawingml/2006/main">
-            <a:off x="1143000" y="4857750"/>
-            <a:ext cx="9906000" cy="552450"/>
+          <a:bodyPr xmlns:a="http://schemas.openxmlformats.org/drawingml/2006/main"/>
+          <a:lstStyle xmlns:a="http://schemas.openxmlformats.org/drawingml/2006/main"/>
+          <a:p xmlns:a="http://schemas.openxmlformats.org/drawingml/2006/main">
+            <a:pPr>
+              <a:defRPr sz="1500" b="1">
+                <a:solidFill>
+                  <a:srgbClr val="2B7F6E"/>
+                </a:solidFill>
+                <a:latin typeface="Calibri"/>
+                <a:ea typeface="Calibri"/>
+                <a:cs typeface="Calibri"/>
+              </a:defRPr>
+            </a:pPr>
+            <a:r>
+              <a:rPr sz="1500" b="1">
+                <a:solidFill>
+                  <a:srgbClr val="2B7F6E"/>
+                </a:solidFill>
+                <a:latin typeface="Calibri"/>
+                <a:ea typeface="Calibri"/>
+                <a:cs typeface="Calibri"/>
+              </a:rPr>
+              <a:t>UNE TRACE EXPLOITABLE</a:t>
+            </a:r>
+          </a:p>
+        </p:txBody>
+      </p:sp>
+      <p:sp>
+        <p:nvSpPr>
+          <p:cNvPr id="6" name="">
+            <a:extLst xmlns:a="http://schemas.openxmlformats.org/drawingml/2006/main">
+              <a:ext uri="{FF2B5EF4-FFF2-40B4-BE49-F238E27FC236}">
+                <a16:creationId xmlns:a16="http://schemas.microsoft.com/office/drawing/2014/main" id="{E18E3400-5A29-441B-B3A5-5AB256D2826E}"/>
+              </a:ext>
+            </a:extLst>
+          </p:cNvPr>
+          <p:cNvSpPr>
+            <a:spLocks xmlns:a="http://schemas.openxmlformats.org/drawingml/2006/main" noGrp="1"/>
+          </p:cNvSpPr>
+          <p:nvPr/>
+        </p:nvSpPr>
+        <p:spPr>
+          <a:xfrm xmlns:a="http://schemas.openxmlformats.org/drawingml/2006/main">
+            <a:off x="762000" y="1809750"/>
+            <a:ext cx="10668000" cy="1619250"/>
+          </a:xfrm>
+          <a:prstGeom xmlns:a="http://schemas.openxmlformats.org/drawingml/2006/main" prst="rect">
+            <a:avLst/>
+          </a:prstGeom>
+          <a:solidFill xmlns:a="http://schemas.openxmlformats.org/drawingml/2006/main">
+            <a:srgbClr val="F4F7F9"/>
+          </a:solidFill>
+          <a:ln xmlns:a="http://schemas.openxmlformats.org/drawingml/2006/main" w="9525">
+            <a:solidFill>
+              <a:srgbClr val="CFDCE5"/>
+            </a:solidFill>
+            <a:prstDash val="solid"/>
+          </a:ln>
+        </p:spPr>
+        <p:txBody>
+          <a:bodyPr xmlns:a="http://schemas.openxmlformats.org/drawingml/2006/main"/>
+          <a:lstStyle xmlns:a="http://schemas.openxmlformats.org/drawingml/2006/main"/>
+          <a:p xmlns:a="http://schemas.openxmlformats.org/drawingml/2006/main">
+            <a:pPr>
+              <a:defRPr sz="1275">
+                <a:solidFill>
+                  <a:srgbClr val="1B252C"/>
+                </a:solidFill>
+                <a:latin typeface="Consolas"/>
+                <a:ea typeface="Consolas"/>
+                <a:cs typeface="Consolas"/>
+              </a:defRPr>
+            </a:pPr>
+            <a:r>
+              <a:rPr sz="1275">
+                <a:solidFill>
+                  <a:srgbClr val="1B252C"/>
+                </a:solidFill>
+                <a:latin typeface="Consolas"/>
+                <a:ea typeface="Consolas"/>
+                <a:cs typeface="Consolas"/>
+              </a:rPr>
+              <a:t>{</a:t>
+            </a:r>
+          </a:p>
+          <a:p xmlns:a="http://schemas.openxmlformats.org/drawingml/2006/main">
+            <a:pPr>
+              <a:defRPr sz="1275">
+                <a:solidFill>
+                  <a:srgbClr val="1B252C"/>
+                </a:solidFill>
+                <a:latin typeface="Consolas"/>
+                <a:ea typeface="Consolas"/>
+                <a:cs typeface="Consolas"/>
+              </a:defRPr>
+            </a:pPr>
+            <a:r>
+              <a:rPr sz="1275">
+                <a:solidFill>
+                  <a:srgbClr val="1B252C"/>
+                </a:solidFill>
+                <a:latin typeface="Consolas"/>
+                <a:ea typeface="Consolas"/>
+                <a:cs typeface="Consolas"/>
+              </a:rPr>
+              <a:t>  "timestamp":"2026-07-21T14:05:24+00:00", "level":"INFO",</a:t>
+            </a:r>
+          </a:p>
+          <a:p xmlns:a="http://schemas.openxmlformats.org/drawingml/2006/main">
+            <a:pPr>
+              <a:defRPr sz="1275">
+                <a:solidFill>
+                  <a:srgbClr val="1B252C"/>
+                </a:solidFill>
+                <a:latin typeface="Consolas"/>
+                <a:ea typeface="Consolas"/>
+                <a:cs typeface="Consolas"/>
+              </a:defRPr>
+            </a:pPr>
+            <a:r>
+              <a:rPr sz="1275">
+                <a:solidFill>
+                  <a:srgbClr val="1B252C"/>
+                </a:solidFill>
+                <a:latin typeface="Consolas"/>
+                <a:ea typeface="Consolas"/>
+                <a:cs typeface="Consolas"/>
+              </a:rPr>
+              <a:t>  "event":"api_request", "request_id":"jury-log-proof-001",</a:t>
+            </a:r>
+          </a:p>
+          <a:p xmlns:a="http://schemas.openxmlformats.org/drawingml/2006/main">
+            <a:pPr>
+              <a:defRPr sz="1275">
+                <a:solidFill>
+                  <a:srgbClr val="1B252C"/>
+                </a:solidFill>
+                <a:latin typeface="Consolas"/>
+                <a:ea typeface="Consolas"/>
+                <a:cs typeface="Consolas"/>
+              </a:defRPr>
+            </a:pPr>
+            <a:r>
+              <a:rPr sz="1275">
+                <a:solidFill>
+                  <a:srgbClr val="1B252C"/>
+                </a:solidFill>
+                <a:latin typeface="Consolas"/>
+                <a:ea typeface="Consolas"/>
+                <a:cs typeface="Consolas"/>
+              </a:rPr>
+              <a:t>  "method":"GET", "path":"/health", "status":200, "duration_ms":2.45</a:t>
+            </a:r>
+          </a:p>
+          <a:p xmlns:a="http://schemas.openxmlformats.org/drawingml/2006/main">
+            <a:pPr>
+              <a:defRPr sz="1275">
+                <a:solidFill>
+                  <a:srgbClr val="1B252C"/>
+                </a:solidFill>
+                <a:latin typeface="Consolas"/>
+                <a:ea typeface="Consolas"/>
+                <a:cs typeface="Consolas"/>
+              </a:defRPr>
+            </a:pPr>
+            <a:r>
+              <a:rPr sz="1275">
+                <a:solidFill>
+                  <a:srgbClr val="1B252C"/>
+                </a:solidFill>
+                <a:latin typeface="Consolas"/>
+                <a:ea typeface="Consolas"/>
+                <a:cs typeface="Consolas"/>
+              </a:rPr>
+              <a:t>}</a:t>
+            </a:r>
+          </a:p>
+        </p:txBody>
+      </p:sp>
+      <p:sp>
+        <p:nvSpPr>
+          <p:cNvPr id="7" name="">
+            <a:extLst xmlns:a="http://schemas.openxmlformats.org/drawingml/2006/main">
+              <a:ext uri="{FF2B5EF4-FFF2-40B4-BE49-F238E27FC236}">
+                <a16:creationId xmlns:a16="http://schemas.microsoft.com/office/drawing/2014/main" id="{6BFE3BAD-2D94-48D2-8F9F-7C7C9A8C5646}"/>
+              </a:ext>
+            </a:extLst>
+          </p:cNvPr>
+          <p:cNvSpPr>
+            <a:spLocks xmlns:a="http://schemas.openxmlformats.org/drawingml/2006/main" noGrp="1"/>
+          </p:cNvSpPr>
+          <p:nvPr/>
+        </p:nvSpPr>
+        <p:spPr>
+          <a:xfrm xmlns:a="http://schemas.openxmlformats.org/drawingml/2006/main">
+            <a:off x="904875" y="3762375"/>
+            <a:ext cx="10191750" cy="1619250"/>
           </a:xfrm>
           <a:prstGeom xmlns:a="http://schemas.openxmlformats.org/drawingml/2006/main" prst="rect">
             <a:avLst/>
@@ -12159,75 +12043,145 @@
           </a:ln>
         </p:spPr>
         <p:txBody>
-          <a:bodyPr xmlns:a="http://schemas.openxmlformats.org/drawingml/2006/main" anchor="t"/>
+          <a:bodyPr xmlns:a="http://schemas.openxmlformats.org/drawingml/2006/main"/>
+          <a:lstStyle xmlns:a="http://schemas.openxmlformats.org/drawingml/2006/main"/>
+          <a:p xmlns:a="http://schemas.openxmlformats.org/drawingml/2006/main">
+            <a:pPr>
+              <a:defRPr sz="1575">
+                <a:solidFill>
+                  <a:srgbClr val="1B252C"/>
+                </a:solidFill>
+                <a:latin typeface="Calibri"/>
+                <a:ea typeface="Calibri"/>
+                <a:cs typeface="Calibri"/>
+              </a:defRPr>
+            </a:pPr>
+            <a:r>
+              <a:rPr sz="1575">
+                <a:solidFill>
+                  <a:srgbClr val="1B252C"/>
+                </a:solidFill>
+                <a:latin typeface="Calibri"/>
+                <a:ea typeface="Calibri"/>
+                <a:cs typeface="Calibri"/>
+              </a:rPr>
+              <a:t>• Une ligne JSON par requête, sans payload étudiant ni clé API.</a:t>
+            </a:r>
+          </a:p>
+          <a:p xmlns:a="http://schemas.openxmlformats.org/drawingml/2006/main">
+            <a:r>
+              <a:t/>
+            </a:r>
+          </a:p>
+          <a:p xmlns:a="http://schemas.openxmlformats.org/drawingml/2006/main">
+            <a:pPr>
+              <a:defRPr sz="1575">
+                <a:solidFill>
+                  <a:srgbClr val="1B252C"/>
+                </a:solidFill>
+                <a:latin typeface="Calibri"/>
+                <a:ea typeface="Calibri"/>
+                <a:cs typeface="Calibri"/>
+              </a:defRPr>
+            </a:pPr>
+            <a:r>
+              <a:rPr sz="1575">
+                <a:solidFill>
+                  <a:srgbClr val="1B252C"/>
+                </a:solidFill>
+                <a:latin typeface="Calibri"/>
+                <a:ea typeface="Calibri"/>
+                <a:cs typeface="Calibri"/>
+              </a:rPr>
+              <a:t>• X-Request-ID relie la réponse au journal technique.</a:t>
+            </a:r>
+          </a:p>
+          <a:p xmlns:a="http://schemas.openxmlformats.org/drawingml/2006/main">
+            <a:r>
+              <a:t/>
+            </a:r>
+          </a:p>
+          <a:p xmlns:a="http://schemas.openxmlformats.org/drawingml/2006/main">
+            <a:pPr>
+              <a:defRPr sz="1575">
+                <a:solidFill>
+                  <a:srgbClr val="1B252C"/>
+                </a:solidFill>
+                <a:latin typeface="Calibri"/>
+                <a:ea typeface="Calibri"/>
+                <a:cs typeface="Calibri"/>
+              </a:defRPr>
+            </a:pPr>
+            <a:r>
+              <a:rPr sz="1575">
+                <a:solidFill>
+                  <a:srgbClr val="1B252C"/>
+                </a:solidFill>
+                <a:latin typeface="Calibri"/>
+                <a:ea typeface="Calibri"/>
+                <a:cs typeface="Calibri"/>
+              </a:rPr>
+              <a:t>• Rotation Docker : 10 Mo par fichier, 5 fichiers conservés.</a:t>
+            </a:r>
+          </a:p>
+        </p:txBody>
+      </p:sp>
+      <p:sp>
+        <p:nvSpPr>
+          <p:cNvPr id="8" name="">
+            <a:extLst xmlns:a="http://schemas.openxmlformats.org/drawingml/2006/main">
+              <a:ext uri="{FF2B5EF4-FFF2-40B4-BE49-F238E27FC236}">
+                <a16:creationId xmlns:a16="http://schemas.microsoft.com/office/drawing/2014/main" id="{74C6751A-0FE9-4D56-9103-F8D3B1E60E04}"/>
+              </a:ext>
+            </a:extLst>
+          </p:cNvPr>
+          <p:cNvSpPr>
+            <a:spLocks xmlns:a="http://schemas.openxmlformats.org/drawingml/2006/main" noGrp="1"/>
+          </p:cNvSpPr>
+          <p:nvPr/>
+        </p:nvSpPr>
+        <p:spPr>
+          <a:xfrm xmlns:a="http://schemas.openxmlformats.org/drawingml/2006/main">
+            <a:off x="1619250" y="5572125"/>
+            <a:ext cx="8953500" cy="457200"/>
+          </a:xfrm>
+          <a:prstGeom xmlns:a="http://schemas.openxmlformats.org/drawingml/2006/main" prst="rect">
+            <a:avLst/>
+          </a:prstGeom>
+          <a:solidFill xmlns:a="http://schemas.openxmlformats.org/drawingml/2006/main">
+            <a:srgbClr val="EAF5F1"/>
+          </a:solidFill>
+          <a:ln xmlns:a="http://schemas.openxmlformats.org/drawingml/2006/main" w="9525">
+            <a:solidFill>
+              <a:srgbClr val="6AA998"/>
+            </a:solidFill>
+            <a:prstDash val="solid"/>
+          </a:ln>
+        </p:spPr>
+        <p:txBody>
+          <a:bodyPr xmlns:a="http://schemas.openxmlformats.org/drawingml/2006/main"/>
           <a:lstStyle xmlns:a="http://schemas.openxmlformats.org/drawingml/2006/main"/>
           <a:p xmlns:a="http://schemas.openxmlformats.org/drawingml/2006/main">
             <a:pPr algn="ctr">
-              <a:buNone/>
-              <a:defRPr sz="2100" b="1">
-                <a:solidFill>
-                  <a:srgbClr val="173B57"/>
-                </a:solidFill>
-              </a:defRPr>
-            </a:pPr>
-            <a:r>
-              <a:rPr sz="2100" b="1">
-                <a:solidFill>
-                  <a:srgbClr val="173B57"/>
-                </a:solidFill>
-              </a:rPr>
-              <a:t>Une aide concrète pour accompagner à temps les étudiants à risque.</a:t>
-            </a:r>
-          </a:p>
-        </p:txBody>
-      </p:sp>
-      <p:sp>
-        <p:nvSpPr>
-          <p:cNvPr id="6" name="">
-            <a:extLst xmlns:a="http://schemas.openxmlformats.org/drawingml/2006/main">
-              <a:ext uri="{FF2B5EF4-FFF2-40B4-BE49-F238E27FC236}">
-                <a16:creationId xmlns:a16="http://schemas.microsoft.com/office/drawing/2014/main" id="{A64D75A9-DA66-4759-B2CC-DB1AD74B0DC2}"/>
-              </a:ext>
-            </a:extLst>
-          </p:cNvPr>
-          <p:cNvSpPr>
-            <a:spLocks xmlns:a="http://schemas.openxmlformats.org/drawingml/2006/main" noGrp="1"/>
-          </p:cNvSpPr>
-          <p:nvPr/>
-        </p:nvSpPr>
-        <p:spPr>
-          <a:xfrm xmlns:a="http://schemas.openxmlformats.org/drawingml/2006/main">
-            <a:off x="1143000" y="5695950"/>
-            <a:ext cx="9906000" cy="428625"/>
-          </a:xfrm>
-          <a:prstGeom xmlns:a="http://schemas.openxmlformats.org/drawingml/2006/main" prst="rect">
-            <a:avLst/>
-          </a:prstGeom>
-          <a:noFill xmlns:a="http://schemas.openxmlformats.org/drawingml/2006/main"/>
-          <a:ln xmlns:a="http://schemas.openxmlformats.org/drawingml/2006/main" w="0">
-            <a:noFill/>
-            <a:prstDash val="solid"/>
-          </a:ln>
-        </p:spPr>
-        <p:txBody>
-          <a:bodyPr xmlns:a="http://schemas.openxmlformats.org/drawingml/2006/main" anchor="t"/>
-          <a:lstStyle xmlns:a="http://schemas.openxmlformats.org/drawingml/2006/main"/>
-          <a:p xmlns:a="http://schemas.openxmlformats.org/drawingml/2006/main">
-            <a:pPr algn="ctr">
-              <a:buNone/>
-              <a:defRPr sz="1800">
-                <a:solidFill>
-                  <a:srgbClr val="2E6F9E"/>
-                </a:solidFill>
-              </a:defRPr>
-            </a:pPr>
-            <a:r>
-              <a:rPr sz="1800">
-                <a:solidFill>
-                  <a:srgbClr val="2E6F9E"/>
-                </a:solidFill>
-              </a:rPr>
-              <a:t>Merci — vos questions ?</a:t>
+              <a:defRPr sz="1500" b="1">
+                <a:solidFill>
+                  <a:srgbClr val="2B7F6E"/>
+                </a:solidFill>
+                <a:latin typeface="Calibri"/>
+                <a:ea typeface="Calibri"/>
+                <a:cs typeface="Calibri"/>
+              </a:defRPr>
+            </a:pPr>
+            <a:r>
+              <a:rPr sz="1500" b="1">
+                <a:solidFill>
+                  <a:srgbClr val="2B7F6E"/>
+                </a:solidFill>
+                <a:latin typeface="Calibri"/>
+                <a:ea typeface="Calibri"/>
+                <a:cs typeface="Calibri"/>
+              </a:rPr>
+              <a:t>Traçabilité utile, exposition des données minimisée.</a:t>
             </a:r>
           </a:p>
         </p:txBody>
@@ -12235,7 +12189,7 @@
     </p:spTree>
     <p:extLst>
       <p:ext uri="{BB962C8B-B14F-4D97-AF65-F5344CB8AC3E}">
-        <p14:creationId xmlns:p14="http://schemas.microsoft.com/office/powerpoint/2010/main" val="447710926"/>
+        <p14:creationId xmlns:p14="http://schemas.microsoft.com/office/powerpoint/2010/main" val="177717618"/>
       </p:ext>
     </p:extLst>
   </p:cSld>
@@ -12263,21 +12217,72 @@
       </p:grpSpPr>
       <p:sp>
         <p:nvSpPr>
-          <p:cNvPr id="8" name="">
-            <a:extLst xmlns:a="http://schemas.openxmlformats.org/drawingml/2006/main">
-              <a:ext uri="{FF2B5EF4-FFF2-40B4-BE49-F238E27FC236}">
-                <a16:creationId xmlns:a16="http://schemas.microsoft.com/office/drawing/2014/main" id="{8FE78200-8E93-43F2-9CE9-454429C9A537}"/>
-              </a:ext>
-            </a:extLst>
-          </p:cNvPr>
-          <p:cNvSpPr>
-            <a:spLocks xmlns:a="http://schemas.openxmlformats.org/drawingml/2006/main" noGrp="1"/>
-          </p:cNvSpPr>
-          <p:nvPr/>
-        </p:nvSpPr>
-        <p:spPr>
-          <a:xfrm xmlns:a="http://schemas.openxmlformats.org/drawingml/2006/main">
-            <a:off x="609600" y="438150"/>
+          <p:cNvPr id="13" name="">
+            <a:extLst xmlns:a="http://schemas.openxmlformats.org/drawingml/2006/main">
+              <a:ext uri="{FF2B5EF4-FFF2-40B4-BE49-F238E27FC236}">
+                <a16:creationId xmlns:a16="http://schemas.microsoft.com/office/drawing/2014/main" id="{08E5B9D7-38EE-457C-8A4A-0FADE80FEED4}"/>
+              </a:ext>
+            </a:extLst>
+          </p:cNvPr>
+          <p:cNvSpPr>
+            <a:spLocks xmlns:a="http://schemas.openxmlformats.org/drawingml/2006/main" noGrp="1"/>
+          </p:cNvSpPr>
+          <p:nvPr/>
+        </p:nvSpPr>
+        <p:spPr>
+          <a:xfrm xmlns:a="http://schemas.openxmlformats.org/drawingml/2006/main">
+            <a:off x="609600" y="323850"/>
+            <a:ext cx="4000500" cy="228600"/>
+          </a:xfrm>
+          <a:prstGeom xmlns:a="http://schemas.openxmlformats.org/drawingml/2006/main" prst="rect">
+            <a:avLst/>
+          </a:prstGeom>
+          <a:noFill xmlns:a="http://schemas.openxmlformats.org/drawingml/2006/main"/>
+          <a:ln xmlns:a="http://schemas.openxmlformats.org/drawingml/2006/main" w="0">
+            <a:noFill/>
+            <a:prstDash val="solid"/>
+          </a:ln>
+        </p:spPr>
+        <p:txBody>
+          <a:bodyPr xmlns:a="http://schemas.openxmlformats.org/drawingml/2006/main" anchor="t"/>
+          <a:lstStyle xmlns:a="http://schemas.openxmlformats.org/drawingml/2006/main"/>
+          <a:p xmlns:a="http://schemas.openxmlformats.org/drawingml/2006/main">
+            <a:pPr>
+              <a:buNone/>
+              <a:defRPr sz="975" b="1">
+                <a:solidFill>
+                  <a:srgbClr val="2E6F9E"/>
+                </a:solidFill>
+              </a:defRPr>
+            </a:pPr>
+            <a:r>
+              <a:rPr sz="975" b="1">
+                <a:solidFill>
+                  <a:srgbClr val="2E6F9E"/>
+                </a:solidFill>
+              </a:rPr>
+              <a:t>RUN</a:t>
+            </a:r>
+          </a:p>
+        </p:txBody>
+      </p:sp>
+      <p:sp>
+        <p:nvSpPr>
+          <p:cNvPr id="2" name="">
+            <a:extLst xmlns:a="http://schemas.openxmlformats.org/drawingml/2006/main">
+              <a:ext uri="{FF2B5EF4-FFF2-40B4-BE49-F238E27FC236}">
+                <a16:creationId xmlns:a16="http://schemas.microsoft.com/office/drawing/2014/main" id="{407216D8-1468-4494-9489-2281004F2869}"/>
+              </a:ext>
+            </a:extLst>
+          </p:cNvPr>
+          <p:cNvSpPr>
+            <a:spLocks xmlns:a="http://schemas.openxmlformats.org/drawingml/2006/main" noGrp="1"/>
+          </p:cNvSpPr>
+          <p:nvPr/>
+        </p:nvSpPr>
+        <p:spPr>
+          <a:xfrm xmlns:a="http://schemas.openxmlformats.org/drawingml/2006/main">
+            <a:off x="609600" y="590550"/>
             <a:ext cx="10953750" cy="552450"/>
           </a:xfrm>
           <a:prstGeom xmlns:a="http://schemas.openxmlformats.org/drawingml/2006/main" prst="rect">
@@ -12307,28 +12312,28 @@
                   <a:srgbClr val="173B57"/>
                 </a:solidFill>
               </a:rPr>
-              <a:t>Backup — questions probables du jury</a:t>
-            </a:r>
-          </a:p>
-        </p:txBody>
-      </p:sp>
-      <p:sp>
-        <p:nvSpPr>
-          <p:cNvPr id="2" name="">
-            <a:extLst xmlns:a="http://schemas.openxmlformats.org/drawingml/2006/main">
-              <a:ext uri="{FF2B5EF4-FFF2-40B4-BE49-F238E27FC236}">
-                <a16:creationId xmlns:a16="http://schemas.microsoft.com/office/drawing/2014/main" id="{880BE2F1-5B0C-407D-8AC6-AB571CAC4CAA}"/>
-              </a:ext>
-            </a:extLst>
-          </p:cNvPr>
-          <p:cNvSpPr>
-            <a:spLocks xmlns:a="http://schemas.openxmlformats.org/drawingml/2006/main" noGrp="1"/>
-          </p:cNvSpPr>
-          <p:nvPr/>
-        </p:nvSpPr>
-        <p:spPr>
-          <a:xfrm xmlns:a="http://schemas.openxmlformats.org/drawingml/2006/main">
-            <a:off x="609600" y="1028700"/>
+              <a:t>18. TCO &amp; valeur du pilote — C7 / C9</a:t>
+            </a:r>
+          </a:p>
+        </p:txBody>
+      </p:sp>
+      <p:sp>
+        <p:nvSpPr>
+          <p:cNvPr id="3" name="">
+            <a:extLst xmlns:a="http://schemas.openxmlformats.org/drawingml/2006/main">
+              <a:ext uri="{FF2B5EF4-FFF2-40B4-BE49-F238E27FC236}">
+                <a16:creationId xmlns:a16="http://schemas.microsoft.com/office/drawing/2014/main" id="{5A350BB4-D686-490A-8D2F-F263F9C1B696}"/>
+              </a:ext>
+            </a:extLst>
+          </p:cNvPr>
+          <p:cNvSpPr>
+            <a:spLocks xmlns:a="http://schemas.openxmlformats.org/drawingml/2006/main" noGrp="1"/>
+          </p:cNvSpPr>
+          <p:nvPr/>
+        </p:nvSpPr>
+        <p:spPr>
+          <a:xfrm xmlns:a="http://schemas.openxmlformats.org/drawingml/2006/main">
+            <a:off x="609600" y="1162050"/>
             <a:ext cx="10972800" cy="19050"/>
           </a:xfrm>
           <a:prstGeom xmlns:a="http://schemas.openxmlformats.org/drawingml/2006/main" prst="rect">
@@ -12345,10 +12350,10 @@
       </p:sp>
       <p:sp>
         <p:nvSpPr>
-          <p:cNvPr id="3" name="">
-            <a:extLst xmlns:a="http://schemas.openxmlformats.org/drawingml/2006/main">
-              <a:ext uri="{FF2B5EF4-FFF2-40B4-BE49-F238E27FC236}">
-                <a16:creationId xmlns:a16="http://schemas.microsoft.com/office/drawing/2014/main" id="{FBED50F1-8926-4612-8E4F-79B7F90FFA8A}"/>
+          <p:cNvPr id="4" name="">
+            <a:extLst xmlns:a="http://schemas.openxmlformats.org/drawingml/2006/main">
+              <a:ext uri="{FF2B5EF4-FFF2-40B4-BE49-F238E27FC236}">
+                <a16:creationId xmlns:a16="http://schemas.microsoft.com/office/drawing/2014/main" id="{D84B452A-4055-4478-8C17-CD03ADC6FD08}"/>
               </a:ext>
             </a:extLst>
           </p:cNvPr>
@@ -12390,6 +12395,1382 @@
                 </a:solidFill>
               </a:rPr>
               <a:t>26</a:t>
+            </a:r>
+          </a:p>
+        </p:txBody>
+      </p:sp>
+      <p:sp>
+        <p:nvSpPr>
+          <p:cNvPr id="5" name="">
+            <a:extLst xmlns:a="http://schemas.openxmlformats.org/drawingml/2006/main">
+              <a:ext uri="{FF2B5EF4-FFF2-40B4-BE49-F238E27FC236}">
+                <a16:creationId xmlns:a16="http://schemas.microsoft.com/office/drawing/2014/main" id="{3CB13EF8-6241-418B-B648-E2B10A90F0DF}"/>
+              </a:ext>
+            </a:extLst>
+          </p:cNvPr>
+          <p:cNvSpPr>
+            <a:spLocks xmlns:a="http://schemas.openxmlformats.org/drawingml/2006/main" noGrp="1"/>
+          </p:cNvSpPr>
+          <p:nvPr/>
+        </p:nvSpPr>
+        <p:spPr>
+          <a:xfrm xmlns:a="http://schemas.openxmlformats.org/drawingml/2006/main">
+            <a:off x="781050" y="1571625"/>
+            <a:ext cx="2000250" cy="666750"/>
+          </a:xfrm>
+          <a:prstGeom xmlns:a="http://schemas.openxmlformats.org/drawingml/2006/main" prst="rect">
+            <a:avLst/>
+          </a:prstGeom>
+          <a:noFill xmlns:a="http://schemas.openxmlformats.org/drawingml/2006/main"/>
+          <a:ln xmlns:a="http://schemas.openxmlformats.org/drawingml/2006/main" w="0">
+            <a:noFill/>
+            <a:prstDash val="solid"/>
+          </a:ln>
+        </p:spPr>
+        <p:txBody>
+          <a:bodyPr xmlns:a="http://schemas.openxmlformats.org/drawingml/2006/main" anchor="t"/>
+          <a:lstStyle xmlns:a="http://schemas.openxmlformats.org/drawingml/2006/main"/>
+          <a:p xmlns:a="http://schemas.openxmlformats.org/drawingml/2006/main">
+            <a:pPr>
+              <a:buNone/>
+              <a:defRPr sz="3750" b="1">
+                <a:solidFill>
+                  <a:srgbClr val="2E6F9E"/>
+                </a:solidFill>
+              </a:defRPr>
+            </a:pPr>
+            <a:r>
+              <a:rPr sz="3750" b="1">
+                <a:solidFill>
+                  <a:srgbClr val="2E6F9E"/>
+                </a:solidFill>
+              </a:rPr>
+              <a:t>TCO</a:t>
+            </a:r>
+          </a:p>
+        </p:txBody>
+      </p:sp>
+      <p:sp>
+        <p:nvSpPr>
+          <p:cNvPr id="6" name="">
+            <a:extLst xmlns:a="http://schemas.openxmlformats.org/drawingml/2006/main">
+              <a:ext uri="{FF2B5EF4-FFF2-40B4-BE49-F238E27FC236}">
+                <a16:creationId xmlns:a16="http://schemas.microsoft.com/office/drawing/2014/main" id="{B9905803-6BBE-402C-9A83-ADC024E712F4}"/>
+              </a:ext>
+            </a:extLst>
+          </p:cNvPr>
+          <p:cNvSpPr>
+            <a:spLocks xmlns:a="http://schemas.openxmlformats.org/drawingml/2006/main" noGrp="1"/>
+          </p:cNvSpPr>
+          <p:nvPr/>
+        </p:nvSpPr>
+        <p:spPr>
+          <a:xfrm xmlns:a="http://schemas.openxmlformats.org/drawingml/2006/main">
+            <a:off x="2857500" y="1695450"/>
+            <a:ext cx="8096250" cy="590550"/>
+          </a:xfrm>
+          <a:prstGeom xmlns:a="http://schemas.openxmlformats.org/drawingml/2006/main" prst="rect">
+            <a:avLst/>
+          </a:prstGeom>
+          <a:noFill xmlns:a="http://schemas.openxmlformats.org/drawingml/2006/main"/>
+          <a:ln xmlns:a="http://schemas.openxmlformats.org/drawingml/2006/main" w="0">
+            <a:noFill/>
+            <a:prstDash val="solid"/>
+          </a:ln>
+        </p:spPr>
+        <p:txBody>
+          <a:bodyPr xmlns:a="http://schemas.openxmlformats.org/drawingml/2006/main" anchor="t"/>
+          <a:lstStyle xmlns:a="http://schemas.openxmlformats.org/drawingml/2006/main"/>
+          <a:p xmlns:a="http://schemas.openxmlformats.org/drawingml/2006/main">
+            <a:pPr>
+              <a:buNone/>
+              <a:defRPr sz="1725">
+                <a:solidFill>
+                  <a:srgbClr val="1B252C"/>
+                </a:solidFill>
+              </a:defRPr>
+            </a:pPr>
+            <a:r>
+              <a:rPr sz="1725">
+                <a:solidFill>
+                  <a:srgbClr val="1B252C"/>
+                </a:solidFill>
+              </a:rPr>
+              <a:t>hébergement + sauvegardes + temps DSI/DPO + revue modèle + interventions</a:t>
+            </a:r>
+          </a:p>
+        </p:txBody>
+      </p:sp>
+      <p:sp>
+        <p:nvSpPr>
+          <p:cNvPr id="7" name="">
+            <a:extLst xmlns:a="http://schemas.openxmlformats.org/drawingml/2006/main">
+              <a:ext uri="{FF2B5EF4-FFF2-40B4-BE49-F238E27FC236}">
+                <a16:creationId xmlns:a16="http://schemas.microsoft.com/office/drawing/2014/main" id="{45AC8204-DF35-4EB4-907D-DC5E173B4515}"/>
+              </a:ext>
+            </a:extLst>
+          </p:cNvPr>
+          <p:cNvSpPr>
+            <a:spLocks xmlns:a="http://schemas.openxmlformats.org/drawingml/2006/main" noGrp="1"/>
+          </p:cNvSpPr>
+          <p:nvPr/>
+        </p:nvSpPr>
+        <p:spPr>
+          <a:xfrm xmlns:a="http://schemas.openxmlformats.org/drawingml/2006/main">
+            <a:off x="781050" y="2571750"/>
+            <a:ext cx="10382250" cy="19050"/>
+          </a:xfrm>
+          <a:prstGeom xmlns:a="http://schemas.openxmlformats.org/drawingml/2006/main" prst="rect">
+            <a:avLst/>
+          </a:prstGeom>
+          <a:solidFill xmlns:a="http://schemas.openxmlformats.org/drawingml/2006/main">
+            <a:srgbClr val="CFDCE5"/>
+          </a:solidFill>
+          <a:ln xmlns:a="http://schemas.openxmlformats.org/drawingml/2006/main" w="0">
+            <a:noFill/>
+            <a:prstDash val="solid"/>
+          </a:ln>
+        </p:spPr>
+      </p:sp>
+      <p:sp>
+        <p:nvSpPr>
+          <p:cNvPr id="8" name="">
+            <a:extLst xmlns:a="http://schemas.openxmlformats.org/drawingml/2006/main">
+              <a:ext uri="{FF2B5EF4-FFF2-40B4-BE49-F238E27FC236}">
+                <a16:creationId xmlns:a16="http://schemas.microsoft.com/office/drawing/2014/main" id="{CECD97E2-724E-495C-A39F-C0868400BD0F}"/>
+              </a:ext>
+            </a:extLst>
+          </p:cNvPr>
+          <p:cNvSpPr>
+            <a:spLocks xmlns:a="http://schemas.openxmlformats.org/drawingml/2006/main" noGrp="1"/>
+          </p:cNvSpPr>
+          <p:nvPr/>
+        </p:nvSpPr>
+        <p:spPr>
+          <a:xfrm xmlns:a="http://schemas.openxmlformats.org/drawingml/2006/main">
+            <a:off x="781050" y="2905125"/>
+            <a:ext cx="3333750" cy="400050"/>
+          </a:xfrm>
+          <a:prstGeom xmlns:a="http://schemas.openxmlformats.org/drawingml/2006/main" prst="rect">
+            <a:avLst/>
+          </a:prstGeom>
+          <a:noFill xmlns:a="http://schemas.openxmlformats.org/drawingml/2006/main"/>
+          <a:ln xmlns:a="http://schemas.openxmlformats.org/drawingml/2006/main" w="0">
+            <a:noFill/>
+            <a:prstDash val="solid"/>
+          </a:ln>
+        </p:spPr>
+        <p:txBody>
+          <a:bodyPr xmlns:a="http://schemas.openxmlformats.org/drawingml/2006/main" anchor="t"/>
+          <a:lstStyle xmlns:a="http://schemas.openxmlformats.org/drawingml/2006/main"/>
+          <a:p xmlns:a="http://schemas.openxmlformats.org/drawingml/2006/main">
+            <a:pPr>
+              <a:buNone/>
+              <a:defRPr sz="1800" b="1">
+                <a:solidFill>
+                  <a:srgbClr val="2F7D67"/>
+                </a:solidFill>
+              </a:defRPr>
+            </a:pPr>
+            <a:r>
+              <a:rPr sz="1800" b="1">
+                <a:solidFill>
+                  <a:srgbClr val="2F7D67"/>
+                </a:solidFill>
+              </a:rPr>
+              <a:t>VALEUR DU PILOTE</a:t>
+            </a:r>
+          </a:p>
+        </p:txBody>
+      </p:sp>
+      <p:sp>
+        <p:nvSpPr>
+          <p:cNvPr id="9" name="">
+            <a:extLst xmlns:a="http://schemas.openxmlformats.org/drawingml/2006/main">
+              <a:ext uri="{FF2B5EF4-FFF2-40B4-BE49-F238E27FC236}">
+                <a16:creationId xmlns:a16="http://schemas.microsoft.com/office/drawing/2014/main" id="{5FE46928-A66E-4687-983D-46F6A2277407}"/>
+              </a:ext>
+            </a:extLst>
+          </p:cNvPr>
+          <p:cNvSpPr>
+            <a:spLocks xmlns:a="http://schemas.openxmlformats.org/drawingml/2006/main" noGrp="1"/>
+          </p:cNvSpPr>
+          <p:nvPr/>
+        </p:nvSpPr>
+        <p:spPr>
+          <a:xfrm xmlns:a="http://schemas.openxmlformats.org/drawingml/2006/main">
+            <a:off x="781050" y="3476625"/>
+            <a:ext cx="5905500" cy="1000125"/>
+          </a:xfrm>
+          <a:prstGeom xmlns:a="http://schemas.openxmlformats.org/drawingml/2006/main" prst="rect">
+            <a:avLst/>
+          </a:prstGeom>
+          <a:noFill xmlns:a="http://schemas.openxmlformats.org/drawingml/2006/main"/>
+          <a:ln xmlns:a="http://schemas.openxmlformats.org/drawingml/2006/main" w="0">
+            <a:noFill/>
+            <a:prstDash val="solid"/>
+          </a:ln>
+        </p:spPr>
+        <p:txBody>
+          <a:bodyPr xmlns:a="http://schemas.openxmlformats.org/drawingml/2006/main" anchor="t"/>
+          <a:lstStyle xmlns:a="http://schemas.openxmlformats.org/drawingml/2006/main"/>
+          <a:p xmlns:a="http://schemas.openxmlformats.org/drawingml/2006/main">
+            <a:pPr>
+              <a:buNone/>
+              <a:defRPr sz="2550" b="1">
+                <a:solidFill>
+                  <a:srgbClr val="173B57"/>
+                </a:solidFill>
+              </a:defRPr>
+            </a:pPr>
+            <a:r>
+              <a:rPr sz="2550" b="1">
+                <a:solidFill>
+                  <a:srgbClr val="173B57"/>
+                </a:solidFill>
+              </a:rPr>
+              <a:t>étudiants utilement accompagnés</a:t>
+            </a:r>
+          </a:p>
+          <a:p xmlns:a="http://schemas.openxmlformats.org/drawingml/2006/main">
+            <a:pPr>
+              <a:buNone/>
+              <a:defRPr sz="2550" b="1">
+                <a:solidFill>
+                  <a:srgbClr val="173B57"/>
+                </a:solidFill>
+              </a:defRPr>
+            </a:pPr>
+            <a:r>
+              <a:rPr sz="2550" b="1">
+                <a:solidFill>
+                  <a:srgbClr val="173B57"/>
+                </a:solidFill>
+              </a:rPr>
+              <a:t>× effet causal du dispositif</a:t>
+            </a:r>
+          </a:p>
+        </p:txBody>
+      </p:sp>
+      <p:sp>
+        <p:nvSpPr>
+          <p:cNvPr id="10" name="">
+            <a:extLst xmlns:a="http://schemas.openxmlformats.org/drawingml/2006/main">
+              <a:ext uri="{FF2B5EF4-FFF2-40B4-BE49-F238E27FC236}">
+                <a16:creationId xmlns:a16="http://schemas.microsoft.com/office/drawing/2014/main" id="{AF18EA22-E80B-46F4-BC2C-D50D40CB99A6}"/>
+              </a:ext>
+            </a:extLst>
+          </p:cNvPr>
+          <p:cNvSpPr>
+            <a:spLocks xmlns:a="http://schemas.openxmlformats.org/drawingml/2006/main" noGrp="1"/>
+          </p:cNvSpPr>
+          <p:nvPr/>
+        </p:nvSpPr>
+        <p:spPr>
+          <a:xfrm xmlns:a="http://schemas.openxmlformats.org/drawingml/2006/main">
+            <a:off x="7239000" y="3095625"/>
+            <a:ext cx="4000500" cy="1809750"/>
+          </a:xfrm>
+          <a:prstGeom xmlns:a="http://schemas.openxmlformats.org/drawingml/2006/main" prst="rect">
+            <a:avLst/>
+          </a:prstGeom>
+          <a:noFill xmlns:a="http://schemas.openxmlformats.org/drawingml/2006/main"/>
+          <a:ln xmlns:a="http://schemas.openxmlformats.org/drawingml/2006/main" w="0">
+            <a:noFill/>
+            <a:prstDash val="solid"/>
+          </a:ln>
+        </p:spPr>
+        <p:txBody>
+          <a:bodyPr xmlns:a="http://schemas.openxmlformats.org/drawingml/2006/main" anchor="t"/>
+          <a:lstStyle xmlns:a="http://schemas.openxmlformats.org/drawingml/2006/main"/>
+          <a:p xmlns:a="http://schemas.openxmlformats.org/drawingml/2006/main">
+            <a:pPr>
+              <a:lnSpc>
+                <a:spcPct val="122000"/>
+              </a:lnSpc>
+              <a:buNone/>
+              <a:defRPr sz="1500">
+                <a:solidFill>
+                  <a:srgbClr val="1B252C"/>
+                </a:solidFill>
+              </a:defRPr>
+            </a:pPr>
+            <a:r>
+              <a:rPr sz="1500">
+                <a:solidFill>
+                  <a:srgbClr val="1B252C"/>
+                </a:solidFill>
+              </a:rPr>
+              <a:t>• L'AUC ne mesure pas l'impact du tutorat.</a:t>
+            </a:r>
+          </a:p>
+          <a:p xmlns:a="http://schemas.openxmlformats.org/drawingml/2006/main">
+            <a:pPr>
+              <a:lnSpc>
+                <a:spcPct val="122000"/>
+              </a:lnSpc>
+              <a:buNone/>
+              <a:defRPr sz="1500">
+                <a:solidFill>
+                  <a:srgbClr val="1B252C"/>
+                </a:solidFill>
+              </a:defRPr>
+            </a:pPr>
+            <a:r>
+              <a:rPr sz="1500">
+                <a:solidFill>
+                  <a:srgbClr val="1B252C"/>
+                </a:solidFill>
+              </a:rPr>
+              <a:t>• Pilote progressif / A-B test nécessaire.</a:t>
+            </a:r>
+          </a:p>
+          <a:p xmlns:a="http://schemas.openxmlformats.org/drawingml/2006/main">
+            <a:pPr>
+              <a:lnSpc>
+                <a:spcPct val="122000"/>
+              </a:lnSpc>
+              <a:buNone/>
+              <a:defRPr sz="1500">
+                <a:solidFill>
+                  <a:srgbClr val="1B252C"/>
+                </a:solidFill>
+              </a:defRPr>
+            </a:pPr>
+            <a:r>
+              <a:rPr sz="1500">
+                <a:solidFill>
+                  <a:srgbClr val="1B252C"/>
+                </a:solidFill>
+              </a:rPr>
+              <a:t>• Capacité des tuteurs et faux positifs intégrés au coût.</a:t>
+            </a:r>
+          </a:p>
+        </p:txBody>
+      </p:sp>
+      <p:sp>
+        <p:nvSpPr>
+          <p:cNvPr id="11" name="">
+            <a:extLst xmlns:a="http://schemas.openxmlformats.org/drawingml/2006/main">
+              <a:ext uri="{FF2B5EF4-FFF2-40B4-BE49-F238E27FC236}">
+                <a16:creationId xmlns:a16="http://schemas.microsoft.com/office/drawing/2014/main" id="{246CB9C7-47D3-4877-ACF2-AC6D9671432C}"/>
+              </a:ext>
+            </a:extLst>
+          </p:cNvPr>
+          <p:cNvSpPr>
+            <a:spLocks xmlns:a="http://schemas.openxmlformats.org/drawingml/2006/main" noGrp="1"/>
+          </p:cNvSpPr>
+          <p:nvPr/>
+        </p:nvSpPr>
+        <p:spPr>
+          <a:xfrm xmlns:a="http://schemas.openxmlformats.org/drawingml/2006/main">
+            <a:off x="1619250" y="5286375"/>
+            <a:ext cx="8953500" cy="723900"/>
+          </a:xfrm>
+          <a:prstGeom xmlns:a="http://schemas.openxmlformats.org/drawingml/2006/main" prst="rect">
+            <a:avLst/>
+          </a:prstGeom>
+          <a:solidFill xmlns:a="http://schemas.openxmlformats.org/drawingml/2006/main">
+            <a:srgbClr val="F8ECE8"/>
+          </a:solidFill>
+          <a:ln xmlns:a="http://schemas.openxmlformats.org/drawingml/2006/main" w="9525">
+            <a:solidFill>
+              <a:srgbClr val="B95D48"/>
+            </a:solidFill>
+            <a:prstDash val="solid"/>
+          </a:ln>
+        </p:spPr>
+      </p:sp>
+      <p:sp>
+        <p:nvSpPr>
+          <p:cNvPr id="12" name="">
+            <a:extLst xmlns:a="http://schemas.openxmlformats.org/drawingml/2006/main">
+              <a:ext uri="{FF2B5EF4-FFF2-40B4-BE49-F238E27FC236}">
+                <a16:creationId xmlns:a16="http://schemas.microsoft.com/office/drawing/2014/main" id="{4EBBC361-A596-4B17-8B12-B7D53D57EAEE}"/>
+              </a:ext>
+            </a:extLst>
+          </p:cNvPr>
+          <p:cNvSpPr>
+            <a:spLocks xmlns:a="http://schemas.openxmlformats.org/drawingml/2006/main" noGrp="1"/>
+          </p:cNvSpPr>
+          <p:nvPr/>
+        </p:nvSpPr>
+        <p:spPr>
+          <a:xfrm xmlns:a="http://schemas.openxmlformats.org/drawingml/2006/main">
+            <a:off x="1790700" y="5400675"/>
+            <a:ext cx="8610600" cy="495300"/>
+          </a:xfrm>
+          <a:prstGeom xmlns:a="http://schemas.openxmlformats.org/drawingml/2006/main" prst="rect">
+            <a:avLst/>
+          </a:prstGeom>
+          <a:noFill xmlns:a="http://schemas.openxmlformats.org/drawingml/2006/main"/>
+          <a:ln xmlns:a="http://schemas.openxmlformats.org/drawingml/2006/main" w="0">
+            <a:noFill/>
+            <a:prstDash val="solid"/>
+          </a:ln>
+        </p:spPr>
+        <p:txBody>
+          <a:bodyPr xmlns:a="http://schemas.openxmlformats.org/drawingml/2006/main" anchor="ctr"/>
+          <a:lstStyle xmlns:a="http://schemas.openxmlformats.org/drawingml/2006/main"/>
+          <a:p xmlns:a="http://schemas.openxmlformats.org/drawingml/2006/main">
+            <a:pPr>
+              <a:buNone/>
+              <a:defRPr sz="1500" b="1">
+                <a:solidFill>
+                  <a:srgbClr val="B95D48"/>
+                </a:solidFill>
+              </a:defRPr>
+            </a:pPr>
+            <a:r>
+              <a:rPr sz="1500" b="1">
+                <a:solidFill>
+                  <a:srgbClr val="B95D48"/>
+                </a:solidFill>
+              </a:rPr>
+              <a:t>Aucun gain financier inventé : hypothèses à valider avec l'université.</a:t>
+            </a:r>
+          </a:p>
+        </p:txBody>
+      </p:sp>
+    </p:spTree>
+    <p:extLst>
+      <p:ext uri="{BB962C8B-B14F-4D97-AF65-F5344CB8AC3E}">
+        <p14:creationId xmlns:p14="http://schemas.microsoft.com/office/powerpoint/2010/main" val="893676865"/>
+      </p:ext>
+    </p:extLst>
+  </p:cSld>
+</p:sld>
+</file>
+
+<file path=ppt/slides/slide27.xml><?xml version="1.0" encoding="utf-8"?>
+<p:sld xmlns:p="http://schemas.openxmlformats.org/presentationml/2006/main">
+  <p:cSld>
+    <p:bg>
+      <p:bgPr>
+        <a:solidFill xmlns:a="http://schemas.openxmlformats.org/drawingml/2006/main">
+          <a:srgbClr val="FFFFFF"/>
+        </a:solidFill>
+      </p:bgPr>
+    </p:bg>
+    <p:spTree>
+      <p:nvGrpSpPr>
+        <p:cNvPr id="1" name=""/>
+        <p:cNvGrpSpPr/>
+        <p:nvPr/>
+      </p:nvGrpSpPr>
+      <p:grpSpPr>
+        <a:xfrm xmlns:a="http://schemas.openxmlformats.org/drawingml/2006/main"/>
+      </p:grpSpPr>
+      <p:sp>
+        <p:nvSpPr>
+          <p:cNvPr id="7" name="">
+            <a:extLst xmlns:a="http://schemas.openxmlformats.org/drawingml/2006/main">
+              <a:ext uri="{FF2B5EF4-FFF2-40B4-BE49-F238E27FC236}">
+                <a16:creationId xmlns:a16="http://schemas.microsoft.com/office/drawing/2014/main" id="{18A77E1C-2B23-4094-9236-BEC86DCE8B41}"/>
+              </a:ext>
+            </a:extLst>
+          </p:cNvPr>
+          <p:cNvSpPr>
+            <a:spLocks xmlns:a="http://schemas.openxmlformats.org/drawingml/2006/main" noGrp="1"/>
+          </p:cNvSpPr>
+          <p:nvPr/>
+        </p:nvSpPr>
+        <p:spPr>
+          <a:xfrm xmlns:a="http://schemas.openxmlformats.org/drawingml/2006/main">
+            <a:off x="609600" y="438150"/>
+            <a:ext cx="10953750" cy="552450"/>
+          </a:xfrm>
+          <a:prstGeom xmlns:a="http://schemas.openxmlformats.org/drawingml/2006/main" prst="rect">
+            <a:avLst/>
+          </a:prstGeom>
+          <a:noFill xmlns:a="http://schemas.openxmlformats.org/drawingml/2006/main"/>
+          <a:ln xmlns:a="http://schemas.openxmlformats.org/drawingml/2006/main" w="0">
+            <a:noFill/>
+            <a:prstDash val="solid"/>
+          </a:ln>
+        </p:spPr>
+        <p:txBody>
+          <a:bodyPr xmlns:a="http://schemas.openxmlformats.org/drawingml/2006/main" anchor="t"/>
+          <a:lstStyle xmlns:a="http://schemas.openxmlformats.org/drawingml/2006/main"/>
+          <a:p xmlns:a="http://schemas.openxmlformats.org/drawingml/2006/main">
+            <a:pPr>
+              <a:buNone/>
+              <a:defRPr sz="2700" b="1">
+                <a:solidFill>
+                  <a:srgbClr val="173B57"/>
+                </a:solidFill>
+              </a:defRPr>
+            </a:pPr>
+            <a:r>
+              <a:rPr sz="2700" b="1">
+                <a:solidFill>
+                  <a:srgbClr val="173B57"/>
+                </a:solidFill>
+              </a:rPr>
+              <a:t>19. Limites &amp; recommandations</a:t>
+            </a:r>
+          </a:p>
+        </p:txBody>
+      </p:sp>
+      <p:sp>
+        <p:nvSpPr>
+          <p:cNvPr id="2" name="">
+            <a:extLst xmlns:a="http://schemas.openxmlformats.org/drawingml/2006/main">
+              <a:ext uri="{FF2B5EF4-FFF2-40B4-BE49-F238E27FC236}">
+                <a16:creationId xmlns:a16="http://schemas.microsoft.com/office/drawing/2014/main" id="{AAC52D35-FD95-46AD-B4E5-E2594CD9E567}"/>
+              </a:ext>
+            </a:extLst>
+          </p:cNvPr>
+          <p:cNvSpPr>
+            <a:spLocks xmlns:a="http://schemas.openxmlformats.org/drawingml/2006/main" noGrp="1"/>
+          </p:cNvSpPr>
+          <p:nvPr/>
+        </p:nvSpPr>
+        <p:spPr>
+          <a:xfrm xmlns:a="http://schemas.openxmlformats.org/drawingml/2006/main">
+            <a:off x="609600" y="1028700"/>
+            <a:ext cx="10972800" cy="19050"/>
+          </a:xfrm>
+          <a:prstGeom xmlns:a="http://schemas.openxmlformats.org/drawingml/2006/main" prst="rect">
+            <a:avLst/>
+          </a:prstGeom>
+          <a:solidFill xmlns:a="http://schemas.openxmlformats.org/drawingml/2006/main">
+            <a:srgbClr val="CFDCE5"/>
+          </a:solidFill>
+          <a:ln xmlns:a="http://schemas.openxmlformats.org/drawingml/2006/main" w="0">
+            <a:noFill/>
+            <a:prstDash val="solid"/>
+          </a:ln>
+        </p:spPr>
+      </p:sp>
+      <p:sp>
+        <p:nvSpPr>
+          <p:cNvPr id="3" name="">
+            <a:extLst xmlns:a="http://schemas.openxmlformats.org/drawingml/2006/main">
+              <a:ext uri="{FF2B5EF4-FFF2-40B4-BE49-F238E27FC236}">
+                <a16:creationId xmlns:a16="http://schemas.microsoft.com/office/drawing/2014/main" id="{66992DBB-B67F-4143-BBCD-9C63D33D7EBF}"/>
+              </a:ext>
+            </a:extLst>
+          </p:cNvPr>
+          <p:cNvSpPr>
+            <a:spLocks xmlns:a="http://schemas.openxmlformats.org/drawingml/2006/main" noGrp="1"/>
+          </p:cNvSpPr>
+          <p:nvPr/>
+        </p:nvSpPr>
+        <p:spPr>
+          <a:xfrm xmlns:a="http://schemas.openxmlformats.org/drawingml/2006/main">
+            <a:off x="11144250" y="6438900"/>
+            <a:ext cx="438150" cy="190500"/>
+          </a:xfrm>
+          <a:prstGeom xmlns:a="http://schemas.openxmlformats.org/drawingml/2006/main" prst="rect">
+            <a:avLst/>
+          </a:prstGeom>
+          <a:noFill xmlns:a="http://schemas.openxmlformats.org/drawingml/2006/main"/>
+          <a:ln xmlns:a="http://schemas.openxmlformats.org/drawingml/2006/main" w="0">
+            <a:noFill/>
+            <a:prstDash val="solid"/>
+          </a:ln>
+        </p:spPr>
+        <p:txBody>
+          <a:bodyPr xmlns:a="http://schemas.openxmlformats.org/drawingml/2006/main" anchor="t"/>
+          <a:lstStyle xmlns:a="http://schemas.openxmlformats.org/drawingml/2006/main"/>
+          <a:p xmlns:a="http://schemas.openxmlformats.org/drawingml/2006/main">
+            <a:pPr algn="r">
+              <a:buNone/>
+              <a:defRPr sz="900">
+                <a:solidFill>
+                  <a:srgbClr val="85929B"/>
+                </a:solidFill>
+              </a:defRPr>
+            </a:pPr>
+            <a:r>
+              <a:rPr sz="900">
+                <a:solidFill>
+                  <a:srgbClr val="85929B"/>
+                </a:solidFill>
+              </a:rPr>
+              <a:t>27</a:t>
+            </a:r>
+          </a:p>
+        </p:txBody>
+      </p:sp>
+      <p:sp>
+        <p:nvSpPr>
+          <p:cNvPr id="4" name="">
+            <a:extLst xmlns:a="http://schemas.openxmlformats.org/drawingml/2006/main">
+              <a:ext uri="{FF2B5EF4-FFF2-40B4-BE49-F238E27FC236}">
+                <a16:creationId xmlns:a16="http://schemas.microsoft.com/office/drawing/2014/main" id="{EB912D26-5B00-4C7C-AFE8-09DFA87E9904}"/>
+              </a:ext>
+            </a:extLst>
+          </p:cNvPr>
+          <p:cNvSpPr>
+            <a:spLocks xmlns:a="http://schemas.openxmlformats.org/drawingml/2006/main" noGrp="1"/>
+          </p:cNvSpPr>
+          <p:nvPr/>
+        </p:nvSpPr>
+        <p:spPr>
+          <a:xfrm xmlns:a="http://schemas.openxmlformats.org/drawingml/2006/main">
+            <a:off x="904875" y="1571625"/>
+            <a:ext cx="10287000" cy="3333750"/>
+          </a:xfrm>
+          <a:prstGeom xmlns:a="http://schemas.openxmlformats.org/drawingml/2006/main" prst="rect">
+            <a:avLst/>
+          </a:prstGeom>
+          <a:noFill xmlns:a="http://schemas.openxmlformats.org/drawingml/2006/main"/>
+          <a:ln xmlns:a="http://schemas.openxmlformats.org/drawingml/2006/main" w="0">
+            <a:noFill/>
+            <a:prstDash val="solid"/>
+          </a:ln>
+        </p:spPr>
+        <p:txBody>
+          <a:bodyPr xmlns:a="http://schemas.openxmlformats.org/drawingml/2006/main" anchor="t"/>
+          <a:lstStyle xmlns:a="http://schemas.openxmlformats.org/drawingml/2006/main"/>
+          <a:p xmlns:a="http://schemas.openxmlformats.org/drawingml/2006/main">
+            <a:pPr>
+              <a:lnSpc>
+                <a:spcPct val="122000"/>
+              </a:lnSpc>
+              <a:buNone/>
+              <a:defRPr sz="1650">
+                <a:solidFill>
+                  <a:srgbClr val="1B252C"/>
+                </a:solidFill>
+              </a:defRPr>
+            </a:pPr>
+            <a:r>
+              <a:rPr sz="1650">
+                <a:solidFill>
+                  <a:srgbClr val="1B252C"/>
+                </a:solidFill>
+              </a:rPr>
+              <a:t>• Données synthétiques : performance à revalider sur des cohortes réelles.</a:t>
+            </a:r>
+          </a:p>
+          <a:p xmlns:a="http://schemas.openxmlformats.org/drawingml/2006/main">
+            <a:pPr>
+              <a:lnSpc>
+                <a:spcPct val="122000"/>
+              </a:lnSpc>
+              <a:buNone/>
+              <a:defRPr sz="1650">
+                <a:solidFill>
+                  <a:srgbClr val="1B252C"/>
+                </a:solidFill>
+              </a:defRPr>
+            </a:pPr>
+            <a:r>
+              <a:rPr sz="1650">
+                <a:solidFill>
+                  <a:srgbClr val="1B252C"/>
+                </a:solidFill>
+              </a:rPr>
+              <a:t>• Corrélation ≠ causalité : mesurer l'effet du dispositif par pilote.</a:t>
+            </a:r>
+          </a:p>
+          <a:p xmlns:a="http://schemas.openxmlformats.org/drawingml/2006/main">
+            <a:pPr>
+              <a:lnSpc>
+                <a:spcPct val="122000"/>
+              </a:lnSpc>
+              <a:buNone/>
+              <a:defRPr sz="1650">
+                <a:solidFill>
+                  <a:srgbClr val="1B252C"/>
+                </a:solidFill>
+              </a:defRPr>
+            </a:pPr>
+            <a:r>
+              <a:rPr sz="1650">
+                <a:solidFill>
+                  <a:srgbClr val="1B252C"/>
+                </a:solidFill>
+              </a:rPr>
+              <a:t>• Production réelle : DPO, DPIA/AIPD, RBAC, coffre de secrets, sauvegardes testées.</a:t>
+            </a:r>
+          </a:p>
+          <a:p xmlns:a="http://schemas.openxmlformats.org/drawingml/2006/main">
+            <a:pPr>
+              <a:lnSpc>
+                <a:spcPct val="122000"/>
+              </a:lnSpc>
+              <a:buNone/>
+              <a:defRPr sz="1650">
+                <a:solidFill>
+                  <a:srgbClr val="1B252C"/>
+                </a:solidFill>
+              </a:defRPr>
+            </a:pPr>
+            <a:r>
+              <a:rPr sz="1650">
+                <a:solidFill>
+                  <a:srgbClr val="1B252C"/>
+                </a:solidFill>
+              </a:rPr>
+              <a:t>• Run réel : confirmer le TCO, brancher le canal d'alerte et planifier les jobs.</a:t>
+            </a:r>
+          </a:p>
+          <a:p xmlns:a="http://schemas.openxmlformats.org/drawingml/2006/main">
+            <a:pPr>
+              <a:lnSpc>
+                <a:spcPct val="122000"/>
+              </a:lnSpc>
+              <a:buNone/>
+              <a:defRPr sz="1650">
+                <a:solidFill>
+                  <a:srgbClr val="1B252C"/>
+                </a:solidFill>
+              </a:defRPr>
+            </a:pPr>
+            <a:r>
+              <a:rPr sz="1650">
+                <a:solidFill>
+                  <a:srgbClr val="1B252C"/>
+                </a:solidFill>
+              </a:rPr>
+              <a:t>• Éthique : équité continue, explication, recours et formulation non stigmatisante.</a:t>
+            </a:r>
+          </a:p>
+        </p:txBody>
+      </p:sp>
+      <p:sp>
+        <p:nvSpPr>
+          <p:cNvPr id="5" name="">
+            <a:extLst xmlns:a="http://schemas.openxmlformats.org/drawingml/2006/main">
+              <a:ext uri="{FF2B5EF4-FFF2-40B4-BE49-F238E27FC236}">
+                <a16:creationId xmlns:a16="http://schemas.microsoft.com/office/drawing/2014/main" id="{93B0E887-5075-4E9D-BD88-37AFE440B410}"/>
+              </a:ext>
+            </a:extLst>
+          </p:cNvPr>
+          <p:cNvSpPr>
+            <a:spLocks xmlns:a="http://schemas.openxmlformats.org/drawingml/2006/main" noGrp="1"/>
+          </p:cNvSpPr>
+          <p:nvPr/>
+        </p:nvSpPr>
+        <p:spPr>
+          <a:xfrm xmlns:a="http://schemas.openxmlformats.org/drawingml/2006/main">
+            <a:off x="1381125" y="5095875"/>
+            <a:ext cx="9429750" cy="742950"/>
+          </a:xfrm>
+          <a:prstGeom xmlns:a="http://schemas.openxmlformats.org/drawingml/2006/main" prst="rect">
+            <a:avLst/>
+          </a:prstGeom>
+          <a:solidFill xmlns:a="http://schemas.openxmlformats.org/drawingml/2006/main">
+            <a:srgbClr val="E8F3EF"/>
+          </a:solidFill>
+          <a:ln xmlns:a="http://schemas.openxmlformats.org/drawingml/2006/main" w="9525">
+            <a:solidFill>
+              <a:srgbClr val="2F7D67"/>
+            </a:solidFill>
+            <a:prstDash val="solid"/>
+          </a:ln>
+        </p:spPr>
+      </p:sp>
+      <p:sp>
+        <p:nvSpPr>
+          <p:cNvPr id="6" name="">
+            <a:extLst xmlns:a="http://schemas.openxmlformats.org/drawingml/2006/main">
+              <a:ext uri="{FF2B5EF4-FFF2-40B4-BE49-F238E27FC236}">
+                <a16:creationId xmlns:a16="http://schemas.microsoft.com/office/drawing/2014/main" id="{665FCA75-547D-494B-85C1-D42DEE2646CF}"/>
+              </a:ext>
+            </a:extLst>
+          </p:cNvPr>
+          <p:cNvSpPr>
+            <a:spLocks xmlns:a="http://schemas.openxmlformats.org/drawingml/2006/main" noGrp="1"/>
+          </p:cNvSpPr>
+          <p:nvPr/>
+        </p:nvSpPr>
+        <p:spPr>
+          <a:xfrm xmlns:a="http://schemas.openxmlformats.org/drawingml/2006/main">
+            <a:off x="1552575" y="5210175"/>
+            <a:ext cx="9086850" cy="514350"/>
+          </a:xfrm>
+          <a:prstGeom xmlns:a="http://schemas.openxmlformats.org/drawingml/2006/main" prst="rect">
+            <a:avLst/>
+          </a:prstGeom>
+          <a:noFill xmlns:a="http://schemas.openxmlformats.org/drawingml/2006/main"/>
+          <a:ln xmlns:a="http://schemas.openxmlformats.org/drawingml/2006/main" w="0">
+            <a:noFill/>
+            <a:prstDash val="solid"/>
+          </a:ln>
+        </p:spPr>
+        <p:txBody>
+          <a:bodyPr xmlns:a="http://schemas.openxmlformats.org/drawingml/2006/main" anchor="ctr"/>
+          <a:lstStyle xmlns:a="http://schemas.openxmlformats.org/drawingml/2006/main"/>
+          <a:p xmlns:a="http://schemas.openxmlformats.org/drawingml/2006/main">
+            <a:pPr>
+              <a:buNone/>
+              <a:defRPr sz="1500" b="1">
+                <a:solidFill>
+                  <a:srgbClr val="2F7D67"/>
+                </a:solidFill>
+              </a:defRPr>
+            </a:pPr>
+            <a:r>
+              <a:rPr sz="1500" b="1">
+                <a:solidFill>
+                  <a:srgbClr val="2F7D67"/>
+                </a:solidFill>
+              </a:rPr>
+              <a:t>Le score priorise l'accompagnement ; il ne décide jamais du parcours d'un étudiant.</a:t>
+            </a:r>
+          </a:p>
+        </p:txBody>
+      </p:sp>
+    </p:spTree>
+    <p:extLst>
+      <p:ext uri="{BB962C8B-B14F-4D97-AF65-F5344CB8AC3E}">
+        <p14:creationId xmlns:p14="http://schemas.microsoft.com/office/powerpoint/2010/main" val="1218725923"/>
+      </p:ext>
+    </p:extLst>
+  </p:cSld>
+</p:sld>
+</file>
+
+<file path=ppt/slides/slide28.xml><?xml version="1.0" encoding="utf-8"?>
+<p:sld xmlns:p="http://schemas.openxmlformats.org/presentationml/2006/main">
+  <p:cSld>
+    <p:bg>
+      <p:bgPr>
+        <a:solidFill xmlns:a="http://schemas.openxmlformats.org/drawingml/2006/main">
+          <a:srgbClr val="FFFFFF"/>
+        </a:solidFill>
+      </p:bgPr>
+    </p:bg>
+    <p:spTree>
+      <p:nvGrpSpPr>
+        <p:cNvPr id="1" name=""/>
+        <p:cNvGrpSpPr/>
+        <p:nvPr/>
+      </p:nvGrpSpPr>
+      <p:grpSpPr>
+        <a:xfrm xmlns:a="http://schemas.openxmlformats.org/drawingml/2006/main"/>
+      </p:grpSpPr>
+      <p:sp>
+        <p:nvSpPr>
+          <p:cNvPr id="7" name="">
+            <a:extLst xmlns:a="http://schemas.openxmlformats.org/drawingml/2006/main">
+              <a:ext uri="{FF2B5EF4-FFF2-40B4-BE49-F238E27FC236}">
+                <a16:creationId xmlns:a16="http://schemas.microsoft.com/office/drawing/2014/main" id="{94FD13DA-5461-453B-B426-F31AEE47BA61}"/>
+              </a:ext>
+            </a:extLst>
+          </p:cNvPr>
+          <p:cNvSpPr>
+            <a:spLocks xmlns:a="http://schemas.openxmlformats.org/drawingml/2006/main" noGrp="1"/>
+          </p:cNvSpPr>
+          <p:nvPr/>
+        </p:nvSpPr>
+        <p:spPr>
+          <a:xfrm xmlns:a="http://schemas.openxmlformats.org/drawingml/2006/main">
+            <a:off x="609600" y="438150"/>
+            <a:ext cx="10953750" cy="552450"/>
+          </a:xfrm>
+          <a:prstGeom xmlns:a="http://schemas.openxmlformats.org/drawingml/2006/main" prst="rect">
+            <a:avLst/>
+          </a:prstGeom>
+          <a:noFill xmlns:a="http://schemas.openxmlformats.org/drawingml/2006/main"/>
+          <a:ln xmlns:a="http://schemas.openxmlformats.org/drawingml/2006/main" w="0">
+            <a:noFill/>
+            <a:prstDash val="solid"/>
+          </a:ln>
+        </p:spPr>
+        <p:txBody>
+          <a:bodyPr xmlns:a="http://schemas.openxmlformats.org/drawingml/2006/main" anchor="t"/>
+          <a:lstStyle xmlns:a="http://schemas.openxmlformats.org/drawingml/2006/main"/>
+          <a:p xmlns:a="http://schemas.openxmlformats.org/drawingml/2006/main">
+            <a:pPr>
+              <a:buNone/>
+              <a:defRPr sz="2700" b="1">
+                <a:solidFill>
+                  <a:srgbClr val="173B57"/>
+                </a:solidFill>
+              </a:defRPr>
+            </a:pPr>
+            <a:r>
+              <a:rPr sz="2700" b="1">
+                <a:solidFill>
+                  <a:srgbClr val="173B57"/>
+                </a:solidFill>
+              </a:rPr>
+              <a:t>20. Conclusion — du modèle au Run, C1→C9</a:t>
+            </a:r>
+          </a:p>
+        </p:txBody>
+      </p:sp>
+      <p:sp>
+        <p:nvSpPr>
+          <p:cNvPr id="2" name="">
+            <a:extLst xmlns:a="http://schemas.openxmlformats.org/drawingml/2006/main">
+              <a:ext uri="{FF2B5EF4-FFF2-40B4-BE49-F238E27FC236}">
+                <a16:creationId xmlns:a16="http://schemas.microsoft.com/office/drawing/2014/main" id="{10EAF760-C659-4364-8793-21891BDC6BD0}"/>
+              </a:ext>
+            </a:extLst>
+          </p:cNvPr>
+          <p:cNvSpPr>
+            <a:spLocks xmlns:a="http://schemas.openxmlformats.org/drawingml/2006/main" noGrp="1"/>
+          </p:cNvSpPr>
+          <p:nvPr/>
+        </p:nvSpPr>
+        <p:spPr>
+          <a:xfrm xmlns:a="http://schemas.openxmlformats.org/drawingml/2006/main">
+            <a:off x="609600" y="1028700"/>
+            <a:ext cx="10972800" cy="19050"/>
+          </a:xfrm>
+          <a:prstGeom xmlns:a="http://schemas.openxmlformats.org/drawingml/2006/main" prst="rect">
+            <a:avLst/>
+          </a:prstGeom>
+          <a:solidFill xmlns:a="http://schemas.openxmlformats.org/drawingml/2006/main">
+            <a:srgbClr val="CFDCE5"/>
+          </a:solidFill>
+          <a:ln xmlns:a="http://schemas.openxmlformats.org/drawingml/2006/main" w="0">
+            <a:noFill/>
+            <a:prstDash val="solid"/>
+          </a:ln>
+        </p:spPr>
+      </p:sp>
+      <p:sp>
+        <p:nvSpPr>
+          <p:cNvPr id="3" name="">
+            <a:extLst xmlns:a="http://schemas.openxmlformats.org/drawingml/2006/main">
+              <a:ext uri="{FF2B5EF4-FFF2-40B4-BE49-F238E27FC236}">
+                <a16:creationId xmlns:a16="http://schemas.microsoft.com/office/drawing/2014/main" id="{4FED1F7F-F033-479D-B6AB-3E80B816FCEF}"/>
+              </a:ext>
+            </a:extLst>
+          </p:cNvPr>
+          <p:cNvSpPr>
+            <a:spLocks xmlns:a="http://schemas.openxmlformats.org/drawingml/2006/main" noGrp="1"/>
+          </p:cNvSpPr>
+          <p:nvPr/>
+        </p:nvSpPr>
+        <p:spPr>
+          <a:xfrm xmlns:a="http://schemas.openxmlformats.org/drawingml/2006/main">
+            <a:off x="11144250" y="6438900"/>
+            <a:ext cx="438150" cy="190500"/>
+          </a:xfrm>
+          <a:prstGeom xmlns:a="http://schemas.openxmlformats.org/drawingml/2006/main" prst="rect">
+            <a:avLst/>
+          </a:prstGeom>
+          <a:noFill xmlns:a="http://schemas.openxmlformats.org/drawingml/2006/main"/>
+          <a:ln xmlns:a="http://schemas.openxmlformats.org/drawingml/2006/main" w="0">
+            <a:noFill/>
+            <a:prstDash val="solid"/>
+          </a:ln>
+        </p:spPr>
+        <p:txBody>
+          <a:bodyPr xmlns:a="http://schemas.openxmlformats.org/drawingml/2006/main" anchor="t"/>
+          <a:lstStyle xmlns:a="http://schemas.openxmlformats.org/drawingml/2006/main"/>
+          <a:p xmlns:a="http://schemas.openxmlformats.org/drawingml/2006/main">
+            <a:pPr algn="r">
+              <a:buNone/>
+              <a:defRPr sz="900">
+                <a:solidFill>
+                  <a:srgbClr val="85929B"/>
+                </a:solidFill>
+              </a:defRPr>
+            </a:pPr>
+            <a:r>
+              <a:rPr sz="900">
+                <a:solidFill>
+                  <a:srgbClr val="85929B"/>
+                </a:solidFill>
+              </a:rPr>
+              <a:t>28</a:t>
+            </a:r>
+          </a:p>
+        </p:txBody>
+      </p:sp>
+      <p:sp>
+        <p:nvSpPr>
+          <p:cNvPr id="4" name="">
+            <a:extLst xmlns:a="http://schemas.openxmlformats.org/drawingml/2006/main">
+              <a:ext uri="{FF2B5EF4-FFF2-40B4-BE49-F238E27FC236}">
+                <a16:creationId xmlns:a16="http://schemas.microsoft.com/office/drawing/2014/main" id="{CCA343F9-98D8-412B-9C24-F9BC838BE751}"/>
+              </a:ext>
+            </a:extLst>
+          </p:cNvPr>
+          <p:cNvSpPr>
+            <a:spLocks xmlns:a="http://schemas.openxmlformats.org/drawingml/2006/main" noGrp="1"/>
+          </p:cNvSpPr>
+          <p:nvPr/>
+        </p:nvSpPr>
+        <p:spPr>
+          <a:xfrm xmlns:a="http://schemas.openxmlformats.org/drawingml/2006/main">
+            <a:off x="1000125" y="1666875"/>
+            <a:ext cx="10096500" cy="2857500"/>
+          </a:xfrm>
+          <a:prstGeom xmlns:a="http://schemas.openxmlformats.org/drawingml/2006/main" prst="rect">
+            <a:avLst/>
+          </a:prstGeom>
+          <a:noFill xmlns:a="http://schemas.openxmlformats.org/drawingml/2006/main"/>
+          <a:ln xmlns:a="http://schemas.openxmlformats.org/drawingml/2006/main" w="0">
+            <a:noFill/>
+            <a:prstDash val="solid"/>
+          </a:ln>
+        </p:spPr>
+        <p:txBody>
+          <a:bodyPr xmlns:a="http://schemas.openxmlformats.org/drawingml/2006/main" anchor="t"/>
+          <a:lstStyle xmlns:a="http://schemas.openxmlformats.org/drawingml/2006/main"/>
+          <a:p xmlns:a="http://schemas.openxmlformats.org/drawingml/2006/main">
+            <a:pPr>
+              <a:lnSpc>
+                <a:spcPct val="122000"/>
+              </a:lnSpc>
+              <a:buNone/>
+              <a:defRPr sz="1725">
+                <a:solidFill>
+                  <a:srgbClr val="1B252C"/>
+                </a:solidFill>
+              </a:defRPr>
+            </a:pPr>
+            <a:r>
+              <a:rPr sz="1725">
+                <a:solidFill>
+                  <a:srgbClr val="1B252C"/>
+                </a:solidFill>
+              </a:rPr>
+              <a:t>• Rigueur anti-fuite : trois pièges neutralisés et garde-fou codé.</a:t>
+            </a:r>
+          </a:p>
+          <a:p xmlns:a="http://schemas.openxmlformats.org/drawingml/2006/main">
+            <a:pPr>
+              <a:lnSpc>
+                <a:spcPct val="122000"/>
+              </a:lnSpc>
+              <a:buNone/>
+              <a:defRPr sz="1725">
+                <a:solidFill>
+                  <a:srgbClr val="1B252C"/>
+                </a:solidFill>
+              </a:defRPr>
+            </a:pPr>
+            <a:r>
+              <a:rPr sz="1725">
+                <a:solidFill>
+                  <a:srgbClr val="1B252C"/>
+                </a:solidFill>
+              </a:rPr>
+              <a:t>• Modèle explicable : AUC 0,95, rappel 95,9 %, seuil métier assumé.</a:t>
+            </a:r>
+          </a:p>
+          <a:p xmlns:a="http://schemas.openxmlformats.org/drawingml/2006/main">
+            <a:pPr>
+              <a:lnSpc>
+                <a:spcPct val="122000"/>
+              </a:lnSpc>
+              <a:buNone/>
+              <a:defRPr sz="1725">
+                <a:solidFill>
+                  <a:srgbClr val="1B252C"/>
+                </a:solidFill>
+              </a:defRPr>
+            </a:pPr>
+            <a:r>
+              <a:rPr sz="1725">
+                <a:solidFill>
+                  <a:srgbClr val="1B252C"/>
+                </a:solidFill>
+              </a:rPr>
+              <a:t>• Architecture responsable : RGPD, médaillon, décision humaine.</a:t>
+            </a:r>
+          </a:p>
+          <a:p xmlns:a="http://schemas.openxmlformats.org/drawingml/2006/main">
+            <a:pPr>
+              <a:lnSpc>
+                <a:spcPct val="122000"/>
+              </a:lnSpc>
+              <a:buNone/>
+              <a:defRPr sz="1725">
+                <a:solidFill>
+                  <a:srgbClr val="1B252C"/>
+                </a:solidFill>
+              </a:defRPr>
+            </a:pPr>
+            <a:r>
+              <a:rPr sz="1725">
+                <a:solidFill>
+                  <a:srgbClr val="1B252C"/>
+                </a:solidFill>
+              </a:rPr>
+              <a:t>• </a:t>
+            </a:r>
+            <a:r>
+              <a:rPr sz="1725">
+                <a:solidFill>
+                  <a:srgbClr val="1B252C"/>
+                </a:solidFill>
+              </a:rPr>
+              <a:t>Prototype Run vérifiable</a:t>
+            </a:r>
+            <a:r>
+              <a:rPr sz="1725">
+                <a:solidFill>
+                  <a:srgbClr val="1B252C"/>
+                </a:solidFill>
+              </a:rPr>
+              <a:t> : HTTPS, métriques, alertes, heartbeat, promotion et rollback.</a:t>
+            </a:r>
+          </a:p>
+        </p:txBody>
+      </p:sp>
+      <p:sp>
+        <p:nvSpPr>
+          <p:cNvPr id="5" name="">
+            <a:extLst xmlns:a="http://schemas.openxmlformats.org/drawingml/2006/main">
+              <a:ext uri="{FF2B5EF4-FFF2-40B4-BE49-F238E27FC236}">
+                <a16:creationId xmlns:a16="http://schemas.microsoft.com/office/drawing/2014/main" id="{1E9F2FE7-2AC6-495F-A0A2-7078D9454534}"/>
+              </a:ext>
+            </a:extLst>
+          </p:cNvPr>
+          <p:cNvSpPr>
+            <a:spLocks xmlns:a="http://schemas.openxmlformats.org/drawingml/2006/main" noGrp="1"/>
+          </p:cNvSpPr>
+          <p:nvPr/>
+        </p:nvSpPr>
+        <p:spPr>
+          <a:xfrm xmlns:a="http://schemas.openxmlformats.org/drawingml/2006/main">
+            <a:off x="1143000" y="4857750"/>
+            <a:ext cx="9906000" cy="552450"/>
+          </a:xfrm>
+          <a:prstGeom xmlns:a="http://schemas.openxmlformats.org/drawingml/2006/main" prst="rect">
+            <a:avLst/>
+          </a:prstGeom>
+          <a:noFill xmlns:a="http://schemas.openxmlformats.org/drawingml/2006/main"/>
+          <a:ln xmlns:a="http://schemas.openxmlformats.org/drawingml/2006/main" w="0">
+            <a:noFill/>
+            <a:prstDash val="solid"/>
+          </a:ln>
+        </p:spPr>
+        <p:txBody>
+          <a:bodyPr xmlns:a="http://schemas.openxmlformats.org/drawingml/2006/main" anchor="t"/>
+          <a:lstStyle xmlns:a="http://schemas.openxmlformats.org/drawingml/2006/main"/>
+          <a:p xmlns:a="http://schemas.openxmlformats.org/drawingml/2006/main">
+            <a:pPr algn="ctr">
+              <a:buNone/>
+              <a:defRPr sz="2100" b="1">
+                <a:solidFill>
+                  <a:srgbClr val="173B57"/>
+                </a:solidFill>
+              </a:defRPr>
+            </a:pPr>
+            <a:r>
+              <a:rPr sz="2100" b="1">
+                <a:solidFill>
+                  <a:srgbClr val="173B57"/>
+                </a:solidFill>
+              </a:rPr>
+              <a:t>Une aide concrète pour accompagner à temps les étudiants à risque.</a:t>
+            </a:r>
+          </a:p>
+        </p:txBody>
+      </p:sp>
+      <p:sp>
+        <p:nvSpPr>
+          <p:cNvPr id="6" name="">
+            <a:extLst xmlns:a="http://schemas.openxmlformats.org/drawingml/2006/main">
+              <a:ext uri="{FF2B5EF4-FFF2-40B4-BE49-F238E27FC236}">
+                <a16:creationId xmlns:a16="http://schemas.microsoft.com/office/drawing/2014/main" id="{A64D75A9-DA66-4759-B2CC-DB1AD74B0DC2}"/>
+              </a:ext>
+            </a:extLst>
+          </p:cNvPr>
+          <p:cNvSpPr>
+            <a:spLocks xmlns:a="http://schemas.openxmlformats.org/drawingml/2006/main" noGrp="1"/>
+          </p:cNvSpPr>
+          <p:nvPr/>
+        </p:nvSpPr>
+        <p:spPr>
+          <a:xfrm xmlns:a="http://schemas.openxmlformats.org/drawingml/2006/main">
+            <a:off x="1143000" y="5695950"/>
+            <a:ext cx="9906000" cy="428625"/>
+          </a:xfrm>
+          <a:prstGeom xmlns:a="http://schemas.openxmlformats.org/drawingml/2006/main" prst="rect">
+            <a:avLst/>
+          </a:prstGeom>
+          <a:noFill xmlns:a="http://schemas.openxmlformats.org/drawingml/2006/main"/>
+          <a:ln xmlns:a="http://schemas.openxmlformats.org/drawingml/2006/main" w="0">
+            <a:noFill/>
+            <a:prstDash val="solid"/>
+          </a:ln>
+        </p:spPr>
+        <p:txBody>
+          <a:bodyPr xmlns:a="http://schemas.openxmlformats.org/drawingml/2006/main" anchor="t"/>
+          <a:lstStyle xmlns:a="http://schemas.openxmlformats.org/drawingml/2006/main"/>
+          <a:p xmlns:a="http://schemas.openxmlformats.org/drawingml/2006/main">
+            <a:pPr algn="ctr">
+              <a:buNone/>
+              <a:defRPr sz="1800">
+                <a:solidFill>
+                  <a:srgbClr val="2E6F9E"/>
+                </a:solidFill>
+              </a:defRPr>
+            </a:pPr>
+            <a:r>
+              <a:rPr sz="1800">
+                <a:solidFill>
+                  <a:srgbClr val="2E6F9E"/>
+                </a:solidFill>
+              </a:rPr>
+              <a:t>Merci — vos questions ?</a:t>
+            </a:r>
+          </a:p>
+        </p:txBody>
+      </p:sp>
+    </p:spTree>
+    <p:extLst>
+      <p:ext uri="{BB962C8B-B14F-4D97-AF65-F5344CB8AC3E}">
+        <p14:creationId xmlns:p14="http://schemas.microsoft.com/office/powerpoint/2010/main" val="447710926"/>
+      </p:ext>
+    </p:extLst>
+  </p:cSld>
+</p:sld>
+</file>
+
+<file path=ppt/slides/slide29.xml><?xml version="1.0" encoding="utf-8"?>
+<p:sld xmlns:p="http://schemas.openxmlformats.org/presentationml/2006/main">
+  <p:cSld>
+    <p:bg>
+      <p:bgPr>
+        <a:solidFill xmlns:a="http://schemas.openxmlformats.org/drawingml/2006/main">
+          <a:srgbClr val="FFFFFF"/>
+        </a:solidFill>
+      </p:bgPr>
+    </p:bg>
+    <p:spTree>
+      <p:nvGrpSpPr>
+        <p:cNvPr id="1" name=""/>
+        <p:cNvGrpSpPr/>
+        <p:nvPr/>
+      </p:nvGrpSpPr>
+      <p:grpSpPr>
+        <a:xfrm xmlns:a="http://schemas.openxmlformats.org/drawingml/2006/main"/>
+      </p:grpSpPr>
+      <p:sp>
+        <p:nvSpPr>
+          <p:cNvPr id="8" name="">
+            <a:extLst xmlns:a="http://schemas.openxmlformats.org/drawingml/2006/main">
+              <a:ext uri="{FF2B5EF4-FFF2-40B4-BE49-F238E27FC236}">
+                <a16:creationId xmlns:a16="http://schemas.microsoft.com/office/drawing/2014/main" id="{8FE78200-8E93-43F2-9CE9-454429C9A537}"/>
+              </a:ext>
+            </a:extLst>
+          </p:cNvPr>
+          <p:cNvSpPr>
+            <a:spLocks xmlns:a="http://schemas.openxmlformats.org/drawingml/2006/main" noGrp="1"/>
+          </p:cNvSpPr>
+          <p:nvPr/>
+        </p:nvSpPr>
+        <p:spPr>
+          <a:xfrm xmlns:a="http://schemas.openxmlformats.org/drawingml/2006/main">
+            <a:off x="609600" y="438150"/>
+            <a:ext cx="10953750" cy="552450"/>
+          </a:xfrm>
+          <a:prstGeom xmlns:a="http://schemas.openxmlformats.org/drawingml/2006/main" prst="rect">
+            <a:avLst/>
+          </a:prstGeom>
+          <a:noFill xmlns:a="http://schemas.openxmlformats.org/drawingml/2006/main"/>
+          <a:ln xmlns:a="http://schemas.openxmlformats.org/drawingml/2006/main" w="0">
+            <a:noFill/>
+            <a:prstDash val="solid"/>
+          </a:ln>
+        </p:spPr>
+        <p:txBody>
+          <a:bodyPr xmlns:a="http://schemas.openxmlformats.org/drawingml/2006/main" anchor="t"/>
+          <a:lstStyle xmlns:a="http://schemas.openxmlformats.org/drawingml/2006/main"/>
+          <a:p xmlns:a="http://schemas.openxmlformats.org/drawingml/2006/main">
+            <a:pPr>
+              <a:buNone/>
+              <a:defRPr sz="2700" b="1">
+                <a:solidFill>
+                  <a:srgbClr val="173B57"/>
+                </a:solidFill>
+              </a:defRPr>
+            </a:pPr>
+            <a:r>
+              <a:rPr sz="2700" b="1">
+                <a:solidFill>
+                  <a:srgbClr val="173B57"/>
+                </a:solidFill>
+              </a:rPr>
+              <a:t>Backup — questions probables du jury</a:t>
+            </a:r>
+          </a:p>
+        </p:txBody>
+      </p:sp>
+      <p:sp>
+        <p:nvSpPr>
+          <p:cNvPr id="2" name="">
+            <a:extLst xmlns:a="http://schemas.openxmlformats.org/drawingml/2006/main">
+              <a:ext uri="{FF2B5EF4-FFF2-40B4-BE49-F238E27FC236}">
+                <a16:creationId xmlns:a16="http://schemas.microsoft.com/office/drawing/2014/main" id="{880BE2F1-5B0C-407D-8AC6-AB571CAC4CAA}"/>
+              </a:ext>
+            </a:extLst>
+          </p:cNvPr>
+          <p:cNvSpPr>
+            <a:spLocks xmlns:a="http://schemas.openxmlformats.org/drawingml/2006/main" noGrp="1"/>
+          </p:cNvSpPr>
+          <p:nvPr/>
+        </p:nvSpPr>
+        <p:spPr>
+          <a:xfrm xmlns:a="http://schemas.openxmlformats.org/drawingml/2006/main">
+            <a:off x="609600" y="1028700"/>
+            <a:ext cx="10972800" cy="19050"/>
+          </a:xfrm>
+          <a:prstGeom xmlns:a="http://schemas.openxmlformats.org/drawingml/2006/main" prst="rect">
+            <a:avLst/>
+          </a:prstGeom>
+          <a:solidFill xmlns:a="http://schemas.openxmlformats.org/drawingml/2006/main">
+            <a:srgbClr val="CFDCE5"/>
+          </a:solidFill>
+          <a:ln xmlns:a="http://schemas.openxmlformats.org/drawingml/2006/main" w="0">
+            <a:noFill/>
+            <a:prstDash val="solid"/>
+          </a:ln>
+        </p:spPr>
+      </p:sp>
+      <p:sp>
+        <p:nvSpPr>
+          <p:cNvPr id="3" name="">
+            <a:extLst xmlns:a="http://schemas.openxmlformats.org/drawingml/2006/main">
+              <a:ext uri="{FF2B5EF4-FFF2-40B4-BE49-F238E27FC236}">
+                <a16:creationId xmlns:a16="http://schemas.microsoft.com/office/drawing/2014/main" id="{FBED50F1-8926-4612-8E4F-79B7F90FFA8A}"/>
+              </a:ext>
+            </a:extLst>
+          </p:cNvPr>
+          <p:cNvSpPr>
+            <a:spLocks xmlns:a="http://schemas.openxmlformats.org/drawingml/2006/main" noGrp="1"/>
+          </p:cNvSpPr>
+          <p:nvPr/>
+        </p:nvSpPr>
+        <p:spPr>
+          <a:xfrm xmlns:a="http://schemas.openxmlformats.org/drawingml/2006/main">
+            <a:off x="11144250" y="6438900"/>
+            <a:ext cx="438150" cy="190500"/>
+          </a:xfrm>
+          <a:prstGeom xmlns:a="http://schemas.openxmlformats.org/drawingml/2006/main" prst="rect">
+            <a:avLst/>
+          </a:prstGeom>
+          <a:noFill xmlns:a="http://schemas.openxmlformats.org/drawingml/2006/main"/>
+          <a:ln xmlns:a="http://schemas.openxmlformats.org/drawingml/2006/main" w="0">
+            <a:noFill/>
+            <a:prstDash val="solid"/>
+          </a:ln>
+        </p:spPr>
+        <p:txBody>
+          <a:bodyPr xmlns:a="http://schemas.openxmlformats.org/drawingml/2006/main" anchor="t"/>
+          <a:lstStyle xmlns:a="http://schemas.openxmlformats.org/drawingml/2006/main"/>
+          <a:p xmlns:a="http://schemas.openxmlformats.org/drawingml/2006/main">
+            <a:pPr algn="r">
+              <a:buNone/>
+              <a:defRPr sz="900">
+                <a:solidFill>
+                  <a:srgbClr val="85929B"/>
+                </a:solidFill>
+              </a:defRPr>
+            </a:pPr>
+            <a:r>
+              <a:rPr sz="900">
+                <a:solidFill>
+                  <a:srgbClr val="85929B"/>
+                </a:solidFill>
+              </a:rPr>
+              <a:t>29</a:t>
             </a:r>
           </a:p>
         </p:txBody>
@@ -15479,7 +16860,7 @@
           <p:nvPr/>
         </p:nvPicPr>
         <p:blipFill>
-          <a:blip xmlns:r="http://schemas.openxmlformats.org/officeDocument/2006/relationships" xmlns:a="http://schemas.openxmlformats.org/drawingml/2006/main" r:embed="R2ac645e9c744411f"/>
+          <a:blip xmlns:r="http://schemas.openxmlformats.org/officeDocument/2006/relationships" xmlns:a="http://schemas.openxmlformats.org/drawingml/2006/main" r:embed="R9eebee096b6c44c8"/>
           <a:stretch xmlns:a="http://schemas.openxmlformats.org/drawingml/2006/main"/>
         </p:blipFill>
         <p:spPr>
@@ -15759,7 +17140,7 @@
           <p:nvPr/>
         </p:nvPicPr>
         <p:blipFill>
-          <a:blip xmlns:r="http://schemas.openxmlformats.org/officeDocument/2006/relationships" xmlns:a="http://schemas.openxmlformats.org/drawingml/2006/main" r:embed="R98cd639614874d1e"/>
+          <a:blip xmlns:r="http://schemas.openxmlformats.org/officeDocument/2006/relationships" xmlns:a="http://schemas.openxmlformats.org/drawingml/2006/main" r:embed="R4f28012767234e6b"/>
           <a:stretch xmlns:a="http://schemas.openxmlformats.org/drawingml/2006/main"/>
         </p:blipFill>
         <p:spPr>

</xml_diff>